<commit_message>
BP v17: rebuild the market page as one chain
Page 14 mixed three different measures (vendor revenue, a share of AI
infrastructure spend, and economic value) and called the last one our
market. It now reads left to right in one line of reasoning:
- today: what labs pay for training data and environments ($8.5B/yr)
- 2030: the training layer we sell into ($150-400B/yr = AI infrastructure
  spend x a 5-10% training share), with why that share rises
- 2030: the ~$7T AI economy that layer serves; the training layer is 2-6%
  of the value it unlocks
The overview's market cell now uses the same measure ($8.5B -> $150-400B).

Co-Authored-By: Claude Opus 5.5 <noreply@anthropic.com>
Claude-Session: https://claude.ai/code/session_01EKqGwTA92C8Wo4e47t73NN
</commit_message>
<xml_diff>
--- a/SimReal-BP-v17.pptx
+++ b/SimReal-BP-v17.pptx
@@ -12449,156 +12449,6 @@
           <a:chExt cx="0" cy="0"/>
         </a:xfrm>
       </p:grpSpPr>
-      <p:sp>
-        <p:nvSpPr>
-          <p:cNvPr id="450" name="Google Shape;450;p16"/>
-          <p:cNvSpPr txBox="1"/>
-          <p:nvPr/>
-        </p:nvSpPr>
-        <p:spPr>
-          <a:xfrm>
-            <a:off x="548640" y="384048"/>
-            <a:ext cx="8229600" cy="219456"/>
-          </a:xfrm>
-          <a:prstGeom prst="rect">
-            <a:avLst/>
-          </a:prstGeom>
-          <a:noFill/>
-          <a:ln>
-            <a:noFill/>
-          </a:ln>
-        </p:spPr>
-        <p:txBody>
-          <a:bodyPr spcFirstLastPara="1" wrap="square" lIns="0" tIns="0" rIns="0" bIns="0" anchor="ctr" anchorCtr="0">
-            <a:noAutofit/>
-          </a:bodyPr>
-          <a:lstStyle/>
-          <a:p>
-            <a:pPr marL="0" marR="0" lvl="0" indent="0" algn="l" rtl="0">
-              <a:spcBef>
-                <a:spcPts val="0"/>
-              </a:spcBef>
-              <a:spcAft>
-                <a:spcPts val="0"/>
-              </a:spcAft>
-              <a:buClr>
-                <a:srgbClr val="C2410C"/>
-              </a:buClr>
-              <a:buSzPts val="1000"/>
-              <a:buFont typeface="IBM Plex Mono"/>
-              <a:buNone/>
-            </a:pPr>
-            <a:r>
-              <a:rPr lang="zh-CN" sz="1000" b="1" i="0" u="none" strike="noStrike" cap="none">
-                <a:solidFill>
-                  <a:srgbClr val="C2410C"/>
-                </a:solidFill>
-                <a:latin typeface="IBM Plex Mono"/>
-                <a:ea typeface="IBM Plex Mono"/>
-                <a:cs typeface="IBM Plex Mono"/>
-                <a:sym typeface="IBM Plex Mono"/>
-              </a:rPr>
-              <a:t>14</a:t>
-            </a:r>
-            <a:r>
-              <a:rPr lang="zh-CN" sz="1100" b="1" i="0" u="none" strike="noStrike" cap="none">
-                <a:solidFill>
-                  <a:srgbClr val="6E6C66"/>
-                </a:solidFill>
-                <a:latin typeface="Instrument Sans"/>
-                <a:ea typeface="Instrument Sans"/>
-                <a:cs typeface="Instrument Sans"/>
-                <a:sym typeface="Instrument Sans"/>
-              </a:rPr>
-              <a:t>    市场</a:t>
-            </a:r>
-            <a:endParaRPr sz="1300" b="1" i="0" u="none" strike="noStrike" cap="none">
-              <a:solidFill>
-                <a:schemeClr val="dk1"/>
-              </a:solidFill>
-              <a:latin typeface="Instrument Sans"/>
-              <a:ea typeface="Instrument Sans"/>
-              <a:cs typeface="Instrument Sans"/>
-              <a:sym typeface="Instrument Sans"/>
-            </a:endParaRPr>
-          </a:p>
-        </p:txBody>
-      </p:sp>
-      <p:sp>
-        <p:nvSpPr>
-          <p:cNvPr id="451" name="Google Shape;451;p16"/>
-          <p:cNvSpPr txBox="1"/>
-          <p:nvPr/>
-        </p:nvSpPr>
-        <p:spPr>
-          <a:xfrm>
-            <a:off x="548640" y="676656"/>
-            <a:ext cx="11094415" cy="566928"/>
-          </a:xfrm>
-          <a:prstGeom prst="rect">
-            <a:avLst/>
-          </a:prstGeom>
-          <a:noFill/>
-          <a:ln>
-            <a:noFill/>
-          </a:ln>
-        </p:spPr>
-        <p:txBody>
-          <a:bodyPr spcFirstLastPara="1" wrap="square" lIns="0" tIns="0" rIns="0" bIns="0" anchor="t" anchorCtr="0">
-            <a:noAutofit/>
-          </a:bodyPr>
-          <a:lstStyle/>
-          <a:p>
-            <a:pPr marL="0" marR="0" lvl="0" indent="0" algn="l" rtl="0">
-              <a:spcBef>
-                <a:spcPts val="0"/>
-              </a:spcBef>
-              <a:spcAft>
-                <a:spcPts val="0"/>
-              </a:spcAft>
-              <a:buClr>
-                <a:srgbClr val="111110"/>
-              </a:buClr>
-              <a:buSzPts val="2800"/>
-              <a:buFont typeface="Newsreader"/>
-              <a:buNone/>
-            </a:pPr>
-            <a:r>
-              <a:rPr lang="zh-CN" sz="2800" b="0" i="0" u="none" strike="noStrike" cap="none">
-                <a:solidFill>
-                  <a:srgbClr val="111110"/>
-                </a:solidFill>
-                <a:latin typeface="Newsreader"/>
-                <a:ea typeface="Newsreader"/>
-                <a:cs typeface="Newsreader"/>
-                <a:sym typeface="Newsreader"/>
-              </a:rPr>
-              <a:t>AI经济有多大，训练世界就有多大：2030年</a:t>
-            </a:r>
-            <a:r>
-              <a:rPr lang="zh-CN" sz="2800" b="0" i="0" u="none" strike="noStrike" cap="none">
-                <a:solidFill>
-                  <a:srgbClr val="C2410C"/>
-                </a:solidFill>
-                <a:latin typeface="Newsreader"/>
-                <a:ea typeface="Newsreader"/>
-                <a:cs typeface="Newsreader"/>
-                <a:sym typeface="Newsreader"/>
-              </a:rPr>
-              <a:t>7万亿美元</a:t>
-            </a:r>
-            <a:endParaRPr sz="2800" b="0" i="0" u="none" strike="noStrike" cap="none">
-              <a:solidFill>
-                <a:schemeClr val="dk1"/>
-              </a:solidFill>
-              <a:latin typeface="Instrument Sans"/>
-              <a:ea typeface="Instrument Sans"/>
-              <a:cs typeface="Instrument Sans"/>
-              <a:sym typeface="Instrument Sans"/>
-            </a:endParaRPr>
-          </a:p>
-        </p:txBody>
-      </p:sp>
       <p:pic>
         <p:nvPicPr>
           <p:cNvPr id="470" name="Google Shape;470;p16" descr="SimReal"/>
@@ -12754,58 +12604,52 @@
       </p:sp>
       <p:sp>
         <p:nvSpPr>
-          <p:cNvPr id="473" name="Rectangle 472"/>
-          <p:cNvSpPr/>
-          <p:nvPr/>
-        </p:nvSpPr>
-        <p:spPr>
-          <a:xfrm>
-            <a:off x="548640" y="1474978"/>
-            <a:ext cx="5440680" cy="12700"/>
-          </a:xfrm>
-          <a:prstGeom prst="rect">
-            <a:avLst/>
-          </a:prstGeom>
-          <a:solidFill>
-            <a:srgbClr val="111110"/>
-          </a:solidFill>
-          <a:ln>
-            <a:noFill/>
-          </a:ln>
-        </p:spPr>
-        <p:txBody>
-          <a:bodyPr rtlCol="0" anchor="ctr"/>
-          <a:lstStyle/>
-          <a:p>
-            <a:endParaRPr/>
-          </a:p>
-        </p:txBody>
-      </p:sp>
-      <p:sp>
-        <p:nvSpPr>
-          <p:cNvPr id="474" name="TextBox 473"/>
+          <p:cNvPr id="3001" name="SimReal 3001"/>
           <p:cNvSpPr txBox="1"/>
           <p:nvPr/>
         </p:nvSpPr>
         <p:spPr>
           <a:xfrm>
-            <a:off x="548640" y="1554480"/>
-            <a:ext cx="5440680" cy="256032"/>
-          </a:xfrm>
-          <a:prstGeom prst="rect">
-            <a:avLst/>
-          </a:prstGeom>
-          <a:noFill/>
-        </p:spPr>
-        <p:txBody>
-          <a:bodyPr wrap="square" lIns="0" tIns="0" rIns="0" bIns="0" anchor="ctr">
-            <a:spAutoFit/>
-          </a:bodyPr>
-          <a:lstStyle/>
-          <a:p>
-            <a:pPr algn="l"/>
-            <a:r>
-              <a:rPr sz="1100" b="0">
+            <a:off x="548640" y="384048"/>
+            <a:ext cx="8229600" cy="219456"/>
+          </a:xfrm>
+          <a:prstGeom prst="rect">
+            <a:avLst/>
+          </a:prstGeom>
+          <a:noFill/>
+          <a:ln>
+            <a:noFill/>
+          </a:ln>
+        </p:spPr>
+        <p:txBody>
+          <a:bodyPr spcFirstLastPara="1" wrap="square" lIns="0" tIns="0" rIns="0" bIns="0" anchor="ctr" anchorCtr="0">
+            <a:noAutofit/>
+          </a:bodyPr>
+          <a:lstStyle/>
+          <a:p>
+            <a:pPr marL="0" marR="0" lvl="0" indent="0" algn="l" rtl="0">
+              <a:spcBef>
+                <a:spcPts val="0"/>
+              </a:spcBef>
+              <a:spcAft>
+                <a:spcPts val="0"/>
+              </a:spcAft>
+              <a:buNone/>
+            </a:pPr>
+            <a:r>
+              <a:rPr lang="zh-CN" sz="1000" b="1" i="0" u="none" strike="noStrike" cap="none">
+                <a:solidFill>
+                  <a:srgbClr val="C2410C"/>
+                </a:solidFill>
+                <a:latin typeface="IBM Plex Mono"/>
+                <a:ea typeface="IBM Plex Mono"/>
+                <a:cs typeface="IBM Plex Mono"/>
+                <a:sym typeface="IBM Plex Mono"/>
+              </a:rPr>
+              <a:t>14</a:t>
+            </a:r>
+            <a:r>
+              <a:rPr lang="zh-CN" sz="1100" b="1" i="0" u="none" strike="noStrike" cap="none">
                 <a:solidFill>
                   <a:srgbClr val="6E6C66"/>
                 </a:solidFill>
@@ -12814,36 +12658,47 @@
                 <a:cs typeface="Instrument Sans"/>
                 <a:sym typeface="Instrument Sans"/>
               </a:rPr>
-              <a:t>今天：实验室已经在付费</a:t>
-            </a:r>
-          </a:p>
-        </p:txBody>
-      </p:sp>
-      <p:sp>
-        <p:nvSpPr>
-          <p:cNvPr id="475" name="TextBox 474"/>
+              <a:t>    市场</a:t>
+            </a:r>
+          </a:p>
+        </p:txBody>
+      </p:sp>
+      <p:sp>
+        <p:nvSpPr>
+          <p:cNvPr id="3002" name="SimReal 3002"/>
           <p:cNvSpPr txBox="1"/>
           <p:nvPr/>
         </p:nvSpPr>
         <p:spPr>
           <a:xfrm>
-            <a:off x="548640" y="1810512"/>
-            <a:ext cx="5440680" cy="274320"/>
-          </a:xfrm>
-          <a:prstGeom prst="rect">
-            <a:avLst/>
-          </a:prstGeom>
-          <a:noFill/>
-        </p:spPr>
-        <p:txBody>
-          <a:bodyPr wrap="square" lIns="0" tIns="0" rIns="0" bIns="0" anchor="ctr">
-            <a:spAutoFit/>
-          </a:bodyPr>
-          <a:lstStyle/>
-          <a:p>
-            <a:pPr algn="l"/>
-            <a:r>
-              <a:rPr sz="1400" b="0">
+            <a:off x="548640" y="676656"/>
+            <a:ext cx="11091672" cy="566928"/>
+          </a:xfrm>
+          <a:prstGeom prst="rect">
+            <a:avLst/>
+          </a:prstGeom>
+          <a:noFill/>
+          <a:ln>
+            <a:noFill/>
+          </a:ln>
+        </p:spPr>
+        <p:txBody>
+          <a:bodyPr spcFirstLastPara="1" wrap="square" lIns="0" tIns="0" rIns="0" bIns="0" anchor="t" anchorCtr="0">
+            <a:noAutofit/>
+          </a:bodyPr>
+          <a:lstStyle/>
+          <a:p>
+            <a:pPr marL="0" marR="0" lvl="0" indent="0" algn="l" rtl="0">
+              <a:spcBef>
+                <a:spcPts val="0"/>
+              </a:spcBef>
+              <a:spcAft>
+                <a:spcPts val="0"/>
+              </a:spcAft>
+              <a:buNone/>
+            </a:pPr>
+            <a:r>
+              <a:rPr lang="zh-CN" sz="2800" b="0" i="0" u="none" strike="noStrike" cap="none">
                 <a:solidFill>
                   <a:srgbClr val="111110"/>
                 </a:solidFill>
@@ -12852,74 +12707,71 @@
                 <a:cs typeface="Newsreader"/>
                 <a:sym typeface="Newsreader"/>
               </a:rPr>
-              <a:t>头部AI训练数据公司收入（最新报道）</a:t>
-            </a:r>
-          </a:p>
-        </p:txBody>
-      </p:sp>
-      <p:sp>
-        <p:nvSpPr>
-          <p:cNvPr id="476" name="TextBox 475"/>
-          <p:cNvSpPr txBox="1"/>
-          <p:nvPr/>
-        </p:nvSpPr>
-        <p:spPr>
-          <a:xfrm>
-            <a:off x="548640" y="2240280"/>
-            <a:ext cx="1508760" cy="237744"/>
-          </a:xfrm>
-          <a:prstGeom prst="rect">
-            <a:avLst/>
-          </a:prstGeom>
-          <a:noFill/>
-        </p:spPr>
-        <p:txBody>
-          <a:bodyPr wrap="square" lIns="0" tIns="0" rIns="0" bIns="0" anchor="ctr">
-            <a:spAutoFit/>
-          </a:bodyPr>
-          <a:lstStyle/>
-          <a:p>
-            <a:pPr algn="l"/>
-            <a:r>
-              <a:rPr sz="1300" b="0">
-                <a:solidFill>
-                  <a:srgbClr val="111110"/>
+              <a:t>2030年：</a:t>
+            </a:r>
+            <a:r>
+              <a:rPr lang="zh-CN" sz="2800" b="0" i="0" u="none" strike="noStrike" cap="none">
+                <a:solidFill>
+                  <a:srgbClr val="C2410C"/>
                 </a:solidFill>
                 <a:latin typeface="Newsreader"/>
                 <a:ea typeface="Newsreader"/>
                 <a:cs typeface="Newsreader"/>
                 <a:sym typeface="Newsreader"/>
               </a:rPr>
-              <a:t>Mercor</a:t>
-            </a:r>
-          </a:p>
-        </p:txBody>
-      </p:sp>
-      <p:sp>
-        <p:nvSpPr>
-          <p:cNvPr id="477" name="TextBox 476"/>
+              <a:t>7万亿美元</a:t>
+            </a:r>
+            <a:r>
+              <a:rPr lang="zh-CN" sz="2800" b="0" i="0" u="none" strike="noStrike" cap="none">
+                <a:solidFill>
+                  <a:srgbClr val="111110"/>
+                </a:solidFill>
+                <a:latin typeface="Newsreader"/>
+                <a:ea typeface="Newsreader"/>
+                <a:cs typeface="Newsreader"/>
+                <a:sym typeface="Newsreader"/>
+              </a:rPr>
+              <a:t>的AI经济，数千亿美元的训练市场</a:t>
+            </a:r>
+          </a:p>
+        </p:txBody>
+      </p:sp>
+      <p:sp>
+        <p:nvSpPr>
+          <p:cNvPr id="3003" name="SimReal 3003"/>
           <p:cNvSpPr txBox="1"/>
           <p:nvPr/>
         </p:nvSpPr>
         <p:spPr>
           <a:xfrm>
-            <a:off x="548640" y="2468880"/>
-            <a:ext cx="1508760" cy="164592"/>
-          </a:xfrm>
-          <a:prstGeom prst="rect">
-            <a:avLst/>
-          </a:prstGeom>
-          <a:noFill/>
-        </p:spPr>
-        <p:txBody>
-          <a:bodyPr wrap="square" lIns="0" tIns="0" rIns="0" bIns="0" anchor="ctr">
-            <a:spAutoFit/>
-          </a:bodyPr>
-          <a:lstStyle/>
-          <a:p>
-            <a:pPr algn="l"/>
-            <a:r>
-              <a:rPr sz="750" b="0">
+            <a:off x="4062984" y="1847088"/>
+            <a:ext cx="274320" cy="548640"/>
+          </a:xfrm>
+          <a:prstGeom prst="rect">
+            <a:avLst/>
+          </a:prstGeom>
+          <a:noFill/>
+          <a:ln>
+            <a:noFill/>
+          </a:ln>
+        </p:spPr>
+        <p:txBody>
+          <a:bodyPr spcFirstLastPara="1" wrap="square" lIns="0" tIns="0" rIns="0" bIns="0" anchor="ctr" anchorCtr="0">
+            <a:noAutofit/>
+          </a:bodyPr>
+          <a:lstStyle/>
+          <a:p>
+            <a:pPr marL="0" marR="0" lvl="0" indent="0" algn="ctr" rtl="0">
+              <a:spcBef>
+                <a:spcPts val="0"/>
+              </a:spcBef>
+              <a:spcAft>
+                <a:spcPts val="0"/>
+              </a:spcAft>
+              <a:buNone/>
+            </a:pPr>
+            <a:r>
+              <a:rPr lang="zh-CN" sz="1400" b="0" i="0" u="none" strike="noStrike" cap="none">
                 <a:solidFill>
                   <a:srgbClr val="6E6C66"/>
                 </a:solidFill>
@@ -12928,103 +12780,174 @@
                 <a:cs typeface="Instrument Sans"/>
                 <a:sym typeface="Instrument Sans"/>
               </a:rPr>
-              <a:t>年化毛营收，2026年7月</a:t>
-            </a:r>
-          </a:p>
-        </p:txBody>
-      </p:sp>
-      <p:sp>
-        <p:nvSpPr>
-          <p:cNvPr id="478" name="Rectangle 477"/>
-          <p:cNvSpPr/>
-          <p:nvPr/>
-        </p:nvSpPr>
-        <p:spPr>
-          <a:xfrm>
-            <a:off x="2148840" y="2276856"/>
-            <a:ext cx="2926080" cy="274320"/>
-          </a:xfrm>
-          <a:prstGeom prst="rect">
-            <a:avLst/>
-          </a:prstGeom>
-          <a:solidFill>
-            <a:srgbClr val="111110"/>
-          </a:solidFill>
-          <a:ln>
-            <a:noFill/>
-          </a:ln>
-        </p:spPr>
-        <p:txBody>
-          <a:bodyPr rtlCol="0" anchor="ctr"/>
-          <a:lstStyle/>
-          <a:p>
-            <a:endParaRPr/>
-          </a:p>
-        </p:txBody>
-      </p:sp>
-      <p:sp>
-        <p:nvSpPr>
-          <p:cNvPr id="479" name="TextBox 478"/>
+              <a:t>→</a:t>
+            </a:r>
+          </a:p>
+        </p:txBody>
+      </p:sp>
+      <p:sp>
+        <p:nvSpPr>
+          <p:cNvPr id="3004" name="SimReal 3004"/>
           <p:cNvSpPr txBox="1"/>
           <p:nvPr/>
         </p:nvSpPr>
         <p:spPr>
           <a:xfrm>
-            <a:off x="5148072" y="2276856"/>
-            <a:ext cx="914400" cy="274320"/>
-          </a:xfrm>
-          <a:prstGeom prst="rect">
-            <a:avLst/>
-          </a:prstGeom>
-          <a:noFill/>
-        </p:spPr>
-        <p:txBody>
-          <a:bodyPr wrap="square" lIns="0" tIns="0" rIns="0" bIns="0" anchor="ctr">
-            <a:spAutoFit/>
-          </a:bodyPr>
-          <a:lstStyle/>
-          <a:p>
-            <a:pPr algn="l"/>
-            <a:r>
-              <a:rPr sz="1150" b="0">
-                <a:solidFill>
-                  <a:srgbClr val="111110"/>
+            <a:off x="7851648" y="1847088"/>
+            <a:ext cx="274320" cy="548640"/>
+          </a:xfrm>
+          <a:prstGeom prst="rect">
+            <a:avLst/>
+          </a:prstGeom>
+          <a:noFill/>
+          <a:ln>
+            <a:noFill/>
+          </a:ln>
+        </p:spPr>
+        <p:txBody>
+          <a:bodyPr spcFirstLastPara="1" wrap="square" lIns="0" tIns="0" rIns="0" bIns="0" anchor="ctr" anchorCtr="0">
+            <a:noAutofit/>
+          </a:bodyPr>
+          <a:lstStyle/>
+          <a:p>
+            <a:pPr marL="0" marR="0" lvl="0" indent="0" algn="ctr" rtl="0">
+              <a:spcBef>
+                <a:spcPts val="0"/>
+              </a:spcBef>
+              <a:spcAft>
+                <a:spcPts val="0"/>
+              </a:spcAft>
+              <a:buNone/>
+            </a:pPr>
+            <a:r>
+              <a:rPr lang="zh-CN" sz="1400" b="0" i="0" u="none" strike="noStrike" cap="none">
+                <a:solidFill>
+                  <a:srgbClr val="6E6C66"/>
                 </a:solidFill>
                 <a:latin typeface="Instrument Sans"/>
                 <a:ea typeface="Instrument Sans"/>
                 <a:cs typeface="Instrument Sans"/>
                 <a:sym typeface="Instrument Sans"/>
               </a:rPr>
-              <a:t>$2.0B</a:t>
-            </a:r>
-          </a:p>
-        </p:txBody>
-      </p:sp>
-      <p:sp>
-        <p:nvSpPr>
-          <p:cNvPr id="480" name="TextBox 479"/>
+              <a:t>→</a:t>
+            </a:r>
+          </a:p>
+        </p:txBody>
+      </p:sp>
+      <p:sp>
+        <p:nvSpPr>
+          <p:cNvPr id="3005" name="SimReal 3005"/>
+          <p:cNvSpPr/>
+          <p:nvPr/>
+        </p:nvSpPr>
+        <p:spPr>
+          <a:xfrm>
+            <a:off x="548640" y="1481328"/>
+            <a:ext cx="3514344" cy="18288"/>
+          </a:xfrm>
+          <a:prstGeom prst="rect">
+            <a:avLst/>
+          </a:prstGeom>
+          <a:solidFill>
+            <a:srgbClr val="111110"/>
+          </a:solidFill>
+          <a:ln>
+            <a:noFill/>
+          </a:ln>
+        </p:spPr>
+        <p:txBody>
+          <a:bodyPr/>
+          <a:lstStyle/>
+          <a:p>
+            <a:endParaRPr/>
+          </a:p>
+        </p:txBody>
+      </p:sp>
+      <p:sp>
+        <p:nvSpPr>
+          <p:cNvPr id="3006" name="SimReal 3006"/>
           <p:cNvSpPr txBox="1"/>
           <p:nvPr/>
         </p:nvSpPr>
         <p:spPr>
           <a:xfrm>
-            <a:off x="548640" y="2697480"/>
-            <a:ext cx="1508760" cy="237744"/>
-          </a:xfrm>
-          <a:prstGeom prst="rect">
-            <a:avLst/>
-          </a:prstGeom>
-          <a:noFill/>
-        </p:spPr>
-        <p:txBody>
-          <a:bodyPr wrap="square" lIns="0" tIns="0" rIns="0" bIns="0" anchor="ctr">
-            <a:spAutoFit/>
-          </a:bodyPr>
-          <a:lstStyle/>
-          <a:p>
-            <a:pPr algn="l"/>
-            <a:r>
-              <a:rPr sz="1300" b="0">
+            <a:off x="548640" y="1609344"/>
+            <a:ext cx="3514344" cy="201168"/>
+          </a:xfrm>
+          <a:prstGeom prst="rect">
+            <a:avLst/>
+          </a:prstGeom>
+          <a:noFill/>
+          <a:ln>
+            <a:noFill/>
+          </a:ln>
+        </p:spPr>
+        <p:txBody>
+          <a:bodyPr spcFirstLastPara="1" wrap="square" lIns="0" tIns="0" rIns="0" bIns="0" anchor="t" anchorCtr="0">
+            <a:noAutofit/>
+          </a:bodyPr>
+          <a:lstStyle/>
+          <a:p>
+            <a:pPr marL="0" marR="0" lvl="0" indent="0" algn="l" rtl="0">
+              <a:spcBef>
+                <a:spcPts val="0"/>
+              </a:spcBef>
+              <a:spcAft>
+                <a:spcPts val="0"/>
+              </a:spcAft>
+              <a:buNone/>
+            </a:pPr>
+            <a:r>
+              <a:rPr lang="zh-CN" sz="1000" b="0" i="0" u="none" strike="noStrike" cap="none">
+                <a:solidFill>
+                  <a:srgbClr val="6E6C66"/>
+                </a:solidFill>
+                <a:latin typeface="IBM Plex Mono"/>
+                <a:ea typeface="IBM Plex Mono"/>
+                <a:cs typeface="IBM Plex Mono"/>
+                <a:sym typeface="IBM Plex Mono"/>
+              </a:rPr>
+              <a:t>今天 · 实验室已经在付费</a:t>
+            </a:r>
+          </a:p>
+        </p:txBody>
+      </p:sp>
+      <p:sp>
+        <p:nvSpPr>
+          <p:cNvPr id="3007" name="SimReal 3007"/>
+          <p:cNvSpPr txBox="1"/>
+          <p:nvPr/>
+        </p:nvSpPr>
+        <p:spPr>
+          <a:xfrm>
+            <a:off x="548640" y="1865376"/>
+            <a:ext cx="3514344" cy="548640"/>
+          </a:xfrm>
+          <a:prstGeom prst="rect">
+            <a:avLst/>
+          </a:prstGeom>
+          <a:noFill/>
+          <a:ln>
+            <a:noFill/>
+          </a:ln>
+        </p:spPr>
+        <p:txBody>
+          <a:bodyPr spcFirstLastPara="1" wrap="square" lIns="0" tIns="0" rIns="0" bIns="0" anchor="t" anchorCtr="0">
+            <a:noAutofit/>
+          </a:bodyPr>
+          <a:lstStyle/>
+          <a:p>
+            <a:pPr marL="0" marR="0" lvl="0" indent="0" algn="l" rtl="0">
+              <a:spcBef>
+                <a:spcPts val="0"/>
+              </a:spcBef>
+              <a:spcAft>
+                <a:spcPts val="0"/>
+              </a:spcAft>
+              <a:buNone/>
+            </a:pPr>
+            <a:r>
+              <a:rPr lang="zh-CN" sz="2800" b="0" i="0" u="none" strike="noStrike" cap="none">
                 <a:solidFill>
                   <a:srgbClr val="111110"/>
                 </a:solidFill>
@@ -13033,141 +12956,275 @@
                 <a:cs typeface="Newsreader"/>
                 <a:sym typeface="Newsreader"/>
               </a:rPr>
-              <a:t>Surge AI</a:t>
-            </a:r>
-          </a:p>
-        </p:txBody>
-      </p:sp>
-      <p:sp>
-        <p:nvSpPr>
-          <p:cNvPr id="481" name="TextBox 480"/>
+              <a:t>85亿美元/年</a:t>
+            </a:r>
+          </a:p>
+        </p:txBody>
+      </p:sp>
+      <p:sp>
+        <p:nvSpPr>
+          <p:cNvPr id="3008" name="SimReal 3008"/>
           <p:cNvSpPr txBox="1"/>
           <p:nvPr/>
         </p:nvSpPr>
         <p:spPr>
           <a:xfrm>
-            <a:off x="548640" y="2926080"/>
-            <a:ext cx="1508760" cy="164592"/>
-          </a:xfrm>
-          <a:prstGeom prst="rect">
-            <a:avLst/>
-          </a:prstGeom>
-          <a:noFill/>
-        </p:spPr>
-        <p:txBody>
-          <a:bodyPr wrap="square" lIns="0" tIns="0" rIns="0" bIns="0" anchor="ctr">
-            <a:spAutoFit/>
-          </a:bodyPr>
-          <a:lstStyle/>
-          <a:p>
-            <a:pPr algn="l"/>
-            <a:r>
-              <a:rPr sz="750" b="0">
-                <a:solidFill>
-                  <a:srgbClr val="6E6C66"/>
+            <a:off x="548640" y="2468880"/>
+            <a:ext cx="3514344" cy="457200"/>
+          </a:xfrm>
+          <a:prstGeom prst="rect">
+            <a:avLst/>
+          </a:prstGeom>
+          <a:noFill/>
+          <a:ln>
+            <a:noFill/>
+          </a:ln>
+        </p:spPr>
+        <p:txBody>
+          <a:bodyPr spcFirstLastPara="1" wrap="square" lIns="0" tIns="0" rIns="0" bIns="0" anchor="t" anchorCtr="0">
+            <a:noAutofit/>
+          </a:bodyPr>
+          <a:lstStyle/>
+          <a:p>
+            <a:pPr marL="0" marR="0" lvl="0" indent="0" algn="l" rtl="0">
+              <a:lnSpc>
+                <a:spcPct val="110000"/>
+              </a:lnSpc>
+              <a:spcBef>
+                <a:spcPts val="0"/>
+              </a:spcBef>
+              <a:spcAft>
+                <a:spcPts val="0"/>
+              </a:spcAft>
+              <a:buNone/>
+            </a:pPr>
+            <a:r>
+              <a:rPr lang="zh-CN" sz="1100" b="0" i="0" u="none" strike="noStrike" cap="none">
+                <a:solidFill>
+                  <a:srgbClr val="33322F"/>
                 </a:solidFill>
                 <a:latin typeface="Instrument Sans"/>
                 <a:ea typeface="Instrument Sans"/>
                 <a:cs typeface="Instrument Sans"/>
                 <a:sym typeface="Instrument Sans"/>
               </a:rPr>
-              <a:t>2024年收入</a:t>
-            </a:r>
-          </a:p>
-        </p:txBody>
-      </p:sp>
-      <p:sp>
-        <p:nvSpPr>
-          <p:cNvPr id="482" name="Rectangle 481"/>
-          <p:cNvSpPr/>
-          <p:nvPr/>
-        </p:nvSpPr>
-        <p:spPr>
-          <a:xfrm>
-            <a:off x="2148840" y="2734056"/>
-            <a:ext cx="1755648" cy="274320"/>
-          </a:xfrm>
-          <a:prstGeom prst="rect">
-            <a:avLst/>
-          </a:prstGeom>
-          <a:solidFill>
-            <a:srgbClr val="D9D6CE"/>
-          </a:solidFill>
-          <a:ln>
-            <a:noFill/>
-          </a:ln>
-        </p:spPr>
-        <p:txBody>
-          <a:bodyPr rtlCol="0" anchor="ctr"/>
-          <a:lstStyle/>
-          <a:p>
-            <a:endParaRPr/>
-          </a:p>
-        </p:txBody>
-      </p:sp>
-      <p:sp>
-        <p:nvSpPr>
-          <p:cNvPr id="483" name="TextBox 482"/>
+              <a:t>50余家公司向AI实验室出售训练数据和RL环境的年收入合计</a:t>
+            </a:r>
+          </a:p>
+        </p:txBody>
+      </p:sp>
+      <p:sp>
+        <p:nvSpPr>
+          <p:cNvPr id="3009" name="SimReal 3009"/>
           <p:cNvSpPr txBox="1"/>
           <p:nvPr/>
         </p:nvSpPr>
         <p:spPr>
           <a:xfrm>
-            <a:off x="3977639" y="2734056"/>
-            <a:ext cx="914400" cy="274320"/>
-          </a:xfrm>
-          <a:prstGeom prst="rect">
-            <a:avLst/>
-          </a:prstGeom>
-          <a:noFill/>
-        </p:spPr>
-        <p:txBody>
-          <a:bodyPr wrap="square" lIns="0" tIns="0" rIns="0" bIns="0" anchor="ctr">
-            <a:spAutoFit/>
-          </a:bodyPr>
-          <a:lstStyle/>
-          <a:p>
-            <a:pPr algn="l"/>
-            <a:r>
-              <a:rPr sz="1150" b="0">
+            <a:off x="548640" y="3163824"/>
+            <a:ext cx="1097280" cy="237744"/>
+          </a:xfrm>
+          <a:prstGeom prst="rect">
+            <a:avLst/>
+          </a:prstGeom>
+          <a:noFill/>
+          <a:ln>
+            <a:noFill/>
+          </a:ln>
+        </p:spPr>
+        <p:txBody>
+          <a:bodyPr spcFirstLastPara="1" wrap="square" lIns="0" tIns="0" rIns="0" bIns="0" anchor="t" anchorCtr="0">
+            <a:noAutofit/>
+          </a:bodyPr>
+          <a:lstStyle/>
+          <a:p>
+            <a:pPr marL="0" marR="0" lvl="0" indent="0" algn="l" rtl="0">
+              <a:spcBef>
+                <a:spcPts val="0"/>
+              </a:spcBef>
+              <a:spcAft>
+                <a:spcPts val="0"/>
+              </a:spcAft>
+              <a:buNone/>
+            </a:pPr>
+            <a:r>
+              <a:rPr lang="zh-CN" sz="1200" b="0" i="0" u="none" strike="noStrike" cap="none">
                 <a:solidFill>
                   <a:srgbClr val="111110"/>
+                </a:solidFill>
+                <a:latin typeface="Newsreader"/>
+                <a:ea typeface="Newsreader"/>
+                <a:cs typeface="Newsreader"/>
+                <a:sym typeface="Newsreader"/>
+              </a:rPr>
+              <a:t>Mercor</a:t>
+            </a:r>
+          </a:p>
+        </p:txBody>
+      </p:sp>
+      <p:sp>
+        <p:nvSpPr>
+          <p:cNvPr id="3010" name="SimReal 3010"/>
+          <p:cNvSpPr txBox="1"/>
+          <p:nvPr/>
+        </p:nvSpPr>
+        <p:spPr>
+          <a:xfrm>
+            <a:off x="548640" y="3392424"/>
+            <a:ext cx="1097280" cy="182880"/>
+          </a:xfrm>
+          <a:prstGeom prst="rect">
+            <a:avLst/>
+          </a:prstGeom>
+          <a:noFill/>
+          <a:ln>
+            <a:noFill/>
+          </a:ln>
+        </p:spPr>
+        <p:txBody>
+          <a:bodyPr spcFirstLastPara="1" wrap="square" lIns="0" tIns="0" rIns="0" bIns="0" anchor="t" anchorCtr="0">
+            <a:noAutofit/>
+          </a:bodyPr>
+          <a:lstStyle/>
+          <a:p>
+            <a:pPr marL="0" marR="0" lvl="0" indent="0" algn="l" rtl="0">
+              <a:spcBef>
+                <a:spcPts val="0"/>
+              </a:spcBef>
+              <a:spcAft>
+                <a:spcPts val="0"/>
+              </a:spcAft>
+              <a:buNone/>
+            </a:pPr>
+            <a:r>
+              <a:rPr lang="zh-CN" sz="750" b="0" i="0" u="none" strike="noStrike" cap="none">
+                <a:solidFill>
+                  <a:srgbClr val="6E6C66"/>
                 </a:solidFill>
                 <a:latin typeface="Instrument Sans"/>
                 <a:ea typeface="Instrument Sans"/>
                 <a:cs typeface="Instrument Sans"/>
                 <a:sym typeface="Instrument Sans"/>
               </a:rPr>
-              <a:t>$1.2B</a:t>
-            </a:r>
-          </a:p>
-        </p:txBody>
-      </p:sp>
-      <p:sp>
-        <p:nvSpPr>
-          <p:cNvPr id="484" name="TextBox 483"/>
+              <a:t>年化毛营收，2026年7月</a:t>
+            </a:r>
+          </a:p>
+        </p:txBody>
+      </p:sp>
+      <p:sp>
+        <p:nvSpPr>
+          <p:cNvPr id="3011" name="SimReal 3011"/>
+          <p:cNvSpPr/>
+          <p:nvPr/>
+        </p:nvSpPr>
+        <p:spPr>
+          <a:xfrm>
+            <a:off x="1645920" y="3218688"/>
+            <a:ext cx="1691640" cy="256032"/>
+          </a:xfrm>
+          <a:prstGeom prst="rect">
+            <a:avLst/>
+          </a:prstGeom>
+          <a:solidFill>
+            <a:srgbClr val="111110"/>
+          </a:solidFill>
+          <a:ln>
+            <a:noFill/>
+          </a:ln>
+        </p:spPr>
+        <p:txBody>
+          <a:bodyPr/>
+          <a:lstStyle/>
+          <a:p>
+            <a:endParaRPr/>
+          </a:p>
+        </p:txBody>
+      </p:sp>
+      <p:sp>
+        <p:nvSpPr>
+          <p:cNvPr id="3012" name="SimReal 3012"/>
           <p:cNvSpPr txBox="1"/>
           <p:nvPr/>
         </p:nvSpPr>
         <p:spPr>
           <a:xfrm>
-            <a:off x="548640" y="3154680"/>
-            <a:ext cx="1508760" cy="237744"/>
-          </a:xfrm>
-          <a:prstGeom prst="rect">
-            <a:avLst/>
-          </a:prstGeom>
-          <a:noFill/>
-        </p:spPr>
-        <p:txBody>
-          <a:bodyPr wrap="square" lIns="0" tIns="0" rIns="0" bIns="0" anchor="ctr">
-            <a:spAutoFit/>
-          </a:bodyPr>
-          <a:lstStyle/>
-          <a:p>
-            <a:pPr algn="l"/>
-            <a:r>
-              <a:rPr sz="1300" b="0">
+            <a:off x="3410712" y="3218688"/>
+            <a:ext cx="822960" cy="256032"/>
+          </a:xfrm>
+          <a:prstGeom prst="rect">
+            <a:avLst/>
+          </a:prstGeom>
+          <a:noFill/>
+          <a:ln>
+            <a:noFill/>
+          </a:ln>
+        </p:spPr>
+        <p:txBody>
+          <a:bodyPr spcFirstLastPara="1" wrap="square" lIns="0" tIns="0" rIns="0" bIns="0" anchor="ctr" anchorCtr="0">
+            <a:noAutofit/>
+          </a:bodyPr>
+          <a:lstStyle/>
+          <a:p>
+            <a:pPr marL="0" marR="0" lvl="0" indent="0" algn="l" rtl="0">
+              <a:spcBef>
+                <a:spcPts val="0"/>
+              </a:spcBef>
+              <a:spcAft>
+                <a:spcPts val="0"/>
+              </a:spcAft>
+              <a:buNone/>
+            </a:pPr>
+            <a:r>
+              <a:rPr lang="zh-CN" sz="1100" b="0" i="0" u="none" strike="noStrike" cap="none">
+                <a:solidFill>
+                  <a:srgbClr val="111110"/>
+                </a:solidFill>
+                <a:latin typeface="Instrument Sans"/>
+                <a:ea typeface="Instrument Sans"/>
+                <a:cs typeface="Instrument Sans"/>
+                <a:sym typeface="Instrument Sans"/>
+              </a:rPr>
+              <a:t>$2.0B</a:t>
+            </a:r>
+          </a:p>
+        </p:txBody>
+      </p:sp>
+      <p:sp>
+        <p:nvSpPr>
+          <p:cNvPr id="3013" name="SimReal 3013"/>
+          <p:cNvSpPr txBox="1"/>
+          <p:nvPr/>
+        </p:nvSpPr>
+        <p:spPr>
+          <a:xfrm>
+            <a:off x="548640" y="3675888"/>
+            <a:ext cx="1097280" cy="237744"/>
+          </a:xfrm>
+          <a:prstGeom prst="rect">
+            <a:avLst/>
+          </a:prstGeom>
+          <a:noFill/>
+          <a:ln>
+            <a:noFill/>
+          </a:ln>
+        </p:spPr>
+        <p:txBody>
+          <a:bodyPr spcFirstLastPara="1" wrap="square" lIns="0" tIns="0" rIns="0" bIns="0" anchor="t" anchorCtr="0">
+            <a:noAutofit/>
+          </a:bodyPr>
+          <a:lstStyle/>
+          <a:p>
+            <a:pPr marL="0" marR="0" lvl="0" indent="0" algn="l" rtl="0">
+              <a:spcBef>
+                <a:spcPts val="0"/>
+              </a:spcBef>
+              <a:spcAft>
+                <a:spcPts val="0"/>
+              </a:spcAft>
+              <a:buNone/>
+            </a:pPr>
+            <a:r>
+              <a:rPr lang="zh-CN" sz="1200" b="0" i="0" u="none" strike="noStrike" cap="none">
                 <a:solidFill>
                   <a:srgbClr val="111110"/>
                 </a:solidFill>
@@ -13176,36 +13233,47 @@
                 <a:cs typeface="Newsreader"/>
                 <a:sym typeface="Newsreader"/>
               </a:rPr>
-              <a:t>Snorkel AI</a:t>
-            </a:r>
-          </a:p>
-        </p:txBody>
-      </p:sp>
-      <p:sp>
-        <p:nvSpPr>
-          <p:cNvPr id="485" name="TextBox 484"/>
+              <a:t>Surge AI</a:t>
+            </a:r>
+          </a:p>
+        </p:txBody>
+      </p:sp>
+      <p:sp>
+        <p:nvSpPr>
+          <p:cNvPr id="3014" name="SimReal 3014"/>
           <p:cNvSpPr txBox="1"/>
           <p:nvPr/>
         </p:nvSpPr>
         <p:spPr>
           <a:xfrm>
-            <a:off x="548640" y="3383280"/>
-            <a:ext cx="1508760" cy="164592"/>
-          </a:xfrm>
-          <a:prstGeom prst="rect">
-            <a:avLst/>
-          </a:prstGeom>
-          <a:noFill/>
-        </p:spPr>
-        <p:txBody>
-          <a:bodyPr wrap="square" lIns="0" tIns="0" rIns="0" bIns="0" anchor="ctr">
-            <a:spAutoFit/>
-          </a:bodyPr>
-          <a:lstStyle/>
-          <a:p>
-            <a:pPr algn="l"/>
-            <a:r>
-              <a:rPr sz="750" b="0">
+            <a:off x="548640" y="3904488"/>
+            <a:ext cx="1097280" cy="182880"/>
+          </a:xfrm>
+          <a:prstGeom prst="rect">
+            <a:avLst/>
+          </a:prstGeom>
+          <a:noFill/>
+          <a:ln>
+            <a:noFill/>
+          </a:ln>
+        </p:spPr>
+        <p:txBody>
+          <a:bodyPr spcFirstLastPara="1" wrap="square" lIns="0" tIns="0" rIns="0" bIns="0" anchor="t" anchorCtr="0">
+            <a:noAutofit/>
+          </a:bodyPr>
+          <a:lstStyle/>
+          <a:p>
+            <a:pPr marL="0" marR="0" lvl="0" indent="0" algn="l" rtl="0">
+              <a:spcBef>
+                <a:spcPts val="0"/>
+              </a:spcBef>
+              <a:spcAft>
+                <a:spcPts val="0"/>
+              </a:spcAft>
+              <a:buNone/>
+            </a:pPr>
+            <a:r>
+              <a:rPr lang="zh-CN" sz="750" b="0" i="0" u="none" strike="noStrike" cap="none">
                 <a:solidFill>
                   <a:srgbClr val="6E6C66"/>
                 </a:solidFill>
@@ -13214,34 +13282,34 @@
                 <a:cs typeface="Instrument Sans"/>
                 <a:sym typeface="Instrument Sans"/>
               </a:rPr>
-              <a:t>年化收入，2026年9月</a:t>
-            </a:r>
-          </a:p>
-        </p:txBody>
-      </p:sp>
-      <p:sp>
-        <p:nvSpPr>
-          <p:cNvPr id="486" name="Rectangle 485"/>
+              <a:t>2024年收入</a:t>
+            </a:r>
+          </a:p>
+        </p:txBody>
+      </p:sp>
+      <p:sp>
+        <p:nvSpPr>
+          <p:cNvPr id="3015" name="SimReal 3015"/>
           <p:cNvSpPr/>
           <p:nvPr/>
         </p:nvSpPr>
         <p:spPr>
           <a:xfrm>
-            <a:off x="2148840" y="3191256"/>
-            <a:ext cx="548640" cy="274320"/>
+            <a:off x="1645920" y="3730752"/>
+            <a:ext cx="1014984" cy="256032"/>
           </a:xfrm>
           <a:prstGeom prst="rect">
             <a:avLst/>
           </a:prstGeom>
           <a:solidFill>
-            <a:srgbClr val="D9D6CE"/>
+            <a:srgbClr val="C4C0B7"/>
           </a:solidFill>
           <a:ln>
             <a:noFill/>
           </a:ln>
         </p:spPr>
         <p:txBody>
-          <a:bodyPr rtlCol="0" anchor="ctr"/>
+          <a:bodyPr/>
           <a:lstStyle/>
           <a:p>
             <a:endParaRPr/>
@@ -13250,29 +13318,40 @@
       </p:sp>
       <p:sp>
         <p:nvSpPr>
-          <p:cNvPr id="487" name="TextBox 486"/>
+          <p:cNvPr id="3016" name="SimReal 3016"/>
           <p:cNvSpPr txBox="1"/>
           <p:nvPr/>
         </p:nvSpPr>
         <p:spPr>
           <a:xfrm>
-            <a:off x="2770632" y="3191256"/>
-            <a:ext cx="914400" cy="274320"/>
-          </a:xfrm>
-          <a:prstGeom prst="rect">
-            <a:avLst/>
-          </a:prstGeom>
-          <a:noFill/>
-        </p:spPr>
-        <p:txBody>
-          <a:bodyPr wrap="square" lIns="0" tIns="0" rIns="0" bIns="0" anchor="ctr">
-            <a:spAutoFit/>
-          </a:bodyPr>
-          <a:lstStyle/>
-          <a:p>
-            <a:pPr algn="l"/>
-            <a:r>
-              <a:rPr sz="1150" b="0">
+            <a:off x="2734056" y="3730752"/>
+            <a:ext cx="822960" cy="256032"/>
+          </a:xfrm>
+          <a:prstGeom prst="rect">
+            <a:avLst/>
+          </a:prstGeom>
+          <a:noFill/>
+          <a:ln>
+            <a:noFill/>
+          </a:ln>
+        </p:spPr>
+        <p:txBody>
+          <a:bodyPr spcFirstLastPara="1" wrap="square" lIns="0" tIns="0" rIns="0" bIns="0" anchor="ctr" anchorCtr="0">
+            <a:noAutofit/>
+          </a:bodyPr>
+          <a:lstStyle/>
+          <a:p>
+            <a:pPr marL="0" marR="0" lvl="0" indent="0" algn="l" rtl="0">
+              <a:spcBef>
+                <a:spcPts val="0"/>
+              </a:spcBef>
+              <a:spcAft>
+                <a:spcPts val="0"/>
+              </a:spcAft>
+              <a:buNone/>
+            </a:pPr>
+            <a:r>
+              <a:rPr lang="zh-CN" sz="1100" b="0" i="0" u="none" strike="noStrike" cap="none">
                 <a:solidFill>
                   <a:srgbClr val="111110"/>
                 </a:solidFill>
@@ -13281,36 +13360,47 @@
                 <a:cs typeface="Instrument Sans"/>
                 <a:sym typeface="Instrument Sans"/>
               </a:rPr>
-              <a:t>$0.375B</a:t>
-            </a:r>
-          </a:p>
-        </p:txBody>
-      </p:sp>
-      <p:sp>
-        <p:nvSpPr>
-          <p:cNvPr id="488" name="TextBox 487"/>
+              <a:t>$1.2B</a:t>
+            </a:r>
+          </a:p>
+        </p:txBody>
+      </p:sp>
+      <p:sp>
+        <p:nvSpPr>
+          <p:cNvPr id="3017" name="SimReal 3017"/>
           <p:cNvSpPr txBox="1"/>
           <p:nvPr/>
         </p:nvSpPr>
         <p:spPr>
           <a:xfrm>
-            <a:off x="548640" y="3611880"/>
-            <a:ext cx="1508760" cy="237744"/>
-          </a:xfrm>
-          <a:prstGeom prst="rect">
-            <a:avLst/>
-          </a:prstGeom>
-          <a:noFill/>
-        </p:spPr>
-        <p:txBody>
-          <a:bodyPr wrap="square" lIns="0" tIns="0" rIns="0" bIns="0" anchor="ctr">
-            <a:spAutoFit/>
-          </a:bodyPr>
-          <a:lstStyle/>
-          <a:p>
-            <a:pPr algn="l"/>
-            <a:r>
-              <a:rPr sz="1300" b="0">
+            <a:off x="548640" y="4187952"/>
+            <a:ext cx="1097280" cy="237744"/>
+          </a:xfrm>
+          <a:prstGeom prst="rect">
+            <a:avLst/>
+          </a:prstGeom>
+          <a:noFill/>
+          <a:ln>
+            <a:noFill/>
+          </a:ln>
+        </p:spPr>
+        <p:txBody>
+          <a:bodyPr spcFirstLastPara="1" wrap="square" lIns="0" tIns="0" rIns="0" bIns="0" anchor="t" anchorCtr="0">
+            <a:noAutofit/>
+          </a:bodyPr>
+          <a:lstStyle/>
+          <a:p>
+            <a:pPr marL="0" marR="0" lvl="0" indent="0" algn="l" rtl="0">
+              <a:spcBef>
+                <a:spcPts val="0"/>
+              </a:spcBef>
+              <a:spcAft>
+                <a:spcPts val="0"/>
+              </a:spcAft>
+              <a:buNone/>
+            </a:pPr>
+            <a:r>
+              <a:rPr lang="zh-CN" sz="1200" b="0" i="0" u="none" strike="noStrike" cap="none">
                 <a:solidFill>
                   <a:srgbClr val="111110"/>
                 </a:solidFill>
@@ -13319,36 +13409,47 @@
                 <a:cs typeface="Newsreader"/>
                 <a:sym typeface="Newsreader"/>
               </a:rPr>
-              <a:t>AfterQuery</a:t>
-            </a:r>
-          </a:p>
-        </p:txBody>
-      </p:sp>
-      <p:sp>
-        <p:nvSpPr>
-          <p:cNvPr id="489" name="TextBox 488"/>
+              <a:t>Snorkel AI</a:t>
+            </a:r>
+          </a:p>
+        </p:txBody>
+      </p:sp>
+      <p:sp>
+        <p:nvSpPr>
+          <p:cNvPr id="3018" name="SimReal 3018"/>
           <p:cNvSpPr txBox="1"/>
           <p:nvPr/>
         </p:nvSpPr>
         <p:spPr>
           <a:xfrm>
-            <a:off x="548640" y="3840480"/>
-            <a:ext cx="1508760" cy="164592"/>
-          </a:xfrm>
-          <a:prstGeom prst="rect">
-            <a:avLst/>
-          </a:prstGeom>
-          <a:noFill/>
-        </p:spPr>
-        <p:txBody>
-          <a:bodyPr wrap="square" lIns="0" tIns="0" rIns="0" bIns="0" anchor="ctr">
-            <a:spAutoFit/>
-          </a:bodyPr>
-          <a:lstStyle/>
-          <a:p>
-            <a:pPr algn="l"/>
-            <a:r>
-              <a:rPr sz="750" b="0">
+            <a:off x="548640" y="4416552"/>
+            <a:ext cx="1097280" cy="182880"/>
+          </a:xfrm>
+          <a:prstGeom prst="rect">
+            <a:avLst/>
+          </a:prstGeom>
+          <a:noFill/>
+          <a:ln>
+            <a:noFill/>
+          </a:ln>
+        </p:spPr>
+        <p:txBody>
+          <a:bodyPr spcFirstLastPara="1" wrap="square" lIns="0" tIns="0" rIns="0" bIns="0" anchor="t" anchorCtr="0">
+            <a:noAutofit/>
+          </a:bodyPr>
+          <a:lstStyle/>
+          <a:p>
+            <a:pPr marL="0" marR="0" lvl="0" indent="0" algn="l" rtl="0">
+              <a:spcBef>
+                <a:spcPts val="0"/>
+              </a:spcBef>
+              <a:spcAft>
+                <a:spcPts val="0"/>
+              </a:spcAft>
+              <a:buNone/>
+            </a:pPr>
+            <a:r>
+              <a:rPr lang="zh-CN" sz="750" b="0" i="0" u="none" strike="noStrike" cap="none">
                 <a:solidFill>
                   <a:srgbClr val="6E6C66"/>
                 </a:solidFill>
@@ -13357,34 +13458,34 @@
                 <a:cs typeface="Instrument Sans"/>
                 <a:sym typeface="Instrument Sans"/>
               </a:rPr>
-              <a:t>年化收入，2026年4月</a:t>
-            </a:r>
-          </a:p>
-        </p:txBody>
-      </p:sp>
-      <p:sp>
-        <p:nvSpPr>
-          <p:cNvPr id="490" name="Rectangle 489"/>
+              <a:t>年化收入，2026年9月</a:t>
+            </a:r>
+          </a:p>
+        </p:txBody>
+      </p:sp>
+      <p:sp>
+        <p:nvSpPr>
+          <p:cNvPr id="3019" name="SimReal 3019"/>
           <p:cNvSpPr/>
           <p:nvPr/>
         </p:nvSpPr>
         <p:spPr>
           <a:xfrm>
-            <a:off x="2148840" y="3648456"/>
-            <a:ext cx="146304" cy="274320"/>
+            <a:off x="1645920" y="4242816"/>
+            <a:ext cx="317183" cy="256032"/>
           </a:xfrm>
           <a:prstGeom prst="rect">
             <a:avLst/>
           </a:prstGeom>
           <a:solidFill>
-            <a:srgbClr val="D9D6CE"/>
+            <a:srgbClr val="C4C0B7"/>
           </a:solidFill>
           <a:ln>
             <a:noFill/>
           </a:ln>
         </p:spPr>
         <p:txBody>
-          <a:bodyPr rtlCol="0" anchor="ctr"/>
+          <a:bodyPr/>
           <a:lstStyle/>
           <a:p>
             <a:endParaRPr/>
@@ -13393,29 +13494,40 @@
       </p:sp>
       <p:sp>
         <p:nvSpPr>
-          <p:cNvPr id="491" name="TextBox 490"/>
+          <p:cNvPr id="3020" name="SimReal 3020"/>
           <p:cNvSpPr txBox="1"/>
           <p:nvPr/>
         </p:nvSpPr>
         <p:spPr>
           <a:xfrm>
-            <a:off x="2368296" y="3648456"/>
-            <a:ext cx="914400" cy="274320"/>
-          </a:xfrm>
-          <a:prstGeom prst="rect">
-            <a:avLst/>
-          </a:prstGeom>
-          <a:noFill/>
-        </p:spPr>
-        <p:txBody>
-          <a:bodyPr wrap="square" lIns="0" tIns="0" rIns="0" bIns="0" anchor="ctr">
-            <a:spAutoFit/>
-          </a:bodyPr>
-          <a:lstStyle/>
-          <a:p>
-            <a:pPr algn="l"/>
-            <a:r>
-              <a:rPr sz="1150" b="0">
+            <a:off x="2036254" y="4242816"/>
+            <a:ext cx="822960" cy="256032"/>
+          </a:xfrm>
+          <a:prstGeom prst="rect">
+            <a:avLst/>
+          </a:prstGeom>
+          <a:noFill/>
+          <a:ln>
+            <a:noFill/>
+          </a:ln>
+        </p:spPr>
+        <p:txBody>
+          <a:bodyPr spcFirstLastPara="1" wrap="square" lIns="0" tIns="0" rIns="0" bIns="0" anchor="ctr" anchorCtr="0">
+            <a:noAutofit/>
+          </a:bodyPr>
+          <a:lstStyle/>
+          <a:p>
+            <a:pPr marL="0" marR="0" lvl="0" indent="0" algn="l" rtl="0">
+              <a:spcBef>
+                <a:spcPts val="0"/>
+              </a:spcBef>
+              <a:spcAft>
+                <a:spcPts val="0"/>
+              </a:spcAft>
+              <a:buNone/>
+            </a:pPr>
+            <a:r>
+              <a:rPr lang="zh-CN" sz="1100" b="0" i="0" u="none" strike="noStrike" cap="none">
                 <a:solidFill>
                   <a:srgbClr val="111110"/>
                 </a:solidFill>
@@ -13424,40 +13536,203 @@
                 <a:cs typeface="Instrument Sans"/>
                 <a:sym typeface="Instrument Sans"/>
               </a:rPr>
-              <a:t>$0.1B+</a:t>
-            </a:r>
-          </a:p>
-        </p:txBody>
-      </p:sp>
-      <p:sp>
-        <p:nvSpPr>
-          <p:cNvPr id="492" name="TextBox 491"/>
+              <a:t>$0.375B</a:t>
+            </a:r>
+          </a:p>
+        </p:txBody>
+      </p:sp>
+      <p:sp>
+        <p:nvSpPr>
+          <p:cNvPr id="3021" name="SimReal 3021"/>
+          <p:cNvSpPr/>
+          <p:nvPr/>
+        </p:nvSpPr>
+        <p:spPr>
+          <a:xfrm>
+            <a:off x="4337304" y="1481328"/>
+            <a:ext cx="3514344" cy="27432"/>
+          </a:xfrm>
+          <a:prstGeom prst="rect">
+            <a:avLst/>
+          </a:prstGeom>
+          <a:solidFill>
+            <a:srgbClr val="C2410C"/>
+          </a:solidFill>
+          <a:ln>
+            <a:noFill/>
+          </a:ln>
+        </p:spPr>
+        <p:txBody>
+          <a:bodyPr/>
+          <a:lstStyle/>
+          <a:p>
+            <a:endParaRPr/>
+          </a:p>
+        </p:txBody>
+      </p:sp>
+      <p:sp>
+        <p:nvSpPr>
+          <p:cNvPr id="3022" name="SimReal 3022"/>
           <p:cNvSpPr txBox="1"/>
           <p:nvPr/>
         </p:nvSpPr>
         <p:spPr>
           <a:xfrm>
-            <a:off x="548640" y="4114800"/>
-            <a:ext cx="5440680" cy="384048"/>
-          </a:xfrm>
-          <a:prstGeom prst="rect">
-            <a:avLst/>
-          </a:prstGeom>
-          <a:noFill/>
-        </p:spPr>
-        <p:txBody>
-          <a:bodyPr wrap="square" lIns="0" tIns="0" rIns="0" bIns="0" anchor="t">
-            <a:spAutoFit/>
-          </a:bodyPr>
-          <a:lstStyle/>
-          <a:p>
-            <a:pPr algn="l">
-              <a:lnSpc>
-                <a:spcPct val="110000"/>
-              </a:lnSpc>
-            </a:pPr>
-            <a:r>
-              <a:rPr sz="1000" b="0">
+            <a:off x="4337304" y="1609344"/>
+            <a:ext cx="3514344" cy="201168"/>
+          </a:xfrm>
+          <a:prstGeom prst="rect">
+            <a:avLst/>
+          </a:prstGeom>
+          <a:noFill/>
+          <a:ln>
+            <a:noFill/>
+          </a:ln>
+        </p:spPr>
+        <p:txBody>
+          <a:bodyPr spcFirstLastPara="1" wrap="square" lIns="0" tIns="0" rIns="0" bIns="0" anchor="t" anchorCtr="0">
+            <a:noAutofit/>
+          </a:bodyPr>
+          <a:lstStyle/>
+          <a:p>
+            <a:pPr marL="0" marR="0" lvl="0" indent="0" algn="l" rtl="0">
+              <a:spcBef>
+                <a:spcPts val="0"/>
+              </a:spcBef>
+              <a:spcAft>
+                <a:spcPts val="0"/>
+              </a:spcAft>
+              <a:buNone/>
+            </a:pPr>
+            <a:r>
+              <a:rPr lang="zh-CN" sz="1000" b="0" i="0" u="none" strike="noStrike" cap="none">
+                <a:solidFill>
+                  <a:srgbClr val="C2410C"/>
+                </a:solidFill>
+                <a:latin typeface="IBM Plex Mono"/>
+                <a:ea typeface="IBM Plex Mono"/>
+                <a:cs typeface="IBM Plex Mono"/>
+                <a:sym typeface="IBM Plex Mono"/>
+              </a:rPr>
+              <a:t>2030年 · 训练层：我们的市场</a:t>
+            </a:r>
+          </a:p>
+        </p:txBody>
+      </p:sp>
+      <p:sp>
+        <p:nvSpPr>
+          <p:cNvPr id="3023" name="SimReal 3023"/>
+          <p:cNvSpPr txBox="1"/>
+          <p:nvPr/>
+        </p:nvSpPr>
+        <p:spPr>
+          <a:xfrm>
+            <a:off x="4337304" y="1865376"/>
+            <a:ext cx="3514344" cy="548640"/>
+          </a:xfrm>
+          <a:prstGeom prst="rect">
+            <a:avLst/>
+          </a:prstGeom>
+          <a:noFill/>
+          <a:ln>
+            <a:noFill/>
+          </a:ln>
+        </p:spPr>
+        <p:txBody>
+          <a:bodyPr spcFirstLastPara="1" wrap="square" lIns="0" tIns="0" rIns="0" bIns="0" anchor="ctr" anchorCtr="0">
+            <a:noAutofit/>
+          </a:bodyPr>
+          <a:lstStyle/>
+          <a:p>
+            <a:pPr marL="0" marR="0" lvl="0" indent="0" algn="l" rtl="0">
+              <a:spcBef>
+                <a:spcPts val="0"/>
+              </a:spcBef>
+              <a:spcAft>
+                <a:spcPts val="0"/>
+              </a:spcAft>
+              <a:buNone/>
+            </a:pPr>
+            <a:r>
+              <a:rPr lang="zh-CN" sz="2400" b="0" i="0" u="none" strike="noStrike" cap="none">
+                <a:solidFill>
+                  <a:srgbClr val="C2410C"/>
+                </a:solidFill>
+                <a:latin typeface="Newsreader"/>
+                <a:ea typeface="Newsreader"/>
+                <a:cs typeface="Newsreader"/>
+                <a:sym typeface="Newsreader"/>
+              </a:rPr>
+              <a:t>1,500–4,000亿美元/年</a:t>
+            </a:r>
+          </a:p>
+        </p:txBody>
+      </p:sp>
+      <p:sp>
+        <p:nvSpPr>
+          <p:cNvPr id="3024" name="SimReal 3024"/>
+          <p:cNvSpPr/>
+          <p:nvPr/>
+        </p:nvSpPr>
+        <p:spPr>
+          <a:xfrm>
+            <a:off x="4337304" y="2505456"/>
+            <a:ext cx="3514344" cy="932688"/>
+          </a:xfrm>
+          <a:prstGeom prst="rect">
+            <a:avLst/>
+          </a:prstGeom>
+          <a:solidFill>
+            <a:srgbClr val="F2F1EC"/>
+          </a:solidFill>
+          <a:ln>
+            <a:noFill/>
+          </a:ln>
+        </p:spPr>
+        <p:txBody>
+          <a:bodyPr/>
+          <a:lstStyle/>
+          <a:p>
+            <a:endParaRPr/>
+          </a:p>
+        </p:txBody>
+      </p:sp>
+      <p:sp>
+        <p:nvSpPr>
+          <p:cNvPr id="3025" name="SimReal 3025"/>
+          <p:cNvSpPr txBox="1"/>
+          <p:nvPr/>
+        </p:nvSpPr>
+        <p:spPr>
+          <a:xfrm>
+            <a:off x="4520184" y="2578608"/>
+            <a:ext cx="1776984" cy="310896"/>
+          </a:xfrm>
+          <a:prstGeom prst="rect">
+            <a:avLst/>
+          </a:prstGeom>
+          <a:noFill/>
+          <a:ln>
+            <a:noFill/>
+          </a:ln>
+        </p:spPr>
+        <p:txBody>
+          <a:bodyPr spcFirstLastPara="1" wrap="square" lIns="0" tIns="0" rIns="0" bIns="0" anchor="ctr" anchorCtr="0">
+            <a:noAutofit/>
+          </a:bodyPr>
+          <a:lstStyle/>
+          <a:p>
+            <a:pPr marL="0" marR="0" lvl="0" indent="0" algn="l" rtl="0">
+              <a:spcBef>
+                <a:spcPts val="0"/>
+              </a:spcBef>
+              <a:spcAft>
+                <a:spcPts val="0"/>
+              </a:spcAft>
+              <a:buNone/>
+            </a:pPr>
+            <a:r>
+              <a:rPr lang="zh-CN" sz="1100" b="0" i="0" u="none" strike="noStrike" cap="none">
                 <a:solidFill>
                   <a:srgbClr val="33322F"/>
                 </a:solidFill>
@@ -13466,103 +13741,145 @@
                 <a:cs typeface="Instrument Sans"/>
                 <a:sym typeface="Instrument Sans"/>
               </a:rPr>
-              <a:t>Mercor、AfterQuery、Snorkel、UniPat各做闭环中的一环，估值都已达数十亿美元。</a:t>
-            </a:r>
-          </a:p>
-        </p:txBody>
-      </p:sp>
-      <p:sp>
-        <p:nvSpPr>
-          <p:cNvPr id="493" name="Rectangle 492"/>
-          <p:cNvSpPr/>
-          <p:nvPr/>
-        </p:nvSpPr>
-        <p:spPr>
-          <a:xfrm>
-            <a:off x="6355080" y="1471803"/>
-            <a:ext cx="5285232" cy="19050"/>
-          </a:xfrm>
-          <a:prstGeom prst="rect">
-            <a:avLst/>
-          </a:prstGeom>
-          <a:solidFill>
-            <a:srgbClr val="111110"/>
-          </a:solidFill>
-          <a:ln>
-            <a:noFill/>
-          </a:ln>
-        </p:spPr>
-        <p:txBody>
-          <a:bodyPr rtlCol="0" anchor="ctr"/>
-          <a:lstStyle/>
-          <a:p>
-            <a:endParaRPr/>
-          </a:p>
-        </p:txBody>
-      </p:sp>
-      <p:sp>
-        <p:nvSpPr>
-          <p:cNvPr id="494" name="TextBox 493"/>
+              <a:t>全球AI基础设施支出</a:t>
+            </a:r>
+          </a:p>
+        </p:txBody>
+      </p:sp>
+      <p:sp>
+        <p:nvSpPr>
+          <p:cNvPr id="3026" name="SimReal 3026"/>
           <p:cNvSpPr txBox="1"/>
           <p:nvPr/>
         </p:nvSpPr>
         <p:spPr>
           <a:xfrm>
-            <a:off x="6355080" y="1554480"/>
-            <a:ext cx="5285232" cy="256032"/>
-          </a:xfrm>
-          <a:prstGeom prst="rect">
-            <a:avLst/>
-          </a:prstGeom>
-          <a:noFill/>
-        </p:spPr>
-        <p:txBody>
-          <a:bodyPr wrap="square" lIns="0" tIns="0" rIns="0" bIns="0" anchor="ctr">
-            <a:spAutoFit/>
-          </a:bodyPr>
-          <a:lstStyle/>
-          <a:p>
-            <a:pPr algn="l"/>
-            <a:r>
-              <a:rPr sz="1100" b="0">
-                <a:solidFill>
-                  <a:srgbClr val="6E6C66"/>
+            <a:off x="6251448" y="2578608"/>
+            <a:ext cx="1417320" cy="310896"/>
+          </a:xfrm>
+          <a:prstGeom prst="rect">
+            <a:avLst/>
+          </a:prstGeom>
+          <a:noFill/>
+          <a:ln>
+            <a:noFill/>
+          </a:ln>
+        </p:spPr>
+        <p:txBody>
+          <a:bodyPr spcFirstLastPara="1" wrap="square" lIns="0" tIns="0" rIns="0" bIns="0" anchor="ctr" anchorCtr="0">
+            <a:noAutofit/>
+          </a:bodyPr>
+          <a:lstStyle/>
+          <a:p>
+            <a:pPr marL="0" marR="0" lvl="0" indent="0" algn="r" rtl="0">
+              <a:spcBef>
+                <a:spcPts val="0"/>
+              </a:spcBef>
+              <a:spcAft>
+                <a:spcPts val="0"/>
+              </a:spcAft>
+              <a:buNone/>
+            </a:pPr>
+            <a:r>
+              <a:rPr lang="zh-CN" sz="1300" b="0" i="0" u="none" strike="noStrike" cap="none">
+                <a:solidFill>
+                  <a:srgbClr val="111110"/>
+                </a:solidFill>
+                <a:latin typeface="Newsreader"/>
+                <a:ea typeface="Newsreader"/>
+                <a:cs typeface="Newsreader"/>
+                <a:sym typeface="Newsreader"/>
+              </a:rPr>
+              <a:t>3–4万亿美元/年</a:t>
+            </a:r>
+          </a:p>
+        </p:txBody>
+      </p:sp>
+      <p:sp>
+        <p:nvSpPr>
+          <p:cNvPr id="3027" name="SimReal 3027"/>
+          <p:cNvSpPr txBox="1"/>
+          <p:nvPr/>
+        </p:nvSpPr>
+        <p:spPr>
+          <a:xfrm>
+            <a:off x="4520184" y="2907792"/>
+            <a:ext cx="1776984" cy="310896"/>
+          </a:xfrm>
+          <a:prstGeom prst="rect">
+            <a:avLst/>
+          </a:prstGeom>
+          <a:noFill/>
+          <a:ln>
+            <a:noFill/>
+          </a:ln>
+        </p:spPr>
+        <p:txBody>
+          <a:bodyPr spcFirstLastPara="1" wrap="square" lIns="0" tIns="0" rIns="0" bIns="0" anchor="ctr" anchorCtr="0">
+            <a:noAutofit/>
+          </a:bodyPr>
+          <a:lstStyle/>
+          <a:p>
+            <a:pPr marL="0" marR="0" lvl="0" indent="0" algn="l" rtl="0">
+              <a:spcBef>
+                <a:spcPts val="0"/>
+              </a:spcBef>
+              <a:spcAft>
+                <a:spcPts val="0"/>
+              </a:spcAft>
+              <a:buNone/>
+            </a:pPr>
+            <a:r>
+              <a:rPr lang="zh-CN" sz="1100" b="0" i="0" u="none" strike="noStrike" cap="none">
+                <a:solidFill>
+                  <a:srgbClr val="33322F"/>
                 </a:solidFill>
                 <a:latin typeface="Instrument Sans"/>
                 <a:ea typeface="Instrument Sans"/>
                 <a:cs typeface="Instrument Sans"/>
                 <a:sym typeface="Instrument Sans"/>
               </a:rPr>
-              <a:t>终局：2030年全球AI经济</a:t>
-            </a:r>
-          </a:p>
-        </p:txBody>
-      </p:sp>
-      <p:sp>
-        <p:nvSpPr>
-          <p:cNvPr id="495" name="TextBox 494"/>
+              <a:t>× 训练数据与环境的占比</a:t>
+            </a:r>
+          </a:p>
+        </p:txBody>
+      </p:sp>
+      <p:sp>
+        <p:nvSpPr>
+          <p:cNvPr id="3028" name="SimReal 3028"/>
           <p:cNvSpPr txBox="1"/>
           <p:nvPr/>
         </p:nvSpPr>
         <p:spPr>
           <a:xfrm>
-            <a:off x="6355080" y="1810512"/>
-            <a:ext cx="5285232" cy="274320"/>
-          </a:xfrm>
-          <a:prstGeom prst="rect">
-            <a:avLst/>
-          </a:prstGeom>
-          <a:noFill/>
-        </p:spPr>
-        <p:txBody>
-          <a:bodyPr wrap="square" lIns="0" tIns="0" rIns="0" bIns="0" anchor="ctr">
-            <a:spAutoFit/>
-          </a:bodyPr>
-          <a:lstStyle/>
-          <a:p>
-            <a:pPr algn="l"/>
-            <a:r>
-              <a:rPr sz="1400" b="0">
+            <a:off x="6251448" y="2907792"/>
+            <a:ext cx="1417320" cy="310896"/>
+          </a:xfrm>
+          <a:prstGeom prst="rect">
+            <a:avLst/>
+          </a:prstGeom>
+          <a:noFill/>
+          <a:ln>
+            <a:noFill/>
+          </a:ln>
+        </p:spPr>
+        <p:txBody>
+          <a:bodyPr spcFirstLastPara="1" wrap="square" lIns="0" tIns="0" rIns="0" bIns="0" anchor="ctr" anchorCtr="0">
+            <a:noAutofit/>
+          </a:bodyPr>
+          <a:lstStyle/>
+          <a:p>
+            <a:pPr marL="0" marR="0" lvl="0" indent="0" algn="r" rtl="0">
+              <a:spcBef>
+                <a:spcPts val="0"/>
+              </a:spcBef>
+              <a:spcAft>
+                <a:spcPts val="0"/>
+              </a:spcAft>
+              <a:buNone/>
+            </a:pPr>
+            <a:r>
+              <a:rPr lang="zh-CN" sz="1300" b="0" i="0" u="none" strike="noStrike" cap="none">
                 <a:solidFill>
                   <a:srgbClr val="111110"/>
                 </a:solidFill>
@@ -13571,36 +13888,158 @@
                 <a:cs typeface="Newsreader"/>
                 <a:sym typeface="Newsreader"/>
               </a:rPr>
-              <a:t>约7万亿美元/年：由麦肯锡的美国数字推到全球</a:t>
-            </a:r>
-          </a:p>
-        </p:txBody>
-      </p:sp>
-      <p:sp>
-        <p:nvSpPr>
-          <p:cNvPr id="522" name="Rectangle 521"/>
+              <a:t>5–10%</a:t>
+            </a:r>
+          </a:p>
+        </p:txBody>
+      </p:sp>
+      <p:sp>
+        <p:nvSpPr>
+          <p:cNvPr id="3029" name="SimReal 3029"/>
+          <p:cNvSpPr txBox="1"/>
+          <p:nvPr/>
+        </p:nvSpPr>
+        <p:spPr>
+          <a:xfrm>
+            <a:off x="4520184" y="3218688"/>
+            <a:ext cx="3148584" cy="182880"/>
+          </a:xfrm>
+          <a:prstGeom prst="rect">
+            <a:avLst/>
+          </a:prstGeom>
+          <a:noFill/>
+          <a:ln>
+            <a:noFill/>
+          </a:ln>
+        </p:spPr>
+        <p:txBody>
+          <a:bodyPr spcFirstLastPara="1" wrap="square" lIns="0" tIns="0" rIns="0" bIns="0" anchor="t" anchorCtr="0">
+            <a:noAutofit/>
+          </a:bodyPr>
+          <a:lstStyle/>
+          <a:p>
+            <a:pPr marL="0" marR="0" lvl="0" indent="0" algn="l" rtl="0">
+              <a:spcBef>
+                <a:spcPts val="0"/>
+              </a:spcBef>
+              <a:spcAft>
+                <a:spcPts val="0"/>
+              </a:spcAft>
+              <a:buNone/>
+            </a:pPr>
+            <a:r>
+              <a:rPr lang="zh-CN" sz="850" b="0" i="0" u="none" strike="noStrike" cap="none">
+                <a:solidFill>
+                  <a:srgbClr val="6E6C66"/>
+                </a:solidFill>
+                <a:latin typeface="Instrument Sans"/>
+                <a:ea typeface="Instrument Sans"/>
+                <a:cs typeface="Instrument Sans"/>
+                <a:sym typeface="Instrument Sans"/>
+              </a:rPr>
+              <a:t>今天约1%：85亿美元对四大云厂商约7,000亿美元资本开支</a:t>
+            </a:r>
+          </a:p>
+        </p:txBody>
+      </p:sp>
+      <p:sp>
+        <p:nvSpPr>
+          <p:cNvPr id="3030" name="SimReal 3030"/>
+          <p:cNvSpPr txBox="1"/>
+          <p:nvPr/>
+        </p:nvSpPr>
+        <p:spPr>
+          <a:xfrm>
+            <a:off x="4337304" y="3639312"/>
+            <a:ext cx="3514344" cy="1280160"/>
+          </a:xfrm>
+          <a:prstGeom prst="rect">
+            <a:avLst/>
+          </a:prstGeom>
+          <a:noFill/>
+          <a:ln>
+            <a:noFill/>
+          </a:ln>
+        </p:spPr>
+        <p:txBody>
+          <a:bodyPr spcFirstLastPara="1" wrap="square" lIns="0" tIns="0" rIns="0" bIns="0" anchor="t" anchorCtr="0">
+            <a:noAutofit/>
+          </a:bodyPr>
+          <a:lstStyle/>
+          <a:p>
+            <a:pPr marL="0" marR="0" lvl="0" indent="0" algn="l" rtl="0">
+              <a:spcBef>
+                <a:spcPts val="0"/>
+              </a:spcBef>
+              <a:spcAft>
+                <a:spcPts val="0"/>
+              </a:spcAft>
+              <a:buNone/>
+            </a:pPr>
+            <a:r>
+              <a:rPr lang="zh-CN" sz="1100" b="1" i="0" u="none" strike="noStrike" cap="none">
+                <a:solidFill>
+                  <a:srgbClr val="111110"/>
+                </a:solidFill>
+                <a:latin typeface="Instrument Sans"/>
+                <a:ea typeface="Instrument Sans"/>
+                <a:cs typeface="Instrument Sans"/>
+                <a:sym typeface="Instrument Sans"/>
+              </a:rPr>
+              <a:t>为什么占比会升</a:t>
+            </a:r>
+          </a:p>
+          <a:p>
+            <a:pPr marL="0" marR="0" lvl="0" indent="0" algn="l" rtl="0">
+              <a:lnSpc>
+                <a:spcPct val="110000"/>
+              </a:lnSpc>
+              <a:spcBef>
+                <a:spcPts val="300"/>
+              </a:spcBef>
+              <a:spcAft>
+                <a:spcPts val="0"/>
+              </a:spcAft>
+              <a:buNone/>
+            </a:pPr>
+            <a:r>
+              <a:rPr lang="zh-CN" sz="1100" b="0" i="0" u="none" strike="noStrike" cap="none">
+                <a:solidFill>
+                  <a:srgbClr val="33322F"/>
+                </a:solidFill>
+                <a:latin typeface="Instrument Sans"/>
+                <a:ea typeface="Instrument Sans"/>
+                <a:cs typeface="Instrument Sans"/>
+                <a:sym typeface="Instrument Sans"/>
+              </a:rPr>
+              <a:t>数据和算力是互补品：每个RL任务约2,400美元算力，任务质量差，算力就白烧（Mechanize）。算力投得越多，高质量训练世界越值钱。</a:t>
+            </a:r>
+          </a:p>
+        </p:txBody>
+      </p:sp>
+      <p:sp>
+        <p:nvSpPr>
+          <p:cNvPr id="3031" name="SimReal 3031"/>
           <p:cNvSpPr/>
           <p:nvPr/>
         </p:nvSpPr>
         <p:spPr>
           <a:xfrm>
-            <a:off x="548640" y="4617720"/>
-            <a:ext cx="3483864" cy="960120"/>
+            <a:off x="8125968" y="1481328"/>
+            <a:ext cx="3514344" cy="3657600"/>
           </a:xfrm>
           <a:prstGeom prst="rect">
             <a:avLst/>
           </a:prstGeom>
           <a:solidFill>
-            <a:srgbClr val="FFFFFF"/>
+            <a:srgbClr val="111110"/>
           </a:solidFill>
-          <a:ln w="9525">
-            <a:solidFill>
-              <a:srgbClr val="E2E0DA"/>
-            </a:solidFill>
-          </a:ln>
-        </p:spPr>
-        <p:txBody>
-          <a:bodyPr rtlCol="0" anchor="ctr"/>
+          <a:ln>
+            <a:noFill/>
+          </a:ln>
+        </p:spPr>
+        <p:txBody>
+          <a:bodyPr/>
           <a:lstStyle/>
           <a:p>
             <a:endParaRPr/>
@@ -13609,519 +14048,701 @@
       </p:sp>
       <p:sp>
         <p:nvSpPr>
-          <p:cNvPr id="523" name="TextBox 522"/>
+          <p:cNvPr id="3032" name="SimReal 3032"/>
           <p:cNvSpPr txBox="1"/>
           <p:nvPr/>
         </p:nvSpPr>
         <p:spPr>
           <a:xfrm>
-            <a:off x="777240" y="4727448"/>
-            <a:ext cx="3026664" cy="201168"/>
-          </a:xfrm>
-          <a:prstGeom prst="rect">
-            <a:avLst/>
-          </a:prstGeom>
-          <a:noFill/>
-        </p:spPr>
-        <p:txBody>
-          <a:bodyPr wrap="square" lIns="0" tIns="0" rIns="0" bIns="0" anchor="ctr">
-            <a:spAutoFit/>
-          </a:bodyPr>
-          <a:lstStyle/>
-          <a:p>
-            <a:pPr algn="l"/>
-            <a:r>
-              <a:rPr sz="900" b="0">
-                <a:solidFill>
-                  <a:srgbClr val="C2410C"/>
+            <a:off x="8363712" y="1609344"/>
+            <a:ext cx="3038856" cy="201168"/>
+          </a:xfrm>
+          <a:prstGeom prst="rect">
+            <a:avLst/>
+          </a:prstGeom>
+          <a:noFill/>
+          <a:ln>
+            <a:noFill/>
+          </a:ln>
+        </p:spPr>
+        <p:txBody>
+          <a:bodyPr spcFirstLastPara="1" wrap="square" lIns="0" tIns="0" rIns="0" bIns="0" anchor="t" anchorCtr="0">
+            <a:noAutofit/>
+          </a:bodyPr>
+          <a:lstStyle/>
+          <a:p>
+            <a:pPr marL="0" marR="0" lvl="0" indent="0" algn="l" rtl="0">
+              <a:spcBef>
+                <a:spcPts val="0"/>
+              </a:spcBef>
+              <a:spcAft>
+                <a:spcPts val="0"/>
+              </a:spcAft>
+              <a:buNone/>
+            </a:pPr>
+            <a:r>
+              <a:rPr lang="zh-CN" sz="1000" b="0" i="0" u="none" strike="noStrike" cap="none">
+                <a:solidFill>
+                  <a:srgbClr val="E27A3F"/>
                 </a:solidFill>
                 <a:latin typeface="IBM Plex Mono"/>
                 <a:ea typeface="IBM Plex Mono"/>
                 <a:cs typeface="IBM Plex Mono"/>
                 <a:sym typeface="IBM Plex Mono"/>
               </a:rPr>
-              <a:t>切入点</a:t>
-            </a:r>
-          </a:p>
-        </p:txBody>
-      </p:sp>
-      <p:sp>
-        <p:nvSpPr>
-          <p:cNvPr id="524" name="TextBox 523"/>
+              <a:t>2030年 · 训练层服务的AI经济</a:t>
+            </a:r>
+          </a:p>
+        </p:txBody>
+      </p:sp>
+      <p:sp>
+        <p:nvSpPr>
+          <p:cNvPr id="3033" name="SimReal 3033"/>
           <p:cNvSpPr txBox="1"/>
           <p:nvPr/>
         </p:nvSpPr>
         <p:spPr>
           <a:xfrm>
-            <a:off x="777240" y="4946904"/>
-            <a:ext cx="3026664" cy="310896"/>
-          </a:xfrm>
-          <a:prstGeom prst="rect">
-            <a:avLst/>
-          </a:prstGeom>
-          <a:noFill/>
-        </p:spPr>
-        <p:txBody>
-          <a:bodyPr wrap="square" lIns="0" tIns="0" rIns="0" bIns="0" anchor="ctr">
-            <a:spAutoFit/>
-          </a:bodyPr>
-          <a:lstStyle/>
-          <a:p>
-            <a:pPr algn="l"/>
-            <a:r>
-              <a:rPr sz="1600" b="0">
-                <a:solidFill>
-                  <a:srgbClr val="111110"/>
+            <a:off x="8363712" y="1865376"/>
+            <a:ext cx="3038856" cy="548640"/>
+          </a:xfrm>
+          <a:prstGeom prst="rect">
+            <a:avLst/>
+          </a:prstGeom>
+          <a:noFill/>
+          <a:ln>
+            <a:noFill/>
+          </a:ln>
+        </p:spPr>
+        <p:txBody>
+          <a:bodyPr spcFirstLastPara="1" wrap="square" lIns="0" tIns="0" rIns="0" bIns="0" anchor="t" anchorCtr="0">
+            <a:noAutofit/>
+          </a:bodyPr>
+          <a:lstStyle/>
+          <a:p>
+            <a:pPr marL="0" marR="0" lvl="0" indent="0" algn="l" rtl="0">
+              <a:spcBef>
+                <a:spcPts val="0"/>
+              </a:spcBef>
+              <a:spcAft>
+                <a:spcPts val="0"/>
+              </a:spcAft>
+              <a:buNone/>
+            </a:pPr>
+            <a:r>
+              <a:rPr lang="zh-CN" sz="2800" b="0" i="0" u="none" strike="noStrike" cap="none">
+                <a:solidFill>
+                  <a:srgbClr val="E27A3F"/>
                 </a:solidFill>
                 <a:latin typeface="Newsreader"/>
                 <a:ea typeface="Newsreader"/>
                 <a:cs typeface="Newsreader"/>
                 <a:sym typeface="Newsreader"/>
               </a:rPr>
-              <a:t>前沿AI实验室</a:t>
-            </a:r>
-          </a:p>
-        </p:txBody>
-      </p:sp>
-      <p:sp>
-        <p:nvSpPr>
-          <p:cNvPr id="525" name="TextBox 524"/>
+              <a:t>约7万亿美元/年</a:t>
+            </a:r>
+          </a:p>
+        </p:txBody>
+      </p:sp>
+      <p:sp>
+        <p:nvSpPr>
+          <p:cNvPr id="3034" name="SimReal 3034"/>
           <p:cNvSpPr txBox="1"/>
           <p:nvPr/>
         </p:nvSpPr>
         <p:spPr>
           <a:xfrm>
-            <a:off x="777240" y="5257800"/>
-            <a:ext cx="3026664" cy="274320"/>
-          </a:xfrm>
-          <a:prstGeom prst="rect">
-            <a:avLst/>
-          </a:prstGeom>
-          <a:noFill/>
-        </p:spPr>
-        <p:txBody>
-          <a:bodyPr wrap="square" lIns="0" tIns="0" rIns="0" bIns="0" anchor="ctr">
-            <a:spAutoFit/>
-          </a:bodyPr>
-          <a:lstStyle/>
-          <a:p>
-            <a:pPr algn="l">
+            <a:off x="8363712" y="2505456"/>
+            <a:ext cx="2124456" cy="365760"/>
+          </a:xfrm>
+          <a:prstGeom prst="rect">
+            <a:avLst/>
+          </a:prstGeom>
+          <a:noFill/>
+          <a:ln>
+            <a:noFill/>
+          </a:ln>
+        </p:spPr>
+        <p:txBody>
+          <a:bodyPr spcFirstLastPara="1" wrap="square" lIns="0" tIns="0" rIns="0" bIns="0" anchor="ctr" anchorCtr="0">
+            <a:noAutofit/>
+          </a:bodyPr>
+          <a:lstStyle/>
+          <a:p>
+            <a:pPr marL="0" marR="0" lvl="0" indent="0" algn="l" rtl="0">
               <a:lnSpc>
                 <a:spcPct val="105000"/>
               </a:lnSpc>
-            </a:pPr>
-            <a:r>
-              <a:rPr sz="950" b="0">
-                <a:solidFill>
-                  <a:srgbClr val="6E6C66"/>
+              <a:spcBef>
+                <a:spcPts val="0"/>
+              </a:spcBef>
+              <a:spcAft>
+                <a:spcPts val="0"/>
+              </a:spcAft>
+              <a:buNone/>
+            </a:pPr>
+            <a:r>
+              <a:rPr lang="zh-CN" sz="1000" b="0" i="0" u="none" strike="noStrike" cap="none">
+                <a:solidFill>
+                  <a:srgbClr val="C4C0B7"/>
                 </a:solidFill>
                 <a:latin typeface="Instrument Sans"/>
                 <a:ea typeface="Instrument Sans"/>
                 <a:cs typeface="Instrument Sans"/>
                 <a:sym typeface="Instrument Sans"/>
               </a:rPr>
-              <a:t>今天约85亿美元/年，50余家公司合计</a:t>
-            </a:r>
-          </a:p>
-        </p:txBody>
-      </p:sp>
-      <p:sp>
-        <p:nvSpPr>
-          <p:cNvPr id="526" name="TextBox 525"/>
+              <a:t>美国：智能体与机器人每年释放的价值（麦肯锡）</a:t>
+            </a:r>
+          </a:p>
+        </p:txBody>
+      </p:sp>
+      <p:sp>
+        <p:nvSpPr>
+          <p:cNvPr id="3035" name="SimReal 3035"/>
           <p:cNvSpPr txBox="1"/>
           <p:nvPr/>
         </p:nvSpPr>
         <p:spPr>
           <a:xfrm>
-            <a:off x="4032504" y="4914900"/>
-            <a:ext cx="320040" cy="365760"/>
-          </a:xfrm>
-          <a:prstGeom prst="rect">
-            <a:avLst/>
-          </a:prstGeom>
-          <a:noFill/>
-        </p:spPr>
-        <p:txBody>
-          <a:bodyPr wrap="square" lIns="0" tIns="0" rIns="0" bIns="0" anchor="ctr">
-            <a:spAutoFit/>
-          </a:bodyPr>
-          <a:lstStyle/>
-          <a:p>
-            <a:pPr algn="ctr"/>
-            <a:r>
-              <a:rPr sz="1400" b="0">
-                <a:solidFill>
-                  <a:srgbClr val="6E6C66"/>
+            <a:off x="10488168" y="2505456"/>
+            <a:ext cx="914400" cy="365760"/>
+          </a:xfrm>
+          <a:prstGeom prst="rect">
+            <a:avLst/>
+          </a:prstGeom>
+          <a:noFill/>
+          <a:ln>
+            <a:noFill/>
+          </a:ln>
+        </p:spPr>
+        <p:txBody>
+          <a:bodyPr spcFirstLastPara="1" wrap="square" lIns="0" tIns="0" rIns="0" bIns="0" anchor="ctr" anchorCtr="0">
+            <a:noAutofit/>
+          </a:bodyPr>
+          <a:lstStyle/>
+          <a:p>
+            <a:pPr marL="0" marR="0" lvl="0" indent="0" algn="r" rtl="0">
+              <a:spcBef>
+                <a:spcPts val="0"/>
+              </a:spcBef>
+              <a:spcAft>
+                <a:spcPts val="0"/>
+              </a:spcAft>
+              <a:buNone/>
+            </a:pPr>
+            <a:r>
+              <a:rPr lang="zh-CN" sz="1300" b="0" i="0" u="none" strike="noStrike" cap="none">
+                <a:solidFill>
+                  <a:srgbClr val="FAF9F6"/>
+                </a:solidFill>
+                <a:latin typeface="Newsreader"/>
+                <a:ea typeface="Newsreader"/>
+                <a:cs typeface="Newsreader"/>
+                <a:sym typeface="Newsreader"/>
+              </a:rPr>
+              <a:t>2.9万亿</a:t>
+            </a:r>
+          </a:p>
+        </p:txBody>
+      </p:sp>
+      <p:sp>
+        <p:nvSpPr>
+          <p:cNvPr id="3036" name="SimReal 3036"/>
+          <p:cNvSpPr/>
+          <p:nvPr/>
+        </p:nvSpPr>
+        <p:spPr>
+          <a:xfrm>
+            <a:off x="8363712" y="2871216"/>
+            <a:ext cx="3038856" cy="9144"/>
+          </a:xfrm>
+          <a:prstGeom prst="rect">
+            <a:avLst/>
+          </a:prstGeom>
+          <a:solidFill>
+            <a:srgbClr val="3A3935"/>
+          </a:solidFill>
+          <a:ln>
+            <a:noFill/>
+          </a:ln>
+        </p:spPr>
+        <p:txBody>
+          <a:bodyPr/>
+          <a:lstStyle/>
+          <a:p>
+            <a:endParaRPr/>
+          </a:p>
+        </p:txBody>
+      </p:sp>
+      <p:sp>
+        <p:nvSpPr>
+          <p:cNvPr id="3037" name="SimReal 3037"/>
+          <p:cNvSpPr txBox="1"/>
+          <p:nvPr/>
+        </p:nvSpPr>
+        <p:spPr>
+          <a:xfrm>
+            <a:off x="8363712" y="2871216"/>
+            <a:ext cx="2124456" cy="365760"/>
+          </a:xfrm>
+          <a:prstGeom prst="rect">
+            <a:avLst/>
+          </a:prstGeom>
+          <a:noFill/>
+          <a:ln>
+            <a:noFill/>
+          </a:ln>
+        </p:spPr>
+        <p:txBody>
+          <a:bodyPr spcFirstLastPara="1" wrap="square" lIns="0" tIns="0" rIns="0" bIns="0" anchor="ctr" anchorCtr="0">
+            <a:noAutofit/>
+          </a:bodyPr>
+          <a:lstStyle/>
+          <a:p>
+            <a:pPr marL="0" marR="0" lvl="0" indent="0" algn="l" rtl="0">
+              <a:lnSpc>
+                <a:spcPct val="105000"/>
+              </a:lnSpc>
+              <a:spcBef>
+                <a:spcPts val="0"/>
+              </a:spcBef>
+              <a:spcAft>
+                <a:spcPts val="0"/>
+              </a:spcAft>
+              <a:buNone/>
+            </a:pPr>
+            <a:r>
+              <a:rPr lang="zh-CN" sz="1000" b="0" i="0" u="none" strike="noStrike" cap="none">
+                <a:solidFill>
+                  <a:srgbClr val="C4C0B7"/>
                 </a:solidFill>
                 <a:latin typeface="Instrument Sans"/>
                 <a:ea typeface="Instrument Sans"/>
                 <a:cs typeface="Instrument Sans"/>
                 <a:sym typeface="Instrument Sans"/>
               </a:rPr>
-              <a:t>→</a:t>
-            </a:r>
-          </a:p>
-        </p:txBody>
-      </p:sp>
-      <p:sp>
-        <p:nvSpPr>
-          <p:cNvPr id="527" name="Rectangle 526"/>
-          <p:cNvSpPr/>
-          <p:nvPr/>
-        </p:nvSpPr>
-        <p:spPr>
-          <a:xfrm>
-            <a:off x="4352544" y="4617720"/>
-            <a:ext cx="3483864" cy="960120"/>
-          </a:xfrm>
-          <a:prstGeom prst="rect">
-            <a:avLst/>
-          </a:prstGeom>
-          <a:solidFill>
-            <a:srgbClr val="FFFFFF"/>
-          </a:solidFill>
-          <a:ln w="9525">
-            <a:solidFill>
-              <a:srgbClr val="E2E0DA"/>
-            </a:solidFill>
-          </a:ln>
-        </p:spPr>
-        <p:txBody>
-          <a:bodyPr rtlCol="0" anchor="ctr"/>
-          <a:lstStyle/>
-          <a:p>
-            <a:endParaRPr/>
-          </a:p>
-        </p:txBody>
-      </p:sp>
-      <p:sp>
-        <p:nvSpPr>
-          <p:cNvPr id="528" name="TextBox 527"/>
+              <a:t>÷ 美国占全球GDP（IMF）</a:t>
+            </a:r>
+          </a:p>
+        </p:txBody>
+      </p:sp>
+      <p:sp>
+        <p:nvSpPr>
+          <p:cNvPr id="3038" name="SimReal 3038"/>
           <p:cNvSpPr txBox="1"/>
           <p:nvPr/>
         </p:nvSpPr>
         <p:spPr>
           <a:xfrm>
-            <a:off x="4581144" y="4727448"/>
-            <a:ext cx="3026664" cy="201168"/>
-          </a:xfrm>
-          <a:prstGeom prst="rect">
-            <a:avLst/>
-          </a:prstGeom>
-          <a:noFill/>
-        </p:spPr>
-        <p:txBody>
-          <a:bodyPr wrap="square" lIns="0" tIns="0" rIns="0" bIns="0" anchor="ctr">
-            <a:spAutoFit/>
-          </a:bodyPr>
-          <a:lstStyle/>
-          <a:p>
-            <a:pPr algn="l"/>
-            <a:r>
-              <a:rPr sz="900" b="0">
-                <a:solidFill>
-                  <a:srgbClr val="C2410C"/>
-                </a:solidFill>
-                <a:latin typeface="IBM Plex Mono"/>
-                <a:ea typeface="IBM Plex Mono"/>
-                <a:cs typeface="IBM Plex Mono"/>
-                <a:sym typeface="IBM Plex Mono"/>
-              </a:rPr>
-              <a:t>扩展</a:t>
-            </a:r>
-          </a:p>
-        </p:txBody>
-      </p:sp>
-      <p:sp>
-        <p:nvSpPr>
-          <p:cNvPr id="529" name="TextBox 528"/>
-          <p:cNvSpPr txBox="1"/>
-          <p:nvPr/>
-        </p:nvSpPr>
-        <p:spPr>
-          <a:xfrm>
-            <a:off x="4581144" y="4946904"/>
-            <a:ext cx="3026664" cy="310896"/>
-          </a:xfrm>
-          <a:prstGeom prst="rect">
-            <a:avLst/>
-          </a:prstGeom>
-          <a:noFill/>
-        </p:spPr>
-        <p:txBody>
-          <a:bodyPr wrap="square" lIns="0" tIns="0" rIns="0" bIns="0" anchor="ctr">
-            <a:spAutoFit/>
-          </a:bodyPr>
-          <a:lstStyle/>
-          <a:p>
-            <a:pPr algn="l"/>
-            <a:r>
-              <a:rPr sz="1600" b="0">
-                <a:solidFill>
-                  <a:srgbClr val="111110"/>
+            <a:off x="10488168" y="2871216"/>
+            <a:ext cx="914400" cy="365760"/>
+          </a:xfrm>
+          <a:prstGeom prst="rect">
+            <a:avLst/>
+          </a:prstGeom>
+          <a:noFill/>
+          <a:ln>
+            <a:noFill/>
+          </a:ln>
+        </p:spPr>
+        <p:txBody>
+          <a:bodyPr spcFirstLastPara="1" wrap="square" lIns="0" tIns="0" rIns="0" bIns="0" anchor="ctr" anchorCtr="0">
+            <a:noAutofit/>
+          </a:bodyPr>
+          <a:lstStyle/>
+          <a:p>
+            <a:pPr marL="0" marR="0" lvl="0" indent="0" algn="r" rtl="0">
+              <a:spcBef>
+                <a:spcPts val="0"/>
+              </a:spcBef>
+              <a:spcAft>
+                <a:spcPts val="0"/>
+              </a:spcAft>
+              <a:buNone/>
+            </a:pPr>
+            <a:r>
+              <a:rPr lang="zh-CN" sz="1300" b="0" i="0" u="none" strike="noStrike" cap="none">
+                <a:solidFill>
+                  <a:srgbClr val="FAF9F6"/>
                 </a:solidFill>
                 <a:latin typeface="Newsreader"/>
                 <a:ea typeface="Newsreader"/>
                 <a:cs typeface="Newsreader"/>
                 <a:sym typeface="Newsreader"/>
               </a:rPr>
-              <a:t>训练层跟着算力走</a:t>
-            </a:r>
-          </a:p>
-        </p:txBody>
-      </p:sp>
-      <p:sp>
-        <p:nvSpPr>
-          <p:cNvPr id="530" name="TextBox 529"/>
+              <a:t>25.6%</a:t>
+            </a:r>
+          </a:p>
+        </p:txBody>
+      </p:sp>
+      <p:sp>
+        <p:nvSpPr>
+          <p:cNvPr id="3039" name="SimReal 3039"/>
+          <p:cNvSpPr/>
+          <p:nvPr/>
+        </p:nvSpPr>
+        <p:spPr>
+          <a:xfrm>
+            <a:off x="8363712" y="3236976"/>
+            <a:ext cx="3038856" cy="9144"/>
+          </a:xfrm>
+          <a:prstGeom prst="rect">
+            <a:avLst/>
+          </a:prstGeom>
+          <a:solidFill>
+            <a:srgbClr val="3A3935"/>
+          </a:solidFill>
+          <a:ln>
+            <a:noFill/>
+          </a:ln>
+        </p:spPr>
+        <p:txBody>
+          <a:bodyPr/>
+          <a:lstStyle/>
+          <a:p>
+            <a:endParaRPr/>
+          </a:p>
+        </p:txBody>
+      </p:sp>
+      <p:sp>
+        <p:nvSpPr>
+          <p:cNvPr id="3040" name="SimReal 3040"/>
           <p:cNvSpPr txBox="1"/>
           <p:nvPr/>
         </p:nvSpPr>
         <p:spPr>
           <a:xfrm>
-            <a:off x="4581144" y="5257800"/>
-            <a:ext cx="3026664" cy="274320"/>
-          </a:xfrm>
-          <a:prstGeom prst="rect">
-            <a:avLst/>
-          </a:prstGeom>
-          <a:noFill/>
-        </p:spPr>
-        <p:txBody>
-          <a:bodyPr wrap="square" lIns="0" tIns="0" rIns="0" bIns="0" anchor="ctr">
-            <a:spAutoFit/>
-          </a:bodyPr>
-          <a:lstStyle/>
-          <a:p>
-            <a:pPr algn="l">
+            <a:off x="8363712" y="3236976"/>
+            <a:ext cx="2124456" cy="365760"/>
+          </a:xfrm>
+          <a:prstGeom prst="rect">
+            <a:avLst/>
+          </a:prstGeom>
+          <a:noFill/>
+          <a:ln>
+            <a:noFill/>
+          </a:ln>
+        </p:spPr>
+        <p:txBody>
+          <a:bodyPr spcFirstLastPara="1" wrap="square" lIns="0" tIns="0" rIns="0" bIns="0" anchor="ctr" anchorCtr="0">
+            <a:noAutofit/>
+          </a:bodyPr>
+          <a:lstStyle/>
+          <a:p>
+            <a:pPr marL="0" marR="0" lvl="0" indent="0" algn="l" rtl="0">
               <a:lnSpc>
                 <a:spcPct val="105000"/>
               </a:lnSpc>
-            </a:pPr>
-            <a:r>
-              <a:rPr sz="950" b="0">
-                <a:solidFill>
-                  <a:srgbClr val="6E6C66"/>
+              <a:spcBef>
+                <a:spcPts val="0"/>
+              </a:spcBef>
+              <a:spcAft>
+                <a:spcPts val="0"/>
+              </a:spcAft>
+              <a:buNone/>
+            </a:pPr>
+            <a:r>
+              <a:rPr lang="zh-CN" sz="1000" b="0" i="0" u="none" strike="noStrike" cap="none">
+                <a:solidFill>
+                  <a:srgbClr val="C4C0B7"/>
                 </a:solidFill>
                 <a:latin typeface="Instrument Sans"/>
                 <a:ea typeface="Instrument Sans"/>
                 <a:cs typeface="Instrument Sans"/>
                 <a:sym typeface="Instrument Sans"/>
               </a:rPr>
-              <a:t>2030年1,500–4,000亿美元/年：AI基础设施3–4万亿美元 × 训练层5–10%</a:t>
-            </a:r>
-          </a:p>
-        </p:txBody>
-      </p:sp>
-      <p:sp>
-        <p:nvSpPr>
-          <p:cNvPr id="531" name="TextBox 530"/>
+              <a:t>= 按美国渗透率外推到全球</a:t>
+            </a:r>
+          </a:p>
+        </p:txBody>
+      </p:sp>
+      <p:sp>
+        <p:nvSpPr>
+          <p:cNvPr id="3041" name="SimReal 3041"/>
           <p:cNvSpPr txBox="1"/>
           <p:nvPr/>
         </p:nvSpPr>
         <p:spPr>
           <a:xfrm>
-            <a:off x="7836408" y="4914900"/>
-            <a:ext cx="320040" cy="365760"/>
-          </a:xfrm>
-          <a:prstGeom prst="rect">
-            <a:avLst/>
-          </a:prstGeom>
-          <a:noFill/>
-        </p:spPr>
-        <p:txBody>
-          <a:bodyPr wrap="square" lIns="0" tIns="0" rIns="0" bIns="0" anchor="ctr">
-            <a:spAutoFit/>
-          </a:bodyPr>
-          <a:lstStyle/>
-          <a:p>
-            <a:pPr algn="ctr"/>
-            <a:r>
-              <a:rPr sz="1400" b="0">
-                <a:solidFill>
-                  <a:srgbClr val="6E6C66"/>
+            <a:off x="10488168" y="3236976"/>
+            <a:ext cx="914400" cy="365760"/>
+          </a:xfrm>
+          <a:prstGeom prst="rect">
+            <a:avLst/>
+          </a:prstGeom>
+          <a:noFill/>
+          <a:ln>
+            <a:noFill/>
+          </a:ln>
+        </p:spPr>
+        <p:txBody>
+          <a:bodyPr spcFirstLastPara="1" wrap="square" lIns="0" tIns="0" rIns="0" bIns="0" anchor="ctr" anchorCtr="0">
+            <a:noAutofit/>
+          </a:bodyPr>
+          <a:lstStyle/>
+          <a:p>
+            <a:pPr marL="0" marR="0" lvl="0" indent="0" algn="r" rtl="0">
+              <a:spcBef>
+                <a:spcPts val="0"/>
+              </a:spcBef>
+              <a:spcAft>
+                <a:spcPts val="0"/>
+              </a:spcAft>
+              <a:buNone/>
+            </a:pPr>
+            <a:r>
+              <a:rPr lang="zh-CN" sz="1300" b="0" i="0" u="none" strike="noStrike" cap="none">
+                <a:solidFill>
+                  <a:srgbClr val="FAF9F6"/>
+                </a:solidFill>
+                <a:latin typeface="Newsreader"/>
+                <a:ea typeface="Newsreader"/>
+                <a:cs typeface="Newsreader"/>
+                <a:sym typeface="Newsreader"/>
+              </a:rPr>
+              <a:t>11.3万亿</a:t>
+            </a:r>
+          </a:p>
+        </p:txBody>
+      </p:sp>
+      <p:sp>
+        <p:nvSpPr>
+          <p:cNvPr id="3042" name="SimReal 3042"/>
+          <p:cNvSpPr/>
+          <p:nvPr/>
+        </p:nvSpPr>
+        <p:spPr>
+          <a:xfrm>
+            <a:off x="8363712" y="3602736"/>
+            <a:ext cx="3038856" cy="9144"/>
+          </a:xfrm>
+          <a:prstGeom prst="rect">
+            <a:avLst/>
+          </a:prstGeom>
+          <a:solidFill>
+            <a:srgbClr val="3A3935"/>
+          </a:solidFill>
+          <a:ln>
+            <a:noFill/>
+          </a:ln>
+        </p:spPr>
+        <p:txBody>
+          <a:bodyPr/>
+          <a:lstStyle/>
+          <a:p>
+            <a:endParaRPr/>
+          </a:p>
+        </p:txBody>
+      </p:sp>
+      <p:sp>
+        <p:nvSpPr>
+          <p:cNvPr id="3043" name="SimReal 3043"/>
+          <p:cNvSpPr txBox="1"/>
+          <p:nvPr/>
+        </p:nvSpPr>
+        <p:spPr>
+          <a:xfrm>
+            <a:off x="8363712" y="3602736"/>
+            <a:ext cx="2124456" cy="365760"/>
+          </a:xfrm>
+          <a:prstGeom prst="rect">
+            <a:avLst/>
+          </a:prstGeom>
+          <a:noFill/>
+          <a:ln>
+            <a:noFill/>
+          </a:ln>
+        </p:spPr>
+        <p:txBody>
+          <a:bodyPr spcFirstLastPara="1" wrap="square" lIns="0" tIns="0" rIns="0" bIns="0" anchor="ctr" anchorCtr="0">
+            <a:noAutofit/>
+          </a:bodyPr>
+          <a:lstStyle/>
+          <a:p>
+            <a:pPr marL="0" marR="0" lvl="0" indent="0" algn="l" rtl="0">
+              <a:lnSpc>
+                <a:spcPct val="105000"/>
+              </a:lnSpc>
+              <a:spcBef>
+                <a:spcPts val="0"/>
+              </a:spcBef>
+              <a:spcAft>
+                <a:spcPts val="0"/>
+              </a:spcAft>
+              <a:buNone/>
+            </a:pPr>
+            <a:r>
+              <a:rPr lang="zh-CN" sz="1000" b="1" i="0" u="none" strike="noStrike" cap="none">
+                <a:solidFill>
+                  <a:srgbClr val="FAF9F6"/>
                 </a:solidFill>
                 <a:latin typeface="Instrument Sans"/>
                 <a:ea typeface="Instrument Sans"/>
                 <a:cs typeface="Instrument Sans"/>
                 <a:sym typeface="Instrument Sans"/>
               </a:rPr>
-              <a:t>→</a:t>
-            </a:r>
-          </a:p>
-        </p:txBody>
-      </p:sp>
-      <p:sp>
-        <p:nvSpPr>
-          <p:cNvPr id="532" name="Rectangle 531"/>
-          <p:cNvSpPr/>
-          <p:nvPr/>
-        </p:nvSpPr>
-        <p:spPr>
-          <a:xfrm>
-            <a:off x="8156448" y="4617720"/>
-            <a:ext cx="3483864" cy="960120"/>
-          </a:xfrm>
-          <a:prstGeom prst="rect">
-            <a:avLst/>
-          </a:prstGeom>
-          <a:solidFill>
-            <a:srgbClr val="111110"/>
-          </a:solidFill>
-          <a:ln>
-            <a:noFill/>
-          </a:ln>
-        </p:spPr>
-        <p:txBody>
-          <a:bodyPr rtlCol="0" anchor="ctr"/>
-          <a:lstStyle/>
-          <a:p>
-            <a:endParaRPr/>
-          </a:p>
-        </p:txBody>
-      </p:sp>
-      <p:sp>
-        <p:nvSpPr>
-          <p:cNvPr id="533" name="TextBox 532"/>
+              <a:t>美国以外只按一半渗透率</a:t>
+            </a:r>
+          </a:p>
+        </p:txBody>
+      </p:sp>
+      <p:sp>
+        <p:nvSpPr>
+          <p:cNvPr id="3044" name="SimReal 3044"/>
           <p:cNvSpPr txBox="1"/>
           <p:nvPr/>
         </p:nvSpPr>
         <p:spPr>
           <a:xfrm>
-            <a:off x="8385048" y="4727448"/>
-            <a:ext cx="3026664" cy="201168"/>
-          </a:xfrm>
-          <a:prstGeom prst="rect">
-            <a:avLst/>
-          </a:prstGeom>
-          <a:noFill/>
-        </p:spPr>
-        <p:txBody>
-          <a:bodyPr wrap="square" lIns="0" tIns="0" rIns="0" bIns="0" anchor="ctr">
-            <a:spAutoFit/>
-          </a:bodyPr>
-          <a:lstStyle/>
-          <a:p>
-            <a:pPr algn="l"/>
-            <a:r>
-              <a:rPr sz="900" b="0">
+            <a:off x="10488168" y="3602736"/>
+            <a:ext cx="914400" cy="365760"/>
+          </a:xfrm>
+          <a:prstGeom prst="rect">
+            <a:avLst/>
+          </a:prstGeom>
+          <a:noFill/>
+          <a:ln>
+            <a:noFill/>
+          </a:ln>
+        </p:spPr>
+        <p:txBody>
+          <a:bodyPr spcFirstLastPara="1" wrap="square" lIns="0" tIns="0" rIns="0" bIns="0" anchor="ctr" anchorCtr="0">
+            <a:noAutofit/>
+          </a:bodyPr>
+          <a:lstStyle/>
+          <a:p>
+            <a:pPr marL="0" marR="0" lvl="0" indent="0" algn="r" rtl="0">
+              <a:spcBef>
+                <a:spcPts val="0"/>
+              </a:spcBef>
+              <a:spcAft>
+                <a:spcPts val="0"/>
+              </a:spcAft>
+              <a:buNone/>
+            </a:pPr>
+            <a:r>
+              <a:rPr lang="zh-CN" sz="1300" b="0" i="0" u="none" strike="noStrike" cap="none">
                 <a:solidFill>
                   <a:srgbClr val="E27A3F"/>
-                </a:solidFill>
-                <a:latin typeface="IBM Plex Mono"/>
-                <a:ea typeface="IBM Plex Mono"/>
-                <a:cs typeface="IBM Plex Mono"/>
-                <a:sym typeface="IBM Plex Mono"/>
-              </a:rPr>
-              <a:t>目标市场</a:t>
-            </a:r>
-          </a:p>
-        </p:txBody>
-      </p:sp>
-      <p:sp>
-        <p:nvSpPr>
-          <p:cNvPr id="534" name="TextBox 533"/>
-          <p:cNvSpPr txBox="1"/>
-          <p:nvPr/>
-        </p:nvSpPr>
-        <p:spPr>
-          <a:xfrm>
-            <a:off x="8385048" y="4946904"/>
-            <a:ext cx="3026664" cy="310896"/>
-          </a:xfrm>
-          <a:prstGeom prst="rect">
-            <a:avLst/>
-          </a:prstGeom>
-          <a:noFill/>
-        </p:spPr>
-        <p:txBody>
-          <a:bodyPr wrap="square" lIns="0" tIns="0" rIns="0" bIns="0" anchor="ctr">
-            <a:spAutoFit/>
-          </a:bodyPr>
-          <a:lstStyle/>
-          <a:p>
-            <a:pPr algn="l"/>
-            <a:r>
-              <a:rPr sz="1600" b="0">
-                <a:solidFill>
-                  <a:srgbClr val="FAF9F6"/>
                 </a:solidFill>
                 <a:latin typeface="Newsreader"/>
                 <a:ea typeface="Newsreader"/>
                 <a:cs typeface="Newsreader"/>
                 <a:sym typeface="Newsreader"/>
               </a:rPr>
-              <a:t>自主经济</a:t>
-            </a:r>
-          </a:p>
-        </p:txBody>
-      </p:sp>
-      <p:sp>
-        <p:nvSpPr>
-          <p:cNvPr id="535" name="TextBox 534"/>
+              <a:t>约7.1万亿</a:t>
+            </a:r>
+          </a:p>
+        </p:txBody>
+      </p:sp>
+      <p:sp>
+        <p:nvSpPr>
+          <p:cNvPr id="3045" name="SimReal 3045"/>
           <p:cNvSpPr txBox="1"/>
           <p:nvPr/>
         </p:nvSpPr>
         <p:spPr>
           <a:xfrm>
-            <a:off x="8385048" y="5257800"/>
-            <a:ext cx="3026664" cy="274320"/>
-          </a:xfrm>
-          <a:prstGeom prst="rect">
-            <a:avLst/>
-          </a:prstGeom>
-          <a:noFill/>
-        </p:spPr>
-        <p:txBody>
-          <a:bodyPr wrap="square" lIns="0" tIns="0" rIns="0" bIns="0" anchor="ctr">
-            <a:spAutoFit/>
-          </a:bodyPr>
-          <a:lstStyle/>
-          <a:p>
-            <a:pPr algn="l">
-              <a:lnSpc>
-                <a:spcPct val="105000"/>
-              </a:lnSpc>
-            </a:pPr>
-            <a:r>
-              <a:rPr sz="950" b="0">
-                <a:solidFill>
-                  <a:srgbClr val="C4C0B7"/>
+            <a:off x="8363712" y="4133088"/>
+            <a:ext cx="3038856" cy="731520"/>
+          </a:xfrm>
+          <a:prstGeom prst="rect">
+            <a:avLst/>
+          </a:prstGeom>
+          <a:noFill/>
+          <a:ln>
+            <a:noFill/>
+          </a:ln>
+        </p:spPr>
+        <p:txBody>
+          <a:bodyPr spcFirstLastPara="1" wrap="square" lIns="0" tIns="0" rIns="0" bIns="0" anchor="t" anchorCtr="0">
+            <a:noAutofit/>
+          </a:bodyPr>
+          <a:lstStyle/>
+          <a:p>
+            <a:pPr marL="0" marR="0" lvl="0" indent="0" algn="l" rtl="0">
+              <a:spcBef>
+                <a:spcPts val="0"/>
+              </a:spcBef>
+              <a:spcAft>
+                <a:spcPts val="0"/>
+              </a:spcAft>
+              <a:buNone/>
+            </a:pPr>
+            <a:r>
+              <a:rPr lang="zh-CN" sz="1200" b="1" i="0" u="none" strike="noStrike" cap="none">
+                <a:solidFill>
+                  <a:srgbClr val="FAF9F6"/>
                 </a:solidFill>
                 <a:latin typeface="Instrument Sans"/>
                 <a:ea typeface="Instrument Sans"/>
                 <a:cs typeface="Instrument Sans"/>
                 <a:sym typeface="Instrument Sans"/>
               </a:rPr>
-              <a:t>2030年约7万亿美元/年：每一份交给AI的工作，都要先在训练世界里练过</a:t>
-            </a:r>
-          </a:p>
-        </p:txBody>
-      </p:sp>
-      <p:sp>
-        <p:nvSpPr>
-          <p:cNvPr id="536" name="TextBox 535"/>
+              <a:t>训练层只相当于它创造价值的2–6%</a:t>
+            </a:r>
+          </a:p>
+          <a:p>
+            <a:pPr marL="0" marR="0" lvl="0" indent="0" algn="l" rtl="0">
+              <a:spcBef>
+                <a:spcPts val="400"/>
+              </a:spcBef>
+              <a:spcAft>
+                <a:spcPts val="0"/>
+              </a:spcAft>
+              <a:buNone/>
+            </a:pPr>
+            <a:r>
+              <a:rPr lang="zh-CN" sz="1000" b="0" i="0" u="none" strike="noStrike" cap="none">
+                <a:solidFill>
+                  <a:srgbClr val="C4C0B7"/>
+                </a:solidFill>
+                <a:latin typeface="Instrument Sans"/>
+                <a:ea typeface="Instrument Sans"/>
+                <a:cs typeface="Instrument Sans"/>
+                <a:sym typeface="Instrument Sans"/>
+              </a:rPr>
+              <a:t>每一份交给AI的工作，都要先在训练世界里练过</a:t>
+            </a:r>
+          </a:p>
+        </p:txBody>
+      </p:sp>
+      <p:sp>
+        <p:nvSpPr>
+          <p:cNvPr id="3046" name="SimReal 3046"/>
           <p:cNvSpPr txBox="1"/>
           <p:nvPr/>
         </p:nvSpPr>
         <p:spPr>
           <a:xfrm>
-            <a:off x="548640" y="5687568"/>
-            <a:ext cx="11091672" cy="457200"/>
-          </a:xfrm>
-          <a:prstGeom prst="rect">
-            <a:avLst/>
-          </a:prstGeom>
-          <a:noFill/>
-        </p:spPr>
-        <p:txBody>
-          <a:bodyPr wrap="square" lIns="0" tIns="0" rIns="0" bIns="0" anchor="ctr">
-            <a:spAutoFit/>
-          </a:bodyPr>
-          <a:lstStyle/>
-          <a:p>
-            <a:pPr algn="l"/>
-            <a:r>
-              <a:rPr sz="1800" b="0">
+            <a:off x="548640" y="5358384"/>
+            <a:ext cx="11091672" cy="402336"/>
+          </a:xfrm>
+          <a:prstGeom prst="rect">
+            <a:avLst/>
+          </a:prstGeom>
+          <a:noFill/>
+          <a:ln>
+            <a:noFill/>
+          </a:ln>
+        </p:spPr>
+        <p:txBody>
+          <a:bodyPr spcFirstLastPara="1" wrap="square" lIns="0" tIns="0" rIns="0" bIns="0" anchor="ctr" anchorCtr="0">
+            <a:noAutofit/>
+          </a:bodyPr>
+          <a:lstStyle/>
+          <a:p>
+            <a:pPr marL="0" marR="0" lvl="0" indent="0" algn="l" rtl="0">
+              <a:spcBef>
+                <a:spcPts val="0"/>
+              </a:spcBef>
+              <a:spcAft>
+                <a:spcPts val="0"/>
+              </a:spcAft>
+              <a:buNone/>
+            </a:pPr>
+            <a:r>
+              <a:rPr lang="zh-CN" sz="2000" b="0" i="0" u="none" strike="noStrike" cap="none">
                 <a:solidFill>
                   <a:srgbClr val="111110"/>
                 </a:solidFill>
@@ -14130,10 +14751,10 @@
                 <a:cs typeface="Newsreader"/>
                 <a:sym typeface="Newsreader"/>
               </a:rPr>
-              <a:t>实验室训练是切入点，</a:t>
-            </a:r>
-            <a:r>
-              <a:rPr sz="1800" b="0">
+              <a:t>今天卖给实验室，2030年卖给</a:t>
+            </a:r>
+            <a:r>
+              <a:rPr lang="zh-CN" sz="2000" b="0" i="0" u="none" strike="noStrike" cap="none">
                 <a:solidFill>
                   <a:srgbClr val="C2410C"/>
                 </a:solidFill>
@@ -14142,10 +14763,10 @@
                 <a:cs typeface="Newsreader"/>
                 <a:sym typeface="Newsreader"/>
               </a:rPr>
-              <a:t>自主经济</a:t>
-            </a:r>
-            <a:r>
-              <a:rPr sz="1800" b="0">
+              <a:t>整个AI经济的训练层</a:t>
+            </a:r>
+            <a:r>
+              <a:rPr lang="zh-CN" sz="2000" b="0" i="0" u="none" strike="noStrike" cap="none">
                 <a:solidFill>
                   <a:srgbClr val="111110"/>
                 </a:solidFill>
@@ -14154,691 +14775,59 @@
                 <a:cs typeface="Newsreader"/>
                 <a:sym typeface="Newsreader"/>
               </a:rPr>
-              <a:t>是我们的目标市场：2030年约7万亿美元。</a:t>
-            </a:r>
-          </a:p>
-        </p:txBody>
-      </p:sp>
-      <p:sp>
-        <p:nvSpPr>
-          <p:cNvPr id="3001" name="SimReal 3001"/>
+              <a:t>：它只占AI创造价值的2–6%。</a:t>
+            </a:r>
+          </a:p>
+        </p:txBody>
+      </p:sp>
+      <p:sp>
+        <p:nvSpPr>
+          <p:cNvPr id="3047" name="SimReal 3047"/>
           <p:cNvSpPr txBox="1"/>
           <p:nvPr/>
         </p:nvSpPr>
         <p:spPr>
           <a:xfrm>
-            <a:off x="6355080" y="2212848"/>
-            <a:ext cx="3886200" cy="365760"/>
-          </a:xfrm>
-          <a:prstGeom prst="rect">
-            <a:avLst/>
-          </a:prstGeom>
-          <a:noFill/>
-          <a:ln>
-            <a:noFill/>
-          </a:ln>
-        </p:spPr>
-        <p:txBody>
-          <a:bodyPr spcFirstLastPara="1" wrap="square" lIns="0" tIns="0" rIns="0" bIns="0" anchor="ctr" anchorCtr="0">
+            <a:off x="548640" y="5870448"/>
+            <a:ext cx="11091672" cy="329184"/>
+          </a:xfrm>
+          <a:prstGeom prst="rect">
+            <a:avLst/>
+          </a:prstGeom>
+          <a:noFill/>
+          <a:ln>
+            <a:noFill/>
+          </a:ln>
+        </p:spPr>
+        <p:txBody>
+          <a:bodyPr spcFirstLastPara="1" wrap="square" lIns="0" tIns="0" rIns="0" bIns="0" anchor="t" anchorCtr="0">
             <a:noAutofit/>
           </a:bodyPr>
           <a:lstStyle/>
           <a:p>
             <a:pPr marL="0" marR="0" lvl="0" indent="0" algn="l" rtl="0">
-              <a:spcBef>
-                <a:spcPts val="0"/>
-              </a:spcBef>
-              <a:spcAft>
-                <a:spcPts val="0"/>
-              </a:spcAft>
-              <a:buNone/>
-            </a:pPr>
-            <a:r>
-              <a:rPr lang="zh-CN" sz="1050" b="0" i="0" u="none" strike="noStrike" cap="none">
-                <a:solidFill>
-                  <a:srgbClr val="33322F"/>
+              <a:lnSpc>
+                <a:spcPct val="110000"/>
+              </a:lnSpc>
+              <a:spcBef>
+                <a:spcPts val="0"/>
+              </a:spcBef>
+              <a:spcAft>
+                <a:spcPts val="0"/>
+              </a:spcAft>
+              <a:buNone/>
+            </a:pPr>
+            <a:r>
+              <a:rPr lang="zh-CN" sz="800" b="0" i="0" u="none" strike="noStrike" cap="none">
+                <a:solidFill>
+                  <a:srgbClr val="6E6C66"/>
                 </a:solidFill>
                 <a:latin typeface="Instrument Sans"/>
                 <a:ea typeface="Instrument Sans"/>
                 <a:cs typeface="Instrument Sans"/>
                 <a:sym typeface="Instrument Sans"/>
               </a:rPr>
-              <a:t>美国：2030年智能体与机器人每年释放的经济价值（麦肯锡）</a:t>
-            </a:r>
-          </a:p>
-        </p:txBody>
-      </p:sp>
-      <p:sp>
-        <p:nvSpPr>
-          <p:cNvPr id="3002" name="SimReal 3002"/>
-          <p:cNvSpPr txBox="1"/>
-          <p:nvPr/>
-        </p:nvSpPr>
-        <p:spPr>
-          <a:xfrm>
-            <a:off x="10241280" y="2212848"/>
-            <a:ext cx="1399032" cy="365760"/>
-          </a:xfrm>
-          <a:prstGeom prst="rect">
-            <a:avLst/>
-          </a:prstGeom>
-          <a:noFill/>
-          <a:ln>
-            <a:noFill/>
-          </a:ln>
-        </p:spPr>
-        <p:txBody>
-          <a:bodyPr spcFirstLastPara="1" wrap="square" lIns="0" tIns="0" rIns="0" bIns="0" anchor="ctr" anchorCtr="0">
-            <a:noAutofit/>
-          </a:bodyPr>
-          <a:lstStyle/>
-          <a:p>
-            <a:pPr marL="0" marR="0" lvl="0" indent="0" algn="r" rtl="0">
-              <a:spcBef>
-                <a:spcPts val="0"/>
-              </a:spcBef>
-              <a:spcAft>
-                <a:spcPts val="0"/>
-              </a:spcAft>
-              <a:buNone/>
-            </a:pPr>
-            <a:r>
-              <a:rPr lang="zh-CN" sz="1400" b="0" i="0" u="none" strike="noStrike" cap="none">
-                <a:solidFill>
-                  <a:srgbClr val="111110"/>
-                </a:solidFill>
-                <a:latin typeface="Newsreader"/>
-                <a:ea typeface="Newsreader"/>
-                <a:cs typeface="Newsreader"/>
-                <a:sym typeface="Newsreader"/>
-              </a:rPr>
-              <a:t>2.9万亿美元</a:t>
-            </a:r>
-          </a:p>
-        </p:txBody>
-      </p:sp>
-      <p:sp>
-        <p:nvSpPr>
-          <p:cNvPr id="3003" name="SimReal 3003"/>
-          <p:cNvSpPr/>
-          <p:nvPr/>
-        </p:nvSpPr>
-        <p:spPr>
-          <a:xfrm>
-            <a:off x="6355080" y="2578608"/>
-            <a:ext cx="5285232" cy="9144"/>
-          </a:xfrm>
-          <a:prstGeom prst="rect">
-            <a:avLst/>
-          </a:prstGeom>
-          <a:solidFill>
-            <a:srgbClr val="E2E0DA"/>
-          </a:solidFill>
-          <a:ln>
-            <a:noFill/>
-          </a:ln>
-        </p:spPr>
-        <p:txBody>
-          <a:bodyPr/>
-          <a:lstStyle/>
-          <a:p>
-            <a:endParaRPr/>
-          </a:p>
-        </p:txBody>
-      </p:sp>
-      <p:sp>
-        <p:nvSpPr>
-          <p:cNvPr id="3004" name="SimReal 3004"/>
-          <p:cNvSpPr txBox="1"/>
-          <p:nvPr/>
-        </p:nvSpPr>
-        <p:spPr>
-          <a:xfrm>
-            <a:off x="6355080" y="2578608"/>
-            <a:ext cx="3886200" cy="365760"/>
-          </a:xfrm>
-          <a:prstGeom prst="rect">
-            <a:avLst/>
-          </a:prstGeom>
-          <a:noFill/>
-          <a:ln>
-            <a:noFill/>
-          </a:ln>
-        </p:spPr>
-        <p:txBody>
-          <a:bodyPr spcFirstLastPara="1" wrap="square" lIns="0" tIns="0" rIns="0" bIns="0" anchor="ctr" anchorCtr="0">
-            <a:noAutofit/>
-          </a:bodyPr>
-          <a:lstStyle/>
-          <a:p>
-            <a:pPr marL="0" marR="0" lvl="0" indent="0" algn="l" rtl="0">
-              <a:spcBef>
-                <a:spcPts val="0"/>
-              </a:spcBef>
-              <a:spcAft>
-                <a:spcPts val="0"/>
-              </a:spcAft>
-              <a:buNone/>
-            </a:pPr>
-            <a:r>
-              <a:rPr lang="zh-CN" sz="1050" b="0" i="0" u="none" strike="noStrike" cap="none">
-                <a:solidFill>
-                  <a:srgbClr val="33322F"/>
-                </a:solidFill>
-                <a:latin typeface="Instrument Sans"/>
-                <a:ea typeface="Instrument Sans"/>
-                <a:cs typeface="Instrument Sans"/>
-                <a:sym typeface="Instrument Sans"/>
-              </a:rPr>
-              <a:t>美国占全球GDP（IMF，2026年：32.4 / 126.3万亿美元）</a:t>
-            </a:r>
-          </a:p>
-        </p:txBody>
-      </p:sp>
-      <p:sp>
-        <p:nvSpPr>
-          <p:cNvPr id="3005" name="SimReal 3005"/>
-          <p:cNvSpPr txBox="1"/>
-          <p:nvPr/>
-        </p:nvSpPr>
-        <p:spPr>
-          <a:xfrm>
-            <a:off x="10241280" y="2578608"/>
-            <a:ext cx="1399032" cy="365760"/>
-          </a:xfrm>
-          <a:prstGeom prst="rect">
-            <a:avLst/>
-          </a:prstGeom>
-          <a:noFill/>
-          <a:ln>
-            <a:noFill/>
-          </a:ln>
-        </p:spPr>
-        <p:txBody>
-          <a:bodyPr spcFirstLastPara="1" wrap="square" lIns="0" tIns="0" rIns="0" bIns="0" anchor="ctr" anchorCtr="0">
-            <a:noAutofit/>
-          </a:bodyPr>
-          <a:lstStyle/>
-          <a:p>
-            <a:pPr marL="0" marR="0" lvl="0" indent="0" algn="r" rtl="0">
-              <a:spcBef>
-                <a:spcPts val="0"/>
-              </a:spcBef>
-              <a:spcAft>
-                <a:spcPts val="0"/>
-              </a:spcAft>
-              <a:buNone/>
-            </a:pPr>
-            <a:r>
-              <a:rPr lang="zh-CN" sz="1400" b="0" i="0" u="none" strike="noStrike" cap="none">
-                <a:solidFill>
-                  <a:srgbClr val="111110"/>
-                </a:solidFill>
-                <a:latin typeface="Newsreader"/>
-                <a:ea typeface="Newsreader"/>
-                <a:cs typeface="Newsreader"/>
-                <a:sym typeface="Newsreader"/>
-              </a:rPr>
-              <a:t>25.6%</a:t>
-            </a:r>
-          </a:p>
-        </p:txBody>
-      </p:sp>
-      <p:sp>
-        <p:nvSpPr>
-          <p:cNvPr id="3006" name="SimReal 3006"/>
-          <p:cNvSpPr/>
-          <p:nvPr/>
-        </p:nvSpPr>
-        <p:spPr>
-          <a:xfrm>
-            <a:off x="6355080" y="2944368"/>
-            <a:ext cx="5285232" cy="9144"/>
-          </a:xfrm>
-          <a:prstGeom prst="rect">
-            <a:avLst/>
-          </a:prstGeom>
-          <a:solidFill>
-            <a:srgbClr val="E2E0DA"/>
-          </a:solidFill>
-          <a:ln>
-            <a:noFill/>
-          </a:ln>
-        </p:spPr>
-        <p:txBody>
-          <a:bodyPr/>
-          <a:lstStyle/>
-          <a:p>
-            <a:endParaRPr/>
-          </a:p>
-        </p:txBody>
-      </p:sp>
-      <p:sp>
-        <p:nvSpPr>
-          <p:cNvPr id="3007" name="SimReal 3007"/>
-          <p:cNvSpPr txBox="1"/>
-          <p:nvPr/>
-        </p:nvSpPr>
-        <p:spPr>
-          <a:xfrm>
-            <a:off x="6355080" y="2944368"/>
-            <a:ext cx="3886200" cy="365760"/>
-          </a:xfrm>
-          <a:prstGeom prst="rect">
-            <a:avLst/>
-          </a:prstGeom>
-          <a:noFill/>
-          <a:ln>
-            <a:noFill/>
-          </a:ln>
-        </p:spPr>
-        <p:txBody>
-          <a:bodyPr spcFirstLastPara="1" wrap="square" lIns="0" tIns="0" rIns="0" bIns="0" anchor="ctr" anchorCtr="0">
-            <a:noAutofit/>
-          </a:bodyPr>
-          <a:lstStyle/>
-          <a:p>
-            <a:pPr marL="0" marR="0" lvl="0" indent="0" algn="l" rtl="0">
-              <a:spcBef>
-                <a:spcPts val="0"/>
-              </a:spcBef>
-              <a:spcAft>
-                <a:spcPts val="0"/>
-              </a:spcAft>
-              <a:buNone/>
-            </a:pPr>
-            <a:r>
-              <a:rPr lang="zh-CN" sz="1050" b="0" i="0" u="none" strike="noStrike" cap="none">
-                <a:solidFill>
-                  <a:srgbClr val="33322F"/>
-                </a:solidFill>
-                <a:latin typeface="Instrument Sans"/>
-                <a:ea typeface="Instrument Sans"/>
-                <a:cs typeface="Instrument Sans"/>
-                <a:sym typeface="Instrument Sans"/>
-              </a:rPr>
-              <a:t>按美国同等渗透率外推到全球：2.9 ÷ 25.6%</a:t>
-            </a:r>
-          </a:p>
-        </p:txBody>
-      </p:sp>
-      <p:sp>
-        <p:nvSpPr>
-          <p:cNvPr id="3008" name="SimReal 3008"/>
-          <p:cNvSpPr txBox="1"/>
-          <p:nvPr/>
-        </p:nvSpPr>
-        <p:spPr>
-          <a:xfrm>
-            <a:off x="10241280" y="2944368"/>
-            <a:ext cx="1399032" cy="365760"/>
-          </a:xfrm>
-          <a:prstGeom prst="rect">
-            <a:avLst/>
-          </a:prstGeom>
-          <a:noFill/>
-          <a:ln>
-            <a:noFill/>
-          </a:ln>
-        </p:spPr>
-        <p:txBody>
-          <a:bodyPr spcFirstLastPara="1" wrap="square" lIns="0" tIns="0" rIns="0" bIns="0" anchor="ctr" anchorCtr="0">
-            <a:noAutofit/>
-          </a:bodyPr>
-          <a:lstStyle/>
-          <a:p>
-            <a:pPr marL="0" marR="0" lvl="0" indent="0" algn="r" rtl="0">
-              <a:spcBef>
-                <a:spcPts val="0"/>
-              </a:spcBef>
-              <a:spcAft>
-                <a:spcPts val="0"/>
-              </a:spcAft>
-              <a:buNone/>
-            </a:pPr>
-            <a:r>
-              <a:rPr lang="zh-CN" sz="1400" b="0" i="0" u="none" strike="noStrike" cap="none">
-                <a:solidFill>
-                  <a:srgbClr val="111110"/>
-                </a:solidFill>
-                <a:latin typeface="Newsreader"/>
-                <a:ea typeface="Newsreader"/>
-                <a:cs typeface="Newsreader"/>
-                <a:sym typeface="Newsreader"/>
-              </a:rPr>
-              <a:t>11.3万亿美元</a:t>
-            </a:r>
-          </a:p>
-        </p:txBody>
-      </p:sp>
-      <p:sp>
-        <p:nvSpPr>
-          <p:cNvPr id="3009" name="SimReal 3009"/>
-          <p:cNvSpPr/>
-          <p:nvPr/>
-        </p:nvSpPr>
-        <p:spPr>
-          <a:xfrm>
-            <a:off x="6355080" y="3310128"/>
-            <a:ext cx="5285232" cy="9144"/>
-          </a:xfrm>
-          <a:prstGeom prst="rect">
-            <a:avLst/>
-          </a:prstGeom>
-          <a:solidFill>
-            <a:srgbClr val="E2E0DA"/>
-          </a:solidFill>
-          <a:ln>
-            <a:noFill/>
-          </a:ln>
-        </p:spPr>
-        <p:txBody>
-          <a:bodyPr/>
-          <a:lstStyle/>
-          <a:p>
-            <a:endParaRPr/>
-          </a:p>
-        </p:txBody>
-      </p:sp>
-      <p:sp>
-        <p:nvSpPr>
-          <p:cNvPr id="3010" name="SimReal 3010"/>
-          <p:cNvSpPr txBox="1"/>
-          <p:nvPr/>
-        </p:nvSpPr>
-        <p:spPr>
-          <a:xfrm>
-            <a:off x="6355080" y="3310128"/>
-            <a:ext cx="3886200" cy="365760"/>
-          </a:xfrm>
-          <a:prstGeom prst="rect">
-            <a:avLst/>
-          </a:prstGeom>
-          <a:noFill/>
-          <a:ln>
-            <a:noFill/>
-          </a:ln>
-        </p:spPr>
-        <p:txBody>
-          <a:bodyPr spcFirstLastPara="1" wrap="square" lIns="0" tIns="0" rIns="0" bIns="0" anchor="ctr" anchorCtr="0">
-            <a:noAutofit/>
-          </a:bodyPr>
-          <a:lstStyle/>
-          <a:p>
-            <a:pPr marL="0" marR="0" lvl="0" indent="0" algn="l" rtl="0">
-              <a:spcBef>
-                <a:spcPts val="0"/>
-              </a:spcBef>
-              <a:spcAft>
-                <a:spcPts val="0"/>
-              </a:spcAft>
-              <a:buNone/>
-            </a:pPr>
-            <a:r>
-              <a:rPr lang="zh-CN" sz="1050" b="0" i="0" u="none" strike="noStrike" cap="none">
-                <a:solidFill>
-                  <a:srgbClr val="33322F"/>
-                </a:solidFill>
-                <a:latin typeface="Instrument Sans"/>
-                <a:ea typeface="Instrument Sans"/>
-                <a:cs typeface="Instrument Sans"/>
-                <a:sym typeface="Instrument Sans"/>
-              </a:rPr>
-              <a:t>美国以外只按美国一半的渗透率：(11.3 − 2.9) × 50%</a:t>
-            </a:r>
-          </a:p>
-        </p:txBody>
-      </p:sp>
-      <p:sp>
-        <p:nvSpPr>
-          <p:cNvPr id="3011" name="SimReal 3011"/>
-          <p:cNvSpPr txBox="1"/>
-          <p:nvPr/>
-        </p:nvSpPr>
-        <p:spPr>
-          <a:xfrm>
-            <a:off x="10241280" y="3310128"/>
-            <a:ext cx="1399032" cy="365760"/>
-          </a:xfrm>
-          <a:prstGeom prst="rect">
-            <a:avLst/>
-          </a:prstGeom>
-          <a:noFill/>
-          <a:ln>
-            <a:noFill/>
-          </a:ln>
-        </p:spPr>
-        <p:txBody>
-          <a:bodyPr spcFirstLastPara="1" wrap="square" lIns="0" tIns="0" rIns="0" bIns="0" anchor="ctr" anchorCtr="0">
-            <a:noAutofit/>
-          </a:bodyPr>
-          <a:lstStyle/>
-          <a:p>
-            <a:pPr marL="0" marR="0" lvl="0" indent="0" algn="r" rtl="0">
-              <a:spcBef>
-                <a:spcPts val="0"/>
-              </a:spcBef>
-              <a:spcAft>
-                <a:spcPts val="0"/>
-              </a:spcAft>
-              <a:buNone/>
-            </a:pPr>
-            <a:r>
-              <a:rPr lang="zh-CN" sz="1400" b="0" i="0" u="none" strike="noStrike" cap="none">
-                <a:solidFill>
-                  <a:srgbClr val="111110"/>
-                </a:solidFill>
-                <a:latin typeface="Newsreader"/>
-                <a:ea typeface="Newsreader"/>
-                <a:cs typeface="Newsreader"/>
-                <a:sym typeface="Newsreader"/>
-              </a:rPr>
-              <a:t>4.2万亿美元</a:t>
-            </a:r>
-          </a:p>
-        </p:txBody>
-      </p:sp>
-      <p:sp>
-        <p:nvSpPr>
-          <p:cNvPr id="3012" name="SimReal 3012"/>
-          <p:cNvSpPr/>
-          <p:nvPr/>
-        </p:nvSpPr>
-        <p:spPr>
-          <a:xfrm>
-            <a:off x="6355080" y="3675888"/>
-            <a:ext cx="5285232" cy="9144"/>
-          </a:xfrm>
-          <a:prstGeom prst="rect">
-            <a:avLst/>
-          </a:prstGeom>
-          <a:solidFill>
-            <a:srgbClr val="E2E0DA"/>
-          </a:solidFill>
-          <a:ln>
-            <a:noFill/>
-          </a:ln>
-        </p:spPr>
-        <p:txBody>
-          <a:bodyPr/>
-          <a:lstStyle/>
-          <a:p>
-            <a:endParaRPr/>
-          </a:p>
-        </p:txBody>
-      </p:sp>
-      <p:sp>
-        <p:nvSpPr>
-          <p:cNvPr id="3013" name="SimReal 3013"/>
-          <p:cNvSpPr/>
-          <p:nvPr/>
-        </p:nvSpPr>
-        <p:spPr>
-          <a:xfrm>
-            <a:off x="6355080" y="3749040"/>
-            <a:ext cx="5285232" cy="402336"/>
-          </a:xfrm>
-          <a:prstGeom prst="rect">
-            <a:avLst/>
-          </a:prstGeom>
-          <a:solidFill>
-            <a:srgbClr val="111110"/>
-          </a:solidFill>
-          <a:ln>
-            <a:noFill/>
-          </a:ln>
-        </p:spPr>
-        <p:txBody>
-          <a:bodyPr/>
-          <a:lstStyle/>
-          <a:p>
-            <a:endParaRPr/>
-          </a:p>
-        </p:txBody>
-      </p:sp>
-      <p:sp>
-        <p:nvSpPr>
-          <p:cNvPr id="3014" name="SimReal 3014"/>
-          <p:cNvSpPr txBox="1"/>
-          <p:nvPr/>
-        </p:nvSpPr>
-        <p:spPr>
-          <a:xfrm>
-            <a:off x="6537960" y="3749040"/>
-            <a:ext cx="3566160" cy="402336"/>
-          </a:xfrm>
-          <a:prstGeom prst="rect">
-            <a:avLst/>
-          </a:prstGeom>
-          <a:noFill/>
-          <a:ln>
-            <a:noFill/>
-          </a:ln>
-        </p:spPr>
-        <p:txBody>
-          <a:bodyPr spcFirstLastPara="1" wrap="square" lIns="0" tIns="0" rIns="0" bIns="0" anchor="ctr" anchorCtr="0">
-            <a:noAutofit/>
-          </a:bodyPr>
-          <a:lstStyle/>
-          <a:p>
-            <a:pPr marL="0" marR="0" lvl="0" indent="0" algn="l" rtl="0">
-              <a:spcBef>
-                <a:spcPts val="0"/>
-              </a:spcBef>
-              <a:spcAft>
-                <a:spcPts val="0"/>
-              </a:spcAft>
-              <a:buNone/>
-            </a:pPr>
-            <a:r>
-              <a:rPr lang="zh-CN" sz="1100" b="1" i="0" u="none" strike="noStrike" cap="none">
-                <a:solidFill>
-                  <a:srgbClr val="FAF9F6"/>
-                </a:solidFill>
-                <a:latin typeface="Instrument Sans"/>
-                <a:ea typeface="Instrument Sans"/>
-                <a:cs typeface="Instrument Sans"/>
-                <a:sym typeface="Instrument Sans"/>
-              </a:rPr>
-              <a:t>2030年全球AI经济：2.9 + 4.2</a:t>
-            </a:r>
-          </a:p>
-        </p:txBody>
-      </p:sp>
-      <p:sp>
-        <p:nvSpPr>
-          <p:cNvPr id="3015" name="SimReal 3015"/>
-          <p:cNvSpPr txBox="1"/>
-          <p:nvPr/>
-        </p:nvSpPr>
-        <p:spPr>
-          <a:xfrm>
-            <a:off x="10104120" y="3749040"/>
-            <a:ext cx="1353312" cy="402336"/>
-          </a:xfrm>
-          <a:prstGeom prst="rect">
-            <a:avLst/>
-          </a:prstGeom>
-          <a:noFill/>
-          <a:ln>
-            <a:noFill/>
-          </a:ln>
-        </p:spPr>
-        <p:txBody>
-          <a:bodyPr spcFirstLastPara="1" wrap="square" lIns="0" tIns="0" rIns="0" bIns="0" anchor="ctr" anchorCtr="0">
-            <a:noAutofit/>
-          </a:bodyPr>
-          <a:lstStyle/>
-          <a:p>
-            <a:pPr marL="0" marR="0" lvl="0" indent="0" algn="r" rtl="0">
-              <a:spcBef>
-                <a:spcPts val="0"/>
-              </a:spcBef>
-              <a:spcAft>
-                <a:spcPts val="0"/>
-              </a:spcAft>
-              <a:buNone/>
-            </a:pPr>
-            <a:r>
-              <a:rPr lang="zh-CN" sz="1500" b="0" i="0" u="none" strike="noStrike" cap="none">
-                <a:solidFill>
-                  <a:srgbClr val="E27A3F"/>
-                </a:solidFill>
-                <a:latin typeface="Newsreader"/>
-                <a:ea typeface="Newsreader"/>
-                <a:cs typeface="Newsreader"/>
-                <a:sym typeface="Newsreader"/>
-              </a:rPr>
-              <a:t>约7.1万亿美元</a:t>
-            </a:r>
-          </a:p>
-        </p:txBody>
-      </p:sp>
-      <p:sp>
-        <p:nvSpPr>
-          <p:cNvPr id="3016" name="SimReal 3016"/>
-          <p:cNvSpPr txBox="1"/>
-          <p:nvPr/>
-        </p:nvSpPr>
-        <p:spPr>
-          <a:xfrm>
-            <a:off x="6355080" y="4224528"/>
-            <a:ext cx="5285232" cy="182880"/>
-          </a:xfrm>
-          <a:prstGeom prst="rect">
-            <a:avLst/>
-          </a:prstGeom>
-          <a:noFill/>
-          <a:ln>
-            <a:noFill/>
-          </a:ln>
-        </p:spPr>
-        <p:txBody>
-          <a:bodyPr spcFirstLastPara="1" wrap="square" lIns="0" tIns="0" rIns="0" bIns="0" anchor="t" anchorCtr="0">
-            <a:noAutofit/>
-          </a:bodyPr>
-          <a:lstStyle/>
-          <a:p>
-            <a:pPr marL="0" marR="0" lvl="0" indent="0" algn="l" rtl="0">
-              <a:spcBef>
-                <a:spcPts val="0"/>
-              </a:spcBef>
-              <a:spcAft>
-                <a:spcPts val="0"/>
-              </a:spcAft>
-              <a:buNone/>
-            </a:pPr>
-            <a:r>
-              <a:rPr lang="zh-CN" sz="750" b="0" i="0" u="none" strike="noStrike" cap="none">
-                <a:solidFill>
-                  <a:srgbClr val="6E6C66"/>
-                </a:solidFill>
-                <a:latin typeface="Instrument Sans"/>
-                <a:ea typeface="Instrument Sans"/>
-                <a:cs typeface="Instrument Sans"/>
-                <a:sym typeface="Instrument Sans"/>
-              </a:rPr>
-              <a:t>麦肯锡《Agents, robots, and us》（2025年11月）；IMF《世界经济展望》（2026年4月）；美国以外按一半渗透率为推算假设</a:t>
+              <a:t>来源：Menlo Ventures（2026年7月）；黄仁勋，高盛Communacopia大会（2026年9月）；CNBC（2026年2月）；Mechanize；麦肯锡《Agents, robots, and us》（2025年11月）；IMF《世界经济展望》（2026年4月）。5–10%占比、美国以外按一半渗透率为推算假设。</a:t>
             </a:r>
           </a:p>
         </p:txBody>
@@ -25076,7 +25065,7 @@
                 <a:cs typeface="Newsreader"/>
                 <a:sym typeface="Newsreader"/>
               </a:rPr>
-              <a:t>$8.5B→$7T</a:t>
+              <a:t>$8.5B→$150–400B</a:t>
             </a:r>
             <a:endParaRPr sz="1300" b="0" i="0" u="none" strike="noStrike" cap="none" dirty="0">
               <a:solidFill>
@@ -25139,7 +25128,7 @@
                 <a:cs typeface="Instrument Sans"/>
                 <a:sym typeface="Instrument Sans"/>
               </a:rPr>
-              <a:t>向AI实验室出售训练数据和RL环境的50余家公司，年收入合计已达约85亿美元；2030年全球AI经济约7万亿美元/年</a:t>
+              <a:t>向AI实验室出售训练数据和RL环境的50余家公司，年收入合计已达约85亿美元；2030年训练层每年1,500–4,000亿美元，服务7万亿美元的AI经济</a:t>
             </a:r>
             <a:endParaRPr sz="1200" b="0" i="0" u="none" strike="noStrike" cap="none" dirty="0">
               <a:solidFill>

</xml_diff>

<commit_message>
BP v17: cut the new pages down to the numbers and one line each
- market (14): three columns, each a label, one figure and its formula;
  company dates and sources moved to the footnote; one-line takeaway
- raise (17): each comparable in one line; footnote states how 2x and 20x
  are computed
- use of funds (18): each spend line names the formula term it moves
- overview (2): market and round cells shortened to one sentence

Co-Authored-By: Claude Opus 5.5 <noreply@anthropic.com>
Claude-Session: https://claude.ai/code/session_01EKqGwTA92C8Wo4e47t73NN
</commit_message>
<xml_diff>
--- a/SimReal-BP-v17.pptx
+++ b/SimReal-BP-v17.pptx
@@ -12707,7 +12707,7 @@
                 <a:cs typeface="Newsreader"/>
                 <a:sym typeface="Newsreader"/>
               </a:rPr>
-              <a:t>2030年：</a:t>
+              <a:t>2030年：AI经济</a:t>
             </a:r>
             <a:r>
               <a:rPr lang="zh-CN" sz="2800" b="0" i="0" u="none" strike="noStrike" cap="none">
@@ -12731,7 +12731,7 @@
                 <a:cs typeface="Newsreader"/>
                 <a:sym typeface="Newsreader"/>
               </a:rPr>
-              <a:t>的AI经济，数千亿美元的训练市场</a:t>
+              <a:t>，训练市场数千亿美元</a:t>
             </a:r>
           </a:p>
         </p:txBody>
@@ -12907,7 +12907,7 @@
                 <a:cs typeface="IBM Plex Mono"/>
                 <a:sym typeface="IBM Plex Mono"/>
               </a:rPr>
-              <a:t>今天 · 实验室已经在付费</a:t>
+              <a:t>今天 · 实验室在买</a:t>
             </a:r>
           </a:p>
         </p:txBody>
@@ -12969,8 +12969,790 @@
         </p:nvSpPr>
         <p:spPr>
           <a:xfrm>
-            <a:off x="548640" y="2468880"/>
-            <a:ext cx="3514344" cy="457200"/>
+            <a:off x="548640" y="2487168"/>
+            <a:ext cx="3514344" cy="274320"/>
+          </a:xfrm>
+          <a:prstGeom prst="rect">
+            <a:avLst/>
+          </a:prstGeom>
+          <a:noFill/>
+          <a:ln>
+            <a:noFill/>
+          </a:ln>
+        </p:spPr>
+        <p:txBody>
+          <a:bodyPr spcFirstLastPara="1" wrap="square" lIns="0" tIns="0" rIns="0" bIns="0" anchor="t" anchorCtr="0">
+            <a:noAutofit/>
+          </a:bodyPr>
+          <a:lstStyle/>
+          <a:p>
+            <a:pPr marL="0" marR="0" lvl="0" indent="0" algn="l" rtl="0">
+              <a:spcBef>
+                <a:spcPts val="0"/>
+              </a:spcBef>
+              <a:spcAft>
+                <a:spcPts val="0"/>
+              </a:spcAft>
+              <a:buNone/>
+            </a:pPr>
+            <a:r>
+              <a:rPr lang="zh-CN" sz="1100" b="0" i="0" u="none" strike="noStrike" cap="none">
+                <a:solidFill>
+                  <a:srgbClr val="33322F"/>
+                </a:solidFill>
+                <a:latin typeface="Instrument Sans"/>
+                <a:ea typeface="Instrument Sans"/>
+                <a:cs typeface="Instrument Sans"/>
+                <a:sym typeface="Instrument Sans"/>
+              </a:rPr>
+              <a:t>训练数据与RL环境，50余家供应商合计</a:t>
+            </a:r>
+          </a:p>
+        </p:txBody>
+      </p:sp>
+      <p:sp>
+        <p:nvSpPr>
+          <p:cNvPr id="3009" name="SimReal 3009"/>
+          <p:cNvSpPr txBox="1"/>
+          <p:nvPr/>
+        </p:nvSpPr>
+        <p:spPr>
+          <a:xfrm>
+            <a:off x="548640" y="2962656"/>
+            <a:ext cx="1051560" cy="274320"/>
+          </a:xfrm>
+          <a:prstGeom prst="rect">
+            <a:avLst/>
+          </a:prstGeom>
+          <a:noFill/>
+          <a:ln>
+            <a:noFill/>
+          </a:ln>
+        </p:spPr>
+        <p:txBody>
+          <a:bodyPr spcFirstLastPara="1" wrap="square" lIns="0" tIns="0" rIns="0" bIns="0" anchor="ctr" anchorCtr="0">
+            <a:noAutofit/>
+          </a:bodyPr>
+          <a:lstStyle/>
+          <a:p>
+            <a:pPr marL="0" marR="0" lvl="0" indent="0" algn="l" rtl="0">
+              <a:spcBef>
+                <a:spcPts val="0"/>
+              </a:spcBef>
+              <a:spcAft>
+                <a:spcPts val="0"/>
+              </a:spcAft>
+              <a:buNone/>
+            </a:pPr>
+            <a:r>
+              <a:rPr lang="zh-CN" sz="1200" b="0" i="0" u="none" strike="noStrike" cap="none">
+                <a:solidFill>
+                  <a:srgbClr val="111110"/>
+                </a:solidFill>
+                <a:latin typeface="Newsreader"/>
+                <a:ea typeface="Newsreader"/>
+                <a:cs typeface="Newsreader"/>
+                <a:sym typeface="Newsreader"/>
+              </a:rPr>
+              <a:t>Mercor</a:t>
+            </a:r>
+          </a:p>
+        </p:txBody>
+      </p:sp>
+      <p:sp>
+        <p:nvSpPr>
+          <p:cNvPr id="3010" name="SimReal 3010"/>
+          <p:cNvSpPr/>
+          <p:nvPr/>
+        </p:nvSpPr>
+        <p:spPr>
+          <a:xfrm>
+            <a:off x="1600200" y="2990088"/>
+            <a:ext cx="1691640" cy="219456"/>
+          </a:xfrm>
+          <a:prstGeom prst="rect">
+            <a:avLst/>
+          </a:prstGeom>
+          <a:solidFill>
+            <a:srgbClr val="111110"/>
+          </a:solidFill>
+          <a:ln>
+            <a:noFill/>
+          </a:ln>
+        </p:spPr>
+        <p:txBody>
+          <a:bodyPr/>
+          <a:lstStyle/>
+          <a:p>
+            <a:endParaRPr/>
+          </a:p>
+        </p:txBody>
+      </p:sp>
+      <p:sp>
+        <p:nvSpPr>
+          <p:cNvPr id="3011" name="SimReal 3011"/>
+          <p:cNvSpPr txBox="1"/>
+          <p:nvPr/>
+        </p:nvSpPr>
+        <p:spPr>
+          <a:xfrm>
+            <a:off x="3364992" y="2962656"/>
+            <a:ext cx="822960" cy="274320"/>
+          </a:xfrm>
+          <a:prstGeom prst="rect">
+            <a:avLst/>
+          </a:prstGeom>
+          <a:noFill/>
+          <a:ln>
+            <a:noFill/>
+          </a:ln>
+        </p:spPr>
+        <p:txBody>
+          <a:bodyPr spcFirstLastPara="1" wrap="square" lIns="0" tIns="0" rIns="0" bIns="0" anchor="ctr" anchorCtr="0">
+            <a:noAutofit/>
+          </a:bodyPr>
+          <a:lstStyle/>
+          <a:p>
+            <a:pPr marL="0" marR="0" lvl="0" indent="0" algn="l" rtl="0">
+              <a:spcBef>
+                <a:spcPts val="0"/>
+              </a:spcBef>
+              <a:spcAft>
+                <a:spcPts val="0"/>
+              </a:spcAft>
+              <a:buNone/>
+            </a:pPr>
+            <a:r>
+              <a:rPr lang="zh-CN" sz="1100" b="0" i="0" u="none" strike="noStrike" cap="none">
+                <a:solidFill>
+                  <a:srgbClr val="111110"/>
+                </a:solidFill>
+                <a:latin typeface="Instrument Sans"/>
+                <a:ea typeface="Instrument Sans"/>
+                <a:cs typeface="Instrument Sans"/>
+                <a:sym typeface="Instrument Sans"/>
+              </a:rPr>
+              <a:t>$2.0B</a:t>
+            </a:r>
+          </a:p>
+        </p:txBody>
+      </p:sp>
+      <p:sp>
+        <p:nvSpPr>
+          <p:cNvPr id="3012" name="SimReal 3012"/>
+          <p:cNvSpPr txBox="1"/>
+          <p:nvPr/>
+        </p:nvSpPr>
+        <p:spPr>
+          <a:xfrm>
+            <a:off x="548640" y="3364992"/>
+            <a:ext cx="1051560" cy="274320"/>
+          </a:xfrm>
+          <a:prstGeom prst="rect">
+            <a:avLst/>
+          </a:prstGeom>
+          <a:noFill/>
+          <a:ln>
+            <a:noFill/>
+          </a:ln>
+        </p:spPr>
+        <p:txBody>
+          <a:bodyPr spcFirstLastPara="1" wrap="square" lIns="0" tIns="0" rIns="0" bIns="0" anchor="ctr" anchorCtr="0">
+            <a:noAutofit/>
+          </a:bodyPr>
+          <a:lstStyle/>
+          <a:p>
+            <a:pPr marL="0" marR="0" lvl="0" indent="0" algn="l" rtl="0">
+              <a:spcBef>
+                <a:spcPts val="0"/>
+              </a:spcBef>
+              <a:spcAft>
+                <a:spcPts val="0"/>
+              </a:spcAft>
+              <a:buNone/>
+            </a:pPr>
+            <a:r>
+              <a:rPr lang="zh-CN" sz="1200" b="0" i="0" u="none" strike="noStrike" cap="none">
+                <a:solidFill>
+                  <a:srgbClr val="111110"/>
+                </a:solidFill>
+                <a:latin typeface="Newsreader"/>
+                <a:ea typeface="Newsreader"/>
+                <a:cs typeface="Newsreader"/>
+                <a:sym typeface="Newsreader"/>
+              </a:rPr>
+              <a:t>Surge AI</a:t>
+            </a:r>
+          </a:p>
+        </p:txBody>
+      </p:sp>
+      <p:sp>
+        <p:nvSpPr>
+          <p:cNvPr id="3013" name="SimReal 3013"/>
+          <p:cNvSpPr/>
+          <p:nvPr/>
+        </p:nvSpPr>
+        <p:spPr>
+          <a:xfrm>
+            <a:off x="1600200" y="3392424"/>
+            <a:ext cx="1014984" cy="219456"/>
+          </a:xfrm>
+          <a:prstGeom prst="rect">
+            <a:avLst/>
+          </a:prstGeom>
+          <a:solidFill>
+            <a:srgbClr val="C4C0B7"/>
+          </a:solidFill>
+          <a:ln>
+            <a:noFill/>
+          </a:ln>
+        </p:spPr>
+        <p:txBody>
+          <a:bodyPr/>
+          <a:lstStyle/>
+          <a:p>
+            <a:endParaRPr/>
+          </a:p>
+        </p:txBody>
+      </p:sp>
+      <p:sp>
+        <p:nvSpPr>
+          <p:cNvPr id="3014" name="SimReal 3014"/>
+          <p:cNvSpPr txBox="1"/>
+          <p:nvPr/>
+        </p:nvSpPr>
+        <p:spPr>
+          <a:xfrm>
+            <a:off x="2688336" y="3364992"/>
+            <a:ext cx="822960" cy="274320"/>
+          </a:xfrm>
+          <a:prstGeom prst="rect">
+            <a:avLst/>
+          </a:prstGeom>
+          <a:noFill/>
+          <a:ln>
+            <a:noFill/>
+          </a:ln>
+        </p:spPr>
+        <p:txBody>
+          <a:bodyPr spcFirstLastPara="1" wrap="square" lIns="0" tIns="0" rIns="0" bIns="0" anchor="ctr" anchorCtr="0">
+            <a:noAutofit/>
+          </a:bodyPr>
+          <a:lstStyle/>
+          <a:p>
+            <a:pPr marL="0" marR="0" lvl="0" indent="0" algn="l" rtl="0">
+              <a:spcBef>
+                <a:spcPts val="0"/>
+              </a:spcBef>
+              <a:spcAft>
+                <a:spcPts val="0"/>
+              </a:spcAft>
+              <a:buNone/>
+            </a:pPr>
+            <a:r>
+              <a:rPr lang="zh-CN" sz="1100" b="0" i="0" u="none" strike="noStrike" cap="none">
+                <a:solidFill>
+                  <a:srgbClr val="111110"/>
+                </a:solidFill>
+                <a:latin typeface="Instrument Sans"/>
+                <a:ea typeface="Instrument Sans"/>
+                <a:cs typeface="Instrument Sans"/>
+                <a:sym typeface="Instrument Sans"/>
+              </a:rPr>
+              <a:t>$1.2B</a:t>
+            </a:r>
+          </a:p>
+        </p:txBody>
+      </p:sp>
+      <p:sp>
+        <p:nvSpPr>
+          <p:cNvPr id="3015" name="SimReal 3015"/>
+          <p:cNvSpPr txBox="1"/>
+          <p:nvPr/>
+        </p:nvSpPr>
+        <p:spPr>
+          <a:xfrm>
+            <a:off x="548640" y="3767328"/>
+            <a:ext cx="1051560" cy="274320"/>
+          </a:xfrm>
+          <a:prstGeom prst="rect">
+            <a:avLst/>
+          </a:prstGeom>
+          <a:noFill/>
+          <a:ln>
+            <a:noFill/>
+          </a:ln>
+        </p:spPr>
+        <p:txBody>
+          <a:bodyPr spcFirstLastPara="1" wrap="square" lIns="0" tIns="0" rIns="0" bIns="0" anchor="ctr" anchorCtr="0">
+            <a:noAutofit/>
+          </a:bodyPr>
+          <a:lstStyle/>
+          <a:p>
+            <a:pPr marL="0" marR="0" lvl="0" indent="0" algn="l" rtl="0">
+              <a:spcBef>
+                <a:spcPts val="0"/>
+              </a:spcBef>
+              <a:spcAft>
+                <a:spcPts val="0"/>
+              </a:spcAft>
+              <a:buNone/>
+            </a:pPr>
+            <a:r>
+              <a:rPr lang="zh-CN" sz="1200" b="0" i="0" u="none" strike="noStrike" cap="none">
+                <a:solidFill>
+                  <a:srgbClr val="111110"/>
+                </a:solidFill>
+                <a:latin typeface="Newsreader"/>
+                <a:ea typeface="Newsreader"/>
+                <a:cs typeface="Newsreader"/>
+                <a:sym typeface="Newsreader"/>
+              </a:rPr>
+              <a:t>Snorkel AI</a:t>
+            </a:r>
+          </a:p>
+        </p:txBody>
+      </p:sp>
+      <p:sp>
+        <p:nvSpPr>
+          <p:cNvPr id="3016" name="SimReal 3016"/>
+          <p:cNvSpPr/>
+          <p:nvPr/>
+        </p:nvSpPr>
+        <p:spPr>
+          <a:xfrm>
+            <a:off x="1600200" y="3794760"/>
+            <a:ext cx="317183" cy="219456"/>
+          </a:xfrm>
+          <a:prstGeom prst="rect">
+            <a:avLst/>
+          </a:prstGeom>
+          <a:solidFill>
+            <a:srgbClr val="C4C0B7"/>
+          </a:solidFill>
+          <a:ln>
+            <a:noFill/>
+          </a:ln>
+        </p:spPr>
+        <p:txBody>
+          <a:bodyPr/>
+          <a:lstStyle/>
+          <a:p>
+            <a:endParaRPr/>
+          </a:p>
+        </p:txBody>
+      </p:sp>
+      <p:sp>
+        <p:nvSpPr>
+          <p:cNvPr id="3017" name="SimReal 3017"/>
+          <p:cNvSpPr txBox="1"/>
+          <p:nvPr/>
+        </p:nvSpPr>
+        <p:spPr>
+          <a:xfrm>
+            <a:off x="1990534" y="3767328"/>
+            <a:ext cx="822960" cy="274320"/>
+          </a:xfrm>
+          <a:prstGeom prst="rect">
+            <a:avLst/>
+          </a:prstGeom>
+          <a:noFill/>
+          <a:ln>
+            <a:noFill/>
+          </a:ln>
+        </p:spPr>
+        <p:txBody>
+          <a:bodyPr spcFirstLastPara="1" wrap="square" lIns="0" tIns="0" rIns="0" bIns="0" anchor="ctr" anchorCtr="0">
+            <a:noAutofit/>
+          </a:bodyPr>
+          <a:lstStyle/>
+          <a:p>
+            <a:pPr marL="0" marR="0" lvl="0" indent="0" algn="l" rtl="0">
+              <a:spcBef>
+                <a:spcPts val="0"/>
+              </a:spcBef>
+              <a:spcAft>
+                <a:spcPts val="0"/>
+              </a:spcAft>
+              <a:buNone/>
+            </a:pPr>
+            <a:r>
+              <a:rPr lang="zh-CN" sz="1100" b="0" i="0" u="none" strike="noStrike" cap="none">
+                <a:solidFill>
+                  <a:srgbClr val="111110"/>
+                </a:solidFill>
+                <a:latin typeface="Instrument Sans"/>
+                <a:ea typeface="Instrument Sans"/>
+                <a:cs typeface="Instrument Sans"/>
+                <a:sym typeface="Instrument Sans"/>
+              </a:rPr>
+              <a:t>$0.375B</a:t>
+            </a:r>
+          </a:p>
+        </p:txBody>
+      </p:sp>
+      <p:sp>
+        <p:nvSpPr>
+          <p:cNvPr id="3018" name="SimReal 3018"/>
+          <p:cNvSpPr/>
+          <p:nvPr/>
+        </p:nvSpPr>
+        <p:spPr>
+          <a:xfrm>
+            <a:off x="4337304" y="1481328"/>
+            <a:ext cx="3514344" cy="27432"/>
+          </a:xfrm>
+          <a:prstGeom prst="rect">
+            <a:avLst/>
+          </a:prstGeom>
+          <a:solidFill>
+            <a:srgbClr val="C2410C"/>
+          </a:solidFill>
+          <a:ln>
+            <a:noFill/>
+          </a:ln>
+        </p:spPr>
+        <p:txBody>
+          <a:bodyPr/>
+          <a:lstStyle/>
+          <a:p>
+            <a:endParaRPr/>
+          </a:p>
+        </p:txBody>
+      </p:sp>
+      <p:sp>
+        <p:nvSpPr>
+          <p:cNvPr id="3019" name="SimReal 3019"/>
+          <p:cNvSpPr txBox="1"/>
+          <p:nvPr/>
+        </p:nvSpPr>
+        <p:spPr>
+          <a:xfrm>
+            <a:off x="4337304" y="1609344"/>
+            <a:ext cx="3514344" cy="201168"/>
+          </a:xfrm>
+          <a:prstGeom prst="rect">
+            <a:avLst/>
+          </a:prstGeom>
+          <a:noFill/>
+          <a:ln>
+            <a:noFill/>
+          </a:ln>
+        </p:spPr>
+        <p:txBody>
+          <a:bodyPr spcFirstLastPara="1" wrap="square" lIns="0" tIns="0" rIns="0" bIns="0" anchor="t" anchorCtr="0">
+            <a:noAutofit/>
+          </a:bodyPr>
+          <a:lstStyle/>
+          <a:p>
+            <a:pPr marL="0" marR="0" lvl="0" indent="0" algn="l" rtl="0">
+              <a:spcBef>
+                <a:spcPts val="0"/>
+              </a:spcBef>
+              <a:spcAft>
+                <a:spcPts val="0"/>
+              </a:spcAft>
+              <a:buNone/>
+            </a:pPr>
+            <a:r>
+              <a:rPr lang="zh-CN" sz="1000" b="0" i="0" u="none" strike="noStrike" cap="none">
+                <a:solidFill>
+                  <a:srgbClr val="C2410C"/>
+                </a:solidFill>
+                <a:latin typeface="IBM Plex Mono"/>
+                <a:ea typeface="IBM Plex Mono"/>
+                <a:cs typeface="IBM Plex Mono"/>
+                <a:sym typeface="IBM Plex Mono"/>
+              </a:rPr>
+              <a:t>2030年 · 我们的市场</a:t>
+            </a:r>
+          </a:p>
+        </p:txBody>
+      </p:sp>
+      <p:sp>
+        <p:nvSpPr>
+          <p:cNvPr id="3020" name="SimReal 3020"/>
+          <p:cNvSpPr txBox="1"/>
+          <p:nvPr/>
+        </p:nvSpPr>
+        <p:spPr>
+          <a:xfrm>
+            <a:off x="4337304" y="1865376"/>
+            <a:ext cx="3514344" cy="548640"/>
+          </a:xfrm>
+          <a:prstGeom prst="rect">
+            <a:avLst/>
+          </a:prstGeom>
+          <a:noFill/>
+          <a:ln>
+            <a:noFill/>
+          </a:ln>
+        </p:spPr>
+        <p:txBody>
+          <a:bodyPr spcFirstLastPara="1" wrap="square" lIns="0" tIns="0" rIns="0" bIns="0" anchor="ctr" anchorCtr="0">
+            <a:noAutofit/>
+          </a:bodyPr>
+          <a:lstStyle/>
+          <a:p>
+            <a:pPr marL="0" marR="0" lvl="0" indent="0" algn="l" rtl="0">
+              <a:spcBef>
+                <a:spcPts val="0"/>
+              </a:spcBef>
+              <a:spcAft>
+                <a:spcPts val="0"/>
+              </a:spcAft>
+              <a:buNone/>
+            </a:pPr>
+            <a:r>
+              <a:rPr lang="zh-CN" sz="2400" b="0" i="0" u="none" strike="noStrike" cap="none">
+                <a:solidFill>
+                  <a:srgbClr val="C2410C"/>
+                </a:solidFill>
+                <a:latin typeface="Newsreader"/>
+                <a:ea typeface="Newsreader"/>
+                <a:cs typeface="Newsreader"/>
+                <a:sym typeface="Newsreader"/>
+              </a:rPr>
+              <a:t>1,500–4,000亿美元/年</a:t>
+            </a:r>
+          </a:p>
+        </p:txBody>
+      </p:sp>
+      <p:sp>
+        <p:nvSpPr>
+          <p:cNvPr id="3021" name="SimReal 3021"/>
+          <p:cNvSpPr txBox="1"/>
+          <p:nvPr/>
+        </p:nvSpPr>
+        <p:spPr>
+          <a:xfrm>
+            <a:off x="4337304" y="2505456"/>
+            <a:ext cx="2325624" cy="365760"/>
+          </a:xfrm>
+          <a:prstGeom prst="rect">
+            <a:avLst/>
+          </a:prstGeom>
+          <a:noFill/>
+          <a:ln>
+            <a:noFill/>
+          </a:ln>
+        </p:spPr>
+        <p:txBody>
+          <a:bodyPr spcFirstLastPara="1" wrap="square" lIns="0" tIns="0" rIns="0" bIns="0" anchor="ctr" anchorCtr="0">
+            <a:noAutofit/>
+          </a:bodyPr>
+          <a:lstStyle/>
+          <a:p>
+            <a:pPr marL="0" marR="0" lvl="0" indent="0" algn="l" rtl="0">
+              <a:spcBef>
+                <a:spcPts val="0"/>
+              </a:spcBef>
+              <a:spcAft>
+                <a:spcPts val="0"/>
+              </a:spcAft>
+              <a:buNone/>
+            </a:pPr>
+            <a:r>
+              <a:rPr lang="zh-CN" sz="1100" b="0" i="0" u="none" strike="noStrike" cap="none">
+                <a:solidFill>
+                  <a:srgbClr val="33322F"/>
+                </a:solidFill>
+                <a:latin typeface="Instrument Sans"/>
+                <a:ea typeface="Instrument Sans"/>
+                <a:cs typeface="Instrument Sans"/>
+                <a:sym typeface="Instrument Sans"/>
+              </a:rPr>
+              <a:t>AI基础设施支出</a:t>
+            </a:r>
+          </a:p>
+        </p:txBody>
+      </p:sp>
+      <p:sp>
+        <p:nvSpPr>
+          <p:cNvPr id="3022" name="SimReal 3022"/>
+          <p:cNvSpPr txBox="1"/>
+          <p:nvPr/>
+        </p:nvSpPr>
+        <p:spPr>
+          <a:xfrm>
+            <a:off x="6662928" y="2505456"/>
+            <a:ext cx="1188720" cy="365760"/>
+          </a:xfrm>
+          <a:prstGeom prst="rect">
+            <a:avLst/>
+          </a:prstGeom>
+          <a:noFill/>
+          <a:ln>
+            <a:noFill/>
+          </a:ln>
+        </p:spPr>
+        <p:txBody>
+          <a:bodyPr spcFirstLastPara="1" wrap="square" lIns="0" tIns="0" rIns="0" bIns="0" anchor="ctr" anchorCtr="0">
+            <a:noAutofit/>
+          </a:bodyPr>
+          <a:lstStyle/>
+          <a:p>
+            <a:pPr marL="0" marR="0" lvl="0" indent="0" algn="r" rtl="0">
+              <a:spcBef>
+                <a:spcPts val="0"/>
+              </a:spcBef>
+              <a:spcAft>
+                <a:spcPts val="0"/>
+              </a:spcAft>
+              <a:buNone/>
+            </a:pPr>
+            <a:r>
+              <a:rPr lang="zh-CN" sz="1400" b="0" i="0" u="none" strike="noStrike" cap="none">
+                <a:solidFill>
+                  <a:srgbClr val="111110"/>
+                </a:solidFill>
+                <a:latin typeface="Newsreader"/>
+                <a:ea typeface="Newsreader"/>
+                <a:cs typeface="Newsreader"/>
+                <a:sym typeface="Newsreader"/>
+              </a:rPr>
+              <a:t>3–4万亿美元</a:t>
+            </a:r>
+          </a:p>
+        </p:txBody>
+      </p:sp>
+      <p:sp>
+        <p:nvSpPr>
+          <p:cNvPr id="3023" name="SimReal 3023"/>
+          <p:cNvSpPr/>
+          <p:nvPr/>
+        </p:nvSpPr>
+        <p:spPr>
+          <a:xfrm>
+            <a:off x="4337304" y="2871216"/>
+            <a:ext cx="3514344" cy="9144"/>
+          </a:xfrm>
+          <a:prstGeom prst="rect">
+            <a:avLst/>
+          </a:prstGeom>
+          <a:solidFill>
+            <a:srgbClr val="E2E0DA"/>
+          </a:solidFill>
+          <a:ln>
+            <a:noFill/>
+          </a:ln>
+        </p:spPr>
+        <p:txBody>
+          <a:bodyPr/>
+          <a:lstStyle/>
+          <a:p>
+            <a:endParaRPr/>
+          </a:p>
+        </p:txBody>
+      </p:sp>
+      <p:sp>
+        <p:nvSpPr>
+          <p:cNvPr id="3024" name="SimReal 3024"/>
+          <p:cNvSpPr txBox="1"/>
+          <p:nvPr/>
+        </p:nvSpPr>
+        <p:spPr>
+          <a:xfrm>
+            <a:off x="4337304" y="2871216"/>
+            <a:ext cx="2325624" cy="365760"/>
+          </a:xfrm>
+          <a:prstGeom prst="rect">
+            <a:avLst/>
+          </a:prstGeom>
+          <a:noFill/>
+          <a:ln>
+            <a:noFill/>
+          </a:ln>
+        </p:spPr>
+        <p:txBody>
+          <a:bodyPr spcFirstLastPara="1" wrap="square" lIns="0" tIns="0" rIns="0" bIns="0" anchor="ctr" anchorCtr="0">
+            <a:noAutofit/>
+          </a:bodyPr>
+          <a:lstStyle/>
+          <a:p>
+            <a:pPr marL="0" marR="0" lvl="0" indent="0" algn="l" rtl="0">
+              <a:spcBef>
+                <a:spcPts val="0"/>
+              </a:spcBef>
+              <a:spcAft>
+                <a:spcPts val="0"/>
+              </a:spcAft>
+              <a:buNone/>
+            </a:pPr>
+            <a:r>
+              <a:rPr lang="zh-CN" sz="1100" b="0" i="0" u="none" strike="noStrike" cap="none">
+                <a:solidFill>
+                  <a:srgbClr val="33322F"/>
+                </a:solidFill>
+                <a:latin typeface="Instrument Sans"/>
+                <a:ea typeface="Instrument Sans"/>
+                <a:cs typeface="Instrument Sans"/>
+                <a:sym typeface="Instrument Sans"/>
+              </a:rPr>
+              <a:t>× 训练层占比</a:t>
+            </a:r>
+          </a:p>
+        </p:txBody>
+      </p:sp>
+      <p:sp>
+        <p:nvSpPr>
+          <p:cNvPr id="3025" name="SimReal 3025"/>
+          <p:cNvSpPr txBox="1"/>
+          <p:nvPr/>
+        </p:nvSpPr>
+        <p:spPr>
+          <a:xfrm>
+            <a:off x="6662928" y="2871216"/>
+            <a:ext cx="1188720" cy="365760"/>
+          </a:xfrm>
+          <a:prstGeom prst="rect">
+            <a:avLst/>
+          </a:prstGeom>
+          <a:noFill/>
+          <a:ln>
+            <a:noFill/>
+          </a:ln>
+        </p:spPr>
+        <p:txBody>
+          <a:bodyPr spcFirstLastPara="1" wrap="square" lIns="0" tIns="0" rIns="0" bIns="0" anchor="ctr" anchorCtr="0">
+            <a:noAutofit/>
+          </a:bodyPr>
+          <a:lstStyle/>
+          <a:p>
+            <a:pPr marL="0" marR="0" lvl="0" indent="0" algn="r" rtl="0">
+              <a:spcBef>
+                <a:spcPts val="0"/>
+              </a:spcBef>
+              <a:spcAft>
+                <a:spcPts val="0"/>
+              </a:spcAft>
+              <a:buNone/>
+            </a:pPr>
+            <a:r>
+              <a:rPr lang="zh-CN" sz="1400" b="0" i="0" u="none" strike="noStrike" cap="none">
+                <a:solidFill>
+                  <a:srgbClr val="111110"/>
+                </a:solidFill>
+                <a:latin typeface="Newsreader"/>
+                <a:ea typeface="Newsreader"/>
+                <a:cs typeface="Newsreader"/>
+                <a:sym typeface="Newsreader"/>
+              </a:rPr>
+              <a:t>5–10%</a:t>
+            </a:r>
+          </a:p>
+        </p:txBody>
+      </p:sp>
+      <p:sp>
+        <p:nvSpPr>
+          <p:cNvPr id="3026" name="SimReal 3026"/>
+          <p:cNvSpPr txBox="1"/>
+          <p:nvPr/>
+        </p:nvSpPr>
+        <p:spPr>
+          <a:xfrm>
+            <a:off x="4337304" y="3328416"/>
+            <a:ext cx="3514344" cy="548640"/>
           </a:xfrm>
           <a:prstGeom prst="rect">
             <a:avLst/>
@@ -13008,21 +13790,50 @@
                 <a:cs typeface="Instrument Sans"/>
                 <a:sym typeface="Instrument Sans"/>
               </a:rPr>
-              <a:t>50余家公司向AI实验室出售训练数据和RL环境的年收入合计</a:t>
-            </a:r>
-          </a:p>
-        </p:txBody>
-      </p:sp>
-      <p:sp>
-        <p:nvSpPr>
-          <p:cNvPr id="3009" name="SimReal 3009"/>
+              <a:t>今天约1%。数据与算力互补：算力越多，训练越值钱。</a:t>
+            </a:r>
+          </a:p>
+        </p:txBody>
+      </p:sp>
+      <p:sp>
+        <p:nvSpPr>
+          <p:cNvPr id="3027" name="SimReal 3027"/>
+          <p:cNvSpPr/>
+          <p:nvPr/>
+        </p:nvSpPr>
+        <p:spPr>
+          <a:xfrm>
+            <a:off x="8125968" y="1481328"/>
+            <a:ext cx="3514344" cy="3383280"/>
+          </a:xfrm>
+          <a:prstGeom prst="rect">
+            <a:avLst/>
+          </a:prstGeom>
+          <a:solidFill>
+            <a:srgbClr val="111110"/>
+          </a:solidFill>
+          <a:ln>
+            <a:noFill/>
+          </a:ln>
+        </p:spPr>
+        <p:txBody>
+          <a:bodyPr/>
+          <a:lstStyle/>
+          <a:p>
+            <a:endParaRPr/>
+          </a:p>
+        </p:txBody>
+      </p:sp>
+      <p:sp>
+        <p:nvSpPr>
+          <p:cNvPr id="3028" name="SimReal 3028"/>
           <p:cNvSpPr txBox="1"/>
           <p:nvPr/>
         </p:nvSpPr>
         <p:spPr>
           <a:xfrm>
-            <a:off x="548640" y="3163824"/>
-            <a:ext cx="1097280" cy="237744"/>
+            <a:off x="8363712" y="1609344"/>
+            <a:ext cx="3038856" cy="201168"/>
           </a:xfrm>
           <a:prstGeom prst="rect">
             <a:avLst/>
@@ -13048,41 +13859,90 @@
               <a:buNone/>
             </a:pPr>
             <a:r>
-              <a:rPr lang="zh-CN" sz="1200" b="0" i="0" u="none" strike="noStrike" cap="none">
-                <a:solidFill>
-                  <a:srgbClr val="111110"/>
+              <a:rPr lang="zh-CN" sz="1000" b="0" i="0" u="none" strike="noStrike" cap="none">
+                <a:solidFill>
+                  <a:srgbClr val="E27A3F"/>
+                </a:solidFill>
+                <a:latin typeface="IBM Plex Mono"/>
+                <a:ea typeface="IBM Plex Mono"/>
+                <a:cs typeface="IBM Plex Mono"/>
+                <a:sym typeface="IBM Plex Mono"/>
+              </a:rPr>
+              <a:t>2030年 · AI经济</a:t>
+            </a:r>
+          </a:p>
+        </p:txBody>
+      </p:sp>
+      <p:sp>
+        <p:nvSpPr>
+          <p:cNvPr id="3029" name="SimReal 3029"/>
+          <p:cNvSpPr txBox="1"/>
+          <p:nvPr/>
+        </p:nvSpPr>
+        <p:spPr>
+          <a:xfrm>
+            <a:off x="8363712" y="1865376"/>
+            <a:ext cx="3038856" cy="548640"/>
+          </a:xfrm>
+          <a:prstGeom prst="rect">
+            <a:avLst/>
+          </a:prstGeom>
+          <a:noFill/>
+          <a:ln>
+            <a:noFill/>
+          </a:ln>
+        </p:spPr>
+        <p:txBody>
+          <a:bodyPr spcFirstLastPara="1" wrap="square" lIns="0" tIns="0" rIns="0" bIns="0" anchor="t" anchorCtr="0">
+            <a:noAutofit/>
+          </a:bodyPr>
+          <a:lstStyle/>
+          <a:p>
+            <a:pPr marL="0" marR="0" lvl="0" indent="0" algn="l" rtl="0">
+              <a:spcBef>
+                <a:spcPts val="0"/>
+              </a:spcBef>
+              <a:spcAft>
+                <a:spcPts val="0"/>
+              </a:spcAft>
+              <a:buNone/>
+            </a:pPr>
+            <a:r>
+              <a:rPr lang="zh-CN" sz="2800" b="0" i="0" u="none" strike="noStrike" cap="none">
+                <a:solidFill>
+                  <a:srgbClr val="E27A3F"/>
                 </a:solidFill>
                 <a:latin typeface="Newsreader"/>
                 <a:ea typeface="Newsreader"/>
                 <a:cs typeface="Newsreader"/>
                 <a:sym typeface="Newsreader"/>
               </a:rPr>
-              <a:t>Mercor</a:t>
-            </a:r>
-          </a:p>
-        </p:txBody>
-      </p:sp>
-      <p:sp>
-        <p:nvSpPr>
-          <p:cNvPr id="3010" name="SimReal 3010"/>
+              <a:t>约7万亿美元/年</a:t>
+            </a:r>
+          </a:p>
+        </p:txBody>
+      </p:sp>
+      <p:sp>
+        <p:nvSpPr>
+          <p:cNvPr id="3030" name="SimReal 3030"/>
           <p:cNvSpPr txBox="1"/>
           <p:nvPr/>
         </p:nvSpPr>
         <p:spPr>
           <a:xfrm>
-            <a:off x="548640" y="3392424"/>
-            <a:ext cx="1097280" cy="182880"/>
-          </a:xfrm>
-          <a:prstGeom prst="rect">
-            <a:avLst/>
-          </a:prstGeom>
-          <a:noFill/>
-          <a:ln>
-            <a:noFill/>
-          </a:ln>
-        </p:spPr>
-        <p:txBody>
-          <a:bodyPr spcFirstLastPara="1" wrap="square" lIns="0" tIns="0" rIns="0" bIns="0" anchor="t" anchorCtr="0">
+            <a:off x="8363712" y="2505456"/>
+            <a:ext cx="1850136" cy="365760"/>
+          </a:xfrm>
+          <a:prstGeom prst="rect">
+            <a:avLst/>
+          </a:prstGeom>
+          <a:noFill/>
+          <a:ln>
+            <a:noFill/>
+          </a:ln>
+        </p:spPr>
+        <p:txBody>
+          <a:bodyPr spcFirstLastPara="1" wrap="square" lIns="0" tIns="0" rIns="0" bIns="0" anchor="ctr" anchorCtr="0">
             <a:noAutofit/>
           </a:bodyPr>
           <a:lstStyle/>
@@ -13097,59 +13957,30 @@
               <a:buNone/>
             </a:pPr>
             <a:r>
-              <a:rPr lang="zh-CN" sz="750" b="0" i="0" u="none" strike="noStrike" cap="none">
-                <a:solidFill>
-                  <a:srgbClr val="6E6C66"/>
+              <a:rPr lang="zh-CN" sz="1100" b="0" i="0" u="none" strike="noStrike" cap="none">
+                <a:solidFill>
+                  <a:srgbClr val="C4C0B7"/>
                 </a:solidFill>
                 <a:latin typeface="Instrument Sans"/>
                 <a:ea typeface="Instrument Sans"/>
                 <a:cs typeface="Instrument Sans"/>
                 <a:sym typeface="Instrument Sans"/>
               </a:rPr>
-              <a:t>年化毛营收，2026年7月</a:t>
-            </a:r>
-          </a:p>
-        </p:txBody>
-      </p:sp>
-      <p:sp>
-        <p:nvSpPr>
-          <p:cNvPr id="3011" name="SimReal 3011"/>
-          <p:cNvSpPr/>
-          <p:nvPr/>
-        </p:nvSpPr>
-        <p:spPr>
-          <a:xfrm>
-            <a:off x="1645920" y="3218688"/>
-            <a:ext cx="1691640" cy="256032"/>
-          </a:xfrm>
-          <a:prstGeom prst="rect">
-            <a:avLst/>
-          </a:prstGeom>
-          <a:solidFill>
-            <a:srgbClr val="111110"/>
-          </a:solidFill>
-          <a:ln>
-            <a:noFill/>
-          </a:ln>
-        </p:spPr>
-        <p:txBody>
-          <a:bodyPr/>
-          <a:lstStyle/>
-          <a:p>
-            <a:endParaRPr/>
-          </a:p>
-        </p:txBody>
-      </p:sp>
-      <p:sp>
-        <p:nvSpPr>
-          <p:cNvPr id="3012" name="SimReal 3012"/>
+              <a:t>美国（麦肯锡）</a:t>
+            </a:r>
+          </a:p>
+        </p:txBody>
+      </p:sp>
+      <p:sp>
+        <p:nvSpPr>
+          <p:cNvPr id="3031" name="SimReal 3031"/>
           <p:cNvSpPr txBox="1"/>
           <p:nvPr/>
         </p:nvSpPr>
         <p:spPr>
           <a:xfrm>
-            <a:off x="3410712" y="3218688"/>
-            <a:ext cx="822960" cy="256032"/>
+            <a:off x="10213848" y="2505456"/>
+            <a:ext cx="1188720" cy="365760"/>
           </a:xfrm>
           <a:prstGeom prst="rect">
             <a:avLst/>
@@ -13165,6 +13996,84 @@
           </a:bodyPr>
           <a:lstStyle/>
           <a:p>
+            <a:pPr marL="0" marR="0" lvl="0" indent="0" algn="r" rtl="0">
+              <a:spcBef>
+                <a:spcPts val="0"/>
+              </a:spcBef>
+              <a:spcAft>
+                <a:spcPts val="0"/>
+              </a:spcAft>
+              <a:buNone/>
+            </a:pPr>
+            <a:r>
+              <a:rPr lang="zh-CN" sz="1400" b="0" i="0" u="none" strike="noStrike" cap="none">
+                <a:solidFill>
+                  <a:srgbClr val="FAF9F6"/>
+                </a:solidFill>
+                <a:latin typeface="Newsreader"/>
+                <a:ea typeface="Newsreader"/>
+                <a:cs typeface="Newsreader"/>
+                <a:sym typeface="Newsreader"/>
+              </a:rPr>
+              <a:t>2.9万亿</a:t>
+            </a:r>
+          </a:p>
+        </p:txBody>
+      </p:sp>
+      <p:sp>
+        <p:nvSpPr>
+          <p:cNvPr id="3032" name="SimReal 3032"/>
+          <p:cNvSpPr/>
+          <p:nvPr/>
+        </p:nvSpPr>
+        <p:spPr>
+          <a:xfrm>
+            <a:off x="8363712" y="2871216"/>
+            <a:ext cx="3038856" cy="9144"/>
+          </a:xfrm>
+          <a:prstGeom prst="rect">
+            <a:avLst/>
+          </a:prstGeom>
+          <a:solidFill>
+            <a:srgbClr val="3A3935"/>
+          </a:solidFill>
+          <a:ln>
+            <a:noFill/>
+          </a:ln>
+        </p:spPr>
+        <p:txBody>
+          <a:bodyPr/>
+          <a:lstStyle/>
+          <a:p>
+            <a:endParaRPr/>
+          </a:p>
+        </p:txBody>
+      </p:sp>
+      <p:sp>
+        <p:nvSpPr>
+          <p:cNvPr id="3033" name="SimReal 3033"/>
+          <p:cNvSpPr txBox="1"/>
+          <p:nvPr/>
+        </p:nvSpPr>
+        <p:spPr>
+          <a:xfrm>
+            <a:off x="8363712" y="2871216"/>
+            <a:ext cx="1850136" cy="365760"/>
+          </a:xfrm>
+          <a:prstGeom prst="rect">
+            <a:avLst/>
+          </a:prstGeom>
+          <a:noFill/>
+          <a:ln>
+            <a:noFill/>
+          </a:ln>
+        </p:spPr>
+        <p:txBody>
+          <a:bodyPr spcFirstLastPara="1" wrap="square" lIns="0" tIns="0" rIns="0" bIns="0" anchor="ctr" anchorCtr="0">
+            <a:noAutofit/>
+          </a:bodyPr>
+          <a:lstStyle/>
+          <a:p>
             <a:pPr marL="0" marR="0" lvl="0" indent="0" algn="l" rtl="0">
               <a:spcBef>
                 <a:spcPts val="0"/>
@@ -13177,88 +14086,117 @@
             <a:r>
               <a:rPr lang="zh-CN" sz="1100" b="0" i="0" u="none" strike="noStrike" cap="none">
                 <a:solidFill>
-                  <a:srgbClr val="111110"/>
+                  <a:srgbClr val="C4C0B7"/>
                 </a:solidFill>
                 <a:latin typeface="Instrument Sans"/>
                 <a:ea typeface="Instrument Sans"/>
                 <a:cs typeface="Instrument Sans"/>
                 <a:sym typeface="Instrument Sans"/>
               </a:rPr>
-              <a:t>$2.0B</a:t>
-            </a:r>
-          </a:p>
-        </p:txBody>
-      </p:sp>
-      <p:sp>
-        <p:nvSpPr>
-          <p:cNvPr id="3013" name="SimReal 3013"/>
+              <a:t>÷ 美国占全球GDP</a:t>
+            </a:r>
+          </a:p>
+        </p:txBody>
+      </p:sp>
+      <p:sp>
+        <p:nvSpPr>
+          <p:cNvPr id="3034" name="SimReal 3034"/>
           <p:cNvSpPr txBox="1"/>
           <p:nvPr/>
         </p:nvSpPr>
         <p:spPr>
           <a:xfrm>
-            <a:off x="548640" y="3675888"/>
-            <a:ext cx="1097280" cy="237744"/>
-          </a:xfrm>
-          <a:prstGeom prst="rect">
-            <a:avLst/>
-          </a:prstGeom>
-          <a:noFill/>
-          <a:ln>
-            <a:noFill/>
-          </a:ln>
-        </p:spPr>
-        <p:txBody>
-          <a:bodyPr spcFirstLastPara="1" wrap="square" lIns="0" tIns="0" rIns="0" bIns="0" anchor="t" anchorCtr="0">
+            <a:off x="10213848" y="2871216"/>
+            <a:ext cx="1188720" cy="365760"/>
+          </a:xfrm>
+          <a:prstGeom prst="rect">
+            <a:avLst/>
+          </a:prstGeom>
+          <a:noFill/>
+          <a:ln>
+            <a:noFill/>
+          </a:ln>
+        </p:spPr>
+        <p:txBody>
+          <a:bodyPr spcFirstLastPara="1" wrap="square" lIns="0" tIns="0" rIns="0" bIns="0" anchor="ctr" anchorCtr="0">
             <a:noAutofit/>
           </a:bodyPr>
           <a:lstStyle/>
           <a:p>
-            <a:pPr marL="0" marR="0" lvl="0" indent="0" algn="l" rtl="0">
-              <a:spcBef>
-                <a:spcPts val="0"/>
-              </a:spcBef>
-              <a:spcAft>
-                <a:spcPts val="0"/>
-              </a:spcAft>
-              <a:buNone/>
-            </a:pPr>
-            <a:r>
-              <a:rPr lang="zh-CN" sz="1200" b="0" i="0" u="none" strike="noStrike" cap="none">
-                <a:solidFill>
-                  <a:srgbClr val="111110"/>
+            <a:pPr marL="0" marR="0" lvl="0" indent="0" algn="r" rtl="0">
+              <a:spcBef>
+                <a:spcPts val="0"/>
+              </a:spcBef>
+              <a:spcAft>
+                <a:spcPts val="0"/>
+              </a:spcAft>
+              <a:buNone/>
+            </a:pPr>
+            <a:r>
+              <a:rPr lang="zh-CN" sz="1400" b="0" i="0" u="none" strike="noStrike" cap="none">
+                <a:solidFill>
+                  <a:srgbClr val="FAF9F6"/>
                 </a:solidFill>
                 <a:latin typeface="Newsreader"/>
                 <a:ea typeface="Newsreader"/>
                 <a:cs typeface="Newsreader"/>
                 <a:sym typeface="Newsreader"/>
               </a:rPr>
-              <a:t>Surge AI</a:t>
-            </a:r>
-          </a:p>
-        </p:txBody>
-      </p:sp>
-      <p:sp>
-        <p:nvSpPr>
-          <p:cNvPr id="3014" name="SimReal 3014"/>
+              <a:t>25.6%</a:t>
+            </a:r>
+          </a:p>
+        </p:txBody>
+      </p:sp>
+      <p:sp>
+        <p:nvSpPr>
+          <p:cNvPr id="3035" name="SimReal 3035"/>
+          <p:cNvSpPr/>
+          <p:nvPr/>
+        </p:nvSpPr>
+        <p:spPr>
+          <a:xfrm>
+            <a:off x="8363712" y="3236976"/>
+            <a:ext cx="3038856" cy="9144"/>
+          </a:xfrm>
+          <a:prstGeom prst="rect">
+            <a:avLst/>
+          </a:prstGeom>
+          <a:solidFill>
+            <a:srgbClr val="3A3935"/>
+          </a:solidFill>
+          <a:ln>
+            <a:noFill/>
+          </a:ln>
+        </p:spPr>
+        <p:txBody>
+          <a:bodyPr/>
+          <a:lstStyle/>
+          <a:p>
+            <a:endParaRPr/>
+          </a:p>
+        </p:txBody>
+      </p:sp>
+      <p:sp>
+        <p:nvSpPr>
+          <p:cNvPr id="3036" name="SimReal 3036"/>
           <p:cNvSpPr txBox="1"/>
           <p:nvPr/>
         </p:nvSpPr>
         <p:spPr>
           <a:xfrm>
-            <a:off x="548640" y="3904488"/>
-            <a:ext cx="1097280" cy="182880"/>
-          </a:xfrm>
-          <a:prstGeom prst="rect">
-            <a:avLst/>
-          </a:prstGeom>
-          <a:noFill/>
-          <a:ln>
-            <a:noFill/>
-          </a:ln>
-        </p:spPr>
-        <p:txBody>
-          <a:bodyPr spcFirstLastPara="1" wrap="square" lIns="0" tIns="0" rIns="0" bIns="0" anchor="t" anchorCtr="0">
+            <a:off x="8363712" y="3236976"/>
+            <a:ext cx="1850136" cy="365760"/>
+          </a:xfrm>
+          <a:prstGeom prst="rect">
+            <a:avLst/>
+          </a:prstGeom>
+          <a:noFill/>
+          <a:ln>
+            <a:noFill/>
+          </a:ln>
+        </p:spPr>
+        <p:txBody>
+          <a:bodyPr spcFirstLastPara="1" wrap="square" lIns="0" tIns="0" rIns="0" bIns="0" anchor="ctr" anchorCtr="0">
             <a:noAutofit/>
           </a:bodyPr>
           <a:lstStyle/>
@@ -13273,59 +14211,30 @@
               <a:buNone/>
             </a:pPr>
             <a:r>
-              <a:rPr lang="zh-CN" sz="750" b="0" i="0" u="none" strike="noStrike" cap="none">
-                <a:solidFill>
-                  <a:srgbClr val="6E6C66"/>
+              <a:rPr lang="zh-CN" sz="1100" b="0" i="0" u="none" strike="noStrike" cap="none">
+                <a:solidFill>
+                  <a:srgbClr val="C4C0B7"/>
                 </a:solidFill>
                 <a:latin typeface="Instrument Sans"/>
                 <a:ea typeface="Instrument Sans"/>
                 <a:cs typeface="Instrument Sans"/>
                 <a:sym typeface="Instrument Sans"/>
               </a:rPr>
-              <a:t>2024年收入</a:t>
-            </a:r>
-          </a:p>
-        </p:txBody>
-      </p:sp>
-      <p:sp>
-        <p:nvSpPr>
-          <p:cNvPr id="3015" name="SimReal 3015"/>
-          <p:cNvSpPr/>
-          <p:nvPr/>
-        </p:nvSpPr>
-        <p:spPr>
-          <a:xfrm>
-            <a:off x="1645920" y="3730752"/>
-            <a:ext cx="1014984" cy="256032"/>
-          </a:xfrm>
-          <a:prstGeom prst="rect">
-            <a:avLst/>
-          </a:prstGeom>
-          <a:solidFill>
-            <a:srgbClr val="C4C0B7"/>
-          </a:solidFill>
-          <a:ln>
-            <a:noFill/>
-          </a:ln>
-        </p:spPr>
-        <p:txBody>
-          <a:bodyPr/>
-          <a:lstStyle/>
-          <a:p>
-            <a:endParaRPr/>
-          </a:p>
-        </p:txBody>
-      </p:sp>
-      <p:sp>
-        <p:nvSpPr>
-          <p:cNvPr id="3016" name="SimReal 3016"/>
+              <a:t>= 全球，同等渗透</a:t>
+            </a:r>
+          </a:p>
+        </p:txBody>
+      </p:sp>
+      <p:sp>
+        <p:nvSpPr>
+          <p:cNvPr id="3037" name="SimReal 3037"/>
           <p:cNvSpPr txBox="1"/>
           <p:nvPr/>
         </p:nvSpPr>
         <p:spPr>
           <a:xfrm>
-            <a:off x="2734056" y="3730752"/>
-            <a:ext cx="822960" cy="256032"/>
+            <a:off x="10213848" y="3236976"/>
+            <a:ext cx="1188720" cy="365760"/>
           </a:xfrm>
           <a:prstGeom prst="rect">
             <a:avLst/>
@@ -13341,6 +14250,84 @@
           </a:bodyPr>
           <a:lstStyle/>
           <a:p>
+            <a:pPr marL="0" marR="0" lvl="0" indent="0" algn="r" rtl="0">
+              <a:spcBef>
+                <a:spcPts val="0"/>
+              </a:spcBef>
+              <a:spcAft>
+                <a:spcPts val="0"/>
+              </a:spcAft>
+              <a:buNone/>
+            </a:pPr>
+            <a:r>
+              <a:rPr lang="zh-CN" sz="1400" b="0" i="0" u="none" strike="noStrike" cap="none">
+                <a:solidFill>
+                  <a:srgbClr val="FAF9F6"/>
+                </a:solidFill>
+                <a:latin typeface="Newsreader"/>
+                <a:ea typeface="Newsreader"/>
+                <a:cs typeface="Newsreader"/>
+                <a:sym typeface="Newsreader"/>
+              </a:rPr>
+              <a:t>11.3万亿</a:t>
+            </a:r>
+          </a:p>
+        </p:txBody>
+      </p:sp>
+      <p:sp>
+        <p:nvSpPr>
+          <p:cNvPr id="3038" name="SimReal 3038"/>
+          <p:cNvSpPr/>
+          <p:nvPr/>
+        </p:nvSpPr>
+        <p:spPr>
+          <a:xfrm>
+            <a:off x="8363712" y="3602736"/>
+            <a:ext cx="3038856" cy="9144"/>
+          </a:xfrm>
+          <a:prstGeom prst="rect">
+            <a:avLst/>
+          </a:prstGeom>
+          <a:solidFill>
+            <a:srgbClr val="3A3935"/>
+          </a:solidFill>
+          <a:ln>
+            <a:noFill/>
+          </a:ln>
+        </p:spPr>
+        <p:txBody>
+          <a:bodyPr/>
+          <a:lstStyle/>
+          <a:p>
+            <a:endParaRPr/>
+          </a:p>
+        </p:txBody>
+      </p:sp>
+      <p:sp>
+        <p:nvSpPr>
+          <p:cNvPr id="3039" name="SimReal 3039"/>
+          <p:cNvSpPr txBox="1"/>
+          <p:nvPr/>
+        </p:nvSpPr>
+        <p:spPr>
+          <a:xfrm>
+            <a:off x="8363712" y="3602736"/>
+            <a:ext cx="1850136" cy="365760"/>
+          </a:xfrm>
+          <a:prstGeom prst="rect">
+            <a:avLst/>
+          </a:prstGeom>
+          <a:noFill/>
+          <a:ln>
+            <a:noFill/>
+          </a:ln>
+        </p:spPr>
+        <p:txBody>
+          <a:bodyPr spcFirstLastPara="1" wrap="square" lIns="0" tIns="0" rIns="0" bIns="0" anchor="ctr" anchorCtr="0">
+            <a:noAutofit/>
+          </a:bodyPr>
+          <a:lstStyle/>
+          <a:p>
             <a:pPr marL="0" marR="0" lvl="0" indent="0" algn="l" rtl="0">
               <a:spcBef>
                 <a:spcPts val="0"/>
@@ -13351,90 +14338,90 @@
               <a:buNone/>
             </a:pPr>
             <a:r>
-              <a:rPr lang="zh-CN" sz="1100" b="0" i="0" u="none" strike="noStrike" cap="none">
-                <a:solidFill>
-                  <a:srgbClr val="111110"/>
+              <a:rPr lang="zh-CN" sz="1100" b="1" i="0" u="none" strike="noStrike" cap="none">
+                <a:solidFill>
+                  <a:srgbClr val="FAF9F6"/>
                 </a:solidFill>
                 <a:latin typeface="Instrument Sans"/>
                 <a:ea typeface="Instrument Sans"/>
                 <a:cs typeface="Instrument Sans"/>
                 <a:sym typeface="Instrument Sans"/>
               </a:rPr>
-              <a:t>$1.2B</a:t>
-            </a:r>
-          </a:p>
-        </p:txBody>
-      </p:sp>
-      <p:sp>
-        <p:nvSpPr>
-          <p:cNvPr id="3017" name="SimReal 3017"/>
+              <a:t>美国以外渗透减半</a:t>
+            </a:r>
+          </a:p>
+        </p:txBody>
+      </p:sp>
+      <p:sp>
+        <p:nvSpPr>
+          <p:cNvPr id="3040" name="SimReal 3040"/>
           <p:cNvSpPr txBox="1"/>
           <p:nvPr/>
         </p:nvSpPr>
         <p:spPr>
           <a:xfrm>
-            <a:off x="548640" y="4187952"/>
-            <a:ext cx="1097280" cy="237744"/>
-          </a:xfrm>
-          <a:prstGeom prst="rect">
-            <a:avLst/>
-          </a:prstGeom>
-          <a:noFill/>
-          <a:ln>
-            <a:noFill/>
-          </a:ln>
-        </p:spPr>
-        <p:txBody>
-          <a:bodyPr spcFirstLastPara="1" wrap="square" lIns="0" tIns="0" rIns="0" bIns="0" anchor="t" anchorCtr="0">
+            <a:off x="10213848" y="3602736"/>
+            <a:ext cx="1188720" cy="365760"/>
+          </a:xfrm>
+          <a:prstGeom prst="rect">
+            <a:avLst/>
+          </a:prstGeom>
+          <a:noFill/>
+          <a:ln>
+            <a:noFill/>
+          </a:ln>
+        </p:spPr>
+        <p:txBody>
+          <a:bodyPr spcFirstLastPara="1" wrap="square" lIns="0" tIns="0" rIns="0" bIns="0" anchor="ctr" anchorCtr="0">
             <a:noAutofit/>
           </a:bodyPr>
           <a:lstStyle/>
           <a:p>
-            <a:pPr marL="0" marR="0" lvl="0" indent="0" algn="l" rtl="0">
-              <a:spcBef>
-                <a:spcPts val="0"/>
-              </a:spcBef>
-              <a:spcAft>
-                <a:spcPts val="0"/>
-              </a:spcAft>
-              <a:buNone/>
-            </a:pPr>
-            <a:r>
-              <a:rPr lang="zh-CN" sz="1200" b="0" i="0" u="none" strike="noStrike" cap="none">
-                <a:solidFill>
-                  <a:srgbClr val="111110"/>
+            <a:pPr marL="0" marR="0" lvl="0" indent="0" algn="r" rtl="0">
+              <a:spcBef>
+                <a:spcPts val="0"/>
+              </a:spcBef>
+              <a:spcAft>
+                <a:spcPts val="0"/>
+              </a:spcAft>
+              <a:buNone/>
+            </a:pPr>
+            <a:r>
+              <a:rPr lang="zh-CN" sz="1400" b="0" i="0" u="none" strike="noStrike" cap="none">
+                <a:solidFill>
+                  <a:srgbClr val="E27A3F"/>
                 </a:solidFill>
                 <a:latin typeface="Newsreader"/>
                 <a:ea typeface="Newsreader"/>
                 <a:cs typeface="Newsreader"/>
                 <a:sym typeface="Newsreader"/>
               </a:rPr>
-              <a:t>Snorkel AI</a:t>
-            </a:r>
-          </a:p>
-        </p:txBody>
-      </p:sp>
-      <p:sp>
-        <p:nvSpPr>
-          <p:cNvPr id="3018" name="SimReal 3018"/>
+              <a:t>7.1万亿</a:t>
+            </a:r>
+          </a:p>
+        </p:txBody>
+      </p:sp>
+      <p:sp>
+        <p:nvSpPr>
+          <p:cNvPr id="3041" name="SimReal 3041"/>
           <p:cNvSpPr txBox="1"/>
           <p:nvPr/>
         </p:nvSpPr>
         <p:spPr>
           <a:xfrm>
-            <a:off x="548640" y="4416552"/>
-            <a:ext cx="1097280" cy="182880"/>
-          </a:xfrm>
-          <a:prstGeom prst="rect">
-            <a:avLst/>
-          </a:prstGeom>
-          <a:noFill/>
-          <a:ln>
-            <a:noFill/>
-          </a:ln>
-        </p:spPr>
-        <p:txBody>
-          <a:bodyPr spcFirstLastPara="1" wrap="square" lIns="0" tIns="0" rIns="0" bIns="0" anchor="t" anchorCtr="0">
+            <a:off x="8363712" y="4133088"/>
+            <a:ext cx="3038856" cy="365760"/>
+          </a:xfrm>
+          <a:prstGeom prst="rect">
+            <a:avLst/>
+          </a:prstGeom>
+          <a:noFill/>
+          <a:ln>
+            <a:noFill/>
+          </a:ln>
+        </p:spPr>
+        <p:txBody>
+          <a:bodyPr spcFirstLastPara="1" wrap="square" lIns="0" tIns="0" rIns="0" bIns="0" anchor="ctr" anchorCtr="0">
             <a:noAutofit/>
           </a:bodyPr>
           <a:lstStyle/>
@@ -13449,59 +14436,30 @@
               <a:buNone/>
             </a:pPr>
             <a:r>
-              <a:rPr lang="zh-CN" sz="750" b="0" i="0" u="none" strike="noStrike" cap="none">
-                <a:solidFill>
-                  <a:srgbClr val="6E6C66"/>
+              <a:rPr lang="zh-CN" sz="1300" b="1" i="0" u="none" strike="noStrike" cap="none">
+                <a:solidFill>
+                  <a:srgbClr val="FAF9F6"/>
                 </a:solidFill>
                 <a:latin typeface="Instrument Sans"/>
                 <a:ea typeface="Instrument Sans"/>
                 <a:cs typeface="Instrument Sans"/>
                 <a:sym typeface="Instrument Sans"/>
               </a:rPr>
-              <a:t>年化收入，2026年9月</a:t>
-            </a:r>
-          </a:p>
-        </p:txBody>
-      </p:sp>
-      <p:sp>
-        <p:nvSpPr>
-          <p:cNvPr id="3019" name="SimReal 3019"/>
-          <p:cNvSpPr/>
-          <p:nvPr/>
-        </p:nvSpPr>
-        <p:spPr>
-          <a:xfrm>
-            <a:off x="1645920" y="4242816"/>
-            <a:ext cx="317183" cy="256032"/>
-          </a:xfrm>
-          <a:prstGeom prst="rect">
-            <a:avLst/>
-          </a:prstGeom>
-          <a:solidFill>
-            <a:srgbClr val="C4C0B7"/>
-          </a:solidFill>
-          <a:ln>
-            <a:noFill/>
-          </a:ln>
-        </p:spPr>
-        <p:txBody>
-          <a:bodyPr/>
-          <a:lstStyle/>
-          <a:p>
-            <a:endParaRPr/>
-          </a:p>
-        </p:txBody>
-      </p:sp>
-      <p:sp>
-        <p:nvSpPr>
-          <p:cNvPr id="3020" name="SimReal 3020"/>
+              <a:t>训练层 = AI经济的2–6%</a:t>
+            </a:r>
+          </a:p>
+        </p:txBody>
+      </p:sp>
+      <p:sp>
+        <p:nvSpPr>
+          <p:cNvPr id="3042" name="SimReal 3042"/>
           <p:cNvSpPr txBox="1"/>
           <p:nvPr/>
         </p:nvSpPr>
         <p:spPr>
           <a:xfrm>
-            <a:off x="2036254" y="4242816"/>
-            <a:ext cx="822960" cy="256032"/>
+            <a:off x="548640" y="5138928"/>
+            <a:ext cx="11091672" cy="402336"/>
           </a:xfrm>
           <a:prstGeom prst="rect">
             <a:avLst/>
@@ -13527,1307 +14485,92 @@
               <a:buNone/>
             </a:pPr>
             <a:r>
-              <a:rPr lang="zh-CN" sz="1100" b="0" i="0" u="none" strike="noStrike" cap="none">
+              <a:rPr lang="zh-CN" sz="2000" b="0" i="0" u="none" strike="noStrike" cap="none">
                 <a:solidFill>
                   <a:srgbClr val="111110"/>
+                </a:solidFill>
+                <a:latin typeface="Newsreader"/>
+                <a:ea typeface="Newsreader"/>
+                <a:cs typeface="Newsreader"/>
+                <a:sym typeface="Newsreader"/>
+              </a:rPr>
+              <a:t>今天卖给实验室，2030年卖给</a:t>
+            </a:r>
+            <a:r>
+              <a:rPr lang="zh-CN" sz="2000" b="0" i="0" u="none" strike="noStrike" cap="none">
+                <a:solidFill>
+                  <a:srgbClr val="C2410C"/>
+                </a:solidFill>
+                <a:latin typeface="Newsreader"/>
+                <a:ea typeface="Newsreader"/>
+                <a:cs typeface="Newsreader"/>
+                <a:sym typeface="Newsreader"/>
+              </a:rPr>
+              <a:t>整个AI经济</a:t>
+            </a:r>
+            <a:r>
+              <a:rPr lang="zh-CN" sz="2000" b="0" i="0" u="none" strike="noStrike" cap="none">
+                <a:solidFill>
+                  <a:srgbClr val="111110"/>
+                </a:solidFill>
+                <a:latin typeface="Newsreader"/>
+                <a:ea typeface="Newsreader"/>
+                <a:cs typeface="Newsreader"/>
+                <a:sym typeface="Newsreader"/>
+              </a:rPr>
+              <a:t>。</a:t>
+            </a:r>
+          </a:p>
+        </p:txBody>
+      </p:sp>
+      <p:sp>
+        <p:nvSpPr>
+          <p:cNvPr id="3043" name="SimReal 3043"/>
+          <p:cNvSpPr txBox="1"/>
+          <p:nvPr/>
+        </p:nvSpPr>
+        <p:spPr>
+          <a:xfrm>
+            <a:off x="548640" y="5779008"/>
+            <a:ext cx="11091672" cy="365760"/>
+          </a:xfrm>
+          <a:prstGeom prst="rect">
+            <a:avLst/>
+          </a:prstGeom>
+          <a:noFill/>
+          <a:ln>
+            <a:noFill/>
+          </a:ln>
+        </p:spPr>
+        <p:txBody>
+          <a:bodyPr spcFirstLastPara="1" wrap="square" lIns="0" tIns="0" rIns="0" bIns="0" anchor="t" anchorCtr="0">
+            <a:noAutofit/>
+          </a:bodyPr>
+          <a:lstStyle/>
+          <a:p>
+            <a:pPr marL="0" marR="0" lvl="0" indent="0" algn="l" rtl="0">
+              <a:lnSpc>
+                <a:spcPct val="110000"/>
+              </a:lnSpc>
+              <a:spcBef>
+                <a:spcPts val="0"/>
+              </a:spcBef>
+              <a:spcAft>
+                <a:spcPts val="0"/>
+              </a:spcAft>
+              <a:buNone/>
+            </a:pPr>
+            <a:r>
+              <a:rPr lang="zh-CN" sz="800" b="0" i="0" u="none" strike="noStrike" cap="none">
+                <a:solidFill>
+                  <a:srgbClr val="6E6C66"/>
                 </a:solidFill>
                 <a:latin typeface="Instrument Sans"/>
                 <a:ea typeface="Instrument Sans"/>
                 <a:cs typeface="Instrument Sans"/>
                 <a:sym typeface="Instrument Sans"/>
               </a:rPr>
-              <a:t>$0.375B</a:t>
-            </a:r>
-          </a:p>
-        </p:txBody>
-      </p:sp>
-      <p:sp>
-        <p:nvSpPr>
-          <p:cNvPr id="3021" name="SimReal 3021"/>
-          <p:cNvSpPr/>
-          <p:nvPr/>
-        </p:nvSpPr>
-        <p:spPr>
-          <a:xfrm>
-            <a:off x="4337304" y="1481328"/>
-            <a:ext cx="3514344" cy="27432"/>
-          </a:xfrm>
-          <a:prstGeom prst="rect">
-            <a:avLst/>
-          </a:prstGeom>
-          <a:solidFill>
-            <a:srgbClr val="C2410C"/>
-          </a:solidFill>
-          <a:ln>
-            <a:noFill/>
-          </a:ln>
-        </p:spPr>
-        <p:txBody>
-          <a:bodyPr/>
-          <a:lstStyle/>
-          <a:p>
-            <a:endParaRPr/>
-          </a:p>
-        </p:txBody>
-      </p:sp>
-      <p:sp>
-        <p:nvSpPr>
-          <p:cNvPr id="3022" name="SimReal 3022"/>
-          <p:cNvSpPr txBox="1"/>
-          <p:nvPr/>
-        </p:nvSpPr>
-        <p:spPr>
-          <a:xfrm>
-            <a:off x="4337304" y="1609344"/>
-            <a:ext cx="3514344" cy="201168"/>
-          </a:xfrm>
-          <a:prstGeom prst="rect">
-            <a:avLst/>
-          </a:prstGeom>
-          <a:noFill/>
-          <a:ln>
-            <a:noFill/>
-          </a:ln>
-        </p:spPr>
-        <p:txBody>
-          <a:bodyPr spcFirstLastPara="1" wrap="square" lIns="0" tIns="0" rIns="0" bIns="0" anchor="t" anchorCtr="0">
-            <a:noAutofit/>
-          </a:bodyPr>
-          <a:lstStyle/>
-          <a:p>
-            <a:pPr marL="0" marR="0" lvl="0" indent="0" algn="l" rtl="0">
-              <a:spcBef>
-                <a:spcPts val="0"/>
-              </a:spcBef>
-              <a:spcAft>
-                <a:spcPts val="0"/>
-              </a:spcAft>
-              <a:buNone/>
-            </a:pPr>
-            <a:r>
-              <a:rPr lang="zh-CN" sz="1000" b="0" i="0" u="none" strike="noStrike" cap="none">
-                <a:solidFill>
-                  <a:srgbClr val="C2410C"/>
-                </a:solidFill>
-                <a:latin typeface="IBM Plex Mono"/>
-                <a:ea typeface="IBM Plex Mono"/>
-                <a:cs typeface="IBM Plex Mono"/>
-                <a:sym typeface="IBM Plex Mono"/>
-              </a:rPr>
-              <a:t>2030年 · 训练层：我们的市场</a:t>
-            </a:r>
-          </a:p>
-        </p:txBody>
-      </p:sp>
-      <p:sp>
-        <p:nvSpPr>
-          <p:cNvPr id="3023" name="SimReal 3023"/>
-          <p:cNvSpPr txBox="1"/>
-          <p:nvPr/>
-        </p:nvSpPr>
-        <p:spPr>
-          <a:xfrm>
-            <a:off x="4337304" y="1865376"/>
-            <a:ext cx="3514344" cy="548640"/>
-          </a:xfrm>
-          <a:prstGeom prst="rect">
-            <a:avLst/>
-          </a:prstGeom>
-          <a:noFill/>
-          <a:ln>
-            <a:noFill/>
-          </a:ln>
-        </p:spPr>
-        <p:txBody>
-          <a:bodyPr spcFirstLastPara="1" wrap="square" lIns="0" tIns="0" rIns="0" bIns="0" anchor="ctr" anchorCtr="0">
-            <a:noAutofit/>
-          </a:bodyPr>
-          <a:lstStyle/>
-          <a:p>
-            <a:pPr marL="0" marR="0" lvl="0" indent="0" algn="l" rtl="0">
-              <a:spcBef>
-                <a:spcPts val="0"/>
-              </a:spcBef>
-              <a:spcAft>
-                <a:spcPts val="0"/>
-              </a:spcAft>
-              <a:buNone/>
-            </a:pPr>
-            <a:r>
-              <a:rPr lang="zh-CN" sz="2400" b="0" i="0" u="none" strike="noStrike" cap="none">
-                <a:solidFill>
-                  <a:srgbClr val="C2410C"/>
-                </a:solidFill>
-                <a:latin typeface="Newsreader"/>
-                <a:ea typeface="Newsreader"/>
-                <a:cs typeface="Newsreader"/>
-                <a:sym typeface="Newsreader"/>
-              </a:rPr>
-              <a:t>1,500–4,000亿美元/年</a:t>
-            </a:r>
-          </a:p>
-        </p:txBody>
-      </p:sp>
-      <p:sp>
-        <p:nvSpPr>
-          <p:cNvPr id="3024" name="SimReal 3024"/>
-          <p:cNvSpPr/>
-          <p:nvPr/>
-        </p:nvSpPr>
-        <p:spPr>
-          <a:xfrm>
-            <a:off x="4337304" y="2505456"/>
-            <a:ext cx="3514344" cy="932688"/>
-          </a:xfrm>
-          <a:prstGeom prst="rect">
-            <a:avLst/>
-          </a:prstGeom>
-          <a:solidFill>
-            <a:srgbClr val="F2F1EC"/>
-          </a:solidFill>
-          <a:ln>
-            <a:noFill/>
-          </a:ln>
-        </p:spPr>
-        <p:txBody>
-          <a:bodyPr/>
-          <a:lstStyle/>
-          <a:p>
-            <a:endParaRPr/>
-          </a:p>
-        </p:txBody>
-      </p:sp>
-      <p:sp>
-        <p:nvSpPr>
-          <p:cNvPr id="3025" name="SimReal 3025"/>
-          <p:cNvSpPr txBox="1"/>
-          <p:nvPr/>
-        </p:nvSpPr>
-        <p:spPr>
-          <a:xfrm>
-            <a:off x="4520184" y="2578608"/>
-            <a:ext cx="1776984" cy="310896"/>
-          </a:xfrm>
-          <a:prstGeom prst="rect">
-            <a:avLst/>
-          </a:prstGeom>
-          <a:noFill/>
-          <a:ln>
-            <a:noFill/>
-          </a:ln>
-        </p:spPr>
-        <p:txBody>
-          <a:bodyPr spcFirstLastPara="1" wrap="square" lIns="0" tIns="0" rIns="0" bIns="0" anchor="ctr" anchorCtr="0">
-            <a:noAutofit/>
-          </a:bodyPr>
-          <a:lstStyle/>
-          <a:p>
-            <a:pPr marL="0" marR="0" lvl="0" indent="0" algn="l" rtl="0">
-              <a:spcBef>
-                <a:spcPts val="0"/>
-              </a:spcBef>
-              <a:spcAft>
-                <a:spcPts val="0"/>
-              </a:spcAft>
-              <a:buNone/>
-            </a:pPr>
-            <a:r>
-              <a:rPr lang="zh-CN" sz="1100" b="0" i="0" u="none" strike="noStrike" cap="none">
-                <a:solidFill>
-                  <a:srgbClr val="33322F"/>
-                </a:solidFill>
-                <a:latin typeface="Instrument Sans"/>
-                <a:ea typeface="Instrument Sans"/>
-                <a:cs typeface="Instrument Sans"/>
-                <a:sym typeface="Instrument Sans"/>
-              </a:rPr>
-              <a:t>全球AI基础设施支出</a:t>
-            </a:r>
-          </a:p>
-        </p:txBody>
-      </p:sp>
-      <p:sp>
-        <p:nvSpPr>
-          <p:cNvPr id="3026" name="SimReal 3026"/>
-          <p:cNvSpPr txBox="1"/>
-          <p:nvPr/>
-        </p:nvSpPr>
-        <p:spPr>
-          <a:xfrm>
-            <a:off x="6251448" y="2578608"/>
-            <a:ext cx="1417320" cy="310896"/>
-          </a:xfrm>
-          <a:prstGeom prst="rect">
-            <a:avLst/>
-          </a:prstGeom>
-          <a:noFill/>
-          <a:ln>
-            <a:noFill/>
-          </a:ln>
-        </p:spPr>
-        <p:txBody>
-          <a:bodyPr spcFirstLastPara="1" wrap="square" lIns="0" tIns="0" rIns="0" bIns="0" anchor="ctr" anchorCtr="0">
-            <a:noAutofit/>
-          </a:bodyPr>
-          <a:lstStyle/>
-          <a:p>
-            <a:pPr marL="0" marR="0" lvl="0" indent="0" algn="r" rtl="0">
-              <a:spcBef>
-                <a:spcPts val="0"/>
-              </a:spcBef>
-              <a:spcAft>
-                <a:spcPts val="0"/>
-              </a:spcAft>
-              <a:buNone/>
-            </a:pPr>
-            <a:r>
-              <a:rPr lang="zh-CN" sz="1300" b="0" i="0" u="none" strike="noStrike" cap="none">
-                <a:solidFill>
-                  <a:srgbClr val="111110"/>
-                </a:solidFill>
-                <a:latin typeface="Newsreader"/>
-                <a:ea typeface="Newsreader"/>
-                <a:cs typeface="Newsreader"/>
-                <a:sym typeface="Newsreader"/>
-              </a:rPr>
-              <a:t>3–4万亿美元/年</a:t>
-            </a:r>
-          </a:p>
-        </p:txBody>
-      </p:sp>
-      <p:sp>
-        <p:nvSpPr>
-          <p:cNvPr id="3027" name="SimReal 3027"/>
-          <p:cNvSpPr txBox="1"/>
-          <p:nvPr/>
-        </p:nvSpPr>
-        <p:spPr>
-          <a:xfrm>
-            <a:off x="4520184" y="2907792"/>
-            <a:ext cx="1776984" cy="310896"/>
-          </a:xfrm>
-          <a:prstGeom prst="rect">
-            <a:avLst/>
-          </a:prstGeom>
-          <a:noFill/>
-          <a:ln>
-            <a:noFill/>
-          </a:ln>
-        </p:spPr>
-        <p:txBody>
-          <a:bodyPr spcFirstLastPara="1" wrap="square" lIns="0" tIns="0" rIns="0" bIns="0" anchor="ctr" anchorCtr="0">
-            <a:noAutofit/>
-          </a:bodyPr>
-          <a:lstStyle/>
-          <a:p>
-            <a:pPr marL="0" marR="0" lvl="0" indent="0" algn="l" rtl="0">
-              <a:spcBef>
-                <a:spcPts val="0"/>
-              </a:spcBef>
-              <a:spcAft>
-                <a:spcPts val="0"/>
-              </a:spcAft>
-              <a:buNone/>
-            </a:pPr>
-            <a:r>
-              <a:rPr lang="zh-CN" sz="1100" b="0" i="0" u="none" strike="noStrike" cap="none">
-                <a:solidFill>
-                  <a:srgbClr val="33322F"/>
-                </a:solidFill>
-                <a:latin typeface="Instrument Sans"/>
-                <a:ea typeface="Instrument Sans"/>
-                <a:cs typeface="Instrument Sans"/>
-                <a:sym typeface="Instrument Sans"/>
-              </a:rPr>
-              <a:t>× 训练数据与环境的占比</a:t>
-            </a:r>
-          </a:p>
-        </p:txBody>
-      </p:sp>
-      <p:sp>
-        <p:nvSpPr>
-          <p:cNvPr id="3028" name="SimReal 3028"/>
-          <p:cNvSpPr txBox="1"/>
-          <p:nvPr/>
-        </p:nvSpPr>
-        <p:spPr>
-          <a:xfrm>
-            <a:off x="6251448" y="2907792"/>
-            <a:ext cx="1417320" cy="310896"/>
-          </a:xfrm>
-          <a:prstGeom prst="rect">
-            <a:avLst/>
-          </a:prstGeom>
-          <a:noFill/>
-          <a:ln>
-            <a:noFill/>
-          </a:ln>
-        </p:spPr>
-        <p:txBody>
-          <a:bodyPr spcFirstLastPara="1" wrap="square" lIns="0" tIns="0" rIns="0" bIns="0" anchor="ctr" anchorCtr="0">
-            <a:noAutofit/>
-          </a:bodyPr>
-          <a:lstStyle/>
-          <a:p>
-            <a:pPr marL="0" marR="0" lvl="0" indent="0" algn="r" rtl="0">
-              <a:spcBef>
-                <a:spcPts val="0"/>
-              </a:spcBef>
-              <a:spcAft>
-                <a:spcPts val="0"/>
-              </a:spcAft>
-              <a:buNone/>
-            </a:pPr>
-            <a:r>
-              <a:rPr lang="zh-CN" sz="1300" b="0" i="0" u="none" strike="noStrike" cap="none">
-                <a:solidFill>
-                  <a:srgbClr val="111110"/>
-                </a:solidFill>
-                <a:latin typeface="Newsreader"/>
-                <a:ea typeface="Newsreader"/>
-                <a:cs typeface="Newsreader"/>
-                <a:sym typeface="Newsreader"/>
-              </a:rPr>
-              <a:t>5–10%</a:t>
-            </a:r>
-          </a:p>
-        </p:txBody>
-      </p:sp>
-      <p:sp>
-        <p:nvSpPr>
-          <p:cNvPr id="3029" name="SimReal 3029"/>
-          <p:cNvSpPr txBox="1"/>
-          <p:nvPr/>
-        </p:nvSpPr>
-        <p:spPr>
-          <a:xfrm>
-            <a:off x="4520184" y="3218688"/>
-            <a:ext cx="3148584" cy="182880"/>
-          </a:xfrm>
-          <a:prstGeom prst="rect">
-            <a:avLst/>
-          </a:prstGeom>
-          <a:noFill/>
-          <a:ln>
-            <a:noFill/>
-          </a:ln>
-        </p:spPr>
-        <p:txBody>
-          <a:bodyPr spcFirstLastPara="1" wrap="square" lIns="0" tIns="0" rIns="0" bIns="0" anchor="t" anchorCtr="0">
-            <a:noAutofit/>
-          </a:bodyPr>
-          <a:lstStyle/>
-          <a:p>
-            <a:pPr marL="0" marR="0" lvl="0" indent="0" algn="l" rtl="0">
-              <a:spcBef>
-                <a:spcPts val="0"/>
-              </a:spcBef>
-              <a:spcAft>
-                <a:spcPts val="0"/>
-              </a:spcAft>
-              <a:buNone/>
-            </a:pPr>
-            <a:r>
-              <a:rPr lang="zh-CN" sz="850" b="0" i="0" u="none" strike="noStrike" cap="none">
-                <a:solidFill>
-                  <a:srgbClr val="6E6C66"/>
-                </a:solidFill>
-                <a:latin typeface="Instrument Sans"/>
-                <a:ea typeface="Instrument Sans"/>
-                <a:cs typeface="Instrument Sans"/>
-                <a:sym typeface="Instrument Sans"/>
-              </a:rPr>
-              <a:t>今天约1%：85亿美元对四大云厂商约7,000亿美元资本开支</a:t>
-            </a:r>
-          </a:p>
-        </p:txBody>
-      </p:sp>
-      <p:sp>
-        <p:nvSpPr>
-          <p:cNvPr id="3030" name="SimReal 3030"/>
-          <p:cNvSpPr txBox="1"/>
-          <p:nvPr/>
-        </p:nvSpPr>
-        <p:spPr>
-          <a:xfrm>
-            <a:off x="4337304" y="3639312"/>
-            <a:ext cx="3514344" cy="1280160"/>
-          </a:xfrm>
-          <a:prstGeom prst="rect">
-            <a:avLst/>
-          </a:prstGeom>
-          <a:noFill/>
-          <a:ln>
-            <a:noFill/>
-          </a:ln>
-        </p:spPr>
-        <p:txBody>
-          <a:bodyPr spcFirstLastPara="1" wrap="square" lIns="0" tIns="0" rIns="0" bIns="0" anchor="t" anchorCtr="0">
-            <a:noAutofit/>
-          </a:bodyPr>
-          <a:lstStyle/>
-          <a:p>
-            <a:pPr marL="0" marR="0" lvl="0" indent="0" algn="l" rtl="0">
-              <a:spcBef>
-                <a:spcPts val="0"/>
-              </a:spcBef>
-              <a:spcAft>
-                <a:spcPts val="0"/>
-              </a:spcAft>
-              <a:buNone/>
-            </a:pPr>
-            <a:r>
-              <a:rPr lang="zh-CN" sz="1100" b="1" i="0" u="none" strike="noStrike" cap="none">
-                <a:solidFill>
-                  <a:srgbClr val="111110"/>
-                </a:solidFill>
-                <a:latin typeface="Instrument Sans"/>
-                <a:ea typeface="Instrument Sans"/>
-                <a:cs typeface="Instrument Sans"/>
-                <a:sym typeface="Instrument Sans"/>
-              </a:rPr>
-              <a:t>为什么占比会升</a:t>
-            </a:r>
-          </a:p>
-          <a:p>
-            <a:pPr marL="0" marR="0" lvl="0" indent="0" algn="l" rtl="0">
-              <a:lnSpc>
-                <a:spcPct val="110000"/>
-              </a:lnSpc>
-              <a:spcBef>
-                <a:spcPts val="300"/>
-              </a:spcBef>
-              <a:spcAft>
-                <a:spcPts val="0"/>
-              </a:spcAft>
-              <a:buNone/>
-            </a:pPr>
-            <a:r>
-              <a:rPr lang="zh-CN" sz="1100" b="0" i="0" u="none" strike="noStrike" cap="none">
-                <a:solidFill>
-                  <a:srgbClr val="33322F"/>
-                </a:solidFill>
-                <a:latin typeface="Instrument Sans"/>
-                <a:ea typeface="Instrument Sans"/>
-                <a:cs typeface="Instrument Sans"/>
-                <a:sym typeface="Instrument Sans"/>
-              </a:rPr>
-              <a:t>数据和算力是互补品：每个RL任务约2,400美元算力，任务质量差，算力就白烧（Mechanize）。算力投得越多，高质量训练世界越值钱。</a:t>
-            </a:r>
-          </a:p>
-        </p:txBody>
-      </p:sp>
-      <p:sp>
-        <p:nvSpPr>
-          <p:cNvPr id="3031" name="SimReal 3031"/>
-          <p:cNvSpPr/>
-          <p:nvPr/>
-        </p:nvSpPr>
-        <p:spPr>
-          <a:xfrm>
-            <a:off x="8125968" y="1481328"/>
-            <a:ext cx="3514344" cy="3657600"/>
-          </a:xfrm>
-          <a:prstGeom prst="rect">
-            <a:avLst/>
-          </a:prstGeom>
-          <a:solidFill>
-            <a:srgbClr val="111110"/>
-          </a:solidFill>
-          <a:ln>
-            <a:noFill/>
-          </a:ln>
-        </p:spPr>
-        <p:txBody>
-          <a:bodyPr/>
-          <a:lstStyle/>
-          <a:p>
-            <a:endParaRPr/>
-          </a:p>
-        </p:txBody>
-      </p:sp>
-      <p:sp>
-        <p:nvSpPr>
-          <p:cNvPr id="3032" name="SimReal 3032"/>
-          <p:cNvSpPr txBox="1"/>
-          <p:nvPr/>
-        </p:nvSpPr>
-        <p:spPr>
-          <a:xfrm>
-            <a:off x="8363712" y="1609344"/>
-            <a:ext cx="3038856" cy="201168"/>
-          </a:xfrm>
-          <a:prstGeom prst="rect">
-            <a:avLst/>
-          </a:prstGeom>
-          <a:noFill/>
-          <a:ln>
-            <a:noFill/>
-          </a:ln>
-        </p:spPr>
-        <p:txBody>
-          <a:bodyPr spcFirstLastPara="1" wrap="square" lIns="0" tIns="0" rIns="0" bIns="0" anchor="t" anchorCtr="0">
-            <a:noAutofit/>
-          </a:bodyPr>
-          <a:lstStyle/>
-          <a:p>
-            <a:pPr marL="0" marR="0" lvl="0" indent="0" algn="l" rtl="0">
-              <a:spcBef>
-                <a:spcPts val="0"/>
-              </a:spcBef>
-              <a:spcAft>
-                <a:spcPts val="0"/>
-              </a:spcAft>
-              <a:buNone/>
-            </a:pPr>
-            <a:r>
-              <a:rPr lang="zh-CN" sz="1000" b="0" i="0" u="none" strike="noStrike" cap="none">
-                <a:solidFill>
-                  <a:srgbClr val="E27A3F"/>
-                </a:solidFill>
-                <a:latin typeface="IBM Plex Mono"/>
-                <a:ea typeface="IBM Plex Mono"/>
-                <a:cs typeface="IBM Plex Mono"/>
-                <a:sym typeface="IBM Plex Mono"/>
-              </a:rPr>
-              <a:t>2030年 · 训练层服务的AI经济</a:t>
-            </a:r>
-          </a:p>
-        </p:txBody>
-      </p:sp>
-      <p:sp>
-        <p:nvSpPr>
-          <p:cNvPr id="3033" name="SimReal 3033"/>
-          <p:cNvSpPr txBox="1"/>
-          <p:nvPr/>
-        </p:nvSpPr>
-        <p:spPr>
-          <a:xfrm>
-            <a:off x="8363712" y="1865376"/>
-            <a:ext cx="3038856" cy="548640"/>
-          </a:xfrm>
-          <a:prstGeom prst="rect">
-            <a:avLst/>
-          </a:prstGeom>
-          <a:noFill/>
-          <a:ln>
-            <a:noFill/>
-          </a:ln>
-        </p:spPr>
-        <p:txBody>
-          <a:bodyPr spcFirstLastPara="1" wrap="square" lIns="0" tIns="0" rIns="0" bIns="0" anchor="t" anchorCtr="0">
-            <a:noAutofit/>
-          </a:bodyPr>
-          <a:lstStyle/>
-          <a:p>
-            <a:pPr marL="0" marR="0" lvl="0" indent="0" algn="l" rtl="0">
-              <a:spcBef>
-                <a:spcPts val="0"/>
-              </a:spcBef>
-              <a:spcAft>
-                <a:spcPts val="0"/>
-              </a:spcAft>
-              <a:buNone/>
-            </a:pPr>
-            <a:r>
-              <a:rPr lang="zh-CN" sz="2800" b="0" i="0" u="none" strike="noStrike" cap="none">
-                <a:solidFill>
-                  <a:srgbClr val="E27A3F"/>
-                </a:solidFill>
-                <a:latin typeface="Newsreader"/>
-                <a:ea typeface="Newsreader"/>
-                <a:cs typeface="Newsreader"/>
-                <a:sym typeface="Newsreader"/>
-              </a:rPr>
-              <a:t>约7万亿美元/年</a:t>
-            </a:r>
-          </a:p>
-        </p:txBody>
-      </p:sp>
-      <p:sp>
-        <p:nvSpPr>
-          <p:cNvPr id="3034" name="SimReal 3034"/>
-          <p:cNvSpPr txBox="1"/>
-          <p:nvPr/>
-        </p:nvSpPr>
-        <p:spPr>
-          <a:xfrm>
-            <a:off x="8363712" y="2505456"/>
-            <a:ext cx="2124456" cy="365760"/>
-          </a:xfrm>
-          <a:prstGeom prst="rect">
-            <a:avLst/>
-          </a:prstGeom>
-          <a:noFill/>
-          <a:ln>
-            <a:noFill/>
-          </a:ln>
-        </p:spPr>
-        <p:txBody>
-          <a:bodyPr spcFirstLastPara="1" wrap="square" lIns="0" tIns="0" rIns="0" bIns="0" anchor="ctr" anchorCtr="0">
-            <a:noAutofit/>
-          </a:bodyPr>
-          <a:lstStyle/>
-          <a:p>
-            <a:pPr marL="0" marR="0" lvl="0" indent="0" algn="l" rtl="0">
-              <a:lnSpc>
-                <a:spcPct val="105000"/>
-              </a:lnSpc>
-              <a:spcBef>
-                <a:spcPts val="0"/>
-              </a:spcBef>
-              <a:spcAft>
-                <a:spcPts val="0"/>
-              </a:spcAft>
-              <a:buNone/>
-            </a:pPr>
-            <a:r>
-              <a:rPr lang="zh-CN" sz="1000" b="0" i="0" u="none" strike="noStrike" cap="none">
-                <a:solidFill>
-                  <a:srgbClr val="C4C0B7"/>
-                </a:solidFill>
-                <a:latin typeface="Instrument Sans"/>
-                <a:ea typeface="Instrument Sans"/>
-                <a:cs typeface="Instrument Sans"/>
-                <a:sym typeface="Instrument Sans"/>
-              </a:rPr>
-              <a:t>美国：智能体与机器人每年释放的价值（麦肯锡）</a:t>
-            </a:r>
-          </a:p>
-        </p:txBody>
-      </p:sp>
-      <p:sp>
-        <p:nvSpPr>
-          <p:cNvPr id="3035" name="SimReal 3035"/>
-          <p:cNvSpPr txBox="1"/>
-          <p:nvPr/>
-        </p:nvSpPr>
-        <p:spPr>
-          <a:xfrm>
-            <a:off x="10488168" y="2505456"/>
-            <a:ext cx="914400" cy="365760"/>
-          </a:xfrm>
-          <a:prstGeom prst="rect">
-            <a:avLst/>
-          </a:prstGeom>
-          <a:noFill/>
-          <a:ln>
-            <a:noFill/>
-          </a:ln>
-        </p:spPr>
-        <p:txBody>
-          <a:bodyPr spcFirstLastPara="1" wrap="square" lIns="0" tIns="0" rIns="0" bIns="0" anchor="ctr" anchorCtr="0">
-            <a:noAutofit/>
-          </a:bodyPr>
-          <a:lstStyle/>
-          <a:p>
-            <a:pPr marL="0" marR="0" lvl="0" indent="0" algn="r" rtl="0">
-              <a:spcBef>
-                <a:spcPts val="0"/>
-              </a:spcBef>
-              <a:spcAft>
-                <a:spcPts val="0"/>
-              </a:spcAft>
-              <a:buNone/>
-            </a:pPr>
-            <a:r>
-              <a:rPr lang="zh-CN" sz="1300" b="0" i="0" u="none" strike="noStrike" cap="none">
-                <a:solidFill>
-                  <a:srgbClr val="FAF9F6"/>
-                </a:solidFill>
-                <a:latin typeface="Newsreader"/>
-                <a:ea typeface="Newsreader"/>
-                <a:cs typeface="Newsreader"/>
-                <a:sym typeface="Newsreader"/>
-              </a:rPr>
-              <a:t>2.9万亿</a:t>
-            </a:r>
-          </a:p>
-        </p:txBody>
-      </p:sp>
-      <p:sp>
-        <p:nvSpPr>
-          <p:cNvPr id="3036" name="SimReal 3036"/>
-          <p:cNvSpPr/>
-          <p:nvPr/>
-        </p:nvSpPr>
-        <p:spPr>
-          <a:xfrm>
-            <a:off x="8363712" y="2871216"/>
-            <a:ext cx="3038856" cy="9144"/>
-          </a:xfrm>
-          <a:prstGeom prst="rect">
-            <a:avLst/>
-          </a:prstGeom>
-          <a:solidFill>
-            <a:srgbClr val="3A3935"/>
-          </a:solidFill>
-          <a:ln>
-            <a:noFill/>
-          </a:ln>
-        </p:spPr>
-        <p:txBody>
-          <a:bodyPr/>
-          <a:lstStyle/>
-          <a:p>
-            <a:endParaRPr/>
-          </a:p>
-        </p:txBody>
-      </p:sp>
-      <p:sp>
-        <p:nvSpPr>
-          <p:cNvPr id="3037" name="SimReal 3037"/>
-          <p:cNvSpPr txBox="1"/>
-          <p:nvPr/>
-        </p:nvSpPr>
-        <p:spPr>
-          <a:xfrm>
-            <a:off x="8363712" y="2871216"/>
-            <a:ext cx="2124456" cy="365760"/>
-          </a:xfrm>
-          <a:prstGeom prst="rect">
-            <a:avLst/>
-          </a:prstGeom>
-          <a:noFill/>
-          <a:ln>
-            <a:noFill/>
-          </a:ln>
-        </p:spPr>
-        <p:txBody>
-          <a:bodyPr spcFirstLastPara="1" wrap="square" lIns="0" tIns="0" rIns="0" bIns="0" anchor="ctr" anchorCtr="0">
-            <a:noAutofit/>
-          </a:bodyPr>
-          <a:lstStyle/>
-          <a:p>
-            <a:pPr marL="0" marR="0" lvl="0" indent="0" algn="l" rtl="0">
-              <a:lnSpc>
-                <a:spcPct val="105000"/>
-              </a:lnSpc>
-              <a:spcBef>
-                <a:spcPts val="0"/>
-              </a:spcBef>
-              <a:spcAft>
-                <a:spcPts val="0"/>
-              </a:spcAft>
-              <a:buNone/>
-            </a:pPr>
-            <a:r>
-              <a:rPr lang="zh-CN" sz="1000" b="0" i="0" u="none" strike="noStrike" cap="none">
-                <a:solidFill>
-                  <a:srgbClr val="C4C0B7"/>
-                </a:solidFill>
-                <a:latin typeface="Instrument Sans"/>
-                <a:ea typeface="Instrument Sans"/>
-                <a:cs typeface="Instrument Sans"/>
-                <a:sym typeface="Instrument Sans"/>
-              </a:rPr>
-              <a:t>÷ 美国占全球GDP（IMF）</a:t>
-            </a:r>
-          </a:p>
-        </p:txBody>
-      </p:sp>
-      <p:sp>
-        <p:nvSpPr>
-          <p:cNvPr id="3038" name="SimReal 3038"/>
-          <p:cNvSpPr txBox="1"/>
-          <p:nvPr/>
-        </p:nvSpPr>
-        <p:spPr>
-          <a:xfrm>
-            <a:off x="10488168" y="2871216"/>
-            <a:ext cx="914400" cy="365760"/>
-          </a:xfrm>
-          <a:prstGeom prst="rect">
-            <a:avLst/>
-          </a:prstGeom>
-          <a:noFill/>
-          <a:ln>
-            <a:noFill/>
-          </a:ln>
-        </p:spPr>
-        <p:txBody>
-          <a:bodyPr spcFirstLastPara="1" wrap="square" lIns="0" tIns="0" rIns="0" bIns="0" anchor="ctr" anchorCtr="0">
-            <a:noAutofit/>
-          </a:bodyPr>
-          <a:lstStyle/>
-          <a:p>
-            <a:pPr marL="0" marR="0" lvl="0" indent="0" algn="r" rtl="0">
-              <a:spcBef>
-                <a:spcPts val="0"/>
-              </a:spcBef>
-              <a:spcAft>
-                <a:spcPts val="0"/>
-              </a:spcAft>
-              <a:buNone/>
-            </a:pPr>
-            <a:r>
-              <a:rPr lang="zh-CN" sz="1300" b="0" i="0" u="none" strike="noStrike" cap="none">
-                <a:solidFill>
-                  <a:srgbClr val="FAF9F6"/>
-                </a:solidFill>
-                <a:latin typeface="Newsreader"/>
-                <a:ea typeface="Newsreader"/>
-                <a:cs typeface="Newsreader"/>
-                <a:sym typeface="Newsreader"/>
-              </a:rPr>
-              <a:t>25.6%</a:t>
-            </a:r>
-          </a:p>
-        </p:txBody>
-      </p:sp>
-      <p:sp>
-        <p:nvSpPr>
-          <p:cNvPr id="3039" name="SimReal 3039"/>
-          <p:cNvSpPr/>
-          <p:nvPr/>
-        </p:nvSpPr>
-        <p:spPr>
-          <a:xfrm>
-            <a:off x="8363712" y="3236976"/>
-            <a:ext cx="3038856" cy="9144"/>
-          </a:xfrm>
-          <a:prstGeom prst="rect">
-            <a:avLst/>
-          </a:prstGeom>
-          <a:solidFill>
-            <a:srgbClr val="3A3935"/>
-          </a:solidFill>
-          <a:ln>
-            <a:noFill/>
-          </a:ln>
-        </p:spPr>
-        <p:txBody>
-          <a:bodyPr/>
-          <a:lstStyle/>
-          <a:p>
-            <a:endParaRPr/>
-          </a:p>
-        </p:txBody>
-      </p:sp>
-      <p:sp>
-        <p:nvSpPr>
-          <p:cNvPr id="3040" name="SimReal 3040"/>
-          <p:cNvSpPr txBox="1"/>
-          <p:nvPr/>
-        </p:nvSpPr>
-        <p:spPr>
-          <a:xfrm>
-            <a:off x="8363712" y="3236976"/>
-            <a:ext cx="2124456" cy="365760"/>
-          </a:xfrm>
-          <a:prstGeom prst="rect">
-            <a:avLst/>
-          </a:prstGeom>
-          <a:noFill/>
-          <a:ln>
-            <a:noFill/>
-          </a:ln>
-        </p:spPr>
-        <p:txBody>
-          <a:bodyPr spcFirstLastPara="1" wrap="square" lIns="0" tIns="0" rIns="0" bIns="0" anchor="ctr" anchorCtr="0">
-            <a:noAutofit/>
-          </a:bodyPr>
-          <a:lstStyle/>
-          <a:p>
-            <a:pPr marL="0" marR="0" lvl="0" indent="0" algn="l" rtl="0">
-              <a:lnSpc>
-                <a:spcPct val="105000"/>
-              </a:lnSpc>
-              <a:spcBef>
-                <a:spcPts val="0"/>
-              </a:spcBef>
-              <a:spcAft>
-                <a:spcPts val="0"/>
-              </a:spcAft>
-              <a:buNone/>
-            </a:pPr>
-            <a:r>
-              <a:rPr lang="zh-CN" sz="1000" b="0" i="0" u="none" strike="noStrike" cap="none">
-                <a:solidFill>
-                  <a:srgbClr val="C4C0B7"/>
-                </a:solidFill>
-                <a:latin typeface="Instrument Sans"/>
-                <a:ea typeface="Instrument Sans"/>
-                <a:cs typeface="Instrument Sans"/>
-                <a:sym typeface="Instrument Sans"/>
-              </a:rPr>
-              <a:t>= 按美国渗透率外推到全球</a:t>
-            </a:r>
-          </a:p>
-        </p:txBody>
-      </p:sp>
-      <p:sp>
-        <p:nvSpPr>
-          <p:cNvPr id="3041" name="SimReal 3041"/>
-          <p:cNvSpPr txBox="1"/>
-          <p:nvPr/>
-        </p:nvSpPr>
-        <p:spPr>
-          <a:xfrm>
-            <a:off x="10488168" y="3236976"/>
-            <a:ext cx="914400" cy="365760"/>
-          </a:xfrm>
-          <a:prstGeom prst="rect">
-            <a:avLst/>
-          </a:prstGeom>
-          <a:noFill/>
-          <a:ln>
-            <a:noFill/>
-          </a:ln>
-        </p:spPr>
-        <p:txBody>
-          <a:bodyPr spcFirstLastPara="1" wrap="square" lIns="0" tIns="0" rIns="0" bIns="0" anchor="ctr" anchorCtr="0">
-            <a:noAutofit/>
-          </a:bodyPr>
-          <a:lstStyle/>
-          <a:p>
-            <a:pPr marL="0" marR="0" lvl="0" indent="0" algn="r" rtl="0">
-              <a:spcBef>
-                <a:spcPts val="0"/>
-              </a:spcBef>
-              <a:spcAft>
-                <a:spcPts val="0"/>
-              </a:spcAft>
-              <a:buNone/>
-            </a:pPr>
-            <a:r>
-              <a:rPr lang="zh-CN" sz="1300" b="0" i="0" u="none" strike="noStrike" cap="none">
-                <a:solidFill>
-                  <a:srgbClr val="FAF9F6"/>
-                </a:solidFill>
-                <a:latin typeface="Newsreader"/>
-                <a:ea typeface="Newsreader"/>
-                <a:cs typeface="Newsreader"/>
-                <a:sym typeface="Newsreader"/>
-              </a:rPr>
-              <a:t>11.3万亿</a:t>
-            </a:r>
-          </a:p>
-        </p:txBody>
-      </p:sp>
-      <p:sp>
-        <p:nvSpPr>
-          <p:cNvPr id="3042" name="SimReal 3042"/>
-          <p:cNvSpPr/>
-          <p:nvPr/>
-        </p:nvSpPr>
-        <p:spPr>
-          <a:xfrm>
-            <a:off x="8363712" y="3602736"/>
-            <a:ext cx="3038856" cy="9144"/>
-          </a:xfrm>
-          <a:prstGeom prst="rect">
-            <a:avLst/>
-          </a:prstGeom>
-          <a:solidFill>
-            <a:srgbClr val="3A3935"/>
-          </a:solidFill>
-          <a:ln>
-            <a:noFill/>
-          </a:ln>
-        </p:spPr>
-        <p:txBody>
-          <a:bodyPr/>
-          <a:lstStyle/>
-          <a:p>
-            <a:endParaRPr/>
-          </a:p>
-        </p:txBody>
-      </p:sp>
-      <p:sp>
-        <p:nvSpPr>
-          <p:cNvPr id="3043" name="SimReal 3043"/>
-          <p:cNvSpPr txBox="1"/>
-          <p:nvPr/>
-        </p:nvSpPr>
-        <p:spPr>
-          <a:xfrm>
-            <a:off x="8363712" y="3602736"/>
-            <a:ext cx="2124456" cy="365760"/>
-          </a:xfrm>
-          <a:prstGeom prst="rect">
-            <a:avLst/>
-          </a:prstGeom>
-          <a:noFill/>
-          <a:ln>
-            <a:noFill/>
-          </a:ln>
-        </p:spPr>
-        <p:txBody>
-          <a:bodyPr spcFirstLastPara="1" wrap="square" lIns="0" tIns="0" rIns="0" bIns="0" anchor="ctr" anchorCtr="0">
-            <a:noAutofit/>
-          </a:bodyPr>
-          <a:lstStyle/>
-          <a:p>
-            <a:pPr marL="0" marR="0" lvl="0" indent="0" algn="l" rtl="0">
-              <a:lnSpc>
-                <a:spcPct val="105000"/>
-              </a:lnSpc>
-              <a:spcBef>
-                <a:spcPts val="0"/>
-              </a:spcBef>
-              <a:spcAft>
-                <a:spcPts val="0"/>
-              </a:spcAft>
-              <a:buNone/>
-            </a:pPr>
-            <a:r>
-              <a:rPr lang="zh-CN" sz="1000" b="1" i="0" u="none" strike="noStrike" cap="none">
-                <a:solidFill>
-                  <a:srgbClr val="FAF9F6"/>
-                </a:solidFill>
-                <a:latin typeface="Instrument Sans"/>
-                <a:ea typeface="Instrument Sans"/>
-                <a:cs typeface="Instrument Sans"/>
-                <a:sym typeface="Instrument Sans"/>
-              </a:rPr>
-              <a:t>美国以外只按一半渗透率</a:t>
-            </a:r>
-          </a:p>
-        </p:txBody>
-      </p:sp>
-      <p:sp>
-        <p:nvSpPr>
-          <p:cNvPr id="3044" name="SimReal 3044"/>
-          <p:cNvSpPr txBox="1"/>
-          <p:nvPr/>
-        </p:nvSpPr>
-        <p:spPr>
-          <a:xfrm>
-            <a:off x="10488168" y="3602736"/>
-            <a:ext cx="914400" cy="365760"/>
-          </a:xfrm>
-          <a:prstGeom prst="rect">
-            <a:avLst/>
-          </a:prstGeom>
-          <a:noFill/>
-          <a:ln>
-            <a:noFill/>
-          </a:ln>
-        </p:spPr>
-        <p:txBody>
-          <a:bodyPr spcFirstLastPara="1" wrap="square" lIns="0" tIns="0" rIns="0" bIns="0" anchor="ctr" anchorCtr="0">
-            <a:noAutofit/>
-          </a:bodyPr>
-          <a:lstStyle/>
-          <a:p>
-            <a:pPr marL="0" marR="0" lvl="0" indent="0" algn="r" rtl="0">
-              <a:spcBef>
-                <a:spcPts val="0"/>
-              </a:spcBef>
-              <a:spcAft>
-                <a:spcPts val="0"/>
-              </a:spcAft>
-              <a:buNone/>
-            </a:pPr>
-            <a:r>
-              <a:rPr lang="zh-CN" sz="1300" b="0" i="0" u="none" strike="noStrike" cap="none">
-                <a:solidFill>
-                  <a:srgbClr val="E27A3F"/>
-                </a:solidFill>
-                <a:latin typeface="Newsreader"/>
-                <a:ea typeface="Newsreader"/>
-                <a:cs typeface="Newsreader"/>
-                <a:sym typeface="Newsreader"/>
-              </a:rPr>
-              <a:t>约7.1万亿</a:t>
-            </a:r>
-          </a:p>
-        </p:txBody>
-      </p:sp>
-      <p:sp>
-        <p:nvSpPr>
-          <p:cNvPr id="3045" name="SimReal 3045"/>
-          <p:cNvSpPr txBox="1"/>
-          <p:nvPr/>
-        </p:nvSpPr>
-        <p:spPr>
-          <a:xfrm>
-            <a:off x="8363712" y="4133088"/>
-            <a:ext cx="3038856" cy="731520"/>
-          </a:xfrm>
-          <a:prstGeom prst="rect">
-            <a:avLst/>
-          </a:prstGeom>
-          <a:noFill/>
-          <a:ln>
-            <a:noFill/>
-          </a:ln>
-        </p:spPr>
-        <p:txBody>
-          <a:bodyPr spcFirstLastPara="1" wrap="square" lIns="0" tIns="0" rIns="0" bIns="0" anchor="t" anchorCtr="0">
-            <a:noAutofit/>
-          </a:bodyPr>
-          <a:lstStyle/>
-          <a:p>
-            <a:pPr marL="0" marR="0" lvl="0" indent="0" algn="l" rtl="0">
-              <a:spcBef>
-                <a:spcPts val="0"/>
-              </a:spcBef>
-              <a:spcAft>
-                <a:spcPts val="0"/>
-              </a:spcAft>
-              <a:buNone/>
-            </a:pPr>
-            <a:r>
-              <a:rPr lang="zh-CN" sz="1200" b="1" i="0" u="none" strike="noStrike" cap="none">
-                <a:solidFill>
-                  <a:srgbClr val="FAF9F6"/>
-                </a:solidFill>
-                <a:latin typeface="Instrument Sans"/>
-                <a:ea typeface="Instrument Sans"/>
-                <a:cs typeface="Instrument Sans"/>
-                <a:sym typeface="Instrument Sans"/>
-              </a:rPr>
-              <a:t>训练层只相当于它创造价值的2–6%</a:t>
-            </a:r>
-          </a:p>
-          <a:p>
-            <a:pPr marL="0" marR="0" lvl="0" indent="0" algn="l" rtl="0">
-              <a:spcBef>
-                <a:spcPts val="400"/>
-              </a:spcBef>
-              <a:spcAft>
-                <a:spcPts val="0"/>
-              </a:spcAft>
-              <a:buNone/>
-            </a:pPr>
-            <a:r>
-              <a:rPr lang="zh-CN" sz="1000" b="0" i="0" u="none" strike="noStrike" cap="none">
-                <a:solidFill>
-                  <a:srgbClr val="C4C0B7"/>
-                </a:solidFill>
-                <a:latin typeface="Instrument Sans"/>
-                <a:ea typeface="Instrument Sans"/>
-                <a:cs typeface="Instrument Sans"/>
-                <a:sym typeface="Instrument Sans"/>
-              </a:rPr>
-              <a:t>每一份交给AI的工作，都要先在训练世界里练过</a:t>
-            </a:r>
-          </a:p>
-        </p:txBody>
-      </p:sp>
-      <p:sp>
-        <p:nvSpPr>
-          <p:cNvPr id="3046" name="SimReal 3046"/>
-          <p:cNvSpPr txBox="1"/>
-          <p:nvPr/>
-        </p:nvSpPr>
-        <p:spPr>
-          <a:xfrm>
-            <a:off x="548640" y="5358384"/>
-            <a:ext cx="11091672" cy="402336"/>
-          </a:xfrm>
-          <a:prstGeom prst="rect">
-            <a:avLst/>
-          </a:prstGeom>
-          <a:noFill/>
-          <a:ln>
-            <a:noFill/>
-          </a:ln>
-        </p:spPr>
-        <p:txBody>
-          <a:bodyPr spcFirstLastPara="1" wrap="square" lIns="0" tIns="0" rIns="0" bIns="0" anchor="ctr" anchorCtr="0">
-            <a:noAutofit/>
-          </a:bodyPr>
-          <a:lstStyle/>
-          <a:p>
-            <a:pPr marL="0" marR="0" lvl="0" indent="0" algn="l" rtl="0">
-              <a:spcBef>
-                <a:spcPts val="0"/>
-              </a:spcBef>
-              <a:spcAft>
-                <a:spcPts val="0"/>
-              </a:spcAft>
-              <a:buNone/>
-            </a:pPr>
-            <a:r>
-              <a:rPr lang="zh-CN" sz="2000" b="0" i="0" u="none" strike="noStrike" cap="none">
-                <a:solidFill>
-                  <a:srgbClr val="111110"/>
-                </a:solidFill>
-                <a:latin typeface="Newsreader"/>
-                <a:ea typeface="Newsreader"/>
-                <a:cs typeface="Newsreader"/>
-                <a:sym typeface="Newsreader"/>
-              </a:rPr>
-              <a:t>今天卖给实验室，2030年卖给</a:t>
-            </a:r>
-            <a:r>
-              <a:rPr lang="zh-CN" sz="2000" b="0" i="0" u="none" strike="noStrike" cap="none">
-                <a:solidFill>
-                  <a:srgbClr val="C2410C"/>
-                </a:solidFill>
-                <a:latin typeface="Newsreader"/>
-                <a:ea typeface="Newsreader"/>
-                <a:cs typeface="Newsreader"/>
-                <a:sym typeface="Newsreader"/>
-              </a:rPr>
-              <a:t>整个AI经济的训练层</a:t>
-            </a:r>
-            <a:r>
-              <a:rPr lang="zh-CN" sz="2000" b="0" i="0" u="none" strike="noStrike" cap="none">
-                <a:solidFill>
-                  <a:srgbClr val="111110"/>
-                </a:solidFill>
-                <a:latin typeface="Newsreader"/>
-                <a:ea typeface="Newsreader"/>
-                <a:cs typeface="Newsreader"/>
-                <a:sym typeface="Newsreader"/>
-              </a:rPr>
-              <a:t>：它只占AI创造价值的2–6%。</a:t>
-            </a:r>
-          </a:p>
-        </p:txBody>
-      </p:sp>
-      <p:sp>
-        <p:nvSpPr>
-          <p:cNvPr id="3047" name="SimReal 3047"/>
-          <p:cNvSpPr txBox="1"/>
-          <p:nvPr/>
-        </p:nvSpPr>
-        <p:spPr>
-          <a:xfrm>
-            <a:off x="548640" y="5870448"/>
-            <a:ext cx="11091672" cy="329184"/>
-          </a:xfrm>
-          <a:prstGeom prst="rect">
-            <a:avLst/>
-          </a:prstGeom>
-          <a:noFill/>
-          <a:ln>
-            <a:noFill/>
-          </a:ln>
-        </p:spPr>
-        <p:txBody>
-          <a:bodyPr spcFirstLastPara="1" wrap="square" lIns="0" tIns="0" rIns="0" bIns="0" anchor="t" anchorCtr="0">
-            <a:noAutofit/>
-          </a:bodyPr>
-          <a:lstStyle/>
-          <a:p>
-            <a:pPr marL="0" marR="0" lvl="0" indent="0" algn="l" rtl="0">
-              <a:lnSpc>
-                <a:spcPct val="110000"/>
-              </a:lnSpc>
-              <a:spcBef>
-                <a:spcPts val="0"/>
-              </a:spcBef>
-              <a:spcAft>
-                <a:spcPts val="0"/>
-              </a:spcAft>
-              <a:buNone/>
-            </a:pPr>
-            <a:r>
-              <a:rPr lang="zh-CN" sz="800" b="0" i="0" u="none" strike="noStrike" cap="none">
-                <a:solidFill>
-                  <a:srgbClr val="6E6C66"/>
-                </a:solidFill>
-                <a:latin typeface="Instrument Sans"/>
-                <a:ea typeface="Instrument Sans"/>
-                <a:cs typeface="Instrument Sans"/>
-                <a:sym typeface="Instrument Sans"/>
-              </a:rPr>
-              <a:t>来源：Menlo Ventures（2026年7月）；黄仁勋，高盛Communacopia大会（2026年9月）；CNBC（2026年2月）；Mechanize；麦肯锡《Agents, robots, and us》（2025年11月）；IMF《世界经济展望》（2026年4月）。5–10%占比、美国以外按一半渗透率为推算假设。</a:t>
+              <a:t>来源：Menlo Ventures（2026.7）；Mercor年化毛营收（2026.7）、Surge收入（2024）、Snorkel年化收入（2026.9）；黄仁勋（2026.9）；CNBC（2026.2）；Mechanize；麦肯锡（2025.11）；IMF（2026.4）。训练层占比、美国以外渗透率为假设。</a:t>
             </a:r>
           </a:p>
         </p:txBody>
@@ -19842,7 +19585,7 @@
                 <a:cs typeface="Instrument Sans"/>
                 <a:sym typeface="Instrument Sans"/>
               </a:rPr>
-              <a:t>投后估值1.5亿美元  ·  出让约13%</a:t>
+              <a:t>投后1.5亿美元  ·  出让约13%</a:t>
             </a:r>
           </a:p>
         </p:txBody>
@@ -19963,7 +19706,7 @@
                 <a:cs typeface="IBM Plex Mono"/>
                 <a:sym typeface="IBM Plex Mono"/>
               </a:rPr>
-              <a:t>为什么是这个价格</a:t>
+              <a:t>估值依据</a:t>
             </a:r>
           </a:p>
         </p:txBody>
@@ -20142,7 +19885,7 @@
                 <a:cs typeface="Instrument Sans"/>
                 <a:sym typeface="Instrument Sans"/>
               </a:rPr>
-              <a:t>对标Applied Compute种子轮：成立一个月融资2,000万美元，投后1亿美元；4个月后5亿美元，14个月后约30亿美元</a:t>
+              <a:t>对标Applied Compute种子轮：2,000万美元，投后1亿，14个月后约30亿</a:t>
             </a:r>
           </a:p>
         </p:txBody>
@@ -20269,7 +20012,7 @@
                 <a:cs typeface="Newsreader"/>
                 <a:sym typeface="Newsreader"/>
               </a:rPr>
-              <a:t>产品迭代</a:t>
+              <a:t>产品</a:t>
             </a:r>
           </a:p>
         </p:txBody>
@@ -20321,7 +20064,7 @@
                 <a:cs typeface="Instrument Sans"/>
                 <a:sym typeface="Instrument Sans"/>
               </a:rPr>
-              <a:t>对标Snorkel E轮（估值35亿美元）：同样覆盖专家数据、RL训练环境和评测，我们还有自我进化服务；14天做出7款产品</a:t>
+              <a:t>对标Snorkel E轮（35亿美元）：同样的数据、环境、评测，另有自我进化</a:t>
             </a:r>
           </a:p>
         </p:txBody>
@@ -20448,7 +20191,7 @@
                 <a:cs typeface="Newsreader"/>
                 <a:sym typeface="Newsreader"/>
               </a:rPr>
-              <a:t>收入目标</a:t>
+              <a:t>收入</a:t>
             </a:r>
           </a:p>
         </p:txBody>
@@ -20500,7 +20243,7 @@
                 <a:cs typeface="Instrument Sans"/>
                 <a:sym typeface="Instrument Sans"/>
               </a:rPr>
-              <a:t>6个月年化1亿美元，12个月3亿美元。AfterQuery从加入YC到年化1亿美元用了约13个月</a:t>
+              <a:t>6个月年化1亿美元，12个月3亿美元；AfterQuery做到1亿美元用了13个月</a:t>
             </a:r>
           </a:p>
         </p:txBody>
@@ -20679,7 +20422,7 @@
                 <a:cs typeface="Instrument Sans"/>
                 <a:sym typeface="Instrument Sans"/>
               </a:rPr>
-              <a:t>投后1.5亿美元，是AfterQuery同等收入时A轮估值（3亿美元）的一半；6个月后按其A轮价约2倍，按其最新价约20倍</a:t>
+              <a:t>AfterQuery年化1亿美元时A轮估值3亿美元，我们是一半；6个月回报2–20倍</a:t>
             </a:r>
           </a:p>
         </p:txBody>
@@ -21510,7 +21253,7 @@
                 <a:cs typeface="Instrument Sans"/>
                 <a:sym typeface="Instrument Sans"/>
               </a:rPr>
-              <a:t>估值为投后估值。来源：Upstarts、The Information、TechCrunch、Business Wire、福布斯、彭博。AfterQuery 9月收入未公开，“约20倍”为上限。</a:t>
+              <a:t>估值均为投后。2倍按AfterQuery A轮估值、20倍按其最新估值计（其9月收入未公开，为上限）。来源见A3。</a:t>
             </a:r>
           </a:p>
         </p:txBody>
@@ -25128,7 +24871,7 @@
                 <a:cs typeface="Instrument Sans"/>
                 <a:sym typeface="Instrument Sans"/>
               </a:rPr>
-              <a:t>向AI实验室出售训练数据和RL环境的50余家公司，年收入合计已达约85亿美元；2030年训练层每年1,500–4,000亿美元，服务7万亿美元的AI经济</a:t>
+              <a:t>实验室今天每年买85亿美元训练数据与RL环境；2030年训练层每年1,500–4,000亿美元，服务7万亿美元的AI经济</a:t>
             </a:r>
             <a:endParaRPr sz="1200" b="0" i="0" u="none" strike="noStrike" cap="none" dirty="0">
               <a:solidFill>
@@ -25343,7 +25086,7 @@
                 <a:cs typeface="Instrument Sans"/>
                 <a:sym typeface="Instrument Sans"/>
               </a:rPr>
-              <a:t>种子轮2,000万美元，投后估值1.5亿美元；6个月年化收入1亿美元，12个月3亿美元</a:t>
+              <a:t>种子轮2,000万美元，投后1.5亿美元；6个月年化收入1亿美元，12个月3亿美元</a:t>
             </a:r>
             <a:endParaRPr sz="1200" b="0" i="0" u="none" strike="noStrike" cap="none">
               <a:solidFill>
@@ -32127,7 +31870,7 @@
                 <a:cs typeface="Newsreader"/>
                 <a:sym typeface="Newsreader"/>
               </a:rPr>
-              <a:t>环境数 × 每年卖出次数 × 单价</a:t>
+              <a:t>环境数 × 卖出次数 × 单价</a:t>
             </a:r>
           </a:p>
         </p:txBody>
@@ -32299,7 +32042,7 @@
                 <a:cs typeface="Instrument Sans"/>
                 <a:sym typeface="Instrument Sans"/>
               </a:rPr>
-              <a:t>每年卖出次数 = 实验室数 × 每年约2轮模型迭代；单价：一个环境2万–30万美元，独家4–5倍（Epoch AI）</a:t>
+              <a:t>卖出次数 = 实验室数 × 每年2轮迭代（6个月5家，12个月6家）；单价区间2万–30万美元（Epoch AI）</a:t>
             </a:r>
           </a:p>
         </p:txBody>
@@ -32475,7 +32218,7 @@
                 <a:cs typeface="Newsreader"/>
                 <a:sym typeface="Newsreader"/>
               </a:rPr>
-              <a:t>环境 7→50个</a:t>
+              <a:t>环境 7→50</a:t>
             </a:r>
           </a:p>
         </p:txBody>
@@ -32527,7 +32270,7 @@
                 <a:cs typeface="Instrument Sans"/>
                 <a:sym typeface="Instrument Sans"/>
               </a:rPr>
-              <a:t>推动环境数  </a:t>
+              <a:t>环境数  </a:t>
             </a:r>
             <a:r>
               <a:rPr lang="zh-CN" sz="1050" b="0" i="0" u="none" strike="noStrike" cap="none">
@@ -32539,7 +32282,7 @@
                 <a:cs typeface="Instrument Sans"/>
                 <a:sym typeface="Instrument Sans"/>
               </a:rPr>
-              <a:t>行业专家、环境工程、上线前攻防测试</a:t>
+              <a:t>专家、环境工程、攻防测试</a:t>
             </a:r>
           </a:p>
         </p:txBody>
@@ -32666,7 +32409,7 @@
                 <a:cs typeface="Newsreader"/>
                 <a:sym typeface="Newsreader"/>
               </a:rPr>
-              <a:t>实验室交付</a:t>
+              <a:t>交付</a:t>
             </a:r>
           </a:p>
         </p:txBody>
@@ -32718,7 +32461,7 @@
                 <a:cs typeface="Instrument Sans"/>
                 <a:sym typeface="Instrument Sans"/>
               </a:rPr>
-              <a:t>推动卖出次数  </a:t>
+              <a:t>卖出次数  </a:t>
             </a:r>
             <a:r>
               <a:rPr lang="zh-CN" sz="1050" b="0" i="0" u="none" strike="noStrike" cap="none">
@@ -32730,7 +32473,7 @@
                 <a:cs typeface="Instrument Sans"/>
                 <a:sym typeface="Instrument Sans"/>
               </a:rPr>
-              <a:t>驻场工程师接入实验室训练管线，加沙箱集群</a:t>
+              <a:t>驻场工程师、沙箱集群</a:t>
             </a:r>
           </a:p>
         </p:txBody>
@@ -32909,7 +32652,7 @@
                 <a:cs typeface="Instrument Sans"/>
                 <a:sym typeface="Instrument Sans"/>
               </a:rPr>
-              <a:t>推动单价  </a:t>
+              <a:t>单价  </a:t>
             </a:r>
             <a:r>
               <a:rPr lang="zh-CN" sz="1050" b="0" i="0" u="none" strike="noStrike" cap="none">
@@ -32921,7 +32664,7 @@
                 <a:cs typeface="Instrument Sans"/>
                 <a:sym typeface="Instrument Sans"/>
               </a:rPr>
-              <a:t>每个环境上线前实测训练提升，作为报价依据</a:t>
+              <a:t>上线前实测训练提升</a:t>
             </a:r>
           </a:p>
         </p:txBody>
@@ -33100,7 +32843,7 @@
                 <a:cs typeface="Instrument Sans"/>
                 <a:sym typeface="Instrument Sans"/>
               </a:rPr>
-              <a:t>量化、强化学习研究、环境工程</a:t>
+              <a:t>量化、RL研究、环境工程</a:t>
             </a:r>
           </a:p>
         </p:txBody>
@@ -33279,7 +33022,7 @@
                 <a:cs typeface="Instrument Sans"/>
                 <a:sym typeface="Instrument Sans"/>
               </a:rPr>
-              <a:t>法务、财务、办公</a:t>
+              <a:t>法务、财务</a:t>
             </a:r>
           </a:p>
         </p:txBody>
@@ -33885,7 +33628,7 @@
                 <a:cs typeface="Instrument Sans"/>
                 <a:sym typeface="Instrument Sans"/>
               </a:rPr>
-              <a:t>6个月之后，从年化1亿美元到3亿美元的扩张由收入支撑。</a:t>
+              <a:t>6个月后，扩张由收入支撑。</a:t>
             </a:r>
           </a:p>
         </p:txBody>

</xml_diff>

<commit_message>
BP v17: tighten copy on every remaining page
Same facts, fewer words across pages 1-13, 15-16, closing and A1/A4:
drop repeated phrases, keep each line to one claim. Text is replaced
paragraph by paragraph so original spacing, line breaks and accent
colours carry over. Closing page: move subtitle and contacts below the
two-line title so they no longer overlap.

Co-Authored-By: Claude Opus 5.5 <noreply@anthropic.com>
Claude-Session: https://claude.ai/code/session_01EKqGwTA92C8Wo4e47t73NN
</commit_message>
<xml_diff>
--- a/SimReal-BP-v17.pptx
+++ b/SimReal-BP-v17.pptx
@@ -5968,7 +5968,7 @@
                   </a:schemeClr>
                 </a:solidFill>
               </a:rPr>
-              <a:t>AI经济的引擎：以数据、环境与自我进化，推动AI的下一次跃迁。</a:t>
+              <a:t>AI经济的引擎：用数据、环境与自我进化，推动AI下一次跃迁</a:t>
             </a:r>
             <a:br>
               <a:rPr lang="en-CN" b="1" dirty="0">
@@ -6112,7 +6112,7 @@
                 <a:cs typeface="Newsreader"/>
                 <a:sym typeface="Newsreader"/>
               </a:rPr>
-              <a:t>都会来自我们搭建的世界</a:t>
+              <a:t>都来自我们搭建的世界</a:t>
             </a:r>
             <a:endParaRPr sz="5400" dirty="0">
               <a:solidFill>
@@ -7103,43 +7103,19 @@
                 <a:cs typeface="Newsreader"/>
                 <a:sym typeface="Newsreader"/>
               </a:rPr>
-              <a:t>AI无法作弊的</a:t>
-            </a:r>
-            <a:r>
-              <a:rPr lang="en-CN" sz="2800" b="0" dirty="0">
-                <a:solidFill>
-                  <a:srgbClr val="111110"/>
+              <a:t>AI作弊不了：</a:t>
+            </a:r>
+            <a:r>
+              <a:rPr sz="2800" b="0" dirty="0" err="1">
+                <a:solidFill>
+                  <a:srgbClr val="C2410C"/>
                 </a:solidFill>
                 <a:latin typeface="Newsreader"/>
                 <a:ea typeface="Newsreader"/>
                 <a:cs typeface="Newsreader"/>
                 <a:sym typeface="Newsreader"/>
               </a:rPr>
-              <a:t>高质量</a:t>
-            </a:r>
-            <a:r>
-              <a:rPr sz="2800" b="0" dirty="0" err="1">
-                <a:solidFill>
-                  <a:srgbClr val="111110"/>
-                </a:solidFill>
-                <a:latin typeface="Newsreader"/>
-                <a:ea typeface="Newsreader"/>
-                <a:cs typeface="Newsreader"/>
-                <a:sym typeface="Newsreader"/>
-              </a:rPr>
-              <a:t>训练环境：</a:t>
-            </a:r>
-            <a:r>
-              <a:rPr sz="2800" b="0" dirty="0" err="1">
-                <a:solidFill>
-                  <a:srgbClr val="C2410C"/>
-                </a:solidFill>
-                <a:latin typeface="Newsreader"/>
-                <a:ea typeface="Newsreader"/>
-                <a:cs typeface="Newsreader"/>
-                <a:sym typeface="Newsreader"/>
-              </a:rPr>
-              <a:t>每一分算力，都用在真正的进化上</a:t>
+              <a:t>每一分算力，都用在真进化上</a:t>
             </a:r>
             <a:endParaRPr sz="2800" b="0" dirty="0">
               <a:solidFill>
@@ -7362,44 +7338,67 @@
                 <a:cs typeface="Instrument Sans"/>
                 <a:sym typeface="Instrument Sans"/>
               </a:rPr>
-              <a:t>749道题，每一道上线前我们都先攻击一遍：模型能钻的空子，我们先找到、先补上。</a:t>
-            </a:r>
-          </a:p>
-        </p:txBody>
-      </p:sp>
-      <p:sp>
-        <p:nvSpPr>
-          <p:cNvPr id="346" name="TextBox 345"/>
-          <p:cNvSpPr txBox="1"/>
-          <p:nvPr/>
-        </p:nvSpPr>
-        <p:spPr>
-          <a:xfrm>
-            <a:off x="5120640" y="1554480"/>
-            <a:ext cx="6519672" cy="274320"/>
-          </a:xfrm>
-          <a:prstGeom prst="rect">
-            <a:avLst/>
-          </a:prstGeom>
-          <a:noFill/>
-        </p:spPr>
-        <p:txBody>
-          <a:bodyPr wrap="square" lIns="0" tIns="0" rIns="0" bIns="0" anchor="ctr">
-            <a:spAutoFit/>
-          </a:bodyPr>
-          <a:lstStyle/>
-          <a:p>
-            <a:pPr algn="l"/>
-            <a:r>
-              <a:rPr sz="1100" b="0">
-                <a:solidFill>
-                  <a:srgbClr val="6E6C66"/>
+              <a:t>749道题，上线前逐题攻击</a:t>
+            </a:r>
+            <a:br>
+              <a:rPr sz="1300" b="0">
+                <a:solidFill>
+                  <a:srgbClr val="FAF9F6"/>
                 </a:solidFill>
                 <a:latin typeface="Instrument Sans"/>
                 <a:ea typeface="Instrument Sans"/>
                 <a:cs typeface="Instrument Sans"/>
                 <a:sym typeface="Instrument Sans"/>
               </a:rPr>
+            </a:br>
+            <a:r>
+              <a:rPr sz="1300" b="0">
+                <a:solidFill>
+                  <a:srgbClr val="FAF9F6"/>
+                </a:solidFill>
+                <a:latin typeface="Instrument Sans"/>
+                <a:ea typeface="Instrument Sans"/>
+                <a:cs typeface="Instrument Sans"/>
+                <a:sym typeface="Instrument Sans"/>
+              </a:rPr>
+              <a:t>空子先被我们找到、补上</a:t>
+            </a:r>
+          </a:p>
+        </p:txBody>
+      </p:sp>
+      <p:sp>
+        <p:nvSpPr>
+          <p:cNvPr id="346" name="TextBox 345"/>
+          <p:cNvSpPr txBox="1"/>
+          <p:nvPr/>
+        </p:nvSpPr>
+        <p:spPr>
+          <a:xfrm>
+            <a:off x="5120640" y="1554480"/>
+            <a:ext cx="6519672" cy="274320"/>
+          </a:xfrm>
+          <a:prstGeom prst="rect">
+            <a:avLst/>
+          </a:prstGeom>
+          <a:noFill/>
+        </p:spPr>
+        <p:txBody>
+          <a:bodyPr wrap="square" lIns="0" tIns="0" rIns="0" bIns="0" anchor="ctr">
+            <a:spAutoFit/>
+          </a:bodyPr>
+          <a:lstStyle/>
+          <a:p>
+            <a:pPr algn="l"/>
+            <a:r>
+              <a:rPr sz="1100" b="0">
+                <a:solidFill>
+                  <a:srgbClr val="6E6C66"/>
+                </a:solidFill>
+                <a:latin typeface="Instrument Sans"/>
+                <a:ea typeface="Instrument Sans"/>
+                <a:cs typeface="Instrument Sans"/>
+                <a:sym typeface="Instrument Sans"/>
+              </a:rPr>
               <a:t>实验室为什么需要</a:t>
             </a:r>
           </a:p>
@@ -7509,7 +7508,30 @@
                 <a:cs typeface="Instrument Sans"/>
                 <a:sym typeface="Instrument Sans"/>
               </a:rPr>
-              <a:t>实验室每个强化学习任务要花的算力（Mechanize估算）。任务被钻空子，这笔钱就白花了。</a:t>
+              <a:t>每个RL任务的算力成本（Mechanize估算）</a:t>
+            </a:r>
+            <a:br>
+              <a:rPr sz="1300" b="0">
+                <a:solidFill>
+                  <a:srgbClr val="33322F"/>
+                </a:solidFill>
+                <a:latin typeface="Instrument Sans"/>
+                <a:ea typeface="Instrument Sans"/>
+                <a:cs typeface="Instrument Sans"/>
+                <a:sym typeface="Instrument Sans"/>
+              </a:rPr>
+            </a:br>
+            <a:r>
+              <a:rPr sz="1300" b="0">
+                <a:solidFill>
+                  <a:srgbClr val="33322F"/>
+                </a:solidFill>
+                <a:latin typeface="Instrument Sans"/>
+                <a:ea typeface="Instrument Sans"/>
+                <a:cs typeface="Instrument Sans"/>
+                <a:sym typeface="Instrument Sans"/>
+              </a:rPr>
+              <a:t>被钻空子，钱就白花</a:t>
             </a:r>
           </a:p>
         </p:txBody>
@@ -7642,7 +7664,7 @@
                 <a:cs typeface="Instrument Sans"/>
                 <a:sym typeface="Instrument Sans"/>
               </a:rPr>
-              <a:t>Month-End Close两轮受控对比：评分漏洞从6个降到0个。</a:t>
+              <a:t>Month-End Close两轮受控对比：评分漏洞6个降到0</a:t>
             </a:r>
           </a:p>
         </p:txBody>
@@ -7751,7 +7773,7 @@
                 <a:cs typeface="Instrument Sans"/>
                 <a:sym typeface="Instrument Sans"/>
               </a:rPr>
-              <a:t>只认真实结果：盈亏、账目、代码能不能跑。没有能被糊弄的裁判。</a:t>
+              <a:t>只认真实结果：盈亏、账目、代码能否运行</a:t>
             </a:r>
           </a:p>
         </p:txBody>
@@ -7822,7 +7844,7 @@
                 <a:cs typeface="Newsreader"/>
                 <a:sym typeface="Newsreader"/>
               </a:rPr>
-              <a:t>评分作弊不了，分数才可信；分数可信，AI才能真正进化；</a:t>
+              <a:t>作弊不了，分数才可信；分数可信，AI才能进化</a:t>
             </a:r>
           </a:p>
           <a:p>
@@ -7841,7 +7863,7 @@
                 <a:cs typeface="Newsreader"/>
                 <a:sym typeface="Newsreader"/>
               </a:rPr>
-              <a:t>我们让每一次训练都算数。</a:t>
+              <a:t>我们让每一次训练都算数</a:t>
             </a:r>
           </a:p>
         </p:txBody>
@@ -8003,7 +8025,7 @@
                 <a:cs typeface="Newsreader"/>
                 <a:sym typeface="Newsreader"/>
               </a:rPr>
-              <a:t>训练环境与专家数据打开合作，</a:t>
+              <a:t>环境与数据打开合作，</a:t>
             </a:r>
             <a:r>
               <a:rPr lang="zh-CN" sz="2800" b="0" i="0" u="none" strike="noStrike" cap="none">
@@ -8015,7 +8037,7 @@
                 <a:cs typeface="Newsreader"/>
                 <a:sym typeface="Newsreader"/>
               </a:rPr>
-              <a:t>RSI自我进化服务带来持续收入</a:t>
+              <a:t>自我进化服务带来持续收入</a:t>
             </a:r>
             <a:endParaRPr sz="2800" b="0" i="0" u="none" strike="noStrike" cap="none">
               <a:solidFill>
@@ -8141,7 +8163,7 @@
                 <a:cs typeface="Instrument Sans"/>
                 <a:sym typeface="Instrument Sans"/>
               </a:rPr>
-              <a:t>实验室每训练一个新模型，都会回来再买一轮。</a:t>
+              <a:t>实验室每训一个新模型，就回来再买一轮</a:t>
             </a:r>
             <a:endParaRPr sz="1100" b="0" i="0" u="none" strike="noStrike" cap="none">
               <a:solidFill>
@@ -8777,7 +8799,7 @@
                 <a:cs typeface="Instrument Sans"/>
                 <a:sym typeface="Instrument Sans"/>
               </a:rPr>
-              <a:t>美元 / 每份实验室合同 / 每季度</a:t>
+              <a:t>美元 / 每份合同 / 每季度</a:t>
             </a:r>
             <a:endParaRPr sz="1200" b="0" i="0" u="none" strike="noStrike" cap="none">
               <a:solidFill>
@@ -8814,7 +8836,7 @@
                 <a:cs typeface="Instrument Sans"/>
                 <a:sym typeface="Instrument Sans"/>
               </a:rPr>
-              <a:t>独家4–5倍（行业参考，Epoch AI）</a:t>
+              <a:t>独家4–5倍（Epoch AI）</a:t>
             </a:r>
             <a:endParaRPr sz="1200" b="0" i="0" u="none" strike="noStrike" cap="none">
               <a:solidFill>
@@ -9271,7 +9293,7 @@
                 <a:cs typeface="Instrument Sans"/>
                 <a:sym typeface="Instrument Sans"/>
               </a:rPr>
-              <a:t>环境授权；独家授权价格4–5倍</a:t>
+              <a:t>环境授权；独家价4–5倍</a:t>
             </a:r>
           </a:p>
         </p:txBody>
@@ -9414,7 +9436,7 @@
                 <a:cs typeface="Instrument Sans"/>
                 <a:sym typeface="Instrument Sans"/>
               </a:rPr>
-              <a:t>真实工作里的示范与判断</a:t>
+              <a:t>真实工作的示范与判断</a:t>
             </a:r>
           </a:p>
         </p:txBody>
@@ -9776,7 +9798,7 @@
                 <a:cs typeface="Instrument Sans"/>
                 <a:sym typeface="Instrument Sans"/>
               </a:rPr>
-              <a:t>模型每次升级，都回到我们的环境再训练</a:t>
+              <a:t>每次模型升级，都回来再训练</a:t>
             </a:r>
           </a:p>
         </p:txBody>
@@ -9814,7 +9836,7 @@
                 <a:cs typeface="Instrument Sans"/>
                 <a:sym typeface="Instrument Sans"/>
               </a:rPr>
-              <a:t>持续收费，随客户的模型升级增长</a:t>
+              <a:t>持续收费，随模型升级增长</a:t>
             </a:r>
           </a:p>
         </p:txBody>
@@ -10155,7 +10177,30 @@
                 <a:cs typeface="Instrument Sans"/>
                 <a:sym typeface="Instrument Sans"/>
               </a:rPr>
-              <a:t>家前沿AI实验室正在洽谈，目标第3个月签下首个付费客户</a:t>
+              <a:t>家前沿实验室在谈</a:t>
+            </a:r>
+            <a:br>
+              <a:rPr lang="zh-CN" sz="1200" b="0" i="0" u="none" strike="noStrike" cap="none">
+                <a:solidFill>
+                  <a:srgbClr val="C4C0B7"/>
+                </a:solidFill>
+                <a:latin typeface="Instrument Sans"/>
+                <a:ea typeface="Instrument Sans"/>
+                <a:cs typeface="Instrument Sans"/>
+                <a:sym typeface="Instrument Sans"/>
+              </a:rPr>
+            </a:br>
+            <a:r>
+              <a:rPr lang="zh-CN" sz="1200" b="0" i="0" u="none" strike="noStrike" cap="none">
+                <a:solidFill>
+                  <a:srgbClr val="C4C0B7"/>
+                </a:solidFill>
+                <a:latin typeface="Instrument Sans"/>
+                <a:ea typeface="Instrument Sans"/>
+                <a:cs typeface="Instrument Sans"/>
+                <a:sym typeface="Instrument Sans"/>
+              </a:rPr>
+              <a:t>目标第3个月首单</a:t>
             </a:r>
             <a:endParaRPr sz="1200" b="0" i="0" u="none" strike="noStrike" cap="none">
               <a:solidFill>
@@ -10319,7 +10364,7 @@
                 <a:cs typeface="Instrument Sans"/>
                 <a:sym typeface="Instrument Sans"/>
               </a:rPr>
-              <a:t>名专家在候补名单上</a:t>
+              <a:t>名专家候补</a:t>
             </a:r>
             <a:endParaRPr sz="1200" b="0" i="0" u="none" strike="noStrike" cap="none">
               <a:solidFill>
@@ -10635,7 +10680,7 @@
                 <a:cs typeface="Instrument Sans"/>
                 <a:sym typeface="Instrument Sans"/>
               </a:rPr>
-              <a:t>位硅谷顶级天使主动接洽</a:t>
+              <a:t>位硅谷顶级天使主动联系</a:t>
             </a:r>
             <a:endParaRPr sz="1200" b="0" i="0" u="none" strike="noStrike" cap="none">
               <a:solidFill>
@@ -10724,43 +10769,7 @@
                 <a:cs typeface="Newsreader"/>
                 <a:sym typeface="Newsreader"/>
               </a:rPr>
-              <a:t>全球顶级交易公司的从业者，</a:t>
-            </a:r>
-            <a:r>
-              <a:rPr lang="zh-CN" altLang="en-US" sz="2200" dirty="0">
-                <a:solidFill>
-                  <a:srgbClr val="FAF9F6"/>
-                </a:solidFill>
-                <a:latin typeface="Newsreader"/>
-                <a:ea typeface="Newsreader"/>
-                <a:cs typeface="Newsreader"/>
-                <a:sym typeface="Newsreader"/>
-              </a:rPr>
-              <a:t>正在支持</a:t>
-            </a:r>
-            <a:r>
-              <a:rPr lang="zh-CN" sz="2200" b="0" i="0" u="none" strike="noStrike" cap="none" dirty="0">
-                <a:solidFill>
-                  <a:srgbClr val="FAF9F6"/>
-                </a:solidFill>
-                <a:latin typeface="Newsreader"/>
-                <a:ea typeface="Newsreader"/>
-                <a:cs typeface="Newsreader"/>
-                <a:sym typeface="Newsreader"/>
-              </a:rPr>
-              <a:t>我们</a:t>
-            </a:r>
-            <a:r>
-              <a:rPr lang="zh-CN" altLang="en-US" sz="2200" b="0" i="0" u="none" strike="noStrike" cap="none" dirty="0">
-                <a:solidFill>
-                  <a:srgbClr val="FAF9F6"/>
-                </a:solidFill>
-                <a:latin typeface="Newsreader"/>
-                <a:ea typeface="Newsreader"/>
-                <a:cs typeface="Newsreader"/>
-                <a:sym typeface="Newsreader"/>
-              </a:rPr>
-              <a:t>的产品与研发</a:t>
+              <a:t>顶级交易公司的从业者，在支持我们的研发</a:t>
             </a:r>
             <a:endParaRPr sz="2200" b="0" i="0" u="none" strike="noStrike" cap="none" dirty="0">
               <a:solidFill>
@@ -11456,19 +11465,7 @@
                 <a:cs typeface="Instrument Sans"/>
                 <a:sym typeface="Instrument Sans"/>
               </a:rPr>
-              <a:t>每个训练世界的评分标准，</a:t>
-            </a:r>
-            <a:r>
-              <a:rPr lang="zh-CN" altLang="en-US" sz="1500" b="0" i="0" u="none" strike="noStrike" cap="none" dirty="0">
-                <a:solidFill>
-                  <a:srgbClr val="6E6C66"/>
-                </a:solidFill>
-                <a:latin typeface="Instrument Sans"/>
-                <a:ea typeface="Instrument Sans"/>
-                <a:cs typeface="Instrument Sans"/>
-                <a:sym typeface="Instrument Sans"/>
-              </a:rPr>
-              <a:t>我们都能帮你最快找到对的人</a:t>
+              <a:t>每个训练世界，都能最快找到对的评分人</a:t>
             </a:r>
             <a:endParaRPr sz="1500" b="0" i="0" u="none" strike="noStrike" cap="none" dirty="0">
               <a:solidFill>
@@ -14732,79 +14729,19 @@
                 <a:cs typeface="Newsreader"/>
                 <a:sym typeface="Newsreader"/>
               </a:rPr>
-              <a:t>别人做</a:t>
-            </a:r>
-            <a:r>
-              <a:rPr lang="zh-CN" altLang="en-US" sz="2800" b="0" i="0" u="none" strike="noStrike" cap="none" dirty="0">
-                <a:solidFill>
-                  <a:srgbClr val="111110"/>
+              <a:t>别人做一环，我们做让AI持续进步的</a:t>
+            </a:r>
+            <a:r>
+              <a:rPr lang="zh-CN" sz="2800" b="0" i="0" u="none" strike="noStrike" cap="none" dirty="0">
+                <a:solidFill>
+                  <a:srgbClr val="C2410C"/>
                 </a:solidFill>
                 <a:latin typeface="Newsreader"/>
                 <a:ea typeface="Newsreader"/>
                 <a:cs typeface="Newsreader"/>
                 <a:sym typeface="Newsreader"/>
               </a:rPr>
-              <a:t>其中</a:t>
-            </a:r>
-            <a:r>
-              <a:rPr lang="zh-CN" sz="2800" b="0" i="0" u="none" strike="noStrike" cap="none" dirty="0">
-                <a:solidFill>
-                  <a:srgbClr val="111110"/>
-                </a:solidFill>
-                <a:latin typeface="Newsreader"/>
-                <a:ea typeface="Newsreader"/>
-                <a:cs typeface="Newsreader"/>
-                <a:sym typeface="Newsreader"/>
-              </a:rPr>
-              <a:t>一环，我们提供让AI持续进步的</a:t>
-            </a:r>
-            <a:r>
-              <a:rPr lang="zh-CN" sz="2800" b="0" i="0" u="none" strike="noStrike" cap="none" dirty="0">
-                <a:solidFill>
-                  <a:srgbClr val="C2410C"/>
-                </a:solidFill>
-                <a:latin typeface="Newsreader"/>
-                <a:ea typeface="Newsreader"/>
-                <a:cs typeface="Newsreader"/>
-                <a:sym typeface="Newsreader"/>
-              </a:rPr>
-              <a:t>完整</a:t>
-            </a:r>
-            <a:r>
-              <a:rPr lang="en-US" altLang="zh-CN" sz="2800" b="0" i="0" u="none" strike="noStrike" cap="none" dirty="0" err="1">
-                <a:solidFill>
-                  <a:srgbClr val="C2410C"/>
-                </a:solidFill>
-                <a:latin typeface="Newsreader"/>
-                <a:ea typeface="Newsreader"/>
-                <a:cs typeface="Newsreader"/>
-                <a:sym typeface="Newsreader"/>
-              </a:rPr>
-              <a:t>Simreal</a:t>
-            </a:r>
-            <a:r>
-              <a:rPr lang="zh-CN" altLang="en-US" sz="2800" b="0" i="0" u="none" strike="noStrike" cap="none" dirty="0">
-                <a:solidFill>
-                  <a:srgbClr val="C2410C"/>
-                </a:solidFill>
-                <a:latin typeface="Newsreader"/>
-                <a:ea typeface="Newsreader"/>
-                <a:cs typeface="Newsreader"/>
-                <a:sym typeface="Newsreader"/>
-              </a:rPr>
-              <a:t>生态</a:t>
-            </a:r>
-            <a:r>
-              <a:rPr lang="zh-CN" sz="2800" b="0" i="0" u="none" strike="noStrike" cap="none" dirty="0">
-                <a:solidFill>
-                  <a:srgbClr val="C2410C"/>
-                </a:solidFill>
-                <a:latin typeface="Newsreader"/>
-                <a:ea typeface="Newsreader"/>
-                <a:cs typeface="Newsreader"/>
-                <a:sym typeface="Newsreader"/>
-              </a:rPr>
-              <a:t>闭环</a:t>
+              <a:t>完整闭环</a:t>
             </a:r>
             <a:endParaRPr sz="2800" b="0" i="0" u="none" strike="noStrike" cap="none" dirty="0">
               <a:solidFill>
@@ -15039,7 +14976,7 @@
                 <a:cs typeface="Instrument Sans"/>
                 <a:sym typeface="Instrument Sans"/>
               </a:rPr>
-              <a:t>提供专家示范与判断，按人工意见打分</a:t>
+              <a:t>专家示范与判断，按人工意见打分</a:t>
             </a:r>
             <a:endParaRPr sz="1300" b="0" i="0" u="none" strike="noStrike" cap="none" dirty="0">
               <a:solidFill>
@@ -15211,7 +15148,7 @@
                 <a:cs typeface="Instrument Sans"/>
                 <a:sym typeface="Instrument Sans"/>
               </a:rPr>
-              <a:t>测出模型今天的水平，分数就是产品</a:t>
+              <a:t>测今天的水平，分数就是产品</a:t>
             </a:r>
             <a:endParaRPr sz="1300" b="0" i="0" u="none" strike="noStrike" cap="none" dirty="0">
               <a:solidFill>
@@ -15618,10 +15555,10 @@
                 <a:cs typeface="Instrument Sans"/>
                 <a:sym typeface="Instrument Sans"/>
               </a:rPr>
-              <a:t>不只测出AI</a:t>
-            </a:r>
-            <a:r>
-              <a:rPr lang="zh-CN" altLang="en-US" sz="1300" dirty="0">
+              <a:t>不只测分，还让AI越练越强</a:t>
+            </a:r>
+            <a:br>
+              <a:rPr lang="en-US" altLang="zh-CN" sz="1300" b="0" i="0" u="none" strike="noStrike" cap="none" dirty="0">
                 <a:solidFill>
                   <a:srgbClr val="FAF9F6"/>
                 </a:solidFill>
@@ -15630,8 +15567,7 @@
                 <a:cs typeface="Instrument Sans"/>
                 <a:sym typeface="Instrument Sans"/>
               </a:rPr>
-              <a:t>分数</a:t>
-            </a:r>
+            </a:br>
             <a:r>
               <a:rPr lang="zh-CN" sz="1300" b="0" i="0" u="none" strike="noStrike" cap="none" dirty="0">
                 <a:solidFill>
@@ -15642,54 +15578,7 @@
                 <a:cs typeface="Instrument Sans"/>
                 <a:sym typeface="Instrument Sans"/>
               </a:rPr>
-              <a:t>，还让它</a:t>
-            </a:r>
-            <a:r>
-              <a:rPr lang="zh-CN" altLang="en-US" sz="1300" b="0" i="0" u="none" strike="noStrike" cap="none" dirty="0">
-                <a:solidFill>
-                  <a:srgbClr val="FAF9F6"/>
-                </a:solidFill>
-                <a:latin typeface="Instrument Sans"/>
-                <a:ea typeface="Instrument Sans"/>
-                <a:cs typeface="Instrument Sans"/>
-                <a:sym typeface="Instrument Sans"/>
-              </a:rPr>
-              <a:t>可以</a:t>
-            </a:r>
-            <a:r>
-              <a:rPr lang="zh-CN" sz="1300" b="0" i="0" u="none" strike="noStrike" cap="none" dirty="0">
-                <a:solidFill>
-                  <a:srgbClr val="FAF9F6"/>
-                </a:solidFill>
-                <a:latin typeface="Instrument Sans"/>
-                <a:ea typeface="Instrument Sans"/>
-                <a:cs typeface="Instrument Sans"/>
-                <a:sym typeface="Instrument Sans"/>
-              </a:rPr>
-              <a:t>越练越强</a:t>
-            </a:r>
-            <a:br>
-              <a:rPr lang="en-US" altLang="zh-CN" sz="1300" b="0" i="0" u="none" strike="noStrike" cap="none" dirty="0">
-                <a:solidFill>
-                  <a:srgbClr val="FAF9F6"/>
-                </a:solidFill>
-                <a:latin typeface="Instrument Sans"/>
-                <a:ea typeface="Instrument Sans"/>
-                <a:cs typeface="Instrument Sans"/>
-                <a:sym typeface="Instrument Sans"/>
-              </a:rPr>
-            </a:br>
-            <a:r>
-              <a:rPr lang="zh-CN" sz="1300" b="0" i="0" u="none" strike="noStrike" cap="none" dirty="0">
-                <a:solidFill>
-                  <a:srgbClr val="FAF9F6"/>
-                </a:solidFill>
-                <a:latin typeface="Instrument Sans"/>
-                <a:ea typeface="Instrument Sans"/>
-                <a:cs typeface="Instrument Sans"/>
-                <a:sym typeface="Instrument Sans"/>
-              </a:rPr>
-              <a:t>每一次打分，都变成下一轮训练</a:t>
+              <a:t>每次打分都变成下一轮训练</a:t>
             </a:r>
             <a:endParaRPr sz="1300" b="0" i="0" u="none" strike="noStrike" cap="none" dirty="0">
               <a:solidFill>
@@ -15904,7 +15793,7 @@
                 <a:cs typeface="Instrument Sans"/>
                 <a:sym typeface="Instrument Sans"/>
               </a:rPr>
-              <a:t>训练环境、评分体系和每次运行产生的结果数据，都是我们自己的</a:t>
+              <a:t>环境、评分体系、每次运行的结果数据，都归我们</a:t>
             </a:r>
             <a:endParaRPr sz="1100" b="0" i="0" u="none" strike="noStrike" cap="none" dirty="0">
               <a:solidFill>
@@ -16056,7 +15945,7 @@
                 <a:cs typeface="Instrument Sans"/>
                 <a:sym typeface="Instrument Sans"/>
               </a:rPr>
-              <a:t>模型每次升级，都要在同一套环境里对比和再训练</a:t>
+              <a:t>每次模型升级，都回到同一套环境对比、再训练</a:t>
             </a:r>
             <a:endParaRPr sz="1100" b="0" i="0" u="none" strike="noStrike" cap="none" dirty="0">
               <a:solidFill>
@@ -16208,7 +16097,7 @@
                 <a:cs typeface="Instrument Sans"/>
                 <a:sym typeface="Instrument Sans"/>
               </a:rPr>
-              <a:t>14天做出7款产品。AI变化越快，我们越有利</a:t>
+              <a:t>14天7款产品：AI变得越快，我们越有利</a:t>
             </a:r>
             <a:endParaRPr sz="1100" b="1" i="0" u="none" strike="noStrike" cap="none" dirty="0">
               <a:solidFill>
@@ -16722,73 +16611,21 @@
                 <a:cs typeface="Newsreader"/>
                 <a:sym typeface="Newsreader"/>
               </a:rPr>
-              <a:t>这个赛道的突围者，</a:t>
-            </a:r>
-            <a:r>
-              <a:rPr lang="zh-CN" altLang="en-US" sz="2800" dirty="0">
-                <a:solidFill>
-                  <a:srgbClr val="111110"/>
+              <a:t>赛道突围者都起步年轻、跑得快；</a:t>
+            </a:r>
+            <a:r>
+              <a:rPr lang="zh-CN" altLang="en-US" sz="2800" b="0" i="0" u="none" strike="noStrike" cap="none" dirty="0">
+                <a:solidFill>
+                  <a:schemeClr val="accent2">
+                    <a:lumMod val="75000"/>
+                  </a:schemeClr>
                 </a:solidFill>
                 <a:latin typeface="Newsreader"/>
                 <a:ea typeface="Newsreader"/>
                 <a:cs typeface="Newsreader"/>
                 <a:sym typeface="Newsreader"/>
               </a:rPr>
-              <a:t>起步</a:t>
-            </a:r>
-            <a:r>
-              <a:rPr lang="zh-CN" sz="2800" b="0" i="0" u="none" strike="noStrike" cap="none" dirty="0">
-                <a:solidFill>
-                  <a:srgbClr val="111110"/>
-                </a:solidFill>
-                <a:latin typeface="Newsreader"/>
-                <a:ea typeface="Newsreader"/>
-                <a:cs typeface="Newsreader"/>
-                <a:sym typeface="Newsreader"/>
-              </a:rPr>
-              <a:t>年轻、跑得很快。</a:t>
-            </a:r>
-            <a:r>
-              <a:rPr lang="zh-CN" altLang="en-US" sz="2800" b="0" i="0" u="none" strike="noStrike" cap="none" dirty="0">
-                <a:solidFill>
-                  <a:schemeClr val="accent2">
-                    <a:lumMod val="75000"/>
-                  </a:schemeClr>
-                </a:solidFill>
-                <a:latin typeface="Newsreader"/>
-                <a:ea typeface="Newsreader"/>
-                <a:cs typeface="Newsreader"/>
-                <a:sym typeface="Newsreader"/>
-              </a:rPr>
-              <a:t>而</a:t>
-            </a:r>
-            <a:r>
-              <a:rPr lang="zh-CN" sz="2800" b="0" i="0" u="none" strike="noStrike" cap="none" dirty="0">
-                <a:solidFill>
-                  <a:schemeClr val="accent2">
-                    <a:lumMod val="75000"/>
-                  </a:schemeClr>
-                </a:solidFill>
-                <a:latin typeface="Newsreader"/>
-                <a:ea typeface="Newsreader"/>
-                <a:cs typeface="Newsreader"/>
-                <a:sym typeface="Newsreader"/>
-              </a:rPr>
-              <a:t>我们</a:t>
-            </a:r>
-            <a:r>
-              <a:rPr lang="zh-CN" altLang="en-US" sz="2800" b="0" i="0" u="none" strike="noStrike" cap="none" dirty="0">
-                <a:solidFill>
-                  <a:schemeClr val="accent2">
-                    <a:lumMod val="75000"/>
-                  </a:schemeClr>
-                </a:solidFill>
-                <a:latin typeface="Newsreader"/>
-                <a:ea typeface="Newsreader"/>
-                <a:cs typeface="Newsreader"/>
-                <a:sym typeface="Newsreader"/>
-              </a:rPr>
-              <a:t>的加速度最快</a:t>
+              <a:t>我们更快</a:t>
             </a:r>
             <a:endParaRPr sz="2800" b="0" i="0" u="none" strike="noStrike" cap="none" dirty="0">
               <a:solidFill>
@@ -17114,7 +16951,7 @@
                 <a:cs typeface="Instrument Sans"/>
                 <a:sym typeface="Instrument Sans"/>
               </a:rPr>
-              <a:t>2016年由19岁的Alexandr Wang创立</a:t>
+              <a:t>19岁的Alexandr Wang创立</a:t>
             </a:r>
             <a:endParaRPr sz="1100" b="0" i="0" u="none" strike="noStrike" cap="none">
               <a:solidFill>
@@ -17705,7 +17542,7 @@
                 <a:cs typeface="Instrument Sans"/>
                 <a:sym typeface="Instrument Sans"/>
               </a:rPr>
-              <a:t>22岁成为最年轻的白手起家亿万富翁</a:t>
+              <a:t>22岁成最年轻白手起家亿万富翁</a:t>
             </a:r>
             <a:endParaRPr sz="1100" b="0" i="0" u="none" strike="noStrike" cap="none">
               <a:solidFill>
@@ -18118,7 +17955,7 @@
                 <a:cs typeface="Instrument Sans"/>
                 <a:sym typeface="Instrument Sans"/>
               </a:rPr>
-              <a:t>两位高中好友约21岁创立，当时仍在读大学</a:t>
+              <a:t>两位约21岁的在校大学生创立</a:t>
             </a:r>
             <a:endParaRPr sz="1100" b="0" i="0" u="none" strike="noStrike" cap="none">
               <a:solidFill>
@@ -18207,7 +18044,7 @@
                 <a:cs typeface="Instrument Sans"/>
                 <a:sym typeface="Instrument Sans"/>
               </a:rPr>
-              <a:t>联合创始人曾在Citadel Securities实习</a:t>
+              <a:t>创始人曾在Citadel Securities实习</a:t>
             </a:r>
             <a:endParaRPr sz="1100" b="0" i="0" u="none" strike="noStrike" cap="none">
               <a:solidFill>
@@ -18531,7 +18368,7 @@
                 <a:cs typeface="Instrument Sans"/>
                 <a:sym typeface="Instrument Sans"/>
               </a:rPr>
-              <a:t>做出7款产品</a:t>
+              <a:t>7款产品</a:t>
             </a:r>
             <a:endParaRPr lang="en-US" altLang="zh-CN" sz="1100" b="0" i="0" u="none" strike="noStrike" cap="none" dirty="0">
               <a:solidFill>
@@ -18568,7 +18405,7 @@
                 <a:cs typeface="Instrument Sans"/>
                 <a:sym typeface="Instrument Sans"/>
               </a:rPr>
-              <a:t>和世界第一个自我进化做市环境</a:t>
+              <a:t>全球首个自我进化做市环境</a:t>
             </a:r>
             <a:endParaRPr sz="1100" b="0" i="0" u="none" strike="noStrike" cap="none" dirty="0">
               <a:solidFill>
@@ -18859,10 +18696,10 @@
                 <a:cs typeface="Instrument Sans"/>
                 <a:sym typeface="Instrument Sans"/>
               </a:rPr>
-              <a:t>量化经历：Jane Street、Citadel、D. E. Shaw、Optiver</a:t>
-            </a:r>
-            <a:r>
-              <a:rPr lang="en-US" altLang="zh-CN" sz="1100" b="0" i="0" u="none" strike="noStrike" cap="none" dirty="0">
+              <a:t>量化经历：</a:t>
+            </a:r>
+            <a:br>
+              <a:rPr lang="zh-CN" sz="1100" b="0" i="0" u="none" strike="noStrike" cap="none" dirty="0">
                 <a:solidFill>
                   <a:srgbClr val="FAF9F6"/>
                 </a:solidFill>
@@ -18871,10 +18708,9 @@
                 <a:cs typeface="Instrument Sans"/>
                 <a:sym typeface="Instrument Sans"/>
               </a:rPr>
-              <a:t> </a:t>
-            </a:r>
-            <a:r>
-              <a:rPr lang="zh-CN" altLang="en-US" sz="1100" b="0" i="0" u="none" strike="noStrike" cap="none" dirty="0">
+            </a:br>
+            <a:r>
+              <a:rPr lang="zh-CN" sz="1100" b="0" i="0" u="none" strike="noStrike" cap="none" dirty="0">
                 <a:solidFill>
                   <a:srgbClr val="FAF9F6"/>
                 </a:solidFill>
@@ -18883,10 +18719,10 @@
                 <a:cs typeface="Instrument Sans"/>
                 <a:sym typeface="Instrument Sans"/>
               </a:rPr>
-              <a:t>、</a:t>
-            </a:r>
-            <a:r>
-              <a:rPr lang="en-US" altLang="zh-CN" sz="1100" b="0" i="0" u="none" strike="noStrike" cap="none" dirty="0">
+              <a:t>Jane Street、Citadel、</a:t>
+            </a:r>
+            <a:br>
+              <a:rPr lang="zh-CN" sz="1100" b="0" i="0" u="none" strike="noStrike" cap="none" dirty="0">
                 <a:solidFill>
                   <a:srgbClr val="FAF9F6"/>
                 </a:solidFill>
@@ -18895,7 +18731,18 @@
                 <a:cs typeface="Instrument Sans"/>
                 <a:sym typeface="Instrument Sans"/>
               </a:rPr>
-              <a:t>Millennium</a:t>
+            </a:br>
+            <a:r>
+              <a:rPr lang="zh-CN" sz="1100" b="0" i="0" u="none" strike="noStrike" cap="none" dirty="0">
+                <a:solidFill>
+                  <a:srgbClr val="FAF9F6"/>
+                </a:solidFill>
+                <a:latin typeface="Instrument Sans"/>
+                <a:ea typeface="Instrument Sans"/>
+                <a:cs typeface="Instrument Sans"/>
+                <a:sym typeface="Instrument Sans"/>
+              </a:rPr>
+              <a:t>D. E. Shaw、Optiver、Millennium</a:t>
             </a:r>
             <a:endParaRPr sz="1100" b="0" i="0" u="none" strike="noStrike" cap="none" dirty="0">
               <a:solidFill>
@@ -18958,7 +18805,7 @@
                 <a:cs typeface="Newsreader"/>
                 <a:sym typeface="Newsreader"/>
               </a:rPr>
-              <a:t>同样的起点，同一个赛道。</a:t>
+              <a:t>同样的起点，同一个赛道，</a:t>
             </a:r>
             <a:r>
               <a:rPr lang="zh-CN" sz="2000" b="0" i="0" u="none" strike="noStrike" cap="none" dirty="0">
@@ -18972,35 +18819,7 @@
                 <a:cs typeface="Newsreader"/>
                 <a:sym typeface="Newsreader"/>
               </a:rPr>
-              <a:t>我们</a:t>
-            </a:r>
-            <a:r>
-              <a:rPr lang="zh-CN" altLang="en-US" sz="2000" b="0" i="0" u="none" strike="noStrike" cap="none" dirty="0">
-                <a:solidFill>
-                  <a:schemeClr val="accent2">
-                    <a:lumMod val="75000"/>
-                  </a:schemeClr>
-                </a:solidFill>
-                <a:latin typeface="Newsreader"/>
-                <a:ea typeface="Newsreader"/>
-                <a:cs typeface="Newsreader"/>
-                <a:sym typeface="Newsreader"/>
-              </a:rPr>
-              <a:t>在这里，感受到比他们当年快得多</a:t>
-            </a:r>
-            <a:r>
-              <a:rPr lang="zh-CN" altLang="en-US" sz="2000" dirty="0">
-                <a:solidFill>
-                  <a:schemeClr val="accent2">
-                    <a:lumMod val="75000"/>
-                  </a:schemeClr>
-                </a:solidFill>
-                <a:latin typeface="Newsreader"/>
-                <a:ea typeface="Newsreader"/>
-                <a:cs typeface="Newsreader"/>
-                <a:sym typeface="Newsreader"/>
-              </a:rPr>
-              <a:t>的加速度</a:t>
+              <a:t>更快的加速度</a:t>
             </a:r>
             <a:endParaRPr sz="2000" b="0" i="0" u="none" strike="noStrike" cap="none" dirty="0">
               <a:solidFill>
@@ -21535,7 +21354,7 @@
         </p:nvSpPr>
         <p:spPr>
           <a:xfrm>
-            <a:off x="548640" y="3913632"/>
+            <a:off x="548640" y="4160520"/>
             <a:ext cx="7132320" cy="310896"/>
           </a:xfrm>
           <a:prstGeom prst="rect">
@@ -21576,7 +21395,7 @@
                 <a:cs typeface="Instrument Sans"/>
                 <a:sym typeface="Instrument Sans"/>
               </a:rPr>
-              <a:t>三个世界已经上线：交易、AI研究、未来预测。</a:t>
+              <a:t>三个世界已上线：交易、AI研究、未来预测</a:t>
             </a:r>
             <a:endParaRPr sz="1500" b="0" i="0" u="none" strike="noStrike" cap="none">
               <a:solidFill>
@@ -21598,7 +21417,7 @@
         </p:nvSpPr>
         <p:spPr>
           <a:xfrm>
-            <a:off x="548640" y="4315968"/>
+            <a:off x="548640" y="4526280"/>
             <a:ext cx="7132320" cy="365760"/>
           </a:xfrm>
           <a:prstGeom prst="rect">
@@ -21661,7 +21480,7 @@
         </p:nvCxnSpPr>
         <p:spPr>
           <a:xfrm>
-            <a:off x="548640" y="4956048"/>
+            <a:off x="548640" y="5120640"/>
             <a:ext cx="5120640" cy="0"/>
           </a:xfrm>
           <a:prstGeom prst="straightConnector1">
@@ -21687,7 +21506,7 @@
         </p:nvSpPr>
         <p:spPr>
           <a:xfrm>
-            <a:off x="548640" y="5084064"/>
+            <a:off x="548640" y="5248656"/>
             <a:ext cx="7132320" cy="274320"/>
           </a:xfrm>
           <a:prstGeom prst="rect">
@@ -22141,7 +21960,7 @@
                 <a:cs typeface="Instrument Sans"/>
                 <a:sym typeface="Instrument Sans"/>
               </a:rPr>
-              <a:t>回放真实交易日，包含真实订单簿；每一笔交易由市场结算。</a:t>
+              <a:t>回放真实交易日与订单簿，每笔交易由市场结算</a:t>
             </a:r>
             <a:endParaRPr sz="1300" b="0" i="0" u="none" strike="noStrike" cap="none">
               <a:solidFill>
@@ -22293,7 +22112,7 @@
                 <a:cs typeface="Instrument Sans"/>
                 <a:sym typeface="Instrument Sans"/>
               </a:rPr>
-              <a:t>开源模型Qwen3.8-27B，对比其在Xitadel训练前后的表现。</a:t>
+              <a:t>开源模型Qwen3.8-27B，比较训练前后表现</a:t>
             </a:r>
             <a:endParaRPr sz="1300" b="0" i="0" u="none" strike="noStrike" cap="none">
               <a:solidFill>
@@ -22445,7 +22264,7 @@
                 <a:cs typeface="Instrument Sans"/>
                 <a:sym typeface="Instrument Sans"/>
               </a:rPr>
-              <a:t>模型从未见过的真实交易日。</a:t>
+              <a:t>模型未见过的真实交易日</a:t>
             </a:r>
             <a:endParaRPr sz="1300" b="0" i="0" u="none" strike="noStrike" cap="none">
               <a:solidFill>
@@ -22621,7 +22440,7 @@
                 <a:cs typeface="Instrument Sans"/>
                 <a:sym typeface="Instrument Sans"/>
               </a:rPr>
-              <a:t>，多次独立运行均复现（受控实验）。</a:t>
+              <a:t>，多次独立复现（受控实验）</a:t>
             </a:r>
             <a:endParaRPr sz="1300" b="0" i="0" u="none" strike="noStrike" cap="none">
               <a:solidFill>
@@ -22773,7 +22592,7 @@
                 <a:cs typeface="Instrument Sans"/>
                 <a:sym typeface="Instrument Sans"/>
               </a:rPr>
-              <a:t>Xitadel公开预览版：人类参考分80；前沿模型最高77.28（GPT 6），尚无模型越过人类水平线。</a:t>
+              <a:t>Xitadel公开预览版：人类参考分80，前沿模型最高77.28（GPT 6），尚无模型越过人类线</a:t>
             </a:r>
             <a:endParaRPr sz="1300" b="0" i="0" u="none" strike="noStrike" cap="none">
               <a:solidFill>
@@ -22925,7 +22744,7 @@
                 <a:cs typeface="Instrument Sans"/>
                 <a:sym typeface="Instrument Sans"/>
               </a:rPr>
-              <a:t>完整运行记录、指标定义与脚本，可在尽调中提供。</a:t>
+              <a:t>运行记录、指标定义与脚本，尽调时提供</a:t>
             </a:r>
             <a:endParaRPr sz="1300" b="0" i="0" u="none" strike="noStrike" cap="none">
               <a:solidFill>
@@ -23475,7 +23294,7 @@
                 <a:cs typeface="Newsreader"/>
                 <a:sym typeface="Newsreader"/>
               </a:rPr>
-              <a:t>给AI真实的工作环境，让他重复：犯错，学习，</a:t>
+              <a:t>给AI真实的工作环境，让它反复犯错、学习、</a:t>
             </a:r>
             <a:r>
               <a:rPr lang="zh-CN" sz="2800" b="0" i="0" u="none" strike="noStrike" cap="none">
@@ -23726,9 +23545,9 @@
                 <a:cs typeface="Instrument Sans"/>
                 <a:sym typeface="Instrument Sans"/>
               </a:rPr>
-              <a:t>为AI实验室和企业</a:t>
-            </a:r>
-            <a:r>
+              <a:t>为AI实验室和企业提供评测、数据与训练环境</a:t>
+            </a:r>
+            <a:br>
               <a:rPr lang="zh-CN" sz="1200" dirty="0">
                 <a:solidFill>
                   <a:srgbClr val="33322F"/>
@@ -23738,8 +23557,7 @@
                 <a:cs typeface="Instrument Sans"/>
                 <a:sym typeface="Instrument Sans"/>
               </a:rPr>
-              <a:t>提供Benchmark, 数据和</a:t>
-            </a:r>
+            </a:br>
             <a:r>
               <a:rPr lang="zh-CN" sz="1200" b="0" i="0" u="none" strike="noStrike" cap="none" dirty="0">
                 <a:solidFill>
@@ -23750,30 +23568,7 @@
                 <a:cs typeface="Instrument Sans"/>
                 <a:sym typeface="Instrument Sans"/>
               </a:rPr>
-              <a:t>训练环境</a:t>
-            </a:r>
-            <a:br>
-              <a:rPr lang="zh-CN" sz="1200" dirty="0">
-                <a:solidFill>
-                  <a:srgbClr val="33322F"/>
-                </a:solidFill>
-                <a:latin typeface="Instrument Sans"/>
-                <a:ea typeface="Instrument Sans"/>
-                <a:cs typeface="Instrument Sans"/>
-                <a:sym typeface="Instrument Sans"/>
-              </a:rPr>
-            </a:br>
-            <a:r>
-              <a:rPr lang="zh-CN" sz="1200" dirty="0">
-                <a:solidFill>
-                  <a:srgbClr val="33322F"/>
-                </a:solidFill>
-                <a:latin typeface="Instrument Sans"/>
-                <a:ea typeface="Instrument Sans"/>
-                <a:cs typeface="Instrument Sans"/>
-                <a:sym typeface="Instrument Sans"/>
-              </a:rPr>
-              <a:t>高质量数据提升AI表现，独家训练环境完成AI自我进化（RSI)</a:t>
+              <a:t>独家环境让AI自我进化（RSI）</a:t>
             </a:r>
             <a:endParaRPr sz="1200" b="0" i="0" u="none" strike="noStrike" cap="none" dirty="0">
               <a:solidFill>
@@ -24000,19 +23795,7 @@
                 <a:cs typeface="Instrument Sans"/>
                 <a:sym typeface="Instrument Sans"/>
               </a:rPr>
-              <a:t>成立14天，7款产品</a:t>
-            </a:r>
-            <a:r>
-              <a:rPr lang="zh-CN" sz="1200">
-                <a:solidFill>
-                  <a:srgbClr val="33322F"/>
-                </a:solidFill>
-                <a:latin typeface="Instrument Sans"/>
-                <a:ea typeface="Instrument Sans"/>
-                <a:cs typeface="Instrument Sans"/>
-                <a:sym typeface="Instrument Sans"/>
-              </a:rPr>
-              <a:t>，包括机器学习，事件预测，做市交易的Benchmark，强化学习环境和RSI环境</a:t>
+              <a:t>机器学习、事件预测、做市交易的评测与RL环境</a:t>
             </a:r>
             <a:br>
               <a:rPr lang="zh-CN" sz="1200">
@@ -24060,19 +23843,7 @@
                 <a:cs typeface="Instrument Sans"/>
                 <a:sym typeface="Instrument Sans"/>
               </a:rPr>
-              <a:t>旗舰产品Xitadel已在交易上跑通自我进化</a:t>
-            </a:r>
-            <a:r>
-              <a:rPr lang="zh-CN" sz="1200">
-                <a:solidFill>
-                  <a:srgbClr val="33322F"/>
-                </a:solidFill>
-                <a:latin typeface="Instrument Sans"/>
-                <a:ea typeface="Instrument Sans"/>
-                <a:cs typeface="Instrument Sans"/>
-                <a:sym typeface="Instrument Sans"/>
-              </a:rPr>
-              <a:t>（RSI）</a:t>
+              <a:t>旗舰Xitadel已跑通自我进化（RSI）</a:t>
             </a:r>
             <a:endParaRPr sz="1200" b="0" i="0" u="none" strike="noStrike" cap="none">
               <a:solidFill>
@@ -24311,31 +24082,7 @@
                 <a:cs typeface="Instrument Sans"/>
                 <a:sym typeface="Instrument Sans"/>
               </a:rPr>
-              <a:t>开源模型Qwen3.8-27B在Xitadel训练后，在从未见过的真实市场数据上交易表现</a:t>
-            </a:r>
-            <a:r>
-              <a:rPr lang="zh-CN" sz="1200">
-                <a:solidFill>
-                  <a:srgbClr val="33322F"/>
-                </a:solidFill>
-                <a:latin typeface="Instrument Sans"/>
-                <a:ea typeface="Instrument Sans"/>
-                <a:cs typeface="Instrument Sans"/>
-                <a:sym typeface="Instrument Sans"/>
-              </a:rPr>
-              <a:t>最高</a:t>
-            </a:r>
-            <a:r>
-              <a:rPr lang="zh-CN" sz="1200" b="0" i="0" u="none" strike="noStrike" cap="none">
-                <a:solidFill>
-                  <a:srgbClr val="33322F"/>
-                </a:solidFill>
-                <a:latin typeface="Instrument Sans"/>
-                <a:ea typeface="Instrument Sans"/>
-                <a:cs typeface="Instrument Sans"/>
-                <a:sym typeface="Instrument Sans"/>
-              </a:rPr>
-              <a:t>提升12%，多次独立运行均复现。</a:t>
+              <a:t>Qwen3.8-27B在Xitadel训练后，在未见过的真实行情上交易表现最高提升12%，多次独立复现</a:t>
             </a:r>
             <a:endParaRPr sz="1200" b="0" i="0" u="none" strike="noStrike" cap="none">
               <a:solidFill>
@@ -24565,7 +24312,7 @@
               <a:buNone/>
             </a:pPr>
             <a:r>
-              <a:rPr lang="zh-CN" sz="1200" dirty="0">
+              <a:rPr b="1" lang="zh-CN" sz="1200" dirty="0">
                 <a:solidFill>
                   <a:srgbClr val="33322F"/>
                 </a:solidFill>
@@ -24574,10 +24321,10 @@
                 <a:cs typeface="Instrument Sans"/>
                 <a:sym typeface="Instrument Sans"/>
               </a:rPr>
-              <a:t>本科来自</a:t>
-            </a:r>
-            <a:r>
-              <a:rPr lang="zh-CN" sz="1200" b="1" i="0" u="none" strike="noStrike" cap="none" dirty="0">
+              <a:t>剑桥、LSE、杜克</a:t>
+            </a:r>
+            <a:r>
+              <a:rPr b="0" lang="zh-CN" sz="1200" dirty="0">
                 <a:solidFill>
                   <a:srgbClr val="33322F"/>
                 </a:solidFill>
@@ -24586,7 +24333,7 @@
                 <a:cs typeface="Instrument Sans"/>
                 <a:sym typeface="Instrument Sans"/>
               </a:rPr>
-              <a:t>剑桥、LSE、杜克</a:t>
+              <a:t>本科</a:t>
             </a:r>
             <a:br>
               <a:rPr lang="zh-CN" sz="1200" dirty="0">
@@ -24600,7 +24347,7 @@
               </a:rPr>
             </a:br>
             <a:r>
-              <a:rPr lang="zh-CN" sz="1200" dirty="0">
+              <a:rPr b="1" lang="zh-CN" sz="1200" dirty="0">
                 <a:solidFill>
                   <a:srgbClr val="33322F"/>
                 </a:solidFill>
@@ -24609,10 +24356,10 @@
                 <a:cs typeface="Instrument Sans"/>
                 <a:sym typeface="Instrument Sans"/>
               </a:rPr>
-              <a:t>有</a:t>
-            </a:r>
-            <a:r>
-              <a:rPr lang="zh-CN" sz="1200" b="1" dirty="0">
+              <a:t>剑桥研究中心AI最年轻本科研究员</a:t>
+            </a:r>
+            <a:br>
+              <a:rPr lang="zh-CN" sz="1200" dirty="0">
                 <a:solidFill>
                   <a:srgbClr val="33322F"/>
                 </a:solidFill>
@@ -24621,10 +24368,9 @@
                 <a:cs typeface="Instrument Sans"/>
                 <a:sym typeface="Instrument Sans"/>
               </a:rPr>
-              <a:t>剑桥研究中心AI(ML)最年轻本科研究员</a:t>
-            </a:r>
-            <a:br>
-              <a:rPr lang="zh-CN" sz="1200" dirty="0">
+            </a:br>
+            <a:r>
+              <a:rPr b="1" lang="zh-CN" sz="1200" dirty="0">
                 <a:solidFill>
                   <a:srgbClr val="33322F"/>
                 </a:solidFill>
@@ -24633,8 +24379,9 @@
                 <a:cs typeface="Instrument Sans"/>
                 <a:sym typeface="Instrument Sans"/>
               </a:rPr>
-            </a:br>
-            <a:r>
+              <a:t>Jane Street、Citadel、D. E. Shaw、</a:t>
+            </a:r>
+            <a:br>
               <a:rPr lang="zh-CN" sz="1200" dirty="0">
                 <a:solidFill>
                   <a:srgbClr val="33322F"/>
@@ -24644,10 +24391,9 @@
                 <a:cs typeface="Instrument Sans"/>
                 <a:sym typeface="Instrument Sans"/>
               </a:rPr>
-              <a:t>工作经历包括</a:t>
-            </a:r>
-            <a:r>
-              <a:rPr lang="zh-CN" sz="1200" b="1" i="0" u="none" strike="noStrike" cap="none" dirty="0">
+            </a:br>
+            <a:r>
+              <a:rPr b="1" lang="zh-CN" sz="1200" dirty="0">
                 <a:solidFill>
                   <a:srgbClr val="33322F"/>
                 </a:solidFill>
@@ -24656,7 +24402,7 @@
                 <a:cs typeface="Instrument Sans"/>
                 <a:sym typeface="Instrument Sans"/>
               </a:rPr>
-              <a:t>Jane Street、Citadel、D. E. Shaw、Millennium、Optiver</a:t>
+              <a:t>Millennium、Optiver</a:t>
             </a:r>
             <a:endParaRPr sz="1200" b="1" i="0" u="none" strike="noStrike" cap="none" dirty="0">
               <a:solidFill>
@@ -25149,7 +24895,7 @@
                 <a:cs typeface="Newsreader"/>
                 <a:sym typeface="Newsreader"/>
               </a:rPr>
-              <a:t>谁拥有最好的</a:t>
+              <a:t>谁有最好的</a:t>
             </a:r>
             <a:r>
               <a:rPr lang="zh-CN" sz="2600" b="0" i="0" u="none" strike="noStrike" cap="none">
@@ -25173,7 +24919,7 @@
                 <a:cs typeface="Newsreader"/>
                 <a:sym typeface="Newsreader"/>
               </a:rPr>
-              <a:t>，谁就拥有该行业最好的AI</a:t>
+              <a:t>，谁就有该行业最好的AI</a:t>
             </a:r>
             <a:endParaRPr sz="2600" b="0" i="0" u="none" strike="noStrike" cap="none">
               <a:solidFill>
@@ -25210,7 +24956,7 @@
                 <a:cs typeface="Newsreader"/>
                 <a:sym typeface="Newsreader"/>
               </a:rPr>
-              <a:t>AI自我进化，从交易出发，我们走向整个世界</a:t>
+              <a:t>从交易出发，让AI自我进化，走向整个世界</a:t>
             </a:r>
             <a:endParaRPr sz="2600" b="0" i="0" u="none" strike="noStrike" cap="none">
               <a:solidFill>
@@ -30238,7 +29984,7 @@
                 <a:cs typeface="Instrument Sans"/>
                 <a:sym typeface="Instrument Sans"/>
               </a:rPr>
-              <a:t>让AI反复做真实工作、并按结果打分的系统。行业里常称“RL环境”。</a:t>
+              <a:t>让AI反复做真实工作、按结果打分的系统，常称RL环境</a:t>
             </a:r>
             <a:endParaRPr sz="1300" b="0" i="0" u="none" strike="noStrike" cap="none">
               <a:solidFill>
@@ -30453,7 +30199,7 @@
                 <a:cs typeface="Instrument Sans"/>
                 <a:sym typeface="Instrument Sans"/>
               </a:rPr>
-              <a:t>用真实结果（盈亏、账目是否对平、代码能否运行）打分，不靠另一个AI的主观判断。</a:t>
+              <a:t>按真实结果打分（盈亏、账目、代码能否运行），不靠AI主观判断</a:t>
             </a:r>
             <a:endParaRPr sz="1300" b="0" i="0" u="none" strike="noStrike" cap="none">
               <a:solidFill>
@@ -30668,7 +30414,7 @@
                 <a:cs typeface="Instrument Sans"/>
                 <a:sym typeface="Instrument Sans"/>
               </a:rPr>
-              <a:t>AI用自己在真实环境中的结果训练自己，每一轮都比上一轮更强。</a:t>
+              <a:t>AI用自己在真实环境中的结果训练自己，一轮比一轮强</a:t>
             </a:r>
             <a:endParaRPr sz="1300" b="0" i="0" u="none" strike="noStrike" cap="none">
               <a:solidFill>
@@ -30883,7 +30629,7 @@
                 <a:cs typeface="Instrument Sans"/>
                 <a:sym typeface="Instrument Sans"/>
               </a:rPr>
-              <a:t>上线前模拟各种作弊和攻击，找出评分漏洞并修复。</a:t>
+              <a:t>上线前模拟作弊与攻击，找出并修补评分漏洞</a:t>
             </a:r>
             <a:endParaRPr sz="1300" b="0" i="0" u="none" strike="noStrike" cap="none">
               <a:solidFill>
@@ -31098,7 +30844,7 @@
                 <a:cs typeface="Instrument Sans"/>
                 <a:sym typeface="Instrument Sans"/>
               </a:rPr>
-              <a:t>只改变一个条件（是否在Xitadel训练），比较前后表现的实验。</a:t>
+              <a:t>只改一个条件（是否在Xitadel训练），比较前后表现</a:t>
             </a:r>
             <a:endParaRPr sz="1300" b="0" i="0" u="none" strike="noStrike" cap="none">
               <a:solidFill>
@@ -31313,7 +31059,7 @@
                 <a:cs typeface="Instrument Sans"/>
                 <a:sym typeface="Instrument Sans"/>
               </a:rPr>
-              <a:t>按当前收入推算的全年收入，含支付给专家的部分。</a:t>
+              <a:t>按当前收入推算的全年收入，含付给专家的部分</a:t>
             </a:r>
             <a:endParaRPr sz="1300" b="0" i="0" u="none" strike="noStrike" cap="none">
               <a:solidFill>
@@ -33839,7 +33585,7 @@
                 <a:cs typeface="Newsreader"/>
                 <a:sym typeface="Newsreader"/>
               </a:rPr>
-              <a:t>奥赛&amp;世界名校  →  华尔街最残酷的交易台: 我们最知道做题和做事的差距</a:t>
+              <a:t>奥赛与名校 → 华尔街最残酷的交易台：我们最懂做题与做事的差距</a:t>
             </a:r>
             <a:endParaRPr sz="2700" b="0" i="0" u="none" strike="noStrike" cap="none">
               <a:solidFill>
@@ -34384,79 +34130,7 @@
                 <a:cs typeface="Instrument Sans"/>
                 <a:sym typeface="Instrument Sans"/>
               </a:rPr>
-              <a:t>稳定币公司United Stables首位员工：</a:t>
-            </a:r>
-            <a:r>
-              <a:rPr lang="zh-CN" sz="1100">
-                <a:solidFill>
-                  <a:srgbClr val="33322F"/>
-                </a:solidFill>
-                <a:latin typeface="Instrument Sans"/>
-                <a:ea typeface="Instrument Sans"/>
-                <a:cs typeface="Instrument Sans"/>
-                <a:sym typeface="Instrument Sans"/>
-              </a:rPr>
-              <a:t>从0持续搭建</a:t>
-            </a:r>
-            <a:r>
-              <a:rPr lang="zh-CN" sz="1100" b="0" i="0" u="none" strike="noStrike" cap="none">
-                <a:solidFill>
-                  <a:srgbClr val="33322F"/>
-                </a:solidFill>
-                <a:latin typeface="Instrument Sans"/>
-                <a:ea typeface="Instrument Sans"/>
-                <a:cs typeface="Instrument Sans"/>
-                <a:sym typeface="Instrument Sans"/>
-              </a:rPr>
-              <a:t>U稳定币</a:t>
-            </a:r>
-            <a:r>
-              <a:rPr lang="zh-CN" sz="1100">
-                <a:solidFill>
-                  <a:srgbClr val="33322F"/>
-                </a:solidFill>
-                <a:latin typeface="Instrument Sans"/>
-                <a:ea typeface="Instrument Sans"/>
-                <a:cs typeface="Instrument Sans"/>
-                <a:sym typeface="Instrument Sans"/>
-              </a:rPr>
-              <a:t>到</a:t>
-            </a:r>
-            <a:r>
-              <a:rPr lang="zh-CN" sz="1100" b="0" i="0" u="none" strike="noStrike" cap="none">
-                <a:solidFill>
-                  <a:srgbClr val="33322F"/>
-                </a:solidFill>
-                <a:latin typeface="Instrument Sans"/>
-                <a:ea typeface="Instrument Sans"/>
-                <a:cs typeface="Instrument Sans"/>
-                <a:sym typeface="Instrument Sans"/>
-              </a:rPr>
-              <a:t>14亿美元，</a:t>
-            </a:r>
-            <a:r>
-              <a:rPr lang="zh-CN" sz="1100">
-                <a:solidFill>
-                  <a:srgbClr val="33322F"/>
-                </a:solidFill>
-                <a:latin typeface="Instrument Sans"/>
-                <a:ea typeface="Instrument Sans"/>
-                <a:cs typeface="Instrument Sans"/>
-                <a:sym typeface="Instrument Sans"/>
-              </a:rPr>
-              <a:t>一个月</a:t>
-            </a:r>
-            <a:r>
-              <a:rPr lang="zh-CN" sz="1100" b="0" i="0" u="none" strike="noStrike" cap="none">
-                <a:solidFill>
-                  <a:srgbClr val="33322F"/>
-                </a:solidFill>
-                <a:latin typeface="Instrument Sans"/>
-                <a:ea typeface="Instrument Sans"/>
-                <a:cs typeface="Instrument Sans"/>
-                <a:sym typeface="Instrument Sans"/>
-              </a:rPr>
-              <a:t>上线Binance</a:t>
+              <a:t>United Stables首位员工：U稳定币从0做到14亿美元，一个月上线Binance</a:t>
             </a:r>
             <a:endParaRPr sz="1100">
               <a:solidFill>
@@ -34530,31 +34204,7 @@
                 <a:cs typeface="Instrument Sans"/>
                 <a:sym typeface="Instrument Sans"/>
               </a:rPr>
-              <a:t>Citadel </a:t>
-            </a:r>
-            <a:r>
-              <a:rPr lang="zh-CN" sz="1100">
-                <a:solidFill>
-                  <a:srgbClr val="33322F"/>
-                </a:solidFill>
-                <a:latin typeface="Instrument Sans"/>
-                <a:ea typeface="Instrument Sans"/>
-                <a:cs typeface="Instrument Sans"/>
-                <a:sym typeface="Instrument Sans"/>
-              </a:rPr>
-              <a:t>LLC对冲基金实习</a:t>
-            </a:r>
-            <a:r>
-              <a:rPr lang="zh-CN" sz="1100" b="0" i="0" u="none" strike="noStrike" cap="none">
-                <a:solidFill>
-                  <a:srgbClr val="33322F"/>
-                </a:solidFill>
-                <a:latin typeface="Instrument Sans"/>
-                <a:ea typeface="Instrument Sans"/>
-                <a:cs typeface="Instrument Sans"/>
-                <a:sym typeface="Instrument Sans"/>
-              </a:rPr>
-              <a:t>经历</a:t>
+              <a:t>Citadel对冲基金实习</a:t>
             </a:r>
             <a:endParaRPr sz="1100" b="0" i="0" u="none" strike="noStrike" cap="none">
               <a:solidFill>
@@ -34876,7 +34526,7 @@
                 <a:cs typeface="Instrument Sans"/>
                 <a:sym typeface="Instrument Sans"/>
               </a:rPr>
-              <a:t>师从剑桥统计学教授Po-Ling Loh（国际数理统计学会会士，2025年Ethel Newbold奖得主）</a:t>
+              <a:t>师从剑桥统计学教授Po-Ling Loh（国际数理统计学会会士，2025年Ethel Newbold奖）</a:t>
             </a:r>
             <a:endParaRPr sz="1100">
               <a:solidFill>
@@ -35321,19 +34971,7 @@
                 <a:cs typeface="Instrument Sans"/>
                 <a:sym typeface="Instrument Sans"/>
               </a:rPr>
-              <a:t>千禧年（全球第一对冲基金）</a:t>
-            </a:r>
-            <a:r>
-              <a:rPr lang="zh-CN" sz="1100" b="0" i="0" u="none" strike="noStrike" cap="none">
-                <a:solidFill>
-                  <a:srgbClr val="33322F"/>
-                </a:solidFill>
-                <a:latin typeface="Instrument Sans"/>
-                <a:ea typeface="Instrument Sans"/>
-                <a:cs typeface="Instrument Sans"/>
-                <a:sym typeface="Instrument Sans"/>
-              </a:rPr>
-              <a:t>另类数据团队史上第一位应届招聘</a:t>
+              <a:t>Millennium另类数据团队史上首位应届招聘</a:t>
             </a:r>
             <a:endParaRPr sz="1100" b="0" i="0" u="none" strike="noStrike" cap="none">
               <a:solidFill>
@@ -35892,19 +35530,7 @@
                 <a:cs typeface="Newsreader"/>
                 <a:sym typeface="Newsreader"/>
               </a:rPr>
-              <a:t>Scale AI、Mercor、AfterQuery的创始人，都在20岁上下</a:t>
-            </a:r>
-            <a:r>
-              <a:rPr lang="zh-CN" sz="2000">
-                <a:solidFill>
-                  <a:srgbClr val="111110"/>
-                </a:solidFill>
-                <a:latin typeface="Newsreader"/>
-                <a:ea typeface="Newsreader"/>
-                <a:cs typeface="Newsreader"/>
-                <a:sym typeface="Newsreader"/>
-              </a:rPr>
-              <a:t>起步</a:t>
+              <a:t>Scale AI、Mercor、AfterQuery创始人都在20岁左右起步</a:t>
             </a:r>
             <a:endParaRPr sz="2000">
               <a:solidFill>
@@ -35941,7 +35567,7 @@
                 <a:cs typeface="Newsreader"/>
                 <a:sym typeface="Newsreader"/>
               </a:rPr>
-              <a:t>他们的首轮投资人回报：17,000倍; 40倍; 1,800倍</a:t>
+              <a:t>首轮投资人回报：17,000倍、40倍、1,800倍</a:t>
             </a:r>
             <a:endParaRPr sz="2000">
               <a:solidFill>
@@ -36274,111 +35900,21 @@
                 <a:cs typeface="Newsreader"/>
                 <a:sym typeface="Newsreader"/>
               </a:rPr>
-              <a:t>18</a:t>
-            </a:r>
-            <a:r>
-              <a:rPr sz="2800" b="0" dirty="0">
-                <a:solidFill>
-                  <a:srgbClr val="111110"/>
+              <a:t>18个月内收入涨27倍、估值涨10倍：</a:t>
+            </a:r>
+            <a:r>
+              <a:rPr lang="zh-CN" altLang="en-US" sz="2800" dirty="0">
+                <a:solidFill>
+                  <a:schemeClr val="accent2">
+                    <a:lumMod val="75000"/>
+                  </a:schemeClr>
                 </a:solidFill>
                 <a:latin typeface="Newsreader"/>
                 <a:ea typeface="Newsreader"/>
                 <a:cs typeface="Newsreader"/>
                 <a:sym typeface="Newsreader"/>
               </a:rPr>
-              <a:t>个月内</a:t>
-            </a:r>
-            <a:r>
-              <a:rPr lang="en-CN" sz="2800" b="0" dirty="0">
-                <a:solidFill>
-                  <a:srgbClr val="111110"/>
-                </a:solidFill>
-                <a:latin typeface="Newsreader"/>
-                <a:ea typeface="Newsreader"/>
-                <a:cs typeface="Newsreader"/>
-                <a:sym typeface="Newsreader"/>
-              </a:rPr>
-              <a:t>收入涨</a:t>
-            </a:r>
-            <a:r>
-              <a:rPr sz="2800" b="0" dirty="0">
-                <a:solidFill>
-                  <a:srgbClr val="111110"/>
-                </a:solidFill>
-                <a:latin typeface="Newsreader"/>
-                <a:ea typeface="Newsreader"/>
-                <a:cs typeface="Newsreader"/>
-                <a:sym typeface="Newsreader"/>
-              </a:rPr>
-              <a:t>27倍、估值涨10倍</a:t>
-            </a:r>
-            <a:r>
-              <a:rPr lang="zh-CN" altLang="en-US" sz="2800" dirty="0">
-                <a:solidFill>
-                  <a:srgbClr val="111110"/>
-                </a:solidFill>
-                <a:latin typeface="Newsreader"/>
-                <a:ea typeface="Newsreader"/>
-                <a:cs typeface="Newsreader"/>
-                <a:sym typeface="Newsreader"/>
-              </a:rPr>
-              <a:t>：</a:t>
-            </a:r>
-            <a:r>
-              <a:rPr lang="zh-CN" altLang="en-US" sz="2800" dirty="0">
-                <a:solidFill>
-                  <a:schemeClr val="accent2">
-                    <a:lumMod val="75000"/>
-                  </a:schemeClr>
-                </a:solidFill>
-                <a:latin typeface="Newsreader"/>
-                <a:ea typeface="Newsreader"/>
-                <a:cs typeface="Newsreader"/>
-                <a:sym typeface="Newsreader"/>
-              </a:rPr>
-              <a:t>赛道</a:t>
-            </a:r>
-            <a:r>
-              <a:rPr sz="2800" b="0" dirty="0" err="1">
-                <a:solidFill>
-                  <a:schemeClr val="accent2">
-                    <a:lumMod val="75000"/>
-                  </a:schemeClr>
-                </a:solidFill>
-                <a:latin typeface="Newsreader"/>
-                <a:ea typeface="Newsreader"/>
-                <a:cs typeface="Newsreader"/>
-                <a:sym typeface="Newsreader"/>
-              </a:rPr>
-              <a:t>增长</a:t>
-            </a:r>
-            <a:r>
-              <a:rPr lang="en-CN" sz="2800" b="0" dirty="0">
-                <a:solidFill>
-                  <a:schemeClr val="accent2">
-                    <a:lumMod val="75000"/>
-                  </a:schemeClr>
-                </a:solidFill>
-                <a:latin typeface="Newsreader"/>
-                <a:ea typeface="Newsreader"/>
-                <a:cs typeface="Newsreader"/>
-                <a:sym typeface="Newsreader"/>
-              </a:rPr>
-              <a:t>却</a:t>
-            </a:r>
-            <a:r>
-              <a:rPr sz="2800" b="0" dirty="0" err="1">
-                <a:solidFill>
-                  <a:schemeClr val="accent2">
-                    <a:lumMod val="75000"/>
-                  </a:schemeClr>
-                </a:solidFill>
-                <a:latin typeface="Newsreader"/>
-                <a:ea typeface="Newsreader"/>
-                <a:cs typeface="Newsreader"/>
-                <a:sym typeface="Newsreader"/>
-              </a:rPr>
-              <a:t>才刚刚开始</a:t>
+              <a:t>赛道才刚开始</a:t>
             </a:r>
             <a:endParaRPr sz="2800" b="0" dirty="0">
               <a:solidFill>
@@ -36561,19 +36097,7 @@
                 <a:cs typeface="Instrument Sans"/>
                 <a:sym typeface="Instrument Sans"/>
               </a:rPr>
-              <a:t>数据公司</a:t>
-            </a:r>
-            <a:r>
-              <a:rPr sz="1050" b="0" dirty="0">
-                <a:solidFill>
-                  <a:srgbClr val="33322F"/>
-                </a:solidFill>
-                <a:latin typeface="Instrument Sans"/>
-                <a:ea typeface="Instrument Sans"/>
-                <a:cs typeface="Instrument Sans"/>
-                <a:sym typeface="Instrument Sans"/>
-              </a:rPr>
-              <a:t>Mercor年化毛营收，16个月从7,500万到20亿美元</a:t>
+              <a:t>Mercor年化毛营收：16个月，7,500万→20亿美元</a:t>
             </a:r>
           </a:p>
         </p:txBody>
@@ -37348,7 +36872,7 @@
                 <a:cs typeface="Instrument Sans"/>
                 <a:sym typeface="Instrument Sans"/>
               </a:rPr>
-              <a:t>Snorkel AI年化收入一年增长，达3.75亿美元</a:t>
+              <a:t>Snorkel AI年化收入一年增至3.75亿美元</a:t>
             </a:r>
           </a:p>
         </p:txBody>
@@ -37645,19 +37169,7 @@
                 <a:cs typeface="Instrument Sans"/>
                 <a:sym typeface="Instrument Sans"/>
               </a:rPr>
-              <a:t>数据公司</a:t>
-            </a:r>
-            <a:r>
-              <a:rPr sz="1050" b="0" dirty="0">
-                <a:solidFill>
-                  <a:srgbClr val="33322F"/>
-                </a:solidFill>
-                <a:latin typeface="Instrument Sans"/>
-                <a:ea typeface="Instrument Sans"/>
-                <a:cs typeface="Instrument Sans"/>
-                <a:sym typeface="Instrument Sans"/>
-              </a:rPr>
-              <a:t>Mercor估值，18个月从20亿到200亿美元（洽谈中）</a:t>
+              <a:t>Mercor估值：18个月，20亿→200亿美元（洽谈中）</a:t>
             </a:r>
           </a:p>
         </p:txBody>
@@ -38190,19 +37702,7 @@
                 <a:cs typeface="Instrument Sans"/>
                 <a:sym typeface="Instrument Sans"/>
               </a:rPr>
-              <a:t>同赛道</a:t>
-            </a:r>
-            <a:r>
-              <a:rPr sz="1000" b="0" dirty="0">
-                <a:solidFill>
-                  <a:srgbClr val="33322F"/>
-                </a:solidFill>
-                <a:latin typeface="Instrument Sans"/>
-                <a:ea typeface="Instrument Sans"/>
-                <a:cs typeface="Instrument Sans"/>
-                <a:sym typeface="Instrument Sans"/>
-              </a:rPr>
-              <a:t>AfterQuery估值从3亿美元到32亿美元</a:t>
+              <a:t>AfterQuery估值：3亿→32亿美元</a:t>
             </a:r>
           </a:p>
         </p:txBody>
@@ -38499,31 +37999,7 @@
                 <a:cs typeface="Instrument Sans"/>
                 <a:sym typeface="Instrument Sans"/>
               </a:rPr>
-              <a:t>AI智能体市场，</a:t>
-            </a:r>
-            <a:r>
-              <a:rPr lang="en-US" altLang="zh-CN" sz="1050" b="0" dirty="0">
-                <a:solidFill>
-                  <a:srgbClr val="33322F"/>
-                </a:solidFill>
-                <a:latin typeface="Instrument Sans"/>
-                <a:ea typeface="Instrument Sans"/>
-                <a:cs typeface="Instrument Sans"/>
-                <a:sym typeface="Instrument Sans"/>
-              </a:rPr>
-              <a:t>7</a:t>
-            </a:r>
-            <a:r>
-              <a:rPr sz="1050" b="0" dirty="0">
-                <a:solidFill>
-                  <a:srgbClr val="33322F"/>
-                </a:solidFill>
-                <a:latin typeface="Instrument Sans"/>
-                <a:ea typeface="Instrument Sans"/>
-                <a:cs typeface="Instrument Sans"/>
-                <a:sym typeface="Instrument Sans"/>
-              </a:rPr>
-              <a:t>年从79亿到约1,110亿美元</a:t>
+              <a:t>AI智能体市场：7年，79亿→约1,110亿美元</a:t>
             </a:r>
           </a:p>
         </p:txBody>
@@ -38817,7 +38293,7 @@
                 <a:cs typeface="Instrument Sans"/>
                 <a:sym typeface="Instrument Sans"/>
               </a:rPr>
-              <a:t>Scale AI新数据训练项目已涉及强化学习环境</a:t>
+              <a:t>Scale AI新训练项目已涉及RL环境</a:t>
             </a:r>
           </a:p>
         </p:txBody>
@@ -39080,19 +38556,19 @@
                 <a:cs typeface="Newsreader"/>
                 <a:sym typeface="Newsreader"/>
               </a:rPr>
-              <a:t>当</a:t>
-            </a:r>
-            <a:r>
-              <a:rPr lang="en-US" altLang="zh-CN" sz="2800" dirty="0">
-                <a:solidFill>
-                  <a:srgbClr val="111110"/>
+              <a:t>AI会做题了：谁有最好的</a:t>
+            </a:r>
+            <a:r>
+              <a:rPr lang="zh-CN" altLang="en-US" sz="2800" dirty="0">
+                <a:solidFill>
+                  <a:srgbClr val="C2410C"/>
                 </a:solidFill>
                 <a:latin typeface="Newsreader"/>
                 <a:ea typeface="Newsreader"/>
                 <a:cs typeface="Newsreader"/>
                 <a:sym typeface="Newsreader"/>
               </a:rPr>
-              <a:t>AI</a:t>
+              <a:t>训练世界</a:t>
             </a:r>
             <a:r>
               <a:rPr lang="zh-CN" altLang="en-US" sz="2800" dirty="0">
@@ -39104,43 +38580,7 @@
                 <a:cs typeface="Newsreader"/>
                 <a:sym typeface="Newsreader"/>
               </a:rPr>
-              <a:t>会做题后：谁拥有最好的</a:t>
-            </a:r>
-            <a:r>
-              <a:rPr lang="zh-CN" altLang="en-US" sz="2800" dirty="0">
-                <a:solidFill>
-                  <a:srgbClr val="C2410C"/>
-                </a:solidFill>
-                <a:latin typeface="Newsreader"/>
-                <a:ea typeface="Newsreader"/>
-                <a:cs typeface="Newsreader"/>
-                <a:sym typeface="Newsreader"/>
-              </a:rPr>
-              <a:t>训练世界</a:t>
-            </a:r>
-            <a:r>
-              <a:rPr lang="zh-CN" altLang="en-US" sz="2800" dirty="0">
-                <a:solidFill>
-                  <a:srgbClr val="111110"/>
-                </a:solidFill>
-                <a:latin typeface="Newsreader"/>
-                <a:ea typeface="Newsreader"/>
-                <a:cs typeface="Newsreader"/>
-                <a:sym typeface="Newsreader"/>
-              </a:rPr>
-              <a:t>，谁才能拥有每个领域最好的</a:t>
-            </a:r>
-            <a:r>
-              <a:rPr lang="en-US" altLang="zh-CN" sz="2800" dirty="0">
-                <a:solidFill>
-                  <a:srgbClr val="111110"/>
-                </a:solidFill>
-                <a:latin typeface="Newsreader"/>
-                <a:ea typeface="Newsreader"/>
-                <a:cs typeface="Newsreader"/>
-                <a:sym typeface="Newsreader"/>
-              </a:rPr>
-              <a:t>AI</a:t>
+              <a:t>，谁就有每个领域最好的AI</a:t>
             </a:r>
             <a:endParaRPr sz="2800" b="0" i="0" u="none" strike="noStrike" cap="none" dirty="0">
               <a:solidFill>
@@ -40317,105 +39757,31 @@
                 <a:cs typeface="Newsreader"/>
                 <a:sym typeface="Newsreader"/>
               </a:rPr>
-              <a:t>AI</a:t>
-            </a:r>
-            <a:r>
-              <a:rPr lang="zh-CN" altLang="en-US" sz="2000" dirty="0">
-                <a:solidFill>
-                  <a:srgbClr val="111110"/>
+              <a:t>AI越独立接管经济活动，</a:t>
+            </a:r>
+            <a:r>
+              <a:rPr lang="zh-CN" sz="2000" dirty="0">
+                <a:solidFill>
+                  <a:srgbClr val="C2410C"/>
                 </a:solidFill>
                 <a:latin typeface="Newsreader"/>
                 <a:ea typeface="Newsreader"/>
                 <a:cs typeface="Newsreader"/>
                 <a:sym typeface="Newsreader"/>
               </a:rPr>
-              <a:t>接管经济活动，必须有</a:t>
-            </a:r>
-            <a:r>
-              <a:rPr lang="zh-CN" altLang="en-US" sz="2000" dirty="0">
-                <a:solidFill>
-                  <a:schemeClr val="accent2">
-                    <a:lumMod val="75000"/>
-                  </a:schemeClr>
+              <a:t>判断对错的标准</a:t>
+            </a:r>
+            <a:r>
+              <a:rPr lang="en-US" altLang="zh-CN" sz="2000" dirty="0">
+                <a:solidFill>
+                  <a:srgbClr val="111110"/>
                 </a:solidFill>
                 <a:latin typeface="Newsreader"/>
                 <a:ea typeface="Newsreader"/>
                 <a:cs typeface="Newsreader"/>
                 <a:sym typeface="Newsreader"/>
               </a:rPr>
-              <a:t>海量真实可靠有效的数据环境；</a:t>
-            </a:r>
-            <a:r>
-              <a:rPr lang="zh-CN" sz="2000" dirty="0">
-                <a:solidFill>
-                  <a:srgbClr val="111110"/>
-                </a:solidFill>
-                <a:latin typeface="Newsreader"/>
-                <a:ea typeface="Newsreader"/>
-                <a:cs typeface="Newsreader"/>
-                <a:sym typeface="Newsreader"/>
-              </a:rPr>
-              <a:t>AI 越独立</a:t>
-            </a:r>
-            <a:r>
-              <a:rPr lang="zh-CN" altLang="en-US" sz="2000" dirty="0">
-                <a:solidFill>
-                  <a:srgbClr val="111110"/>
-                </a:solidFill>
-                <a:latin typeface="Newsreader"/>
-                <a:ea typeface="Newsreader"/>
-                <a:cs typeface="Newsreader"/>
-                <a:sym typeface="Newsreader"/>
-              </a:rPr>
-              <a:t>接管</a:t>
-            </a:r>
-            <a:r>
-              <a:rPr lang="zh-CN" sz="2000" dirty="0">
-                <a:solidFill>
-                  <a:srgbClr val="111110"/>
-                </a:solidFill>
-                <a:latin typeface="Newsreader"/>
-                <a:ea typeface="Newsreader"/>
-                <a:cs typeface="Newsreader"/>
-                <a:sym typeface="Newsreader"/>
-              </a:rPr>
-              <a:t>，</a:t>
-            </a:r>
-            <a:r>
-              <a:rPr lang="zh-CN" sz="2000" dirty="0">
-                <a:solidFill>
-                  <a:srgbClr val="C2410C"/>
-                </a:solidFill>
-                <a:latin typeface="Newsreader"/>
-                <a:ea typeface="Newsreader"/>
-                <a:cs typeface="Newsreader"/>
-                <a:sym typeface="Newsreader"/>
-              </a:rPr>
-              <a:t>判断对错的标准</a:t>
-            </a:r>
-            <a:r>
-              <a:rPr lang="zh-CN" sz="2000" dirty="0">
-                <a:solidFill>
-                  <a:srgbClr val="111110"/>
-                </a:solidFill>
-                <a:latin typeface="Newsreader"/>
-                <a:ea typeface="Newsreader"/>
-                <a:cs typeface="Newsreader"/>
-                <a:sym typeface="Newsreader"/>
-              </a:rPr>
               <a:t>就越重要</a:t>
-            </a:r>
-            <a:r>
-              <a:rPr lang="zh-CN" altLang="en-US" sz="2000" dirty="0">
-                <a:solidFill>
-                  <a:srgbClr val="111110"/>
-                </a:solidFill>
-                <a:latin typeface="Newsreader"/>
-                <a:ea typeface="Newsreader"/>
-                <a:cs typeface="Newsreader"/>
-                <a:sym typeface="Newsreader"/>
-              </a:rPr>
-              <a:t>；</a:t>
             </a:r>
             <a:endParaRPr lang="en-US" altLang="zh-CN" sz="2000" dirty="0">
               <a:solidFill>
@@ -40452,19 +39818,7 @@
                 <a:cs typeface="Newsreader"/>
                 <a:sym typeface="Newsreader"/>
               </a:rPr>
-              <a:t>有了准确标准和真实环境，我们让</a:t>
-            </a:r>
-            <a:r>
-              <a:rPr lang="en-US" altLang="zh-CN" sz="2000" dirty="0">
-                <a:solidFill>
-                  <a:schemeClr val="tx1"/>
-                </a:solidFill>
-                <a:latin typeface="Newsreader"/>
-                <a:ea typeface="Newsreader"/>
-                <a:cs typeface="Newsreader"/>
-                <a:sym typeface="Newsreader"/>
-              </a:rPr>
-              <a:t>AI</a:t>
+              <a:t>有了真实环境和准确标准，AI才能</a:t>
             </a:r>
             <a:r>
               <a:rPr lang="zh-CN" altLang="en-US" sz="2000" dirty="0">
@@ -41057,43 +40411,7 @@
                 <a:cs typeface="Instrument Sans"/>
                 <a:sym typeface="Instrument Sans"/>
               </a:rPr>
-              <a:t>考满分的AI，</a:t>
-            </a:r>
-            <a:r>
-              <a:rPr lang="zh-CN" sz="1500">
-                <a:solidFill>
-                  <a:srgbClr val="6E6C66"/>
-                </a:solidFill>
-                <a:latin typeface="Instrument Sans"/>
-                <a:ea typeface="Instrument Sans"/>
-                <a:cs typeface="Instrument Sans"/>
-                <a:sym typeface="Instrument Sans"/>
-              </a:rPr>
-              <a:t>无法被放心交付</a:t>
-            </a:r>
-            <a:r>
-              <a:rPr lang="zh-CN" sz="1500" b="0" i="0" u="none" strike="noStrike" cap="none">
-                <a:solidFill>
-                  <a:srgbClr val="6E6C66"/>
-                </a:solidFill>
-                <a:latin typeface="Instrument Sans"/>
-                <a:ea typeface="Instrument Sans"/>
-                <a:cs typeface="Instrument Sans"/>
-                <a:sym typeface="Instrument Sans"/>
-              </a:rPr>
-              <a:t>：真实工作没有</a:t>
-            </a:r>
-            <a:r>
-              <a:rPr lang="zh-CN" sz="1500">
-                <a:solidFill>
-                  <a:srgbClr val="6E6C66"/>
-                </a:solidFill>
-                <a:latin typeface="Instrument Sans"/>
-                <a:ea typeface="Instrument Sans"/>
-                <a:cs typeface="Instrument Sans"/>
-                <a:sym typeface="Instrument Sans"/>
-              </a:rPr>
-              <a:t>标准答案</a:t>
+              <a:t>真实工作没有标准答案：考满分的AI，未必能放心交付</a:t>
             </a:r>
             <a:endParaRPr sz="1500" b="0" i="0" u="none" strike="noStrike" cap="none">
               <a:solidFill>
@@ -42360,19 +41678,7 @@
                 <a:cs typeface="Instrument Sans"/>
                 <a:sym typeface="Instrument Sans"/>
               </a:rPr>
-              <a:t>AI真正走入现实与经济</a:t>
-            </a:r>
-            <a:r>
-              <a:rPr lang="zh-CN" altLang="en-US" sz="1300" dirty="0">
-                <a:solidFill>
-                  <a:srgbClr val="C4C0B7"/>
-                </a:solidFill>
-                <a:latin typeface="Instrument Sans"/>
-                <a:ea typeface="Instrument Sans"/>
-                <a:cs typeface="Instrument Sans"/>
-                <a:sym typeface="Instrument Sans"/>
-              </a:rPr>
-              <a:t>活动</a:t>
+              <a:t>AI进入现实经济</a:t>
             </a:r>
             <a:endParaRPr sz="1300" b="0" i="0" u="none" strike="noStrike" cap="none" dirty="0">
               <a:solidFill>
@@ -42635,7 +41941,7 @@
                 <a:cs typeface="Newsreader"/>
                 <a:sym typeface="Newsreader"/>
               </a:rPr>
-              <a:t>AI的下一代反馈信号扎根于现实世界</a:t>
+              <a:t>下一代反馈信号，来自现实世界</a:t>
             </a:r>
             <a:endParaRPr sz="2800" b="0" i="0" u="none" strike="noStrike" cap="none">
               <a:solidFill>
@@ -42806,19 +42112,19 @@
                 <a:cs typeface="Newsreader"/>
                 <a:sym typeface="Newsreader"/>
               </a:rPr>
-              <a:t>每个</a:t>
-            </a:r>
-            <a:r>
-              <a:rPr lang="zh-CN" altLang="en-US" sz="2800" dirty="0">
-                <a:solidFill>
-                  <a:srgbClr val="111110"/>
+              <a:t>每个动作都有</a:t>
+            </a:r>
+            <a:r>
+              <a:rPr lang="zh-CN" sz="2800" b="0" i="0" u="none" strike="noStrike" cap="none" dirty="0">
+                <a:solidFill>
+                  <a:srgbClr val="C2410C"/>
                 </a:solidFill>
                 <a:latin typeface="Newsreader"/>
                 <a:ea typeface="Newsreader"/>
                 <a:cs typeface="Newsreader"/>
                 <a:sym typeface="Newsreader"/>
               </a:rPr>
-              <a:t>行为</a:t>
+              <a:t>真实反馈</a:t>
             </a:r>
             <a:r>
               <a:rPr lang="zh-CN" sz="2800" b="0" i="0" u="none" strike="noStrike" cap="none" dirty="0">
@@ -42830,55 +42136,7 @@
                 <a:cs typeface="Newsreader"/>
                 <a:sym typeface="Newsreader"/>
               </a:rPr>
-              <a:t>都有</a:t>
-            </a:r>
-            <a:r>
-              <a:rPr lang="zh-CN" sz="2800" b="0" i="0" u="none" strike="noStrike" cap="none" dirty="0">
-                <a:solidFill>
-                  <a:srgbClr val="C2410C"/>
-                </a:solidFill>
-                <a:latin typeface="Newsreader"/>
-                <a:ea typeface="Newsreader"/>
-                <a:cs typeface="Newsreader"/>
-                <a:sym typeface="Newsreader"/>
-              </a:rPr>
-              <a:t>真实</a:t>
-            </a:r>
-            <a:r>
-              <a:rPr lang="zh-CN" sz="2800" dirty="0">
-                <a:solidFill>
-                  <a:srgbClr val="C2410C"/>
-                </a:solidFill>
-                <a:latin typeface="Newsreader"/>
-                <a:ea typeface="Newsreader"/>
-                <a:cs typeface="Newsreader"/>
-                <a:sym typeface="Newsreader"/>
-              </a:rPr>
-              <a:t>反馈</a:t>
-            </a:r>
-            <a:r>
-              <a:rPr lang="zh-CN" sz="2800" b="0" i="0" u="none" strike="noStrike" cap="none" dirty="0">
-                <a:solidFill>
-                  <a:srgbClr val="111110"/>
-                </a:solidFill>
-                <a:latin typeface="Newsreader"/>
-                <a:ea typeface="Newsreader"/>
-                <a:cs typeface="Newsreader"/>
-                <a:sym typeface="Newsreader"/>
-              </a:rPr>
-              <a:t>，</a:t>
-            </a:r>
-            <a:r>
-              <a:rPr lang="zh-CN" sz="2800" dirty="0">
-                <a:solidFill>
-                  <a:srgbClr val="111110"/>
-                </a:solidFill>
-                <a:latin typeface="Newsreader"/>
-                <a:ea typeface="Newsreader"/>
-                <a:cs typeface="Newsreader"/>
-                <a:sym typeface="Newsreader"/>
-              </a:rPr>
-              <a:t>实现AI自我持续进化</a:t>
+              <a:t>，AI持续自我进化</a:t>
             </a:r>
             <a:endParaRPr sz="2800" b="0" i="0" u="none" strike="noStrike" cap="none" dirty="0">
               <a:solidFill>
@@ -42941,7 +42199,7 @@
                 <a:cs typeface="Instrument Sans"/>
                 <a:sym typeface="Instrument Sans"/>
               </a:rPr>
-              <a:t>训练环境、结果评分、专家判断合为一体：AI练习真实工作，从每次结果中学习。</a:t>
+              <a:t>环境、评分、专家三合一：AI做真实工作，从每次结果中学习</a:t>
             </a:r>
             <a:endParaRPr sz="1500" b="0" i="0" u="none" strike="noStrike" cap="none" dirty="0">
               <a:solidFill>
@@ -43176,7 +42434,7 @@
                 <a:cs typeface="Instrument Sans"/>
                 <a:sym typeface="Instrument Sans"/>
               </a:rPr>
-              <a:t>还原真实工作，供AI练习</a:t>
+              <a:t>还原真实工作</a:t>
             </a:r>
             <a:endParaRPr sz="1200" b="0" i="0" u="none" strike="noStrike" cap="none">
               <a:solidFill>
@@ -44070,7 +43328,7 @@
                 <a:cs typeface="Instrument Sans"/>
                 <a:sym typeface="Instrument Sans"/>
               </a:rPr>
-              <a:t>让AI从每次结果中学习</a:t>
+              <a:t>每次结果都是训练</a:t>
             </a:r>
             <a:endParaRPr sz="1300" b="0" i="0" u="none" strike="noStrike" cap="none">
               <a:solidFill>
@@ -44674,7 +43932,7 @@
                 <a:cs typeface="Instrument Sans"/>
                 <a:sym typeface="Instrument Sans"/>
               </a:rPr>
-              <a:t>更强的模型再次行动：每一轮都从上一轮出发</a:t>
+              <a:t>每一轮都从上一轮出发</a:t>
             </a:r>
           </a:p>
         </p:txBody>
@@ -45051,67 +44309,7 @@
                 <a:cs typeface="Instrument Sans"/>
                 <a:sym typeface="Instrument Sans"/>
               </a:rPr>
-              <a:t>AI进入真实市场，和顶尖交易员同场比赛</a:t>
-            </a:r>
-            <a:r>
-              <a:rPr lang="zh-CN" altLang="en-US" sz="1200" b="0" i="0" u="none" strike="noStrike" cap="none" dirty="0">
-                <a:solidFill>
-                  <a:srgbClr val="33322F"/>
-                </a:solidFill>
-                <a:latin typeface="Instrument Sans"/>
-                <a:ea typeface="Instrument Sans"/>
-                <a:cs typeface="Instrument Sans"/>
-                <a:sym typeface="Instrument Sans"/>
-              </a:rPr>
-              <a:t>。使用</a:t>
-            </a:r>
-            <a:r>
-              <a:rPr lang="en-US" altLang="zh-CN" sz="1200" b="0" i="0" u="none" strike="noStrike" cap="none" dirty="0">
-                <a:solidFill>
-                  <a:srgbClr val="33322F"/>
-                </a:solidFill>
-                <a:latin typeface="Instrument Sans"/>
-                <a:ea typeface="Instrument Sans"/>
-                <a:cs typeface="Instrument Sans"/>
-                <a:sym typeface="Instrument Sans"/>
-              </a:rPr>
-              <a:t>IMC</a:t>
-            </a:r>
-            <a:r>
-              <a:rPr lang="zh-CN" altLang="en-US" sz="1200" b="0" i="0" u="none" strike="noStrike" cap="none" dirty="0">
-                <a:solidFill>
-                  <a:srgbClr val="33322F"/>
-                </a:solidFill>
-                <a:latin typeface="Instrument Sans"/>
-                <a:ea typeface="Instrument Sans"/>
-                <a:cs typeface="Instrument Sans"/>
-                <a:sym typeface="Instrument Sans"/>
-              </a:rPr>
-              <a:t> </a:t>
-            </a:r>
-            <a:r>
-              <a:rPr lang="en-US" altLang="zh-CN" sz="1200" b="0" i="0" u="none" strike="noStrike" cap="none" dirty="0">
-                <a:solidFill>
-                  <a:srgbClr val="33322F"/>
-                </a:solidFill>
-                <a:latin typeface="Instrument Sans"/>
-                <a:ea typeface="Instrument Sans"/>
-                <a:cs typeface="Instrument Sans"/>
-                <a:sym typeface="Instrument Sans"/>
-              </a:rPr>
-              <a:t>Trading</a:t>
-            </a:r>
-            <a:r>
-              <a:rPr lang="zh-CN" altLang="en-US" sz="1200" dirty="0">
-                <a:solidFill>
-                  <a:srgbClr val="33322F"/>
-                </a:solidFill>
-                <a:latin typeface="Instrument Sans"/>
-                <a:ea typeface="Instrument Sans"/>
-                <a:cs typeface="Instrument Sans"/>
-                <a:sym typeface="Instrument Sans"/>
-              </a:rPr>
-              <a:t>授权数据</a:t>
+              <a:t>真实市场，与顶尖交易员同场；IMC Trading授权数据</a:t>
             </a:r>
             <a:endParaRPr sz="1200" b="0" i="0" u="none" strike="noStrike" cap="none" dirty="0">
               <a:solidFill>
@@ -45263,7 +44461,7 @@
                 <a:cs typeface="Instrument Sans"/>
                 <a:sym typeface="Instrument Sans"/>
               </a:rPr>
-              <a:t>每一笔交易由市场结算</a:t>
+              <a:t>每笔交易由市场结算</a:t>
             </a:r>
             <a:endParaRPr sz="1200" b="0" i="0" u="none" strike="noStrike" cap="none" dirty="0">
               <a:solidFill>
@@ -45415,31 +44613,7 @@
                 <a:cs typeface="Instrument Sans"/>
                 <a:sym typeface="Instrument Sans"/>
               </a:rPr>
-              <a:t>AI从每天的盈亏</a:t>
-            </a:r>
-            <a:r>
-              <a:rPr lang="zh-CN" altLang="en-US" sz="1200" dirty="0">
-                <a:solidFill>
-                  <a:srgbClr val="33322F"/>
-                </a:solidFill>
-                <a:latin typeface="Instrument Sans"/>
-                <a:ea typeface="Instrument Sans"/>
-                <a:cs typeface="Instrument Sans"/>
-                <a:sym typeface="Instrument Sans"/>
-              </a:rPr>
-              <a:t>和订单</a:t>
-            </a:r>
-            <a:r>
-              <a:rPr lang="zh-CN" sz="1200" b="0" i="0" u="none" strike="noStrike" cap="none" dirty="0">
-                <a:solidFill>
-                  <a:srgbClr val="33322F"/>
-                </a:solidFill>
-                <a:latin typeface="Instrument Sans"/>
-                <a:ea typeface="Instrument Sans"/>
-                <a:cs typeface="Instrument Sans"/>
-                <a:sym typeface="Instrument Sans"/>
-              </a:rPr>
-              <a:t>中复盘，每一轮都让下一轮更强</a:t>
+              <a:t>每天复盘盈亏与订单，一轮比一轮强</a:t>
             </a:r>
             <a:endParaRPr sz="1200" b="0" i="0" u="none" strike="noStrike" cap="none" dirty="0">
               <a:solidFill>
@@ -45528,7 +44702,7 @@
                 <a:cs typeface="Instrument Sans"/>
                 <a:sym typeface="Instrument Sans"/>
               </a:rPr>
-              <a:t>我们把开源模型Qwen3.8-27B放进Xitadel训练。在从未见过的真实市场数据上，它的交易表现提升12%，在多次独立运行中得到复现</a:t>
+              <a:t>开源模型Qwen3.8-27B在Xitadel训练后，在未见过的真实行情上交易表现提升12%，多次独立复现</a:t>
             </a:r>
             <a:endParaRPr sz="1300" b="0" i="0" u="none" strike="noStrike" cap="none" dirty="0">
               <a:solidFill>
@@ -45591,31 +44765,7 @@
                 <a:cs typeface="Newsreader"/>
                 <a:sym typeface="Newsreader"/>
               </a:rPr>
-              <a:t>我们已经证明，AI可以在真实</a:t>
-            </a:r>
-            <a:r>
-              <a:rPr lang="zh-CN" sz="1700" dirty="0">
-                <a:solidFill>
-                  <a:srgbClr val="111110"/>
-                </a:solidFill>
-                <a:latin typeface="Newsreader"/>
-                <a:ea typeface="Newsreader"/>
-                <a:cs typeface="Newsreader"/>
-                <a:sym typeface="Newsreader"/>
-              </a:rPr>
-              <a:t>金融</a:t>
-            </a:r>
-            <a:r>
-              <a:rPr lang="zh-CN" sz="1700" b="0" i="0" u="none" strike="noStrike" cap="none" dirty="0">
-                <a:solidFill>
-                  <a:srgbClr val="111110"/>
-                </a:solidFill>
-                <a:latin typeface="Newsreader"/>
-                <a:ea typeface="Newsreader"/>
-                <a:cs typeface="Newsreader"/>
-                <a:sym typeface="Newsreader"/>
-              </a:rPr>
-              <a:t>市场里自己变强</a:t>
+              <a:t>已证明：AI能在真实金融市场里自己变强</a:t>
             </a:r>
             <a:endParaRPr sz="1700" b="0" i="0" u="none" strike="noStrike" cap="none" dirty="0">
               <a:solidFill>
@@ -45677,19 +44827,7 @@
                 <a:cs typeface="Newsreader"/>
                 <a:sym typeface="Newsreader"/>
               </a:rPr>
-              <a:t>下一步：扩展到多策略、多市场</a:t>
-            </a:r>
-            <a:r>
-              <a:rPr lang="zh-CN" sz="1700" dirty="0">
-                <a:solidFill>
-                  <a:srgbClr val="C2410C"/>
-                </a:solidFill>
-                <a:latin typeface="Newsreader"/>
-                <a:ea typeface="Newsreader"/>
-                <a:cs typeface="Newsreader"/>
-                <a:sym typeface="Newsreader"/>
-              </a:rPr>
-              <a:t>，多行业</a:t>
+              <a:t>下一步：多策略、多市场、多行业</a:t>
             </a:r>
             <a:endParaRPr sz="1700" b="0" i="0" u="none" strike="noStrike" cap="none" dirty="0">
               <a:solidFill>
@@ -45798,43 +44936,7 @@
                 <a:cs typeface="Instrument Sans SemiBold"/>
                 <a:sym typeface="Instrument Sans SemiBold"/>
               </a:rPr>
-              <a:t>每一轮，都从上一轮</a:t>
-            </a:r>
-            <a:r>
-              <a:rPr lang="zh-CN" sz="1200">
-                <a:solidFill>
-                  <a:srgbClr val="111110"/>
-                </a:solidFill>
-                <a:latin typeface="Instrument Sans SemiBold"/>
-                <a:ea typeface="Instrument Sans SemiBold"/>
-                <a:cs typeface="Instrument Sans SemiBold"/>
-                <a:sym typeface="Instrument Sans SemiBold"/>
-              </a:rPr>
-              <a:t>反馈</a:t>
-            </a:r>
-            <a:r>
-              <a:rPr lang="zh-CN" sz="1200" b="0" i="0" u="none" strike="noStrike" cap="none">
-                <a:solidFill>
-                  <a:srgbClr val="111110"/>
-                </a:solidFill>
-                <a:latin typeface="Instrument Sans SemiBold"/>
-                <a:ea typeface="Instrument Sans SemiBold"/>
-                <a:cs typeface="Instrument Sans SemiBold"/>
-                <a:sym typeface="Instrument Sans SemiBold"/>
-              </a:rPr>
-              <a:t>出发，</a:t>
-            </a:r>
-            <a:r>
-              <a:rPr lang="zh-CN" sz="1200">
-                <a:solidFill>
-                  <a:srgbClr val="111110"/>
-                </a:solidFill>
-                <a:latin typeface="Instrument Sans SemiBold"/>
-                <a:ea typeface="Instrument Sans SemiBold"/>
-                <a:cs typeface="Instrument Sans SemiBold"/>
-                <a:sym typeface="Instrument Sans SemiBold"/>
-              </a:rPr>
-              <a:t>自我进化</a:t>
+              <a:t>每一轮都从上一轮的反馈出发</a:t>
             </a:r>
             <a:endParaRPr sz="1200" b="0" i="0" u="none" strike="noStrike" cap="none">
               <a:solidFill>
@@ -46011,7 +45113,7 @@
                 <a:cs typeface="Instrument Sans"/>
                 <a:sym typeface="Instrument Sans"/>
               </a:rPr>
-              <a:t>交易表现以基础模型=100计；多次独立运行均复现（受控实验，Qwen3.8-27B）。</a:t>
+              <a:t>以基础模型=100计；多次独立复现（受控实验，Qwen3.8-27B）</a:t>
             </a:r>
             <a:endParaRPr sz="900" b="0" i="0" u="none" strike="noStrike" cap="none">
               <a:solidFill>
@@ -46085,43 +45187,7 @@
                 <a:cs typeface="Newsreader"/>
                 <a:sym typeface="Newsreader"/>
               </a:rPr>
-              <a:t>我们</a:t>
-            </a:r>
-            <a:r>
-              <a:rPr lang="zh-CN" altLang="en-US" sz="2000" dirty="0">
-                <a:solidFill>
-                  <a:srgbClr val="111110"/>
-                </a:solidFill>
-                <a:latin typeface="Newsreader"/>
-                <a:ea typeface="Newsreader"/>
-                <a:cs typeface="Newsreader"/>
-                <a:sym typeface="Newsreader"/>
-              </a:rPr>
-              <a:t>两周</a:t>
-            </a:r>
-            <a:r>
-              <a:rPr lang="zh-CN" sz="2000" dirty="0">
-                <a:solidFill>
-                  <a:srgbClr val="111110"/>
-                </a:solidFill>
-                <a:latin typeface="Newsreader"/>
-                <a:ea typeface="Newsreader"/>
-                <a:cs typeface="Newsreader"/>
-                <a:sym typeface="Newsreader"/>
-              </a:rPr>
-              <a:t>跑通了</a:t>
-            </a:r>
-            <a:r>
-              <a:rPr lang="zh-CN" altLang="en-US" sz="2000" dirty="0">
-                <a:solidFill>
-                  <a:srgbClr val="111110"/>
-                </a:solidFill>
-                <a:latin typeface="Newsreader"/>
-                <a:ea typeface="Newsreader"/>
-                <a:cs typeface="Newsreader"/>
-                <a:sym typeface="Newsreader"/>
-              </a:rPr>
-              <a:t>世界第一个做市交易的自我进化</a:t>
+              <a:t>两周，我们跑通了全球首个做市交易的自我进化</a:t>
             </a:r>
             <a:endParaRPr sz="2000" b="0" i="0" u="none" strike="noStrike" cap="none" dirty="0">
               <a:solidFill>
@@ -46473,91 +45539,7 @@
                 <a:cs typeface="Newsreader"/>
                 <a:sym typeface="Newsreader"/>
               </a:rPr>
-              <a:t>我们</a:t>
-            </a:r>
-            <a:r>
-              <a:rPr lang="zh-CN" sz="2800" b="0" i="0" u="none" strike="noStrike" cap="none" dirty="0">
-                <a:solidFill>
-                  <a:srgbClr val="111110"/>
-                </a:solidFill>
-                <a:latin typeface="Newsreader"/>
-                <a:ea typeface="Newsreader"/>
-                <a:cs typeface="Newsreader"/>
-                <a:sym typeface="Newsreader"/>
-              </a:rPr>
-              <a:t>的方法，</a:t>
-            </a:r>
-            <a:r>
-              <a:rPr lang="zh-CN" altLang="en-US" sz="2800" dirty="0">
-                <a:solidFill>
-                  <a:srgbClr val="111110"/>
-                </a:solidFill>
-                <a:latin typeface="Newsreader"/>
-                <a:ea typeface="Newsreader"/>
-                <a:cs typeface="Newsreader"/>
-                <a:sym typeface="Newsreader"/>
-              </a:rPr>
-              <a:t>也</a:t>
-            </a:r>
-            <a:r>
-              <a:rPr lang="zh-CN" sz="2800" b="0" i="0" u="none" strike="noStrike" cap="none" dirty="0">
-                <a:solidFill>
-                  <a:srgbClr val="111110"/>
-                </a:solidFill>
-                <a:latin typeface="Newsreader"/>
-                <a:ea typeface="Newsreader"/>
-                <a:cs typeface="Newsreader"/>
-                <a:sym typeface="Newsreader"/>
-              </a:rPr>
-              <a:t>在</a:t>
-            </a:r>
-            <a:r>
-              <a:rPr lang="zh-CN" altLang="en-US" sz="2800" dirty="0">
-                <a:solidFill>
-                  <a:srgbClr val="111110"/>
-                </a:solidFill>
-                <a:latin typeface="Newsreader"/>
-                <a:ea typeface="Newsreader"/>
-                <a:cs typeface="Newsreader"/>
-                <a:sym typeface="Newsreader"/>
-              </a:rPr>
-              <a:t>机器学习</a:t>
-            </a:r>
-            <a:r>
-              <a:rPr lang="zh-CN" sz="2800" b="0" i="0" u="none" strike="noStrike" cap="none" dirty="0">
-                <a:solidFill>
-                  <a:srgbClr val="111110"/>
-                </a:solidFill>
-                <a:latin typeface="Newsreader"/>
-                <a:ea typeface="Newsreader"/>
-                <a:cs typeface="Newsreader"/>
-                <a:sym typeface="Newsreader"/>
-              </a:rPr>
-              <a:t>和</a:t>
-            </a:r>
-            <a:r>
-              <a:rPr lang="zh-CN" altLang="en-US" sz="2800" b="0" i="0" u="none" strike="noStrike" cap="none" dirty="0">
-                <a:solidFill>
-                  <a:srgbClr val="111110"/>
-                </a:solidFill>
-                <a:latin typeface="Newsreader"/>
-                <a:ea typeface="Newsreader"/>
-                <a:cs typeface="Newsreader"/>
-                <a:sym typeface="Newsreader"/>
-              </a:rPr>
-              <a:t>事件</a:t>
-            </a:r>
-            <a:r>
-              <a:rPr lang="zh-CN" sz="2800" b="0" i="0" u="none" strike="noStrike" cap="none" dirty="0">
-                <a:solidFill>
-                  <a:srgbClr val="111110"/>
-                </a:solidFill>
-                <a:latin typeface="Newsreader"/>
-                <a:ea typeface="Newsreader"/>
-                <a:cs typeface="Newsreader"/>
-                <a:sym typeface="Newsreader"/>
-              </a:rPr>
-              <a:t>预测上运转</a:t>
+              <a:t>同一套方法，已用在机器学习和事件预测</a:t>
             </a:r>
             <a:endParaRPr sz="2800" b="0" i="0" u="none" strike="noStrike" cap="none" dirty="0">
               <a:solidFill>
@@ -46857,31 +45839,7 @@
                 <a:cs typeface="Instrument Sans"/>
                 <a:sym typeface="Instrument Sans"/>
               </a:rPr>
-              <a:t>让AI独立完成整个研究项目，从数据、实验</a:t>
-            </a:r>
-            <a:r>
-              <a:rPr lang="zh-CN" sz="1300" dirty="0">
-                <a:solidFill>
-                  <a:srgbClr val="33322F"/>
-                </a:solidFill>
-                <a:latin typeface="Instrument Sans"/>
-                <a:ea typeface="Instrument Sans"/>
-                <a:cs typeface="Instrument Sans"/>
-                <a:sym typeface="Instrument Sans"/>
-              </a:rPr>
-              <a:t>到</a:t>
-            </a:r>
-            <a:r>
-              <a:rPr lang="zh-CN" sz="1300" b="0" i="0" u="none" strike="noStrike" cap="none" dirty="0">
-                <a:solidFill>
-                  <a:srgbClr val="33322F"/>
-                </a:solidFill>
-                <a:latin typeface="Instrument Sans"/>
-                <a:ea typeface="Instrument Sans"/>
-                <a:cs typeface="Instrument Sans"/>
-                <a:sym typeface="Instrument Sans"/>
-              </a:rPr>
-              <a:t>结果：60个真实任务，覆盖7类数据</a:t>
+              <a:t>AI独立完成研究项目，从数据到结果：60个真实任务，7类数据</a:t>
             </a:r>
             <a:endParaRPr sz="1300" b="0" i="0" u="none" strike="noStrike" cap="none" dirty="0">
               <a:solidFill>
@@ -46944,7 +45902,7 @@
                 <a:cs typeface="Instrument Sans SemiBold"/>
                 <a:sym typeface="Instrument Sans SemiBold"/>
               </a:rPr>
-              <a:t>目标：AI改进AI，进化越来越快</a:t>
+              <a:t>目标：AI改进AI</a:t>
             </a:r>
             <a:endParaRPr sz="1200" b="0" i="0" u="none" strike="noStrike" cap="none" dirty="0">
               <a:solidFill>
@@ -47181,19 +46139,7 @@
                 <a:cs typeface="Instrument Sans"/>
                 <a:sym typeface="Instrument Sans"/>
               </a:rPr>
-              <a:t>让AI对真实世界的事件提前下判断，从体育赛事到地震活动，事件揭晓后按结果打分。</a:t>
-            </a:r>
-            <a:r>
-              <a:rPr lang="zh-CN" sz="1300" dirty="0">
-                <a:solidFill>
-                  <a:srgbClr val="33322F"/>
-                </a:solidFill>
-                <a:latin typeface="Instrument Sans"/>
-                <a:ea typeface="Instrument Sans"/>
-                <a:cs typeface="Instrument Sans"/>
-                <a:sym typeface="Instrument Sans"/>
-              </a:rPr>
-              <a:t>根据结果，持续进化</a:t>
+              <a:t>AI预判真实事件，从体育赛事到地震，揭晓后按结果打分、持续进化</a:t>
             </a:r>
             <a:endParaRPr sz="1300" b="0" i="0" u="none" strike="noStrike" cap="none" dirty="0">
               <a:solidFill>
@@ -47256,19 +46202,7 @@
                 <a:cs typeface="Instrument Sans SemiBold"/>
                 <a:sym typeface="Instrument Sans SemiBold"/>
               </a:rPr>
-              <a:t>目标：做出经得起现实检验的判断。</a:t>
-            </a:r>
-            <a:r>
-              <a:rPr lang="zh-CN" altLang="en-US" sz="1200" b="0" i="0" u="none" strike="noStrike" cap="none" dirty="0">
-                <a:solidFill>
-                  <a:srgbClr val="C2410C"/>
-                </a:solidFill>
-                <a:latin typeface="Instrument Sans SemiBold"/>
-                <a:ea typeface="Instrument Sans SemiBold"/>
-                <a:cs typeface="Instrument Sans SemiBold"/>
-                <a:sym typeface="Instrument Sans SemiBold"/>
-              </a:rPr>
-              <a:t>并根据每一个结果自我提升</a:t>
+              <a:t>目标：经得起现实检验的判断</a:t>
             </a:r>
             <a:endParaRPr sz="1200" b="0" i="0" u="none" strike="noStrike" cap="none" dirty="0">
               <a:solidFill>
@@ -47331,7 +46265,7 @@
                 <a:cs typeface="Newsreader"/>
                 <a:sym typeface="Newsreader"/>
               </a:rPr>
-              <a:t>14天做出7款产品，零外部融资。</a:t>
+              <a:t>14天7款产品，零外部融资</a:t>
             </a:r>
             <a:endParaRPr sz="1800" b="0" i="0" u="none" strike="noStrike" cap="none">
               <a:solidFill>

</xml_diff>

<commit_message>
BP v17: speed as our edge, engines lead with revenue, profit and the 7T target
- Page 10: rebuilt around the team's edge - catching each AI shift first
  and shipping (14 days, 7 products), with proof rows, the moving hot
  spot (labeling -> expert data -> RL envs -> self-evolution) and the
  bet-on-every-paradigm-shift close. Anti-cheat results kept as a proof row.
- Page 18: revenue engine leads with $300M ARR and ~$240M gross profit
  (24x the $10M in), each line shows what it drives, 3-month milestone
  is $20M ARR; RSI engine leads with the $7T AI economy it targets.
- Page 12: first paid order targeted for month 2.
- Page 16: drop 据报道; SimReal team is four quant-intern undergrads,
  high-school classmates.

Co-Authored-By: Claude Opus 5.5 <noreply@anthropic.com>
Claude-Session: https://claude.ai/code/session_01EKqGwTA92C8Wo4e47t73NN
</commit_message>
<xml_diff>
--- a/SimReal-BP-v17.pptx
+++ b/SimReal-BP-v17.pptx
@@ -6767,156 +6767,6 @@
           <a:chExt cx="0" cy="0"/>
         </a:xfrm>
       </p:grpSpPr>
-      <p:sp>
-        <p:nvSpPr>
-          <p:cNvPr id="308" name="Google Shape;308;p12"/>
-          <p:cNvSpPr txBox="1"/>
-          <p:nvPr/>
-        </p:nvSpPr>
-        <p:spPr>
-          <a:xfrm>
-            <a:off x="548640" y="384048"/>
-            <a:ext cx="8229600" cy="219456"/>
-          </a:xfrm>
-          <a:prstGeom prst="rect">
-            <a:avLst/>
-          </a:prstGeom>
-          <a:noFill/>
-          <a:ln>
-            <a:noFill/>
-          </a:ln>
-        </p:spPr>
-        <p:txBody>
-          <a:bodyPr spcFirstLastPara="1" wrap="square" lIns="0" tIns="0" rIns="0" bIns="0" anchor="ctr" anchorCtr="0">
-            <a:noAutofit/>
-          </a:bodyPr>
-          <a:lstStyle/>
-          <a:p>
-            <a:pPr marL="0" marR="0" lvl="0" indent="0" algn="l" rtl="0">
-              <a:spcBef>
-                <a:spcPts val="0"/>
-              </a:spcBef>
-              <a:spcAft>
-                <a:spcPts val="0"/>
-              </a:spcAft>
-              <a:buClr>
-                <a:srgbClr val="C2410C"/>
-              </a:buClr>
-              <a:buSzPts val="1000"/>
-              <a:buFont typeface="IBM Plex Mono"/>
-              <a:buNone/>
-            </a:pPr>
-            <a:r>
-              <a:rPr lang="zh-CN" sz="1000" b="1" i="0" u="none" strike="noStrike" cap="none" dirty="0">
-                <a:solidFill>
-                  <a:srgbClr val="C2410C"/>
-                </a:solidFill>
-                <a:latin typeface="IBM Plex Mono"/>
-                <a:ea typeface="IBM Plex Mono"/>
-                <a:cs typeface="IBM Plex Mono"/>
-                <a:sym typeface="IBM Plex Mono"/>
-              </a:rPr>
-              <a:t>10</a:t>
-            </a:r>
-            <a:r>
-              <a:rPr lang="zh-CN" sz="1100" b="1" i="0" u="none" strike="noStrike" cap="none" dirty="0">
-                <a:solidFill>
-                  <a:srgbClr val="6E6C66"/>
-                </a:solidFill>
-                <a:latin typeface="Instrument Sans"/>
-                <a:ea typeface="Instrument Sans"/>
-                <a:cs typeface="Instrument Sans"/>
-                <a:sym typeface="Instrument Sans"/>
-              </a:rPr>
-              <a:t>    </a:t>
-            </a:r>
-            <a:r>
-              <a:rPr lang="zh-CN" altLang="en-US" sz="1100" b="1" i="0" u="none" strike="noStrike" cap="none" dirty="0">
-                <a:solidFill>
-                  <a:srgbClr val="6E6C66"/>
-                </a:solidFill>
-                <a:latin typeface="Instrument Sans"/>
-                <a:ea typeface="Instrument Sans"/>
-                <a:cs typeface="Instrument Sans"/>
-                <a:sym typeface="Instrument Sans"/>
-              </a:rPr>
-              <a:t>我们的优势</a:t>
-            </a:r>
-            <a:endParaRPr sz="1300" b="1" i="0" u="none" strike="noStrike" cap="none" dirty="0">
-              <a:solidFill>
-                <a:schemeClr val="dk1"/>
-              </a:solidFill>
-              <a:latin typeface="Instrument Sans"/>
-              <a:ea typeface="Instrument Sans"/>
-              <a:cs typeface="Instrument Sans"/>
-              <a:sym typeface="Instrument Sans"/>
-            </a:endParaRPr>
-          </a:p>
-        </p:txBody>
-      </p:sp>
-      <p:sp>
-        <p:nvSpPr>
-          <p:cNvPr id="335" name="Google Shape;335;p12"/>
-          <p:cNvSpPr txBox="1"/>
-          <p:nvPr/>
-        </p:nvSpPr>
-        <p:spPr>
-          <a:xfrm>
-            <a:off x="548640" y="5943600"/>
-            <a:ext cx="11094415" cy="237744"/>
-          </a:xfrm>
-          <a:prstGeom prst="rect">
-            <a:avLst/>
-          </a:prstGeom>
-          <a:noFill/>
-          <a:ln>
-            <a:noFill/>
-          </a:ln>
-        </p:spPr>
-        <p:txBody>
-          <a:bodyPr spcFirstLastPara="1" wrap="square" lIns="0" tIns="0" rIns="0" bIns="0" anchor="t" anchorCtr="0">
-            <a:noAutofit/>
-          </a:bodyPr>
-          <a:lstStyle/>
-          <a:p>
-            <a:pPr marL="0" marR="0" lvl="0" indent="0" algn="l" rtl="0">
-              <a:spcBef>
-                <a:spcPts val="0"/>
-              </a:spcBef>
-              <a:spcAft>
-                <a:spcPts val="0"/>
-              </a:spcAft>
-              <a:buClr>
-                <a:srgbClr val="6E6C66"/>
-              </a:buClr>
-              <a:buSzPts val="900"/>
-              <a:buFont typeface="Instrument Sans"/>
-              <a:buNone/>
-            </a:pPr>
-            <a:r>
-              <a:rPr lang="zh-CN" sz="400" b="0" i="0" u="none" strike="noStrike" cap="none" dirty="0">
-                <a:solidFill>
-                  <a:srgbClr val="6E6C66"/>
-                </a:solidFill>
-                <a:latin typeface="Instrument Sans"/>
-                <a:ea typeface="Instrument Sans"/>
-                <a:cs typeface="Instrument Sans"/>
-                <a:sym typeface="Instrument Sans"/>
-              </a:rPr>
-              <a:t>红队测试记录可在尽调中提供。算力估算：Mechanize，引自Epoch AI《An FAQ on RL environments》（2026年1月）。</a:t>
-            </a:r>
-            <a:endParaRPr sz="400" b="0" i="0" u="none" strike="noStrike" cap="none" dirty="0">
-              <a:solidFill>
-                <a:schemeClr val="dk1"/>
-              </a:solidFill>
-              <a:latin typeface="Instrument Sans"/>
-              <a:ea typeface="Instrument Sans"/>
-              <a:cs typeface="Instrument Sans"/>
-              <a:sym typeface="Instrument Sans"/>
-            </a:endParaRPr>
-          </a:p>
-        </p:txBody>
-      </p:sp>
       <p:pic>
         <p:nvPicPr>
           <p:cNvPr id="336" name="Google Shape;336;p12" descr="SimReal"/>
@@ -7072,29 +6922,101 @@
       </p:sp>
       <p:sp>
         <p:nvSpPr>
-          <p:cNvPr id="339" name="TextBox 338"/>
-          <p:cNvSpPr txBox="1"/>
-          <p:nvPr/>
-        </p:nvSpPr>
-        <p:spPr>
-          <a:xfrm>
-            <a:off x="548640" y="744676"/>
-            <a:ext cx="11091672" cy="430887"/>
-          </a:xfrm>
-          <a:prstGeom prst="rect">
-            <a:avLst/>
-          </a:prstGeom>
-          <a:noFill/>
-        </p:spPr>
-        <p:txBody>
-          <a:bodyPr wrap="square" lIns="0" tIns="0" rIns="0" bIns="0" anchor="ctr">
-            <a:spAutoFit/>
-          </a:bodyPr>
-          <a:lstStyle/>
-          <a:p>
-            <a:pPr algn="l"/>
-            <a:r>
-              <a:rPr sz="2800" b="0" dirty="0" err="1">
+          <p:cNvPr id="3001" name="SimReal 3001"/>
+          <p:cNvSpPr txBox="1"/>
+          <p:nvPr/>
+        </p:nvSpPr>
+        <p:spPr>
+          <a:xfrm>
+            <a:off x="548640" y="384048"/>
+            <a:ext cx="8229600" cy="219456"/>
+          </a:xfrm>
+          <a:prstGeom prst="rect">
+            <a:avLst/>
+          </a:prstGeom>
+          <a:noFill/>
+          <a:ln>
+            <a:noFill/>
+          </a:ln>
+        </p:spPr>
+        <p:txBody>
+          <a:bodyPr spcFirstLastPara="1" wrap="square" lIns="0" tIns="0" rIns="0" bIns="0" anchor="ctr" anchorCtr="0">
+            <a:noAutofit/>
+          </a:bodyPr>
+          <a:lstStyle/>
+          <a:p>
+            <a:pPr marL="0" marR="0" lvl="0" indent="0" algn="l" rtl="0">
+              <a:spcBef>
+                <a:spcPts val="0"/>
+              </a:spcBef>
+              <a:spcAft>
+                <a:spcPts val="0"/>
+              </a:spcAft>
+              <a:buNone/>
+            </a:pPr>
+            <a:r>
+              <a:rPr lang="zh-CN" sz="1000" b="1" i="0" u="none" strike="noStrike" cap="none">
+                <a:solidFill>
+                  <a:srgbClr val="C2410C"/>
+                </a:solidFill>
+                <a:latin typeface="IBM Plex Mono"/>
+                <a:ea typeface="IBM Plex Mono"/>
+                <a:cs typeface="IBM Plex Mono"/>
+                <a:sym typeface="IBM Plex Mono"/>
+              </a:rPr>
+              <a:t>10</a:t>
+            </a:r>
+            <a:r>
+              <a:rPr lang="zh-CN" sz="1100" b="1" i="0" u="none" strike="noStrike" cap="none">
+                <a:solidFill>
+                  <a:srgbClr val="6E6C66"/>
+                </a:solidFill>
+                <a:latin typeface="Instrument Sans"/>
+                <a:ea typeface="Instrument Sans"/>
+                <a:cs typeface="Instrument Sans"/>
+                <a:sym typeface="Instrument Sans"/>
+              </a:rPr>
+              <a:t>    我们的优势</a:t>
+            </a:r>
+          </a:p>
+        </p:txBody>
+      </p:sp>
+      <p:sp>
+        <p:nvSpPr>
+          <p:cNvPr id="3002" name="SimReal 3002"/>
+          <p:cNvSpPr txBox="1"/>
+          <p:nvPr/>
+        </p:nvSpPr>
+        <p:spPr>
+          <a:xfrm>
+            <a:off x="548640" y="676656"/>
+            <a:ext cx="11091672" cy="566928"/>
+          </a:xfrm>
+          <a:prstGeom prst="rect">
+            <a:avLst/>
+          </a:prstGeom>
+          <a:noFill/>
+          <a:ln>
+            <a:noFill/>
+          </a:ln>
+        </p:spPr>
+        <p:txBody>
+          <a:bodyPr spcFirstLastPara="1" wrap="square" lIns="0" tIns="0" rIns="0" bIns="0" anchor="t" anchorCtr="0">
+            <a:noAutofit/>
+          </a:bodyPr>
+          <a:lstStyle/>
+          <a:p>
+            <a:pPr marL="0" marR="0" lvl="0" indent="0" algn="l" rtl="0">
+              <a:spcBef>
+                <a:spcPts val="0"/>
+              </a:spcBef>
+              <a:spcAft>
+                <a:spcPts val="0"/>
+              </a:spcAft>
+              <a:buNone/>
+            </a:pPr>
+            <a:r>
+              <a:rPr lang="zh-CN" sz="2800" b="0" i="0" u="none" strike="noStrike" cap="none">
                 <a:solidFill>
                   <a:srgbClr val="111110"/>
                 </a:solidFill>
@@ -7103,10 +7025,10 @@
                 <a:cs typeface="Newsreader"/>
                 <a:sym typeface="Newsreader"/>
               </a:rPr>
-              <a:t>AI作弊不了：</a:t>
-            </a:r>
-            <a:r>
-              <a:rPr sz="2800" b="0" dirty="0" err="1">
+              <a:t>AI每一次变化，</a:t>
+            </a:r>
+            <a:r>
+              <a:rPr lang="zh-CN" sz="2800" b="0" i="0" u="none" strike="noStrike" cap="none">
                 <a:solidFill>
                   <a:srgbClr val="C2410C"/>
                 </a:solidFill>
@@ -7115,30 +7037,21 @@
                 <a:cs typeface="Newsreader"/>
                 <a:sym typeface="Newsreader"/>
               </a:rPr>
-              <a:t>每一分算力，都用在真进化上</a:t>
-            </a:r>
-            <a:endParaRPr sz="2800" b="0" dirty="0">
-              <a:solidFill>
-                <a:srgbClr val="C2410C"/>
-              </a:solidFill>
-              <a:latin typeface="Newsreader"/>
-              <a:ea typeface="Newsreader"/>
-              <a:cs typeface="Newsreader"/>
-              <a:sym typeface="Newsreader"/>
-            </a:endParaRPr>
-          </a:p>
-        </p:txBody>
-      </p:sp>
-      <p:sp>
-        <p:nvSpPr>
-          <p:cNvPr id="340" name="Rectangle 339"/>
+              <a:t>我们第一个抓住、第一个交付</a:t>
+            </a:r>
+          </a:p>
+        </p:txBody>
+      </p:sp>
+      <p:sp>
+        <p:nvSpPr>
+          <p:cNvPr id="3003" name="SimReal 3003"/>
           <p:cNvSpPr/>
           <p:nvPr/>
         </p:nvSpPr>
         <p:spPr>
           <a:xfrm>
-            <a:off x="548640" y="1554480"/>
-            <a:ext cx="4160520" cy="4206240"/>
+            <a:off x="548640" y="1481328"/>
+            <a:ext cx="3840480" cy="2596896"/>
           </a:xfrm>
           <a:prstGeom prst="rect">
             <a:avLst/>
@@ -7151,7 +7064,7 @@
           </a:ln>
         </p:spPr>
         <p:txBody>
-          <a:bodyPr rtlCol="0" anchor="ctr"/>
+          <a:bodyPr/>
           <a:lstStyle/>
           <a:p>
             <a:endParaRPr/>
@@ -7160,29 +7073,89 @@
       </p:sp>
       <p:sp>
         <p:nvSpPr>
-          <p:cNvPr id="341" name="TextBox 340"/>
-          <p:cNvSpPr txBox="1"/>
-          <p:nvPr/>
-        </p:nvSpPr>
-        <p:spPr>
-          <a:xfrm>
-            <a:off x="868680" y="1783080"/>
-            <a:ext cx="3566160" cy="1188720"/>
-          </a:xfrm>
-          <a:prstGeom prst="rect">
-            <a:avLst/>
-          </a:prstGeom>
-          <a:noFill/>
-        </p:spPr>
-        <p:txBody>
-          <a:bodyPr wrap="square" lIns="0" tIns="0" rIns="0" bIns="0" anchor="ctr">
-            <a:spAutoFit/>
-          </a:bodyPr>
-          <a:lstStyle/>
-          <a:p>
-            <a:pPr algn="l"/>
-            <a:r>
-              <a:rPr sz="7200" b="0">
+          <p:cNvPr id="3004" name="SimReal 3004"/>
+          <p:cNvSpPr txBox="1"/>
+          <p:nvPr/>
+        </p:nvSpPr>
+        <p:spPr>
+          <a:xfrm>
+            <a:off x="868680" y="1700784"/>
+            <a:ext cx="3200400" cy="201168"/>
+          </a:xfrm>
+          <a:prstGeom prst="rect">
+            <a:avLst/>
+          </a:prstGeom>
+          <a:noFill/>
+          <a:ln>
+            <a:noFill/>
+          </a:ln>
+        </p:spPr>
+        <p:txBody>
+          <a:bodyPr spcFirstLastPara="1" wrap="square" lIns="0" tIns="0" rIns="0" bIns="0" anchor="t" anchorCtr="0">
+            <a:noAutofit/>
+          </a:bodyPr>
+          <a:lstStyle/>
+          <a:p>
+            <a:pPr marL="0" marR="0" lvl="0" indent="0" algn="l" rtl="0">
+              <a:spcBef>
+                <a:spcPts val="0"/>
+              </a:spcBef>
+              <a:spcAft>
+                <a:spcPts val="0"/>
+              </a:spcAft>
+              <a:buNone/>
+            </a:pPr>
+            <a:r>
+              <a:rPr lang="zh-CN" sz="1000" b="0" i="0" u="none" strike="noStrike" cap="none">
+                <a:solidFill>
+                  <a:srgbClr val="E27A3F"/>
+                </a:solidFill>
+                <a:latin typeface="IBM Plex Mono"/>
+                <a:ea typeface="IBM Plex Mono"/>
+                <a:cs typeface="IBM Plex Mono"/>
+                <a:sym typeface="IBM Plex Mono"/>
+              </a:rPr>
+              <a:t>交付速度</a:t>
+            </a:r>
+          </a:p>
+        </p:txBody>
+      </p:sp>
+      <p:sp>
+        <p:nvSpPr>
+          <p:cNvPr id="3005" name="SimReal 3005"/>
+          <p:cNvSpPr txBox="1"/>
+          <p:nvPr/>
+        </p:nvSpPr>
+        <p:spPr>
+          <a:xfrm>
+            <a:off x="868680" y="1901952"/>
+            <a:ext cx="3200400" cy="868680"/>
+          </a:xfrm>
+          <a:prstGeom prst="rect">
+            <a:avLst/>
+          </a:prstGeom>
+          <a:noFill/>
+          <a:ln>
+            <a:noFill/>
+          </a:ln>
+        </p:spPr>
+        <p:txBody>
+          <a:bodyPr spcFirstLastPara="1" wrap="square" lIns="0" tIns="0" rIns="0" bIns="0" anchor="t" anchorCtr="0">
+            <a:noAutofit/>
+          </a:bodyPr>
+          <a:lstStyle/>
+          <a:p>
+            <a:pPr marL="0" marR="0" lvl="0" indent="0" algn="l" rtl="0">
+              <a:spcBef>
+                <a:spcPts val="0"/>
+              </a:spcBef>
+              <a:spcAft>
+                <a:spcPts val="0"/>
+              </a:spcAft>
+              <a:buNone/>
+            </a:pPr>
+            <a:r>
+              <a:rPr lang="zh-CN" sz="6000" b="0" i="0" u="none" strike="noStrike" cap="none">
                 <a:solidFill>
                   <a:srgbClr val="E27A3F"/>
                 </a:solidFill>
@@ -7191,36 +7164,47 @@
                 <a:cs typeface="Newsreader"/>
                 <a:sym typeface="Newsreader"/>
               </a:rPr>
-              <a:t>0 / 400</a:t>
-            </a:r>
-          </a:p>
-        </p:txBody>
-      </p:sp>
-      <p:sp>
-        <p:nvSpPr>
-          <p:cNvPr id="342" name="TextBox 341"/>
-          <p:cNvSpPr txBox="1"/>
-          <p:nvPr/>
-        </p:nvSpPr>
-        <p:spPr>
-          <a:xfrm>
-            <a:off x="868680" y="2971800"/>
-            <a:ext cx="3566160" cy="365760"/>
-          </a:xfrm>
-          <a:prstGeom prst="rect">
-            <a:avLst/>
-          </a:prstGeom>
-          <a:noFill/>
-        </p:spPr>
-        <p:txBody>
-          <a:bodyPr wrap="square" lIns="0" tIns="0" rIns="0" bIns="0" anchor="ctr">
-            <a:spAutoFit/>
-          </a:bodyPr>
-          <a:lstStyle/>
-          <a:p>
-            <a:pPr algn="l"/>
-            <a:r>
-              <a:rPr sz="1600" b="0">
+              <a:t>14天</a:t>
+            </a:r>
+          </a:p>
+        </p:txBody>
+      </p:sp>
+      <p:sp>
+        <p:nvSpPr>
+          <p:cNvPr id="3006" name="SimReal 3006"/>
+          <p:cNvSpPr txBox="1"/>
+          <p:nvPr/>
+        </p:nvSpPr>
+        <p:spPr>
+          <a:xfrm>
+            <a:off x="868680" y="2816352"/>
+            <a:ext cx="3200400" cy="274320"/>
+          </a:xfrm>
+          <a:prstGeom prst="rect">
+            <a:avLst/>
+          </a:prstGeom>
+          <a:noFill/>
+          <a:ln>
+            <a:noFill/>
+          </a:ln>
+        </p:spPr>
+        <p:txBody>
+          <a:bodyPr spcFirstLastPara="1" wrap="square" lIns="0" tIns="0" rIns="0" bIns="0" anchor="t" anchorCtr="0">
+            <a:noAutofit/>
+          </a:bodyPr>
+          <a:lstStyle/>
+          <a:p>
+            <a:pPr marL="0" marR="0" lvl="0" indent="0" algn="l" rtl="0">
+              <a:spcBef>
+                <a:spcPts val="0"/>
+              </a:spcBef>
+              <a:spcAft>
+                <a:spcPts val="0"/>
+              </a:spcAft>
+              <a:buNone/>
+            </a:pPr>
+            <a:r>
+              <a:rPr lang="zh-CN" sz="1400" b="0" i="0" u="none" strike="noStrike" cap="none">
                 <a:solidFill>
                   <a:srgbClr val="FAF9F6"/>
                 </a:solidFill>
@@ -7229,21 +7213,21 @@
                 <a:cs typeface="Instrument Sans"/>
                 <a:sym typeface="Instrument Sans"/>
               </a:rPr>
-              <a:t>次作弊攻击成功</a:t>
-            </a:r>
-          </a:p>
-        </p:txBody>
-      </p:sp>
-      <p:sp>
-        <p:nvSpPr>
-          <p:cNvPr id="343" name="Rectangle 342"/>
+              <a:t>7款产品上线，零外部融资</a:t>
+            </a:r>
+          </a:p>
+        </p:txBody>
+      </p:sp>
+      <p:sp>
+        <p:nvSpPr>
+          <p:cNvPr id="3007" name="SimReal 3007"/>
           <p:cNvSpPr/>
           <p:nvPr/>
         </p:nvSpPr>
         <p:spPr>
           <a:xfrm>
-            <a:off x="868680" y="3607117"/>
-            <a:ext cx="3520440" cy="9525"/>
+            <a:off x="868680" y="3218688"/>
+            <a:ext cx="3200400" cy="9144"/>
           </a:xfrm>
           <a:prstGeom prst="rect">
             <a:avLst/>
@@ -7256,7 +7240,7 @@
           </a:ln>
         </p:spPr>
         <p:txBody>
-          <a:bodyPr rtlCol="0" anchor="ctr"/>
+          <a:bodyPr/>
           <a:lstStyle/>
           <a:p>
             <a:endParaRPr/>
@@ -7265,29 +7249,43 @@
       </p:sp>
       <p:sp>
         <p:nvSpPr>
-          <p:cNvPr id="344" name="TextBox 343"/>
-          <p:cNvSpPr txBox="1"/>
-          <p:nvPr/>
-        </p:nvSpPr>
-        <p:spPr>
-          <a:xfrm>
-            <a:off x="868680" y="3749039"/>
-            <a:ext cx="3566160" cy="274320"/>
-          </a:xfrm>
-          <a:prstGeom prst="rect">
-            <a:avLst/>
-          </a:prstGeom>
-          <a:noFill/>
-        </p:spPr>
-        <p:txBody>
-          <a:bodyPr wrap="square" lIns="0" tIns="0" rIns="0" bIns="0" anchor="ctr">
-            <a:spAutoFit/>
-          </a:bodyPr>
-          <a:lstStyle/>
-          <a:p>
-            <a:pPr algn="l"/>
-            <a:r>
-              <a:rPr sz="1000" b="0">
+          <p:cNvPr id="3008" name="SimReal 3008"/>
+          <p:cNvSpPr txBox="1"/>
+          <p:nvPr/>
+        </p:nvSpPr>
+        <p:spPr>
+          <a:xfrm>
+            <a:off x="868680" y="3346704"/>
+            <a:ext cx="3200400" cy="640080"/>
+          </a:xfrm>
+          <a:prstGeom prst="rect">
+            <a:avLst/>
+          </a:prstGeom>
+          <a:noFill/>
+          <a:ln>
+            <a:noFill/>
+          </a:ln>
+        </p:spPr>
+        <p:txBody>
+          <a:bodyPr spcFirstLastPara="1" wrap="square" lIns="0" tIns="0" rIns="0" bIns="0" anchor="t" anchorCtr="0">
+            <a:noAutofit/>
+          </a:bodyPr>
+          <a:lstStyle/>
+          <a:p>
+            <a:pPr marL="0" marR="0" lvl="0" indent="0" algn="l" rtl="0">
+              <a:lnSpc>
+                <a:spcPct val="114999"/>
+              </a:lnSpc>
+              <a:spcBef>
+                <a:spcPts val="0"/>
+              </a:spcBef>
+              <a:spcAft>
+                <a:spcPts val="0"/>
+              </a:spcAft>
+              <a:buNone/>
+            </a:pPr>
+            <a:r>
+              <a:rPr lang="zh-CN" sz="950" b="0" i="0" u="none" strike="noStrike" cap="none">
                 <a:solidFill>
                   <a:srgbClr val="C4C0B7"/>
                 </a:solidFill>
@@ -7296,101 +7294,815 @@
                 <a:cs typeface="IBM Plex Mono"/>
                 <a:sym typeface="IBM Plex Mono"/>
               </a:rPr>
-              <a:t>Puzzle Benchmark</a:t>
-            </a:r>
-          </a:p>
-        </p:txBody>
-      </p:sp>
-      <p:sp>
-        <p:nvSpPr>
-          <p:cNvPr id="345" name="TextBox 344"/>
-          <p:cNvSpPr txBox="1"/>
-          <p:nvPr/>
-        </p:nvSpPr>
-        <p:spPr>
-          <a:xfrm>
-            <a:off x="868680" y="4069080"/>
-            <a:ext cx="3520440" cy="1097280"/>
-          </a:xfrm>
-          <a:prstGeom prst="rect">
-            <a:avLst/>
-          </a:prstGeom>
-          <a:noFill/>
-        </p:spPr>
-        <p:txBody>
-          <a:bodyPr wrap="square" lIns="0" tIns="0" rIns="0" bIns="0" anchor="t">
-            <a:spAutoFit/>
-          </a:bodyPr>
-          <a:lstStyle/>
-          <a:p>
-            <a:pPr algn="l">
+              <a:t>Xitadel · MLBench · Future Prediction</a:t>
+            </a:r>
+          </a:p>
+          <a:p>
+            <a:pPr marL="0" marR="0" lvl="0" indent="0" algn="l" rtl="0">
               <a:lnSpc>
-                <a:spcPct val="120000"/>
+                <a:spcPct val="114999"/>
               </a:lnSpc>
-            </a:pPr>
-            <a:r>
-              <a:rPr sz="1300" b="0">
-                <a:solidFill>
-                  <a:srgbClr val="FAF9F6"/>
+              <a:spcBef>
+                <a:spcPts val="0"/>
+              </a:spcBef>
+              <a:spcAft>
+                <a:spcPts val="0"/>
+              </a:spcAft>
+              <a:buNone/>
+            </a:pPr>
+            <a:r>
+              <a:rPr lang="zh-CN" sz="950" b="0" i="0" u="none" strike="noStrike" cap="none">
+                <a:solidFill>
+                  <a:srgbClr val="C4C0B7"/>
+                </a:solidFill>
+                <a:latin typeface="IBM Plex Mono"/>
+                <a:ea typeface="IBM Plex Mono"/>
+                <a:cs typeface="IBM Plex Mono"/>
+                <a:sym typeface="IBM Plex Mono"/>
+              </a:rPr>
+              <a:t>Month-End Close · SWE-Forward</a:t>
+            </a:r>
+          </a:p>
+          <a:p>
+            <a:pPr marL="0" marR="0" lvl="0" indent="0" algn="l" rtl="0">
+              <a:lnSpc>
+                <a:spcPct val="114999"/>
+              </a:lnSpc>
+              <a:spcBef>
+                <a:spcPts val="0"/>
+              </a:spcBef>
+              <a:spcAft>
+                <a:spcPts val="0"/>
+              </a:spcAft>
+              <a:buNone/>
+            </a:pPr>
+            <a:r>
+              <a:rPr lang="zh-CN" sz="950" b="0" i="0" u="none" strike="noStrike" cap="none">
+                <a:solidFill>
+                  <a:srgbClr val="C4C0B7"/>
+                </a:solidFill>
+                <a:latin typeface="IBM Plex Mono"/>
+                <a:ea typeface="IBM Plex Mono"/>
+                <a:cs typeface="IBM Plex Mono"/>
+                <a:sym typeface="IBM Plex Mono"/>
+              </a:rPr>
+              <a:t>MathmoBench · Puzzle Benchmark</a:t>
+            </a:r>
+          </a:p>
+        </p:txBody>
+      </p:sp>
+      <p:sp>
+        <p:nvSpPr>
+          <p:cNvPr id="3009" name="SimReal 3009"/>
+          <p:cNvSpPr txBox="1"/>
+          <p:nvPr/>
+        </p:nvSpPr>
+        <p:spPr>
+          <a:xfrm>
+            <a:off x="4754880" y="1481328"/>
+            <a:ext cx="4572000" cy="201168"/>
+          </a:xfrm>
+          <a:prstGeom prst="rect">
+            <a:avLst/>
+          </a:prstGeom>
+          <a:noFill/>
+          <a:ln>
+            <a:noFill/>
+          </a:ln>
+        </p:spPr>
+        <p:txBody>
+          <a:bodyPr spcFirstLastPara="1" wrap="square" lIns="0" tIns="0" rIns="0" bIns="0" anchor="t" anchorCtr="0">
+            <a:noAutofit/>
+          </a:bodyPr>
+          <a:lstStyle/>
+          <a:p>
+            <a:pPr marL="0" marR="0" lvl="0" indent="0" algn="l" rtl="0">
+              <a:spcBef>
+                <a:spcPts val="0"/>
+              </a:spcBef>
+              <a:spcAft>
+                <a:spcPts val="0"/>
+              </a:spcAft>
+              <a:buNone/>
+            </a:pPr>
+            <a:r>
+              <a:rPr lang="zh-CN" sz="1000" b="0" i="0" u="none" strike="noStrike" cap="none">
+                <a:solidFill>
+                  <a:srgbClr val="6E6C66"/>
+                </a:solidFill>
+                <a:latin typeface="IBM Plex Mono"/>
+                <a:ea typeface="IBM Plex Mono"/>
+                <a:cs typeface="IBM Plex Mono"/>
+                <a:sym typeface="IBM Plex Mono"/>
+              </a:rPr>
+              <a:t>证明</a:t>
+            </a:r>
+          </a:p>
+        </p:txBody>
+      </p:sp>
+      <p:sp>
+        <p:nvSpPr>
+          <p:cNvPr id="3010" name="SimReal 3010"/>
+          <p:cNvSpPr/>
+          <p:nvPr/>
+        </p:nvSpPr>
+        <p:spPr>
+          <a:xfrm>
+            <a:off x="4754880" y="1737360"/>
+            <a:ext cx="6885432" cy="9144"/>
+          </a:xfrm>
+          <a:prstGeom prst="rect">
+            <a:avLst/>
+          </a:prstGeom>
+          <a:solidFill>
+            <a:srgbClr val="E2E0DA"/>
+          </a:solidFill>
+          <a:ln>
+            <a:noFill/>
+          </a:ln>
+        </p:spPr>
+        <p:txBody>
+          <a:bodyPr/>
+          <a:lstStyle/>
+          <a:p>
+            <a:endParaRPr/>
+          </a:p>
+        </p:txBody>
+      </p:sp>
+      <p:sp>
+        <p:nvSpPr>
+          <p:cNvPr id="3011" name="SimReal 3011"/>
+          <p:cNvSpPr txBox="1"/>
+          <p:nvPr/>
+        </p:nvSpPr>
+        <p:spPr>
+          <a:xfrm>
+            <a:off x="4754880" y="1737360"/>
+            <a:ext cx="457200" cy="585216"/>
+          </a:xfrm>
+          <a:prstGeom prst="rect">
+            <a:avLst/>
+          </a:prstGeom>
+          <a:noFill/>
+          <a:ln>
+            <a:noFill/>
+          </a:ln>
+        </p:spPr>
+        <p:txBody>
+          <a:bodyPr spcFirstLastPara="1" wrap="square" lIns="0" tIns="0" rIns="0" bIns="0" anchor="ctr" anchorCtr="0">
+            <a:noAutofit/>
+          </a:bodyPr>
+          <a:lstStyle/>
+          <a:p>
+            <a:pPr marL="0" marR="0" lvl="0" indent="0" algn="l" rtl="0">
+              <a:spcBef>
+                <a:spcPts val="0"/>
+              </a:spcBef>
+              <a:spcAft>
+                <a:spcPts val="0"/>
+              </a:spcAft>
+              <a:buNone/>
+            </a:pPr>
+            <a:r>
+              <a:rPr lang="zh-CN" sz="1000" b="0" i="0" u="none" strike="noStrike" cap="none">
+                <a:solidFill>
+                  <a:srgbClr val="C2410C"/>
+                </a:solidFill>
+                <a:latin typeface="IBM Plex Mono"/>
+                <a:ea typeface="IBM Plex Mono"/>
+                <a:cs typeface="IBM Plex Mono"/>
+                <a:sym typeface="IBM Plex Mono"/>
+              </a:rPr>
+              <a:t>01</a:t>
+            </a:r>
+          </a:p>
+        </p:txBody>
+      </p:sp>
+      <p:sp>
+        <p:nvSpPr>
+          <p:cNvPr id="3012" name="SimReal 3012"/>
+          <p:cNvSpPr txBox="1"/>
+          <p:nvPr/>
+        </p:nvSpPr>
+        <p:spPr>
+          <a:xfrm>
+            <a:off x="5257800" y="1737360"/>
+            <a:ext cx="1600200" cy="585216"/>
+          </a:xfrm>
+          <a:prstGeom prst="rect">
+            <a:avLst/>
+          </a:prstGeom>
+          <a:noFill/>
+          <a:ln>
+            <a:noFill/>
+          </a:ln>
+        </p:spPr>
+        <p:txBody>
+          <a:bodyPr spcFirstLastPara="1" wrap="square" lIns="0" tIns="0" rIns="0" bIns="0" anchor="ctr" anchorCtr="0">
+            <a:noAutofit/>
+          </a:bodyPr>
+          <a:lstStyle/>
+          <a:p>
+            <a:pPr marL="0" marR="0" lvl="0" indent="0" algn="l" rtl="0">
+              <a:spcBef>
+                <a:spcPts val="0"/>
+              </a:spcBef>
+              <a:spcAft>
+                <a:spcPts val="0"/>
+              </a:spcAft>
+              <a:buNone/>
+            </a:pPr>
+            <a:r>
+              <a:rPr lang="zh-CN" sz="1700" b="0" i="0" u="none" strike="noStrike" cap="none">
+                <a:solidFill>
+                  <a:srgbClr val="111110"/>
+                </a:solidFill>
+                <a:latin typeface="Newsreader"/>
+                <a:ea typeface="Newsreader"/>
+                <a:cs typeface="Newsreader"/>
+                <a:sym typeface="Newsreader"/>
+              </a:rPr>
+              <a:t>抓趋势</a:t>
+            </a:r>
+          </a:p>
+        </p:txBody>
+      </p:sp>
+      <p:sp>
+        <p:nvSpPr>
+          <p:cNvPr id="3013" name="SimReal 3013"/>
+          <p:cNvSpPr txBox="1"/>
+          <p:nvPr/>
+        </p:nvSpPr>
+        <p:spPr>
+          <a:xfrm>
+            <a:off x="6903720" y="1737360"/>
+            <a:ext cx="4736592" cy="585216"/>
+          </a:xfrm>
+          <a:prstGeom prst="rect">
+            <a:avLst/>
+          </a:prstGeom>
+          <a:noFill/>
+          <a:ln>
+            <a:noFill/>
+          </a:ln>
+        </p:spPr>
+        <p:txBody>
+          <a:bodyPr spcFirstLastPara="1" wrap="square" lIns="0" tIns="0" rIns="0" bIns="0" anchor="ctr" anchorCtr="0">
+            <a:noAutofit/>
+          </a:bodyPr>
+          <a:lstStyle/>
+          <a:p>
+            <a:pPr marL="0" marR="0" lvl="0" indent="0" algn="l" rtl="0">
+              <a:lnSpc>
+                <a:spcPct val="110000"/>
+              </a:lnSpc>
+              <a:spcBef>
+                <a:spcPts val="0"/>
+              </a:spcBef>
+              <a:spcAft>
+                <a:spcPts val="0"/>
+              </a:spcAft>
+              <a:buNone/>
+            </a:pPr>
+            <a:r>
+              <a:rPr lang="zh-CN" sz="1100" b="0" i="0" u="none" strike="noStrike" cap="none">
+                <a:solidFill>
+                  <a:srgbClr val="6E6C66"/>
                 </a:solidFill>
                 <a:latin typeface="Instrument Sans"/>
                 <a:ea typeface="Instrument Sans"/>
                 <a:cs typeface="Instrument Sans"/>
                 <a:sym typeface="Instrument Sans"/>
               </a:rPr>
-              <a:t>749道题，上线前逐题攻击</a:t>
-            </a:r>
-            <a:br>
-              <a:rPr sz="1300" b="0">
-                <a:solidFill>
-                  <a:srgbClr val="FAF9F6"/>
+              <a:t>RL环境刚成为实验室刚需，我们两周跑通全球首个做市交易的自我进化</a:t>
+            </a:r>
+          </a:p>
+        </p:txBody>
+      </p:sp>
+      <p:sp>
+        <p:nvSpPr>
+          <p:cNvPr id="3014" name="SimReal 3014"/>
+          <p:cNvSpPr/>
+          <p:nvPr/>
+        </p:nvSpPr>
+        <p:spPr>
+          <a:xfrm>
+            <a:off x="4754880" y="2322576"/>
+            <a:ext cx="6885432" cy="9144"/>
+          </a:xfrm>
+          <a:prstGeom prst="rect">
+            <a:avLst/>
+          </a:prstGeom>
+          <a:solidFill>
+            <a:srgbClr val="E2E0DA"/>
+          </a:solidFill>
+          <a:ln>
+            <a:noFill/>
+          </a:ln>
+        </p:spPr>
+        <p:txBody>
+          <a:bodyPr/>
+          <a:lstStyle/>
+          <a:p>
+            <a:endParaRPr/>
+          </a:p>
+        </p:txBody>
+      </p:sp>
+      <p:sp>
+        <p:nvSpPr>
+          <p:cNvPr id="3015" name="SimReal 3015"/>
+          <p:cNvSpPr txBox="1"/>
+          <p:nvPr/>
+        </p:nvSpPr>
+        <p:spPr>
+          <a:xfrm>
+            <a:off x="4754880" y="2322576"/>
+            <a:ext cx="457200" cy="585216"/>
+          </a:xfrm>
+          <a:prstGeom prst="rect">
+            <a:avLst/>
+          </a:prstGeom>
+          <a:noFill/>
+          <a:ln>
+            <a:noFill/>
+          </a:ln>
+        </p:spPr>
+        <p:txBody>
+          <a:bodyPr spcFirstLastPara="1" wrap="square" lIns="0" tIns="0" rIns="0" bIns="0" anchor="ctr" anchorCtr="0">
+            <a:noAutofit/>
+          </a:bodyPr>
+          <a:lstStyle/>
+          <a:p>
+            <a:pPr marL="0" marR="0" lvl="0" indent="0" algn="l" rtl="0">
+              <a:spcBef>
+                <a:spcPts val="0"/>
+              </a:spcBef>
+              <a:spcAft>
+                <a:spcPts val="0"/>
+              </a:spcAft>
+              <a:buNone/>
+            </a:pPr>
+            <a:r>
+              <a:rPr lang="zh-CN" sz="1000" b="0" i="0" u="none" strike="noStrike" cap="none">
+                <a:solidFill>
+                  <a:srgbClr val="C2410C"/>
+                </a:solidFill>
+                <a:latin typeface="IBM Plex Mono"/>
+                <a:ea typeface="IBM Plex Mono"/>
+                <a:cs typeface="IBM Plex Mono"/>
+                <a:sym typeface="IBM Plex Mono"/>
+              </a:rPr>
+              <a:t>02</a:t>
+            </a:r>
+          </a:p>
+        </p:txBody>
+      </p:sp>
+      <p:sp>
+        <p:nvSpPr>
+          <p:cNvPr id="3016" name="SimReal 3016"/>
+          <p:cNvSpPr txBox="1"/>
+          <p:nvPr/>
+        </p:nvSpPr>
+        <p:spPr>
+          <a:xfrm>
+            <a:off x="5257800" y="2322576"/>
+            <a:ext cx="1600200" cy="585216"/>
+          </a:xfrm>
+          <a:prstGeom prst="rect">
+            <a:avLst/>
+          </a:prstGeom>
+          <a:noFill/>
+          <a:ln>
+            <a:noFill/>
+          </a:ln>
+        </p:spPr>
+        <p:txBody>
+          <a:bodyPr spcFirstLastPara="1" wrap="square" lIns="0" tIns="0" rIns="0" bIns="0" anchor="ctr" anchorCtr="0">
+            <a:noAutofit/>
+          </a:bodyPr>
+          <a:lstStyle/>
+          <a:p>
+            <a:pPr marL="0" marR="0" lvl="0" indent="0" algn="l" rtl="0">
+              <a:spcBef>
+                <a:spcPts val="0"/>
+              </a:spcBef>
+              <a:spcAft>
+                <a:spcPts val="0"/>
+              </a:spcAft>
+              <a:buNone/>
+            </a:pPr>
+            <a:r>
+              <a:rPr lang="zh-CN" sz="1700" b="0" i="0" u="none" strike="noStrike" cap="none">
+                <a:solidFill>
+                  <a:srgbClr val="111110"/>
+                </a:solidFill>
+                <a:latin typeface="Newsreader"/>
+                <a:ea typeface="Newsreader"/>
+                <a:cs typeface="Newsreader"/>
+                <a:sym typeface="Newsreader"/>
+              </a:rPr>
+              <a:t>交付质量</a:t>
+            </a:r>
+          </a:p>
+        </p:txBody>
+      </p:sp>
+      <p:sp>
+        <p:nvSpPr>
+          <p:cNvPr id="3017" name="SimReal 3017"/>
+          <p:cNvSpPr txBox="1"/>
+          <p:nvPr/>
+        </p:nvSpPr>
+        <p:spPr>
+          <a:xfrm>
+            <a:off x="6903720" y="2322576"/>
+            <a:ext cx="4736592" cy="585216"/>
+          </a:xfrm>
+          <a:prstGeom prst="rect">
+            <a:avLst/>
+          </a:prstGeom>
+          <a:noFill/>
+          <a:ln>
+            <a:noFill/>
+          </a:ln>
+        </p:spPr>
+        <p:txBody>
+          <a:bodyPr spcFirstLastPara="1" wrap="square" lIns="0" tIns="0" rIns="0" bIns="0" anchor="ctr" anchorCtr="0">
+            <a:noAutofit/>
+          </a:bodyPr>
+          <a:lstStyle/>
+          <a:p>
+            <a:pPr marL="0" marR="0" lvl="0" indent="0" algn="l" rtl="0">
+              <a:lnSpc>
+                <a:spcPct val="110000"/>
+              </a:lnSpc>
+              <a:spcBef>
+                <a:spcPts val="0"/>
+              </a:spcBef>
+              <a:spcAft>
+                <a:spcPts val="0"/>
+              </a:spcAft>
+              <a:buNone/>
+            </a:pPr>
+            <a:r>
+              <a:rPr lang="zh-CN" sz="1100" b="0" i="0" u="none" strike="noStrike" cap="none">
+                <a:solidFill>
+                  <a:srgbClr val="6E6C66"/>
                 </a:solidFill>
                 <a:latin typeface="Instrument Sans"/>
                 <a:ea typeface="Instrument Sans"/>
                 <a:cs typeface="Instrument Sans"/>
                 <a:sym typeface="Instrument Sans"/>
               </a:rPr>
-            </a:br>
-            <a:r>
-              <a:rPr sz="1300" b="0">
-                <a:solidFill>
-                  <a:srgbClr val="FAF9F6"/>
+              <a:t>749道题、400次作弊攻击0次成功；财务环境评分漏洞6→0</a:t>
+            </a:r>
+          </a:p>
+        </p:txBody>
+      </p:sp>
+      <p:sp>
+        <p:nvSpPr>
+          <p:cNvPr id="3018" name="SimReal 3018"/>
+          <p:cNvSpPr/>
+          <p:nvPr/>
+        </p:nvSpPr>
+        <p:spPr>
+          <a:xfrm>
+            <a:off x="4754880" y="2907792"/>
+            <a:ext cx="6885432" cy="9144"/>
+          </a:xfrm>
+          <a:prstGeom prst="rect">
+            <a:avLst/>
+          </a:prstGeom>
+          <a:solidFill>
+            <a:srgbClr val="E2E0DA"/>
+          </a:solidFill>
+          <a:ln>
+            <a:noFill/>
+          </a:ln>
+        </p:spPr>
+        <p:txBody>
+          <a:bodyPr/>
+          <a:lstStyle/>
+          <a:p>
+            <a:endParaRPr/>
+          </a:p>
+        </p:txBody>
+      </p:sp>
+      <p:sp>
+        <p:nvSpPr>
+          <p:cNvPr id="3019" name="SimReal 3019"/>
+          <p:cNvSpPr txBox="1"/>
+          <p:nvPr/>
+        </p:nvSpPr>
+        <p:spPr>
+          <a:xfrm>
+            <a:off x="4754880" y="2907792"/>
+            <a:ext cx="457200" cy="585216"/>
+          </a:xfrm>
+          <a:prstGeom prst="rect">
+            <a:avLst/>
+          </a:prstGeom>
+          <a:noFill/>
+          <a:ln>
+            <a:noFill/>
+          </a:ln>
+        </p:spPr>
+        <p:txBody>
+          <a:bodyPr spcFirstLastPara="1" wrap="square" lIns="0" tIns="0" rIns="0" bIns="0" anchor="ctr" anchorCtr="0">
+            <a:noAutofit/>
+          </a:bodyPr>
+          <a:lstStyle/>
+          <a:p>
+            <a:pPr marL="0" marR="0" lvl="0" indent="0" algn="l" rtl="0">
+              <a:spcBef>
+                <a:spcPts val="0"/>
+              </a:spcBef>
+              <a:spcAft>
+                <a:spcPts val="0"/>
+              </a:spcAft>
+              <a:buNone/>
+            </a:pPr>
+            <a:r>
+              <a:rPr lang="zh-CN" sz="1000" b="0" i="0" u="none" strike="noStrike" cap="none">
+                <a:solidFill>
+                  <a:srgbClr val="C2410C"/>
+                </a:solidFill>
+                <a:latin typeface="IBM Plex Mono"/>
+                <a:ea typeface="IBM Plex Mono"/>
+                <a:cs typeface="IBM Plex Mono"/>
+                <a:sym typeface="IBM Plex Mono"/>
+              </a:rPr>
+              <a:t>03</a:t>
+            </a:r>
+          </a:p>
+        </p:txBody>
+      </p:sp>
+      <p:sp>
+        <p:nvSpPr>
+          <p:cNvPr id="3020" name="SimReal 3020"/>
+          <p:cNvSpPr txBox="1"/>
+          <p:nvPr/>
+        </p:nvSpPr>
+        <p:spPr>
+          <a:xfrm>
+            <a:off x="5257800" y="2907792"/>
+            <a:ext cx="1600200" cy="585216"/>
+          </a:xfrm>
+          <a:prstGeom prst="rect">
+            <a:avLst/>
+          </a:prstGeom>
+          <a:noFill/>
+          <a:ln>
+            <a:noFill/>
+          </a:ln>
+        </p:spPr>
+        <p:txBody>
+          <a:bodyPr spcFirstLastPara="1" wrap="square" lIns="0" tIns="0" rIns="0" bIns="0" anchor="ctr" anchorCtr="0">
+            <a:noAutofit/>
+          </a:bodyPr>
+          <a:lstStyle/>
+          <a:p>
+            <a:pPr marL="0" marR="0" lvl="0" indent="0" algn="l" rtl="0">
+              <a:spcBef>
+                <a:spcPts val="0"/>
+              </a:spcBef>
+              <a:spcAft>
+                <a:spcPts val="0"/>
+              </a:spcAft>
+              <a:buNone/>
+            </a:pPr>
+            <a:r>
+              <a:rPr lang="zh-CN" sz="1700" b="0" i="0" u="none" strike="noStrike" cap="none">
+                <a:solidFill>
+                  <a:srgbClr val="111110"/>
+                </a:solidFill>
+                <a:latin typeface="Newsreader"/>
+                <a:ea typeface="Newsreader"/>
+                <a:cs typeface="Newsreader"/>
+                <a:sym typeface="Newsreader"/>
+              </a:rPr>
+              <a:t>市场验证</a:t>
+            </a:r>
+          </a:p>
+        </p:txBody>
+      </p:sp>
+      <p:sp>
+        <p:nvSpPr>
+          <p:cNvPr id="3021" name="SimReal 3021"/>
+          <p:cNvSpPr txBox="1"/>
+          <p:nvPr/>
+        </p:nvSpPr>
+        <p:spPr>
+          <a:xfrm>
+            <a:off x="6903720" y="2907792"/>
+            <a:ext cx="4736592" cy="585216"/>
+          </a:xfrm>
+          <a:prstGeom prst="rect">
+            <a:avLst/>
+          </a:prstGeom>
+          <a:noFill/>
+          <a:ln>
+            <a:noFill/>
+          </a:ln>
+        </p:spPr>
+        <p:txBody>
+          <a:bodyPr spcFirstLastPara="1" wrap="square" lIns="0" tIns="0" rIns="0" bIns="0" anchor="ctr" anchorCtr="0">
+            <a:noAutofit/>
+          </a:bodyPr>
+          <a:lstStyle/>
+          <a:p>
+            <a:pPr marL="0" marR="0" lvl="0" indent="0" algn="l" rtl="0">
+              <a:lnSpc>
+                <a:spcPct val="110000"/>
+              </a:lnSpc>
+              <a:spcBef>
+                <a:spcPts val="0"/>
+              </a:spcBef>
+              <a:spcAft>
+                <a:spcPts val="0"/>
+              </a:spcAft>
+              <a:buNone/>
+            </a:pPr>
+            <a:r>
+              <a:rPr lang="zh-CN" sz="1100" b="0" i="0" u="none" strike="noStrike" cap="none">
+                <a:solidFill>
+                  <a:srgbClr val="6E6C66"/>
                 </a:solidFill>
                 <a:latin typeface="Instrument Sans"/>
                 <a:ea typeface="Instrument Sans"/>
                 <a:cs typeface="Instrument Sans"/>
                 <a:sym typeface="Instrument Sans"/>
               </a:rPr>
-              <a:t>空子先被我们找到、补上</a:t>
-            </a:r>
-          </a:p>
-        </p:txBody>
-      </p:sp>
-      <p:sp>
-        <p:nvSpPr>
-          <p:cNvPr id="346" name="TextBox 345"/>
-          <p:cNvSpPr txBox="1"/>
-          <p:nvPr/>
-        </p:nvSpPr>
-        <p:spPr>
-          <a:xfrm>
-            <a:off x="5120640" y="1554480"/>
-            <a:ext cx="6519672" cy="274320"/>
-          </a:xfrm>
-          <a:prstGeom prst="rect">
-            <a:avLst/>
-          </a:prstGeom>
-          <a:noFill/>
-        </p:spPr>
-        <p:txBody>
-          <a:bodyPr wrap="square" lIns="0" tIns="0" rIns="0" bIns="0" anchor="ctr">
-            <a:spAutoFit/>
-          </a:bodyPr>
-          <a:lstStyle/>
-          <a:p>
-            <a:pPr algn="l"/>
-            <a:r>
-              <a:rPr sz="1100" b="0">
+              <a:t>首周GitHub 500+星标、7,000+专家候补、2家前沿实验室在谈</a:t>
+            </a:r>
+          </a:p>
+        </p:txBody>
+      </p:sp>
+      <p:sp>
+        <p:nvSpPr>
+          <p:cNvPr id="3022" name="SimReal 3022"/>
+          <p:cNvSpPr/>
+          <p:nvPr/>
+        </p:nvSpPr>
+        <p:spPr>
+          <a:xfrm>
+            <a:off x="4754880" y="3493008"/>
+            <a:ext cx="6885432" cy="9144"/>
+          </a:xfrm>
+          <a:prstGeom prst="rect">
+            <a:avLst/>
+          </a:prstGeom>
+          <a:solidFill>
+            <a:srgbClr val="E2E0DA"/>
+          </a:solidFill>
+          <a:ln>
+            <a:noFill/>
+          </a:ln>
+        </p:spPr>
+        <p:txBody>
+          <a:bodyPr/>
+          <a:lstStyle/>
+          <a:p>
+            <a:endParaRPr/>
+          </a:p>
+        </p:txBody>
+      </p:sp>
+      <p:sp>
+        <p:nvSpPr>
+          <p:cNvPr id="3023" name="SimReal 3023"/>
+          <p:cNvSpPr txBox="1"/>
+          <p:nvPr/>
+        </p:nvSpPr>
+        <p:spPr>
+          <a:xfrm>
+            <a:off x="4754880" y="3493008"/>
+            <a:ext cx="457200" cy="585216"/>
+          </a:xfrm>
+          <a:prstGeom prst="rect">
+            <a:avLst/>
+          </a:prstGeom>
+          <a:noFill/>
+          <a:ln>
+            <a:noFill/>
+          </a:ln>
+        </p:spPr>
+        <p:txBody>
+          <a:bodyPr spcFirstLastPara="1" wrap="square" lIns="0" tIns="0" rIns="0" bIns="0" anchor="ctr" anchorCtr="0">
+            <a:noAutofit/>
+          </a:bodyPr>
+          <a:lstStyle/>
+          <a:p>
+            <a:pPr marL="0" marR="0" lvl="0" indent="0" algn="l" rtl="0">
+              <a:spcBef>
+                <a:spcPts val="0"/>
+              </a:spcBef>
+              <a:spcAft>
+                <a:spcPts val="0"/>
+              </a:spcAft>
+              <a:buNone/>
+            </a:pPr>
+            <a:r>
+              <a:rPr lang="zh-CN" sz="1000" b="0" i="0" u="none" strike="noStrike" cap="none">
+                <a:solidFill>
+                  <a:srgbClr val="C2410C"/>
+                </a:solidFill>
+                <a:latin typeface="IBM Plex Mono"/>
+                <a:ea typeface="IBM Plex Mono"/>
+                <a:cs typeface="IBM Plex Mono"/>
+                <a:sym typeface="IBM Plex Mono"/>
+              </a:rPr>
+              <a:t>04</a:t>
+            </a:r>
+          </a:p>
+        </p:txBody>
+      </p:sp>
+      <p:sp>
+        <p:nvSpPr>
+          <p:cNvPr id="3024" name="SimReal 3024"/>
+          <p:cNvSpPr txBox="1"/>
+          <p:nvPr/>
+        </p:nvSpPr>
+        <p:spPr>
+          <a:xfrm>
+            <a:off x="5257800" y="3493008"/>
+            <a:ext cx="1600200" cy="585216"/>
+          </a:xfrm>
+          <a:prstGeom prst="rect">
+            <a:avLst/>
+          </a:prstGeom>
+          <a:noFill/>
+          <a:ln>
+            <a:noFill/>
+          </a:ln>
+        </p:spPr>
+        <p:txBody>
+          <a:bodyPr spcFirstLastPara="1" wrap="square" lIns="0" tIns="0" rIns="0" bIns="0" anchor="ctr" anchorCtr="0">
+            <a:noAutofit/>
+          </a:bodyPr>
+          <a:lstStyle/>
+          <a:p>
+            <a:pPr marL="0" marR="0" lvl="0" indent="0" algn="l" rtl="0">
+              <a:spcBef>
+                <a:spcPts val="0"/>
+              </a:spcBef>
+              <a:spcAft>
+                <a:spcPts val="0"/>
+              </a:spcAft>
+              <a:buNone/>
+            </a:pPr>
+            <a:r>
+              <a:rPr lang="zh-CN" sz="1700" b="0" i="0" u="none" strike="noStrike" cap="none">
+                <a:solidFill>
+                  <a:srgbClr val="111110"/>
+                </a:solidFill>
+                <a:latin typeface="Newsreader"/>
+                <a:ea typeface="Newsreader"/>
+                <a:cs typeface="Newsreader"/>
+                <a:sym typeface="Newsreader"/>
+              </a:rPr>
+              <a:t>过往战绩</a:t>
+            </a:r>
+          </a:p>
+        </p:txBody>
+      </p:sp>
+      <p:sp>
+        <p:nvSpPr>
+          <p:cNvPr id="3025" name="SimReal 3025"/>
+          <p:cNvSpPr txBox="1"/>
+          <p:nvPr/>
+        </p:nvSpPr>
+        <p:spPr>
+          <a:xfrm>
+            <a:off x="6903720" y="3493008"/>
+            <a:ext cx="4736592" cy="585216"/>
+          </a:xfrm>
+          <a:prstGeom prst="rect">
+            <a:avLst/>
+          </a:prstGeom>
+          <a:noFill/>
+          <a:ln>
+            <a:noFill/>
+          </a:ln>
+        </p:spPr>
+        <p:txBody>
+          <a:bodyPr spcFirstLastPara="1" wrap="square" lIns="0" tIns="0" rIns="0" bIns="0" anchor="ctr" anchorCtr="0">
+            <a:noAutofit/>
+          </a:bodyPr>
+          <a:lstStyle/>
+          <a:p>
+            <a:pPr marL="0" marR="0" lvl="0" indent="0" algn="l" rtl="0">
+              <a:lnSpc>
+                <a:spcPct val="110000"/>
+              </a:lnSpc>
+              <a:spcBef>
+                <a:spcPts val="0"/>
+              </a:spcBef>
+              <a:spcAft>
+                <a:spcPts val="0"/>
+              </a:spcAft>
+              <a:buNone/>
+            </a:pPr>
+            <a:r>
+              <a:rPr lang="zh-CN" sz="1100" b="0" i="0" u="none" strike="noStrike" cap="none">
                 <a:solidFill>
                   <a:srgbClr val="6E6C66"/>
                 </a:solidFill>
@@ -7399,21 +8111,21 @@
                 <a:cs typeface="Instrument Sans"/>
                 <a:sym typeface="Instrument Sans"/>
               </a:rPr>
-              <a:t>实验室为什么需要</a:t>
-            </a:r>
-          </a:p>
-        </p:txBody>
-      </p:sp>
-      <p:sp>
-        <p:nvSpPr>
-          <p:cNvPr id="347" name="Rectangle 346"/>
+              <a:t>U稳定币0→14亿美元、一个月上线Binance；五家顶级量化机构经历</a:t>
+            </a:r>
+          </a:p>
+        </p:txBody>
+      </p:sp>
+      <p:sp>
+        <p:nvSpPr>
+          <p:cNvPr id="3026" name="SimReal 3026"/>
           <p:cNvSpPr/>
           <p:nvPr/>
         </p:nvSpPr>
         <p:spPr>
           <a:xfrm>
-            <a:off x="5120640" y="1869757"/>
-            <a:ext cx="6519672" cy="9525"/>
+            <a:off x="4754880" y="4078224"/>
+            <a:ext cx="6885432" cy="9144"/>
           </a:xfrm>
           <a:prstGeom prst="rect">
             <a:avLst/>
@@ -7426,7 +8138,7 @@
           </a:ln>
         </p:spPr>
         <p:txBody>
-          <a:bodyPr rtlCol="0" anchor="ctr"/>
+          <a:bodyPr/>
           <a:lstStyle/>
           <a:p>
             <a:endParaRPr/>
@@ -7435,29 +8147,118 @@
       </p:sp>
       <p:sp>
         <p:nvSpPr>
-          <p:cNvPr id="348" name="TextBox 347"/>
-          <p:cNvSpPr txBox="1"/>
-          <p:nvPr/>
-        </p:nvSpPr>
-        <p:spPr>
-          <a:xfrm>
-            <a:off x="5120640" y="1874519"/>
-            <a:ext cx="2331720" cy="1024128"/>
-          </a:xfrm>
-          <a:prstGeom prst="rect">
-            <a:avLst/>
-          </a:prstGeom>
-          <a:noFill/>
-        </p:spPr>
-        <p:txBody>
-          <a:bodyPr wrap="square" lIns="0" tIns="0" rIns="0" bIns="0" anchor="ctr">
-            <a:spAutoFit/>
-          </a:bodyPr>
-          <a:lstStyle/>
-          <a:p>
-            <a:pPr algn="l"/>
-            <a:r>
-              <a:rPr sz="3200" b="0">
+          <p:cNvPr id="3027" name="SimReal 3027"/>
+          <p:cNvSpPr txBox="1"/>
+          <p:nvPr/>
+        </p:nvSpPr>
+        <p:spPr>
+          <a:xfrm>
+            <a:off x="548640" y="4334256"/>
+            <a:ext cx="7315200" cy="201168"/>
+          </a:xfrm>
+          <a:prstGeom prst="rect">
+            <a:avLst/>
+          </a:prstGeom>
+          <a:noFill/>
+          <a:ln>
+            <a:noFill/>
+          </a:ln>
+        </p:spPr>
+        <p:txBody>
+          <a:bodyPr spcFirstLastPara="1" wrap="square" lIns="0" tIns="0" rIns="0" bIns="0" anchor="t" anchorCtr="0">
+            <a:noAutofit/>
+          </a:bodyPr>
+          <a:lstStyle/>
+          <a:p>
+            <a:pPr marL="0" marR="0" lvl="0" indent="0" algn="l" rtl="0">
+              <a:spcBef>
+                <a:spcPts val="0"/>
+              </a:spcBef>
+              <a:spcAft>
+                <a:spcPts val="0"/>
+              </a:spcAft>
+              <a:buNone/>
+            </a:pPr>
+            <a:r>
+              <a:rPr lang="zh-CN" sz="1000" b="0" i="0" u="none" strike="noStrike" cap="none">
+                <a:solidFill>
+                  <a:srgbClr val="6E6C66"/>
+                </a:solidFill>
+                <a:latin typeface="IBM Plex Mono"/>
+                <a:ea typeface="IBM Plex Mono"/>
+                <a:cs typeface="IBM Plex Mono"/>
+                <a:sym typeface="IBM Plex Mono"/>
+              </a:rPr>
+              <a:t>AI的热点一直在变</a:t>
+            </a:r>
+          </a:p>
+        </p:txBody>
+      </p:sp>
+      <p:sp>
+        <p:nvSpPr>
+          <p:cNvPr id="3028" name="SimReal 3028"/>
+          <p:cNvSpPr/>
+          <p:nvPr/>
+        </p:nvSpPr>
+        <p:spPr>
+          <a:xfrm>
+            <a:off x="548640" y="4572000"/>
+            <a:ext cx="2464308" cy="603504"/>
+          </a:xfrm>
+          <a:prstGeom prst="rect">
+            <a:avLst/>
+          </a:prstGeom>
+          <a:solidFill>
+            <a:srgbClr val="F2F1EC"/>
+          </a:solidFill>
+          <a:ln>
+            <a:noFill/>
+          </a:ln>
+        </p:spPr>
+        <p:txBody>
+          <a:bodyPr/>
+          <a:lstStyle/>
+          <a:p>
+            <a:endParaRPr/>
+          </a:p>
+        </p:txBody>
+      </p:sp>
+      <p:sp>
+        <p:nvSpPr>
+          <p:cNvPr id="3029" name="SimReal 3029"/>
+          <p:cNvSpPr txBox="1"/>
+          <p:nvPr/>
+        </p:nvSpPr>
+        <p:spPr>
+          <a:xfrm>
+            <a:off x="768096" y="4572000"/>
+            <a:ext cx="1280160" cy="603504"/>
+          </a:xfrm>
+          <a:prstGeom prst="rect">
+            <a:avLst/>
+          </a:prstGeom>
+          <a:noFill/>
+          <a:ln>
+            <a:noFill/>
+          </a:ln>
+        </p:spPr>
+        <p:txBody>
+          <a:bodyPr spcFirstLastPara="1" wrap="square" lIns="0" tIns="0" rIns="0" bIns="0" anchor="ctr" anchorCtr="0">
+            <a:noAutofit/>
+          </a:bodyPr>
+          <a:lstStyle/>
+          <a:p>
+            <a:pPr marL="0" marR="0" lvl="0" indent="0" algn="l" rtl="0">
+              <a:spcBef>
+                <a:spcPts val="0"/>
+              </a:spcBef>
+              <a:spcAft>
+                <a:spcPts val="0"/>
+              </a:spcAft>
+              <a:buNone/>
+            </a:pPr>
+            <a:r>
+              <a:rPr lang="zh-CN" sz="1500" b="0" i="0" u="none" strike="noStrike" cap="none">
                 <a:solidFill>
                   <a:srgbClr val="111110"/>
                 </a:solidFill>
@@ -7466,99 +8267,484 @@
                 <a:cs typeface="Newsreader"/>
                 <a:sym typeface="Newsreader"/>
               </a:rPr>
-              <a:t>~$2,400</a:t>
-            </a:r>
-          </a:p>
-        </p:txBody>
-      </p:sp>
-      <p:sp>
-        <p:nvSpPr>
-          <p:cNvPr id="349" name="TextBox 348"/>
-          <p:cNvSpPr txBox="1"/>
-          <p:nvPr/>
-        </p:nvSpPr>
-        <p:spPr>
-          <a:xfrm>
-            <a:off x="7589520" y="1874519"/>
-            <a:ext cx="4050792" cy="1024128"/>
-          </a:xfrm>
-          <a:prstGeom prst="rect">
-            <a:avLst/>
-          </a:prstGeom>
-          <a:noFill/>
-        </p:spPr>
-        <p:txBody>
-          <a:bodyPr wrap="square" lIns="0" tIns="0" rIns="0" bIns="0" anchor="ctr">
-            <a:spAutoFit/>
-          </a:bodyPr>
-          <a:lstStyle/>
-          <a:p>
-            <a:pPr algn="l">
-              <a:lnSpc>
-                <a:spcPct val="115000"/>
-              </a:lnSpc>
-            </a:pPr>
-            <a:r>
-              <a:rPr sz="1300" b="0">
-                <a:solidFill>
-                  <a:srgbClr val="33322F"/>
+              <a:t>数据标注</a:t>
+            </a:r>
+          </a:p>
+        </p:txBody>
+      </p:sp>
+      <p:sp>
+        <p:nvSpPr>
+          <p:cNvPr id="3030" name="SimReal 3030"/>
+          <p:cNvSpPr txBox="1"/>
+          <p:nvPr/>
+        </p:nvSpPr>
+        <p:spPr>
+          <a:xfrm>
+            <a:off x="1920240" y="4572000"/>
+            <a:ext cx="891540" cy="603504"/>
+          </a:xfrm>
+          <a:prstGeom prst="rect">
+            <a:avLst/>
+          </a:prstGeom>
+          <a:noFill/>
+          <a:ln>
+            <a:noFill/>
+          </a:ln>
+        </p:spPr>
+        <p:txBody>
+          <a:bodyPr spcFirstLastPara="1" wrap="square" lIns="0" tIns="0" rIns="0" bIns="0" anchor="ctr" anchorCtr="0">
+            <a:noAutofit/>
+          </a:bodyPr>
+          <a:lstStyle/>
+          <a:p>
+            <a:pPr marL="0" marR="0" lvl="0" indent="0" algn="r" rtl="0">
+              <a:spcBef>
+                <a:spcPts val="0"/>
+              </a:spcBef>
+              <a:spcAft>
+                <a:spcPts val="0"/>
+              </a:spcAft>
+              <a:buNone/>
+            </a:pPr>
+            <a:r>
+              <a:rPr lang="zh-CN" sz="1000" b="0" i="0" u="none" strike="noStrike" cap="none">
+                <a:solidFill>
+                  <a:srgbClr val="6E6C66"/>
+                </a:solidFill>
+                <a:latin typeface="IBM Plex Mono"/>
+                <a:ea typeface="IBM Plex Mono"/>
+                <a:cs typeface="IBM Plex Mono"/>
+                <a:sym typeface="IBM Plex Mono"/>
+              </a:rPr>
+              <a:t>Scale AI</a:t>
+            </a:r>
+          </a:p>
+        </p:txBody>
+      </p:sp>
+      <p:sp>
+        <p:nvSpPr>
+          <p:cNvPr id="3031" name="SimReal 3031"/>
+          <p:cNvSpPr txBox="1"/>
+          <p:nvPr/>
+        </p:nvSpPr>
+        <p:spPr>
+          <a:xfrm>
+            <a:off x="3012948" y="4572000"/>
+            <a:ext cx="411480" cy="603504"/>
+          </a:xfrm>
+          <a:prstGeom prst="rect">
+            <a:avLst/>
+          </a:prstGeom>
+          <a:noFill/>
+          <a:ln>
+            <a:noFill/>
+          </a:ln>
+        </p:spPr>
+        <p:txBody>
+          <a:bodyPr spcFirstLastPara="1" wrap="square" lIns="0" tIns="0" rIns="0" bIns="0" anchor="ctr" anchorCtr="0">
+            <a:noAutofit/>
+          </a:bodyPr>
+          <a:lstStyle/>
+          <a:p>
+            <a:pPr marL="0" marR="0" lvl="0" indent="0" algn="ctr" rtl="0">
+              <a:spcBef>
+                <a:spcPts val="0"/>
+              </a:spcBef>
+              <a:spcAft>
+                <a:spcPts val="0"/>
+              </a:spcAft>
+              <a:buNone/>
+            </a:pPr>
+            <a:r>
+              <a:rPr lang="zh-CN" sz="1400" b="0" i="0" u="none" strike="noStrike" cap="none">
+                <a:solidFill>
+                  <a:srgbClr val="6E6C66"/>
                 </a:solidFill>
                 <a:latin typeface="Instrument Sans"/>
                 <a:ea typeface="Instrument Sans"/>
                 <a:cs typeface="Instrument Sans"/>
                 <a:sym typeface="Instrument Sans"/>
               </a:rPr>
-              <a:t>每个RL任务的算力成本（Mechanize估算）</a:t>
-            </a:r>
-            <a:br>
-              <a:rPr sz="1300" b="0">
-                <a:solidFill>
-                  <a:srgbClr val="33322F"/>
+              <a:t>→</a:t>
+            </a:r>
+          </a:p>
+        </p:txBody>
+      </p:sp>
+      <p:sp>
+        <p:nvSpPr>
+          <p:cNvPr id="3032" name="SimReal 3032"/>
+          <p:cNvSpPr/>
+          <p:nvPr/>
+        </p:nvSpPr>
+        <p:spPr>
+          <a:xfrm>
+            <a:off x="3424428" y="4572000"/>
+            <a:ext cx="2464308" cy="603504"/>
+          </a:xfrm>
+          <a:prstGeom prst="rect">
+            <a:avLst/>
+          </a:prstGeom>
+          <a:solidFill>
+            <a:srgbClr val="F2F1EC"/>
+          </a:solidFill>
+          <a:ln>
+            <a:noFill/>
+          </a:ln>
+        </p:spPr>
+        <p:txBody>
+          <a:bodyPr/>
+          <a:lstStyle/>
+          <a:p>
+            <a:endParaRPr/>
+          </a:p>
+        </p:txBody>
+      </p:sp>
+      <p:sp>
+        <p:nvSpPr>
+          <p:cNvPr id="3033" name="SimReal 3033"/>
+          <p:cNvSpPr txBox="1"/>
+          <p:nvPr/>
+        </p:nvSpPr>
+        <p:spPr>
+          <a:xfrm>
+            <a:off x="3643884" y="4572000"/>
+            <a:ext cx="1280160" cy="603504"/>
+          </a:xfrm>
+          <a:prstGeom prst="rect">
+            <a:avLst/>
+          </a:prstGeom>
+          <a:noFill/>
+          <a:ln>
+            <a:noFill/>
+          </a:ln>
+        </p:spPr>
+        <p:txBody>
+          <a:bodyPr spcFirstLastPara="1" wrap="square" lIns="0" tIns="0" rIns="0" bIns="0" anchor="ctr" anchorCtr="0">
+            <a:noAutofit/>
+          </a:bodyPr>
+          <a:lstStyle/>
+          <a:p>
+            <a:pPr marL="0" marR="0" lvl="0" indent="0" algn="l" rtl="0">
+              <a:spcBef>
+                <a:spcPts val="0"/>
+              </a:spcBef>
+              <a:spcAft>
+                <a:spcPts val="0"/>
+              </a:spcAft>
+              <a:buNone/>
+            </a:pPr>
+            <a:r>
+              <a:rPr lang="zh-CN" sz="1500" b="0" i="0" u="none" strike="noStrike" cap="none">
+                <a:solidFill>
+                  <a:srgbClr val="111110"/>
+                </a:solidFill>
+                <a:latin typeface="Newsreader"/>
+                <a:ea typeface="Newsreader"/>
+                <a:cs typeface="Newsreader"/>
+                <a:sym typeface="Newsreader"/>
+              </a:rPr>
+              <a:t>专家数据</a:t>
+            </a:r>
+          </a:p>
+        </p:txBody>
+      </p:sp>
+      <p:sp>
+        <p:nvSpPr>
+          <p:cNvPr id="3034" name="SimReal 3034"/>
+          <p:cNvSpPr txBox="1"/>
+          <p:nvPr/>
+        </p:nvSpPr>
+        <p:spPr>
+          <a:xfrm>
+            <a:off x="4796028" y="4572000"/>
+            <a:ext cx="891540" cy="603504"/>
+          </a:xfrm>
+          <a:prstGeom prst="rect">
+            <a:avLst/>
+          </a:prstGeom>
+          <a:noFill/>
+          <a:ln>
+            <a:noFill/>
+          </a:ln>
+        </p:spPr>
+        <p:txBody>
+          <a:bodyPr spcFirstLastPara="1" wrap="square" lIns="0" tIns="0" rIns="0" bIns="0" anchor="ctr" anchorCtr="0">
+            <a:noAutofit/>
+          </a:bodyPr>
+          <a:lstStyle/>
+          <a:p>
+            <a:pPr marL="0" marR="0" lvl="0" indent="0" algn="r" rtl="0">
+              <a:spcBef>
+                <a:spcPts val="0"/>
+              </a:spcBef>
+              <a:spcAft>
+                <a:spcPts val="0"/>
+              </a:spcAft>
+              <a:buNone/>
+            </a:pPr>
+            <a:r>
+              <a:rPr lang="zh-CN" sz="1000" b="0" i="0" u="none" strike="noStrike" cap="none">
+                <a:solidFill>
+                  <a:srgbClr val="6E6C66"/>
+                </a:solidFill>
+                <a:latin typeface="IBM Plex Mono"/>
+                <a:ea typeface="IBM Plex Mono"/>
+                <a:cs typeface="IBM Plex Mono"/>
+                <a:sym typeface="IBM Plex Mono"/>
+              </a:rPr>
+              <a:t>Mercor</a:t>
+            </a:r>
+          </a:p>
+        </p:txBody>
+      </p:sp>
+      <p:sp>
+        <p:nvSpPr>
+          <p:cNvPr id="3035" name="SimReal 3035"/>
+          <p:cNvSpPr txBox="1"/>
+          <p:nvPr/>
+        </p:nvSpPr>
+        <p:spPr>
+          <a:xfrm>
+            <a:off x="5888736" y="4572000"/>
+            <a:ext cx="411480" cy="603504"/>
+          </a:xfrm>
+          <a:prstGeom prst="rect">
+            <a:avLst/>
+          </a:prstGeom>
+          <a:noFill/>
+          <a:ln>
+            <a:noFill/>
+          </a:ln>
+        </p:spPr>
+        <p:txBody>
+          <a:bodyPr spcFirstLastPara="1" wrap="square" lIns="0" tIns="0" rIns="0" bIns="0" anchor="ctr" anchorCtr="0">
+            <a:noAutofit/>
+          </a:bodyPr>
+          <a:lstStyle/>
+          <a:p>
+            <a:pPr marL="0" marR="0" lvl="0" indent="0" algn="ctr" rtl="0">
+              <a:spcBef>
+                <a:spcPts val="0"/>
+              </a:spcBef>
+              <a:spcAft>
+                <a:spcPts val="0"/>
+              </a:spcAft>
+              <a:buNone/>
+            </a:pPr>
+            <a:r>
+              <a:rPr lang="zh-CN" sz="1400" b="0" i="0" u="none" strike="noStrike" cap="none">
+                <a:solidFill>
+                  <a:srgbClr val="6E6C66"/>
                 </a:solidFill>
                 <a:latin typeface="Instrument Sans"/>
                 <a:ea typeface="Instrument Sans"/>
                 <a:cs typeface="Instrument Sans"/>
                 <a:sym typeface="Instrument Sans"/>
               </a:rPr>
-            </a:br>
-            <a:r>
-              <a:rPr sz="1300" b="0">
-                <a:solidFill>
-                  <a:srgbClr val="33322F"/>
+              <a:t>→</a:t>
+            </a:r>
+          </a:p>
+        </p:txBody>
+      </p:sp>
+      <p:sp>
+        <p:nvSpPr>
+          <p:cNvPr id="3036" name="SimReal 3036"/>
+          <p:cNvSpPr/>
+          <p:nvPr/>
+        </p:nvSpPr>
+        <p:spPr>
+          <a:xfrm>
+            <a:off x="6300216" y="4572000"/>
+            <a:ext cx="2464308" cy="603504"/>
+          </a:xfrm>
+          <a:prstGeom prst="rect">
+            <a:avLst/>
+          </a:prstGeom>
+          <a:solidFill>
+            <a:srgbClr val="F2F1EC"/>
+          </a:solidFill>
+          <a:ln>
+            <a:noFill/>
+          </a:ln>
+        </p:spPr>
+        <p:txBody>
+          <a:bodyPr/>
+          <a:lstStyle/>
+          <a:p>
+            <a:endParaRPr/>
+          </a:p>
+        </p:txBody>
+      </p:sp>
+      <p:sp>
+        <p:nvSpPr>
+          <p:cNvPr id="3037" name="SimReal 3037"/>
+          <p:cNvSpPr txBox="1"/>
+          <p:nvPr/>
+        </p:nvSpPr>
+        <p:spPr>
+          <a:xfrm>
+            <a:off x="6519672" y="4572000"/>
+            <a:ext cx="1280160" cy="603504"/>
+          </a:xfrm>
+          <a:prstGeom prst="rect">
+            <a:avLst/>
+          </a:prstGeom>
+          <a:noFill/>
+          <a:ln>
+            <a:noFill/>
+          </a:ln>
+        </p:spPr>
+        <p:txBody>
+          <a:bodyPr spcFirstLastPara="1" wrap="square" lIns="0" tIns="0" rIns="0" bIns="0" anchor="ctr" anchorCtr="0">
+            <a:noAutofit/>
+          </a:bodyPr>
+          <a:lstStyle/>
+          <a:p>
+            <a:pPr marL="0" marR="0" lvl="0" indent="0" algn="l" rtl="0">
+              <a:spcBef>
+                <a:spcPts val="0"/>
+              </a:spcBef>
+              <a:spcAft>
+                <a:spcPts val="0"/>
+              </a:spcAft>
+              <a:buNone/>
+            </a:pPr>
+            <a:r>
+              <a:rPr lang="zh-CN" sz="1500" b="0" i="0" u="none" strike="noStrike" cap="none">
+                <a:solidFill>
+                  <a:srgbClr val="111110"/>
+                </a:solidFill>
+                <a:latin typeface="Newsreader"/>
+                <a:ea typeface="Newsreader"/>
+                <a:cs typeface="Newsreader"/>
+                <a:sym typeface="Newsreader"/>
+              </a:rPr>
+              <a:t>RL环境</a:t>
+            </a:r>
+          </a:p>
+        </p:txBody>
+      </p:sp>
+      <p:sp>
+        <p:nvSpPr>
+          <p:cNvPr id="3038" name="SimReal 3038"/>
+          <p:cNvSpPr txBox="1"/>
+          <p:nvPr/>
+        </p:nvSpPr>
+        <p:spPr>
+          <a:xfrm>
+            <a:off x="7671816" y="4572000"/>
+            <a:ext cx="891540" cy="603504"/>
+          </a:xfrm>
+          <a:prstGeom prst="rect">
+            <a:avLst/>
+          </a:prstGeom>
+          <a:noFill/>
+          <a:ln>
+            <a:noFill/>
+          </a:ln>
+        </p:spPr>
+        <p:txBody>
+          <a:bodyPr spcFirstLastPara="1" wrap="square" lIns="0" tIns="0" rIns="0" bIns="0" anchor="ctr" anchorCtr="0">
+            <a:noAutofit/>
+          </a:bodyPr>
+          <a:lstStyle/>
+          <a:p>
+            <a:pPr marL="0" marR="0" lvl="0" indent="0" algn="r" rtl="0">
+              <a:spcBef>
+                <a:spcPts val="0"/>
+              </a:spcBef>
+              <a:spcAft>
+                <a:spcPts val="0"/>
+              </a:spcAft>
+              <a:buNone/>
+            </a:pPr>
+            <a:r>
+              <a:rPr lang="zh-CN" sz="1000" b="0" i="0" u="none" strike="noStrike" cap="none">
+                <a:solidFill>
+                  <a:srgbClr val="6E6C66"/>
+                </a:solidFill>
+                <a:latin typeface="IBM Plex Mono"/>
+                <a:ea typeface="IBM Plex Mono"/>
+                <a:cs typeface="IBM Plex Mono"/>
+                <a:sym typeface="IBM Plex Mono"/>
+              </a:rPr>
+              <a:t>AfterQuery</a:t>
+            </a:r>
+          </a:p>
+        </p:txBody>
+      </p:sp>
+      <p:sp>
+        <p:nvSpPr>
+          <p:cNvPr id="3039" name="SimReal 3039"/>
+          <p:cNvSpPr txBox="1"/>
+          <p:nvPr/>
+        </p:nvSpPr>
+        <p:spPr>
+          <a:xfrm>
+            <a:off x="8764524" y="4572000"/>
+            <a:ext cx="411480" cy="603504"/>
+          </a:xfrm>
+          <a:prstGeom prst="rect">
+            <a:avLst/>
+          </a:prstGeom>
+          <a:noFill/>
+          <a:ln>
+            <a:noFill/>
+          </a:ln>
+        </p:spPr>
+        <p:txBody>
+          <a:bodyPr spcFirstLastPara="1" wrap="square" lIns="0" tIns="0" rIns="0" bIns="0" anchor="ctr" anchorCtr="0">
+            <a:noAutofit/>
+          </a:bodyPr>
+          <a:lstStyle/>
+          <a:p>
+            <a:pPr marL="0" marR="0" lvl="0" indent="0" algn="ctr" rtl="0">
+              <a:spcBef>
+                <a:spcPts val="0"/>
+              </a:spcBef>
+              <a:spcAft>
+                <a:spcPts val="0"/>
+              </a:spcAft>
+              <a:buNone/>
+            </a:pPr>
+            <a:r>
+              <a:rPr lang="zh-CN" sz="1400" b="0" i="0" u="none" strike="noStrike" cap="none">
+                <a:solidFill>
+                  <a:srgbClr val="6E6C66"/>
                 </a:solidFill>
                 <a:latin typeface="Instrument Sans"/>
                 <a:ea typeface="Instrument Sans"/>
                 <a:cs typeface="Instrument Sans"/>
                 <a:sym typeface="Instrument Sans"/>
               </a:rPr>
-              <a:t>被钻空子，钱就白花</a:t>
-            </a:r>
-          </a:p>
-        </p:txBody>
-      </p:sp>
-      <p:sp>
-        <p:nvSpPr>
-          <p:cNvPr id="350" name="Rectangle 349"/>
+              <a:t>→</a:t>
+            </a:r>
+          </a:p>
+        </p:txBody>
+      </p:sp>
+      <p:sp>
+        <p:nvSpPr>
+          <p:cNvPr id="3040" name="SimReal 3040"/>
           <p:cNvSpPr/>
           <p:nvPr/>
         </p:nvSpPr>
         <p:spPr>
           <a:xfrm>
-            <a:off x="5120640" y="2893885"/>
-            <a:ext cx="6519672" cy="9525"/>
+            <a:off x="9176004" y="4572000"/>
+            <a:ext cx="2464308" cy="603504"/>
           </a:xfrm>
           <a:prstGeom prst="rect">
             <a:avLst/>
           </a:prstGeom>
           <a:solidFill>
-            <a:srgbClr val="E2E0DA"/>
+            <a:srgbClr val="111110"/>
           </a:solidFill>
           <a:ln>
             <a:noFill/>
           </a:ln>
         </p:spPr>
         <p:txBody>
-          <a:bodyPr rtlCol="0" anchor="ctr"/>
+          <a:bodyPr/>
           <a:lstStyle/>
           <a:p>
             <a:endParaRPr/>
@@ -7567,53 +8753,138 @@
       </p:sp>
       <p:sp>
         <p:nvSpPr>
-          <p:cNvPr id="351" name="TextBox 350"/>
-          <p:cNvSpPr txBox="1"/>
-          <p:nvPr/>
-        </p:nvSpPr>
-        <p:spPr>
-          <a:xfrm>
-            <a:off x="5120640" y="2898648"/>
-            <a:ext cx="2331720" cy="1024128"/>
-          </a:xfrm>
-          <a:prstGeom prst="rect">
-            <a:avLst/>
-          </a:prstGeom>
-          <a:noFill/>
-        </p:spPr>
-        <p:txBody>
-          <a:bodyPr wrap="square" lIns="0" tIns="0" rIns="0" bIns="0" anchor="ctr">
-            <a:spAutoFit/>
-          </a:bodyPr>
-          <a:lstStyle/>
-          <a:p>
-            <a:pPr algn="l"/>
-            <a:r>
-              <a:rPr sz="3200" b="0">
-                <a:solidFill>
-                  <a:srgbClr val="111110"/>
+          <p:cNvPr id="3041" name="SimReal 3041"/>
+          <p:cNvSpPr txBox="1"/>
+          <p:nvPr/>
+        </p:nvSpPr>
+        <p:spPr>
+          <a:xfrm>
+            <a:off x="9395460" y="4572000"/>
+            <a:ext cx="1280160" cy="603504"/>
+          </a:xfrm>
+          <a:prstGeom prst="rect">
+            <a:avLst/>
+          </a:prstGeom>
+          <a:noFill/>
+          <a:ln>
+            <a:noFill/>
+          </a:ln>
+        </p:spPr>
+        <p:txBody>
+          <a:bodyPr spcFirstLastPara="1" wrap="square" lIns="0" tIns="0" rIns="0" bIns="0" anchor="ctr" anchorCtr="0">
+            <a:noAutofit/>
+          </a:bodyPr>
+          <a:lstStyle/>
+          <a:p>
+            <a:pPr marL="0" marR="0" lvl="0" indent="0" algn="l" rtl="0">
+              <a:spcBef>
+                <a:spcPts val="0"/>
+              </a:spcBef>
+              <a:spcAft>
+                <a:spcPts val="0"/>
+              </a:spcAft>
+              <a:buNone/>
+            </a:pPr>
+            <a:r>
+              <a:rPr lang="zh-CN" sz="1500" b="0" i="0" u="none" strike="noStrike" cap="none">
+                <a:solidFill>
+                  <a:srgbClr val="FAF9F6"/>
                 </a:solidFill>
                 <a:latin typeface="Newsreader"/>
                 <a:ea typeface="Newsreader"/>
                 <a:cs typeface="Newsreader"/>
                 <a:sym typeface="Newsreader"/>
               </a:rPr>
-              <a:t>6 </a:t>
-            </a:r>
-            <a:r>
-              <a:rPr sz="3200" b="0">
-                <a:solidFill>
-                  <a:srgbClr val="111110"/>
-                </a:solidFill>
-                <a:latin typeface="Instrument Sans"/>
-                <a:ea typeface="Instrument Sans"/>
-                <a:cs typeface="Instrument Sans"/>
-                <a:sym typeface="Instrument Sans"/>
-              </a:rPr>
-              <a:t>→</a:t>
-            </a:r>
-            <a:r>
-              <a:rPr sz="3200" b="0">
+              <a:t>自我进化</a:t>
+            </a:r>
+          </a:p>
+        </p:txBody>
+      </p:sp>
+      <p:sp>
+        <p:nvSpPr>
+          <p:cNvPr id="3042" name="SimReal 3042"/>
+          <p:cNvSpPr txBox="1"/>
+          <p:nvPr/>
+        </p:nvSpPr>
+        <p:spPr>
+          <a:xfrm>
+            <a:off x="10547604" y="4572000"/>
+            <a:ext cx="891540" cy="603504"/>
+          </a:xfrm>
+          <a:prstGeom prst="rect">
+            <a:avLst/>
+          </a:prstGeom>
+          <a:noFill/>
+          <a:ln>
+            <a:noFill/>
+          </a:ln>
+        </p:spPr>
+        <p:txBody>
+          <a:bodyPr spcFirstLastPara="1" wrap="square" lIns="0" tIns="0" rIns="0" bIns="0" anchor="ctr" anchorCtr="0">
+            <a:noAutofit/>
+          </a:bodyPr>
+          <a:lstStyle/>
+          <a:p>
+            <a:pPr marL="0" marR="0" lvl="0" indent="0" algn="r" rtl="0">
+              <a:spcBef>
+                <a:spcPts val="0"/>
+              </a:spcBef>
+              <a:spcAft>
+                <a:spcPts val="0"/>
+              </a:spcAft>
+              <a:buNone/>
+            </a:pPr>
+            <a:r>
+              <a:rPr lang="zh-CN" sz="1000" b="0" i="0" u="none" strike="noStrike" cap="none">
+                <a:solidFill>
+                  <a:srgbClr val="E27A3F"/>
+                </a:solidFill>
+                <a:latin typeface="IBM Plex Mono"/>
+                <a:ea typeface="IBM Plex Mono"/>
+                <a:cs typeface="IBM Plex Mono"/>
+                <a:sym typeface="IBM Plex Mono"/>
+              </a:rPr>
+              <a:t>SimReal</a:t>
+            </a:r>
+          </a:p>
+        </p:txBody>
+      </p:sp>
+      <p:sp>
+        <p:nvSpPr>
+          <p:cNvPr id="3043" name="SimReal 3043"/>
+          <p:cNvSpPr txBox="1"/>
+          <p:nvPr/>
+        </p:nvSpPr>
+        <p:spPr>
+          <a:xfrm>
+            <a:off x="548640" y="5358384"/>
+            <a:ext cx="11091672" cy="402336"/>
+          </a:xfrm>
+          <a:prstGeom prst="rect">
+            <a:avLst/>
+          </a:prstGeom>
+          <a:noFill/>
+          <a:ln>
+            <a:noFill/>
+          </a:ln>
+        </p:spPr>
+        <p:txBody>
+          <a:bodyPr spcFirstLastPara="1" wrap="square" lIns="0" tIns="0" rIns="0" bIns="0" anchor="ctr" anchorCtr="0">
+            <a:noAutofit/>
+          </a:bodyPr>
+          <a:lstStyle/>
+          <a:p>
+            <a:pPr marL="0" marR="0" lvl="0" indent="0" algn="ctr" rtl="0">
+              <a:spcBef>
+                <a:spcPts val="0"/>
+              </a:spcBef>
+              <a:spcAft>
+                <a:spcPts val="0"/>
+              </a:spcAft>
+              <a:buNone/>
+            </a:pPr>
+            <a:r>
+              <a:rPr lang="zh-CN" sz="2000" b="0" i="0" u="none" strike="noStrike" cap="none">
                 <a:solidFill>
                   <a:srgbClr val="111110"/>
                 </a:solidFill>
@@ -7622,220 +8893,22 @@
                 <a:cs typeface="Newsreader"/>
                 <a:sym typeface="Newsreader"/>
               </a:rPr>
-              <a:t> 0</a:t>
-            </a:r>
-          </a:p>
-        </p:txBody>
-      </p:sp>
-      <p:sp>
-        <p:nvSpPr>
-          <p:cNvPr id="352" name="TextBox 351"/>
-          <p:cNvSpPr txBox="1"/>
-          <p:nvPr/>
-        </p:nvSpPr>
-        <p:spPr>
-          <a:xfrm>
-            <a:off x="7589520" y="2898648"/>
-            <a:ext cx="4050792" cy="1024128"/>
-          </a:xfrm>
-          <a:prstGeom prst="rect">
-            <a:avLst/>
-          </a:prstGeom>
-          <a:noFill/>
-        </p:spPr>
-        <p:txBody>
-          <a:bodyPr wrap="square" lIns="0" tIns="0" rIns="0" bIns="0" anchor="ctr">
-            <a:spAutoFit/>
-          </a:bodyPr>
-          <a:lstStyle/>
-          <a:p>
-            <a:pPr algn="l">
-              <a:lnSpc>
-                <a:spcPct val="115000"/>
-              </a:lnSpc>
-            </a:pPr>
-            <a:r>
-              <a:rPr sz="1300" b="0">
-                <a:solidFill>
-                  <a:srgbClr val="33322F"/>
-                </a:solidFill>
-                <a:latin typeface="Instrument Sans"/>
-                <a:ea typeface="Instrument Sans"/>
-                <a:cs typeface="Instrument Sans"/>
-                <a:sym typeface="Instrument Sans"/>
-              </a:rPr>
-              <a:t>Month-End Close两轮受控对比：评分漏洞6个降到0</a:t>
-            </a:r>
-          </a:p>
-        </p:txBody>
-      </p:sp>
-      <p:sp>
-        <p:nvSpPr>
-          <p:cNvPr id="353" name="Rectangle 352"/>
-          <p:cNvSpPr/>
-          <p:nvPr/>
-        </p:nvSpPr>
-        <p:spPr>
-          <a:xfrm>
-            <a:off x="5120640" y="3918013"/>
-            <a:ext cx="6519672" cy="9525"/>
-          </a:xfrm>
-          <a:prstGeom prst="rect">
-            <a:avLst/>
-          </a:prstGeom>
-          <a:solidFill>
-            <a:srgbClr val="E2E0DA"/>
-          </a:solidFill>
-          <a:ln>
-            <a:noFill/>
-          </a:ln>
-        </p:spPr>
-        <p:txBody>
-          <a:bodyPr rtlCol="0" anchor="ctr"/>
-          <a:lstStyle/>
-          <a:p>
-            <a:endParaRPr/>
-          </a:p>
-        </p:txBody>
-      </p:sp>
-      <p:sp>
-        <p:nvSpPr>
-          <p:cNvPr id="354" name="TextBox 353"/>
-          <p:cNvSpPr txBox="1"/>
-          <p:nvPr/>
-        </p:nvSpPr>
-        <p:spPr>
-          <a:xfrm>
-            <a:off x="5120640" y="3922776"/>
-            <a:ext cx="2331720" cy="1024128"/>
-          </a:xfrm>
-          <a:prstGeom prst="rect">
-            <a:avLst/>
-          </a:prstGeom>
-          <a:noFill/>
-        </p:spPr>
-        <p:txBody>
-          <a:bodyPr wrap="square" lIns="0" tIns="0" rIns="0" bIns="0" anchor="ctr">
-            <a:spAutoFit/>
-          </a:bodyPr>
-          <a:lstStyle/>
-          <a:p>
-            <a:pPr algn="l"/>
-            <a:r>
-              <a:rPr sz="2600" b="0">
-                <a:solidFill>
-                  <a:srgbClr val="111110"/>
+              <a:t>热点变得越快，我们越有利。押注我们，就是押注</a:t>
+            </a:r>
+            <a:r>
+              <a:rPr lang="zh-CN" sz="2000" b="0" i="0" u="none" strike="noStrike" cap="none">
+                <a:solidFill>
+                  <a:srgbClr val="C2410C"/>
                 </a:solidFill>
                 <a:latin typeface="Newsreader"/>
                 <a:ea typeface="Newsreader"/>
                 <a:cs typeface="Newsreader"/>
                 <a:sym typeface="Newsreader"/>
               </a:rPr>
-              <a:t>不靠AI打分</a:t>
-            </a:r>
-          </a:p>
-        </p:txBody>
-      </p:sp>
-      <p:sp>
-        <p:nvSpPr>
-          <p:cNvPr id="355" name="TextBox 354"/>
-          <p:cNvSpPr txBox="1"/>
-          <p:nvPr/>
-        </p:nvSpPr>
-        <p:spPr>
-          <a:xfrm>
-            <a:off x="7589520" y="3922776"/>
-            <a:ext cx="4050792" cy="1024128"/>
-          </a:xfrm>
-          <a:prstGeom prst="rect">
-            <a:avLst/>
-          </a:prstGeom>
-          <a:noFill/>
-        </p:spPr>
-        <p:txBody>
-          <a:bodyPr wrap="square" lIns="0" tIns="0" rIns="0" bIns="0" anchor="ctr">
-            <a:spAutoFit/>
-          </a:bodyPr>
-          <a:lstStyle/>
-          <a:p>
-            <a:pPr algn="l">
-              <a:lnSpc>
-                <a:spcPct val="115000"/>
-              </a:lnSpc>
-            </a:pPr>
-            <a:r>
-              <a:rPr sz="1300" b="0">
-                <a:solidFill>
-                  <a:srgbClr val="33322F"/>
-                </a:solidFill>
-                <a:latin typeface="Instrument Sans"/>
-                <a:ea typeface="Instrument Sans"/>
-                <a:cs typeface="Instrument Sans"/>
-                <a:sym typeface="Instrument Sans"/>
-              </a:rPr>
-              <a:t>只认真实结果：盈亏、账目、代码能否运行</a:t>
-            </a:r>
-          </a:p>
-        </p:txBody>
-      </p:sp>
-      <p:sp>
-        <p:nvSpPr>
-          <p:cNvPr id="356" name="Rectangle 355"/>
-          <p:cNvSpPr/>
-          <p:nvPr/>
-        </p:nvSpPr>
-        <p:spPr>
-          <a:xfrm>
-            <a:off x="5120640" y="4942141"/>
-            <a:ext cx="6519672" cy="9525"/>
-          </a:xfrm>
-          <a:prstGeom prst="rect">
-            <a:avLst/>
-          </a:prstGeom>
-          <a:solidFill>
-            <a:srgbClr val="E2E0DA"/>
-          </a:solidFill>
-          <a:ln>
-            <a:noFill/>
-          </a:ln>
-        </p:spPr>
-        <p:txBody>
-          <a:bodyPr rtlCol="0" anchor="ctr"/>
-          <a:lstStyle/>
-          <a:p>
-            <a:endParaRPr/>
-          </a:p>
-        </p:txBody>
-      </p:sp>
-      <p:sp>
-        <p:nvSpPr>
-          <p:cNvPr id="357" name="TextBox 356"/>
-          <p:cNvSpPr txBox="1"/>
-          <p:nvPr/>
-        </p:nvSpPr>
-        <p:spPr>
-          <a:xfrm>
-            <a:off x="5120640" y="5029200"/>
-            <a:ext cx="6519672" cy="777240"/>
-          </a:xfrm>
-          <a:prstGeom prst="rect">
-            <a:avLst/>
-          </a:prstGeom>
-          <a:noFill/>
-        </p:spPr>
-        <p:txBody>
-          <a:bodyPr wrap="square" lIns="0" tIns="0" rIns="0" bIns="0" anchor="ctr">
-            <a:spAutoFit/>
-          </a:bodyPr>
-          <a:lstStyle/>
-          <a:p>
-            <a:pPr algn="l">
-              <a:lnSpc>
-                <a:spcPct val="120000"/>
-              </a:lnSpc>
-            </a:pPr>
-            <a:r>
-              <a:rPr sz="1600" b="0">
+              <a:t>AI每一次范式变化</a:t>
+            </a:r>
+            <a:r>
+              <a:rPr lang="zh-CN" sz="2000" b="0" i="0" u="none" strike="noStrike" cap="none">
                 <a:solidFill>
                   <a:srgbClr val="111110"/>
                 </a:solidFill>
@@ -7844,26 +8917,7 @@
                 <a:cs typeface="Newsreader"/>
                 <a:sym typeface="Newsreader"/>
               </a:rPr>
-              <a:t>作弊不了，分数才可信；分数可信，AI才能进化</a:t>
-            </a:r>
-          </a:p>
-          <a:p>
-            <a:pPr algn="l">
-              <a:lnSpc>
-                <a:spcPct val="120000"/>
-              </a:lnSpc>
-            </a:pPr>
-            <a:r>
-              <a:rPr sz="1600" b="0">
-                <a:solidFill>
-                  <a:srgbClr val="C2410C"/>
-                </a:solidFill>
-                <a:latin typeface="Newsreader"/>
-                <a:ea typeface="Newsreader"/>
-                <a:cs typeface="Newsreader"/>
-                <a:sym typeface="Newsreader"/>
-              </a:rPr>
-              <a:t>我们让每一次训练都算数</a:t>
+              <a:t>中的机会。</a:t>
             </a:r>
           </a:p>
         </p:txBody>
@@ -10200,7 +11254,7 @@
                 <a:cs typeface="Instrument Sans"/>
                 <a:sym typeface="Instrument Sans"/>
               </a:rPr>
-              <a:t>目标第3个月首单</a:t>
+              <a:t>目标第2个月首单</a:t>
             </a:r>
             <a:endParaRPr sz="1200" b="0" i="0" u="none" strike="noStrike" cap="none">
               <a:solidFill>
@@ -17993,7 +19047,7 @@
                 <a:cs typeface="Instrument Sans"/>
                 <a:sym typeface="Instrument Sans"/>
               </a:rPr>
-              <a:t>据报道，加入YC 18个月</a:t>
+              <a:t>加入YC 18个月</a:t>
             </a:r>
             <a:endParaRPr sz="1100" b="0" i="0" u="none" strike="noStrike" cap="none" dirty="0">
               <a:solidFill>
@@ -18621,7 +19675,7 @@
                 <a:cs typeface="Instrument Sans"/>
                 <a:sym typeface="Instrument Sans"/>
               </a:rPr>
-              <a:t>四位量化人，均21岁</a:t>
+              <a:t>4位量化实习本科生，高中同学</a:t>
             </a:r>
             <a:endParaRPr sz="1100" b="0" i="0" u="none" strike="noStrike" cap="none" dirty="0">
               <a:solidFill>
@@ -29520,7 +30574,7 @@
                 <a:cs typeface="Instrument Sans"/>
                 <a:sym typeface="Instrument Sans"/>
               </a:rPr>
-              <a:t>2030年AI经济 × 10%；10%参照大型科技公司研发投入占收入约10–15%（公司年报），取下限，为推算假设；单任务算力成本：Mechanize《Cheap RL tasks will waste compute》</a:t>
+              <a:t>2030年AI经济 × 10%；10%参照大型科技公司研发投入占收入约10–15%（公司年报），取下限，为推算假设</a:t>
             </a:r>
             <a:endParaRPr sz="1000" b="0" i="0" u="none" strike="noStrike" cap="none">
               <a:solidFill>
@@ -31671,7 +32725,7 @@
                 <a:cs typeface="IBM Plex Mono"/>
                 <a:sym typeface="IBM Plex Mono"/>
               </a:rPr>
-              <a:t>01  收入引擎</a:t>
+              <a:t>01  收入引擎  ·  AfterQuery模式  ·  投入1,000万美元</a:t>
             </a:r>
           </a:p>
         </p:txBody>
@@ -31713,14 +32767,14 @@
             <a:r>
               <a:rPr lang="zh-CN" sz="3000" b="0" i="0" u="none" strike="noStrike" cap="none">
                 <a:solidFill>
-                  <a:srgbClr val="111110"/>
+                  <a:srgbClr val="C2410C"/>
                 </a:solidFill>
                 <a:latin typeface="Newsreader"/>
                 <a:ea typeface="Newsreader"/>
                 <a:cs typeface="Newsreader"/>
                 <a:sym typeface="Newsreader"/>
               </a:rPr>
-              <a:t>1,000万美元</a:t>
+              <a:t>年化3亿美元</a:t>
             </a:r>
           </a:p>
         </p:txBody>
@@ -31769,7 +32823,7 @@
                 <a:cs typeface="Instrument Sans"/>
                 <a:sym typeface="Instrument Sans"/>
               </a:rPr>
-              <a:t>照AfterQuery的模式，向前沿实验室卖训练数据与RL环境</a:t>
+              <a:t>12个月年化收入；毛利约2.4亿美元，是投入的24倍</a:t>
             </a:r>
           </a:p>
         </p:txBody>
@@ -31812,7 +32866,7 @@
         <p:spPr>
           <a:xfrm>
             <a:off x="841248" y="2907792"/>
-            <a:ext cx="868680" cy="329184"/>
+            <a:ext cx="777240" cy="329184"/>
           </a:xfrm>
           <a:prstGeom prst="rect">
             <a:avLst/>
@@ -31860,8 +32914,8 @@
         </p:nvSpPr>
         <p:spPr>
           <a:xfrm>
-            <a:off x="1755648" y="2907792"/>
-            <a:ext cx="1463040" cy="329184"/>
+            <a:off x="1664208" y="2907792"/>
+            <a:ext cx="1143000" cy="329184"/>
           </a:xfrm>
           <a:prstGeom prst="rect">
             <a:avLst/>
@@ -31909,8 +32963,8 @@
         </p:nvSpPr>
         <p:spPr>
           <a:xfrm>
-            <a:off x="3264408" y="2907792"/>
-            <a:ext cx="2400300" cy="329184"/>
+            <a:off x="2852928" y="2907792"/>
+            <a:ext cx="2811780" cy="329184"/>
           </a:xfrm>
           <a:prstGeom prst="rect">
             <a:avLst/>
@@ -31945,7 +32999,7 @@
                 <a:cs typeface="Instrument Sans"/>
                 <a:sym typeface="Instrument Sans"/>
               </a:rPr>
-              <a:t>专家、环境工程、攻防测试</a:t>
+              <a:t>50个环境 → 年化1亿美元</a:t>
             </a:r>
           </a:p>
         </p:txBody>
@@ -31988,7 +33042,7 @@
         <p:spPr>
           <a:xfrm>
             <a:off x="841248" y="3236976"/>
-            <a:ext cx="868680" cy="329184"/>
+            <a:ext cx="777240" cy="329184"/>
           </a:xfrm>
           <a:prstGeom prst="rect">
             <a:avLst/>
@@ -32036,8 +33090,8 @@
         </p:nvSpPr>
         <p:spPr>
           <a:xfrm>
-            <a:off x="1755648" y="3236976"/>
-            <a:ext cx="1463040" cy="329184"/>
+            <a:off x="1664208" y="3236976"/>
+            <a:ext cx="1143000" cy="329184"/>
           </a:xfrm>
           <a:prstGeom prst="rect">
             <a:avLst/>
@@ -32085,8 +33139,8 @@
         </p:nvSpPr>
         <p:spPr>
           <a:xfrm>
-            <a:off x="3264408" y="3236976"/>
-            <a:ext cx="2400300" cy="329184"/>
+            <a:off x="2852928" y="3236976"/>
+            <a:ext cx="2811780" cy="329184"/>
           </a:xfrm>
           <a:prstGeom prst="rect">
             <a:avLst/>
@@ -32121,7 +33175,7 @@
                 <a:cs typeface="Instrument Sans"/>
                 <a:sym typeface="Instrument Sans"/>
               </a:rPr>
-              <a:t>驻场工程师、沙箱集群</a:t>
+              <a:t>每个环境卖10次：5家实验室 × 2轮</a:t>
             </a:r>
           </a:p>
         </p:txBody>
@@ -32164,7 +33218,7 @@
         <p:spPr>
           <a:xfrm>
             <a:off x="841248" y="3566160"/>
-            <a:ext cx="868680" cy="329184"/>
+            <a:ext cx="777240" cy="329184"/>
           </a:xfrm>
           <a:prstGeom prst="rect">
             <a:avLst/>
@@ -32212,8 +33266,8 @@
         </p:nvSpPr>
         <p:spPr>
           <a:xfrm>
-            <a:off x="1755648" y="3566160"/>
-            <a:ext cx="1463040" cy="329184"/>
+            <a:off x="1664208" y="3566160"/>
+            <a:ext cx="1143000" cy="329184"/>
           </a:xfrm>
           <a:prstGeom prst="rect">
             <a:avLst/>
@@ -32261,8 +33315,8 @@
         </p:nvSpPr>
         <p:spPr>
           <a:xfrm>
-            <a:off x="3264408" y="3566160"/>
-            <a:ext cx="2400300" cy="329184"/>
+            <a:off x="2852928" y="3566160"/>
+            <a:ext cx="2811780" cy="329184"/>
           </a:xfrm>
           <a:prstGeom prst="rect">
             <a:avLst/>
@@ -32297,7 +33351,7 @@
                 <a:cs typeface="Instrument Sans"/>
                 <a:sym typeface="Instrument Sans"/>
               </a:rPr>
-              <a:t>实验室BD、法务、财务</a:t>
+              <a:t>5家实验室，第2个月首单</a:t>
             </a:r>
           </a:p>
         </p:txBody>
@@ -32561,7 +33615,7 @@
         <p:spPr>
           <a:xfrm>
             <a:off x="841248" y="5065776"/>
-            <a:ext cx="1516380" cy="310896"/>
+            <a:ext cx="1562100" cy="310896"/>
           </a:xfrm>
           <a:prstGeom prst="rect">
             <a:avLst/>
@@ -32587,7 +33641,7 @@
               <a:buNone/>
             </a:pPr>
             <a:r>
-              <a:rPr lang="zh-CN" sz="1250" b="0" i="0" u="none" strike="noStrike" cap="none">
+              <a:rPr lang="zh-CN" sz="1200" b="0" i="0" u="none" strike="noStrike" cap="none">
                 <a:solidFill>
                   <a:srgbClr val="111110"/>
                 </a:solidFill>
@@ -32596,7 +33650,7 @@
                 <a:cs typeface="Newsreader"/>
                 <a:sym typeface="Newsreader"/>
               </a:rPr>
-              <a:t>首个付费实验室</a:t>
+              <a:t>年化2,000万美元</a:t>
             </a:r>
           </a:p>
         </p:txBody>
@@ -32659,7 +33713,7 @@
         <p:spPr>
           <a:xfrm>
             <a:off x="2449068" y="5065776"/>
-            <a:ext cx="1516380" cy="310896"/>
+            <a:ext cx="1562100" cy="310896"/>
           </a:xfrm>
           <a:prstGeom prst="rect">
             <a:avLst/>
@@ -32685,7 +33739,7 @@
               <a:buNone/>
             </a:pPr>
             <a:r>
-              <a:rPr lang="zh-CN" sz="1250" b="0" i="0" u="none" strike="noStrike" cap="none">
+              <a:rPr lang="zh-CN" sz="1200" b="0" i="0" u="none" strike="noStrike" cap="none">
                 <a:solidFill>
                   <a:srgbClr val="111110"/>
                 </a:solidFill>
@@ -32757,7 +33811,7 @@
         <p:spPr>
           <a:xfrm>
             <a:off x="4056888" y="5065776"/>
-            <a:ext cx="1516380" cy="310896"/>
+            <a:ext cx="1562100" cy="310896"/>
           </a:xfrm>
           <a:prstGeom prst="rect">
             <a:avLst/>
@@ -32783,7 +33837,7 @@
               <a:buNone/>
             </a:pPr>
             <a:r>
-              <a:rPr lang="zh-CN" sz="1250" b="0" i="0" u="none" strike="noStrike" cap="none">
+              <a:rPr lang="zh-CN" sz="1200" b="0" i="0" u="none" strike="noStrike" cap="none">
                 <a:solidFill>
                   <a:srgbClr val="111110"/>
                 </a:solidFill>
@@ -32870,7 +33924,7 @@
                 <a:cs typeface="IBM Plex Mono"/>
                 <a:sym typeface="IBM Plex Mono"/>
               </a:rPr>
-              <a:t>02  RSI引擎</a:t>
+              <a:t>02  RSI引擎  ·  投入1,000万美元</a:t>
             </a:r>
           </a:p>
         </p:txBody>
@@ -32912,14 +33966,14 @@
             <a:r>
               <a:rPr lang="zh-CN" sz="3000" b="0" i="0" u="none" strike="noStrike" cap="none">
                 <a:solidFill>
-                  <a:srgbClr val="FAF9F6"/>
+                  <a:srgbClr val="E27A3F"/>
                 </a:solidFill>
                 <a:latin typeface="Newsreader"/>
                 <a:ea typeface="Newsreader"/>
                 <a:cs typeface="Newsreader"/>
                 <a:sym typeface="Newsreader"/>
               </a:rPr>
-              <a:t>1,000万美元</a:t>
+              <a:t>7万亿美元</a:t>
             </a:r>
           </a:p>
         </p:txBody>
@@ -32968,7 +34022,7 @@
                 <a:cs typeface="Instrument Sans"/>
                 <a:sym typeface="Instrument Sans"/>
               </a:rPr>
-              <a:t>研发自我进化：让AI在真实世界里，用真实结果训练自己</a:t>
+              <a:t>瞄准2030年整个AI经济：每个行业，一个自己变强的AI</a:t>
             </a:r>
           </a:p>
         </p:txBody>
@@ -33011,7 +34065,7 @@
         <p:spPr>
           <a:xfrm>
             <a:off x="6524244" y="2907792"/>
-            <a:ext cx="868680" cy="329184"/>
+            <a:ext cx="777240" cy="329184"/>
           </a:xfrm>
           <a:prstGeom prst="rect">
             <a:avLst/>
@@ -33059,8 +34113,8 @@
         </p:nvSpPr>
         <p:spPr>
           <a:xfrm>
-            <a:off x="7438644" y="2907792"/>
-            <a:ext cx="1463040" cy="329184"/>
+            <a:off x="7347204" y="2907792"/>
+            <a:ext cx="1143000" cy="329184"/>
           </a:xfrm>
           <a:prstGeom prst="rect">
             <a:avLst/>
@@ -33108,8 +34162,8 @@
         </p:nvSpPr>
         <p:spPr>
           <a:xfrm>
-            <a:off x="8947404" y="2907792"/>
-            <a:ext cx="2400300" cy="329184"/>
+            <a:off x="8535924" y="2907792"/>
+            <a:ext cx="2811780" cy="329184"/>
           </a:xfrm>
           <a:prstGeom prst="rect">
             <a:avLst/>
@@ -33144,7 +34198,7 @@
                 <a:cs typeface="Instrument Sans"/>
                 <a:sym typeface="Instrument Sans"/>
               </a:rPr>
-              <a:t>自我进化训练与评测</a:t>
+              <a:t>模型自己训练自己，一轮比一轮强</a:t>
             </a:r>
           </a:p>
         </p:txBody>
@@ -33187,7 +34241,7 @@
         <p:spPr>
           <a:xfrm>
             <a:off x="6524244" y="3236976"/>
-            <a:ext cx="868680" cy="329184"/>
+            <a:ext cx="777240" cy="329184"/>
           </a:xfrm>
           <a:prstGeom prst="rect">
             <a:avLst/>
@@ -33235,8 +34289,8 @@
         </p:nvSpPr>
         <p:spPr>
           <a:xfrm>
-            <a:off x="7438644" y="3236976"/>
-            <a:ext cx="1463040" cy="329184"/>
+            <a:off x="7347204" y="3236976"/>
+            <a:ext cx="1143000" cy="329184"/>
           </a:xfrm>
           <a:prstGeom prst="rect">
             <a:avLst/>
@@ -33284,8 +34338,8 @@
         </p:nvSpPr>
         <p:spPr>
           <a:xfrm>
-            <a:off x="8947404" y="3236976"/>
-            <a:ext cx="2400300" cy="329184"/>
+            <a:off x="8535924" y="3236976"/>
+            <a:ext cx="2811780" cy="329184"/>
           </a:xfrm>
           <a:prstGeom prst="rect">
             <a:avLst/>
@@ -33320,7 +34374,7 @@
                 <a:cs typeface="Instrument Sans"/>
                 <a:sym typeface="Instrument Sans"/>
               </a:rPr>
-              <a:t>RL研究员、量化研究员</a:t>
+              <a:t>从交易走向10个行业</a:t>
             </a:r>
           </a:p>
         </p:txBody>
@@ -33363,7 +34417,7 @@
         <p:spPr>
           <a:xfrm>
             <a:off x="6524244" y="3566160"/>
-            <a:ext cx="868680" cy="329184"/>
+            <a:ext cx="777240" cy="329184"/>
           </a:xfrm>
           <a:prstGeom prst="rect">
             <a:avLst/>
@@ -33411,8 +34465,8 @@
         </p:nvSpPr>
         <p:spPr>
           <a:xfrm>
-            <a:off x="7438644" y="3566160"/>
-            <a:ext cx="1463040" cy="329184"/>
+            <a:off x="7347204" y="3566160"/>
+            <a:ext cx="1143000" cy="329184"/>
           </a:xfrm>
           <a:prstGeom prst="rect">
             <a:avLst/>
@@ -33460,8 +34514,8 @@
         </p:nvSpPr>
         <p:spPr>
           <a:xfrm>
-            <a:off x="8947404" y="3566160"/>
-            <a:ext cx="2400300" cy="329184"/>
+            <a:off x="8535924" y="3566160"/>
+            <a:ext cx="2811780" cy="329184"/>
           </a:xfrm>
           <a:prstGeom prst="rect">
             <a:avLst/>
@@ -33496,7 +34550,7 @@
                 <a:cs typeface="Instrument Sans"/>
                 <a:sym typeface="Instrument Sans"/>
               </a:rPr>
-              <a:t>交易账户、行情数据、合规</a:t>
+              <a:t>真实资金、真实市场、真实结算</a:t>
             </a:r>
           </a:p>
         </p:txBody>
@@ -33621,7 +34675,7 @@
                 <a:cs typeface="Instrument Sans"/>
                 <a:sym typeface="Instrument Sans"/>
               </a:rPr>
-              <a:t>AI对真实事件下判断，揭晓即结算、即训练</a:t>
+              <a:t>AI对全世界的真实事件下判断，揭晓即进化</a:t>
             </a:r>
           </a:p>
           <a:p>
@@ -33644,7 +34698,7 @@
                 <a:cs typeface="Instrument Sans"/>
                 <a:sym typeface="Instrument Sans"/>
               </a:rPr>
-              <a:t>同步开发  </a:t>
+              <a:t>10个行业  </a:t>
             </a:r>
             <a:r>
               <a:rPr lang="zh-CN" sz="1100" b="0" i="0" u="none" strike="noStrike" cap="none">
@@ -33656,7 +34710,7 @@
                 <a:cs typeface="Instrument Sans"/>
                 <a:sym typeface="Instrument Sans"/>
               </a:rPr>
-              <a:t>财务、软件工程、法律、医疗等10个行业的自我进化环境</a:t>
+              <a:t>财务、软件工程、法律、医疗……同步开发自我进化环境</a:t>
             </a:r>
           </a:p>
         </p:txBody>
@@ -33748,7 +34802,7 @@
         <p:spPr>
           <a:xfrm>
             <a:off x="6524244" y="5065776"/>
-            <a:ext cx="1516380" cy="310896"/>
+            <a:ext cx="1562100" cy="310896"/>
           </a:xfrm>
           <a:prstGeom prst="rect">
             <a:avLst/>
@@ -33774,7 +34828,7 @@
               <a:buNone/>
             </a:pPr>
             <a:r>
-              <a:rPr lang="zh-CN" sz="1250" b="0" i="0" u="none" strike="noStrike" cap="none">
+              <a:rPr lang="zh-CN" sz="1200" b="0" i="0" u="none" strike="noStrike" cap="none">
                 <a:solidFill>
                   <a:srgbClr val="FAF9F6"/>
                 </a:solidFill>
@@ -33846,7 +34900,7 @@
         <p:spPr>
           <a:xfrm>
             <a:off x="8132064" y="5065776"/>
-            <a:ext cx="1516380" cy="310896"/>
+            <a:ext cx="1562100" cy="310896"/>
           </a:xfrm>
           <a:prstGeom prst="rect">
             <a:avLst/>
@@ -33872,7 +34926,7 @@
               <a:buNone/>
             </a:pPr>
             <a:r>
-              <a:rPr lang="zh-CN" sz="1250" b="0" i="0" u="none" strike="noStrike" cap="none">
+              <a:rPr lang="zh-CN" sz="1200" b="0" i="0" u="none" strike="noStrike" cap="none">
                 <a:solidFill>
                   <a:srgbClr val="FAF9F6"/>
                 </a:solidFill>
@@ -33944,7 +34998,7 @@
         <p:spPr>
           <a:xfrm>
             <a:off x="9739884" y="5065776"/>
-            <a:ext cx="1516380" cy="310896"/>
+            <a:ext cx="1562100" cy="310896"/>
           </a:xfrm>
           <a:prstGeom prst="rect">
             <a:avLst/>
@@ -33970,7 +35024,7 @@
               <a:buNone/>
             </a:pPr>
             <a:r>
-              <a:rPr lang="zh-CN" sz="1250" b="0" i="0" u="none" strike="noStrike" cap="none">
+              <a:rPr lang="zh-CN" sz="1200" b="0" i="0" u="none" strike="noStrike" cap="none">
                 <a:solidFill>
                   <a:srgbClr val="FAF9F6"/>
                 </a:solidFill>
@@ -33992,7 +35046,7 @@
         </p:nvSpPr>
         <p:spPr>
           <a:xfrm>
-            <a:off x="548640" y="5596128"/>
+            <a:off x="548640" y="5541264"/>
             <a:ext cx="11091672" cy="365760"/>
           </a:xfrm>
           <a:prstGeom prst="rect">
@@ -34053,8 +35107,8 @@
         </p:nvSpPr>
         <p:spPr>
           <a:xfrm>
-            <a:off x="548640" y="6053328"/>
-            <a:ext cx="11091672" cy="201168"/>
+            <a:off x="548640" y="5961888"/>
+            <a:ext cx="11091672" cy="365760"/>
           </a:xfrm>
           <a:prstGeom prst="rect">
             <a:avLst/>
@@ -34071,6 +35125,9 @@
           <a:lstStyle/>
           <a:p>
             <a:pPr marL="0" marR="0" lvl="0" indent="0" algn="l" rtl="0">
+              <a:lnSpc>
+                <a:spcPct val="110000"/>
+              </a:lnSpc>
               <a:spcBef>
                 <a:spcPts val="0"/>
               </a:spcBef>
@@ -34089,7 +35146,33 @@
                 <a:cs typeface="Instrument Sans"/>
                 <a:sym typeface="Instrument Sans"/>
               </a:rPr>
-              <a:t>卖出次数 = 实验室数 × 每年2轮迭代（6个月5家，12个月6家）；单价区间2万–30万美元（Epoch AI）。</a:t>
+              <a:t>卖出次数 = 实验室数 × 每年2轮迭代（3个月2家、25个环境，6个月5家，12个月6家）；单价区间2万–30万美元（Epoch AI）。</a:t>
+            </a:r>
+          </a:p>
+          <a:p>
+            <a:pPr marL="0" marR="0" lvl="0" indent="0" algn="l" rtl="0">
+              <a:lnSpc>
+                <a:spcPct val="110000"/>
+              </a:lnSpc>
+              <a:spcBef>
+                <a:spcPts val="0"/>
+              </a:spcBef>
+              <a:spcAft>
+                <a:spcPts val="0"/>
+              </a:spcAft>
+              <a:buNone/>
+            </a:pPr>
+            <a:r>
+              <a:rPr lang="zh-CN" sz="850" b="0" i="0" u="none" strike="noStrike" cap="none">
+                <a:solidFill>
+                  <a:srgbClr val="6E6C66"/>
+                </a:solidFill>
+                <a:latin typeface="Instrument Sans"/>
+                <a:ea typeface="Instrument Sans"/>
+                <a:cs typeface="Instrument Sans"/>
+                <a:sym typeface="Instrument Sans"/>
+              </a:rPr>
+              <a:t>毛利率约80%为测算：环境一次搭建、反复卖出；按人头卖数据的公司，专家拿走收入的60–70%（彭博）。7万亿美元推算见第14页。</a:t>
             </a:r>
           </a:p>
         </p:txBody>

</xml_diff>

<commit_message>
BP v17: industry coverage, expert-network depth, China peers
- Page 10: fifth proof row - cover every industry's entry-level roles
  quickly and cheaply.
- Page 13: expert network covers entry roles in every industry and top
  research, and keeps deepening.
- Page 15: add UniPat and Humanlaya as the China peers, a line on the
  China market today, and sharpen the independence point.
- A3: sources for the China market line.

Co-Authored-By: Claude Opus 5.5 <noreply@anthropic.com>
Claude-Session: https://claude.ai/code/session_01EKqGwTA92C8Wo4e47t73NN
</commit_message>
<xml_diff>
--- a/SimReal-BP-v17.pptx
+++ b/SimReal-BP-v17.pptx
@@ -7438,7 +7438,7 @@
         <p:spPr>
           <a:xfrm>
             <a:off x="4754880" y="1737360"/>
-            <a:ext cx="457200" cy="585216"/>
+            <a:ext cx="457200" cy="468173"/>
           </a:xfrm>
           <a:prstGeom prst="rect">
             <a:avLst/>
@@ -7487,7 +7487,7 @@
         <p:spPr>
           <a:xfrm>
             <a:off x="5257800" y="1737360"/>
-            <a:ext cx="1600200" cy="585216"/>
+            <a:ext cx="1600200" cy="468173"/>
           </a:xfrm>
           <a:prstGeom prst="rect">
             <a:avLst/>
@@ -7536,7 +7536,7 @@
         <p:spPr>
           <a:xfrm>
             <a:off x="6903720" y="1737360"/>
-            <a:ext cx="4736592" cy="585216"/>
+            <a:ext cx="4736592" cy="468173"/>
           </a:xfrm>
           <a:prstGeom prst="rect">
             <a:avLst/>
@@ -7587,7 +7587,7 @@
         </p:nvSpPr>
         <p:spPr>
           <a:xfrm>
-            <a:off x="4754880" y="2322576"/>
+            <a:off x="4754880" y="2205533"/>
             <a:ext cx="6885432" cy="9144"/>
           </a:xfrm>
           <a:prstGeom prst="rect">
@@ -7616,8 +7616,8 @@
         </p:nvSpPr>
         <p:spPr>
           <a:xfrm>
-            <a:off x="4754880" y="2322576"/>
-            <a:ext cx="457200" cy="585216"/>
+            <a:off x="4754880" y="2205533"/>
+            <a:ext cx="457200" cy="468173"/>
           </a:xfrm>
           <a:prstGeom prst="rect">
             <a:avLst/>
@@ -7665,8 +7665,8 @@
         </p:nvSpPr>
         <p:spPr>
           <a:xfrm>
-            <a:off x="5257800" y="2322576"/>
-            <a:ext cx="1600200" cy="585216"/>
+            <a:off x="5257800" y="2205533"/>
+            <a:ext cx="1600200" cy="468173"/>
           </a:xfrm>
           <a:prstGeom prst="rect">
             <a:avLst/>
@@ -7714,8 +7714,8 @@
         </p:nvSpPr>
         <p:spPr>
           <a:xfrm>
-            <a:off x="6903720" y="2322576"/>
-            <a:ext cx="4736592" cy="585216"/>
+            <a:off x="6903720" y="2205533"/>
+            <a:ext cx="4736592" cy="468173"/>
           </a:xfrm>
           <a:prstGeom prst="rect">
             <a:avLst/>
@@ -7766,7 +7766,7 @@
         </p:nvSpPr>
         <p:spPr>
           <a:xfrm>
-            <a:off x="4754880" y="2907792"/>
+            <a:off x="4754880" y="2673706"/>
             <a:ext cx="6885432" cy="9144"/>
           </a:xfrm>
           <a:prstGeom prst="rect">
@@ -7795,8 +7795,8 @@
         </p:nvSpPr>
         <p:spPr>
           <a:xfrm>
-            <a:off x="4754880" y="2907792"/>
-            <a:ext cx="457200" cy="585216"/>
+            <a:off x="4754880" y="2673706"/>
+            <a:ext cx="457200" cy="468173"/>
           </a:xfrm>
           <a:prstGeom prst="rect">
             <a:avLst/>
@@ -7844,8 +7844,8 @@
         </p:nvSpPr>
         <p:spPr>
           <a:xfrm>
-            <a:off x="5257800" y="2907792"/>
-            <a:ext cx="1600200" cy="585216"/>
+            <a:off x="5257800" y="2673706"/>
+            <a:ext cx="1600200" cy="468173"/>
           </a:xfrm>
           <a:prstGeom prst="rect">
             <a:avLst/>
@@ -7880,7 +7880,7 @@
                 <a:cs typeface="Newsreader"/>
                 <a:sym typeface="Newsreader"/>
               </a:rPr>
-              <a:t>市场验证</a:t>
+              <a:t>行业覆盖</a:t>
             </a:r>
           </a:p>
         </p:txBody>
@@ -7893,8 +7893,8 @@
         </p:nvSpPr>
         <p:spPr>
           <a:xfrm>
-            <a:off x="6903720" y="2907792"/>
-            <a:ext cx="4736592" cy="585216"/>
+            <a:off x="6903720" y="2673706"/>
+            <a:ext cx="4736592" cy="468173"/>
           </a:xfrm>
           <a:prstGeom prst="rect">
             <a:avLst/>
@@ -7932,7 +7932,7 @@
                 <a:cs typeface="Instrument Sans"/>
                 <a:sym typeface="Instrument Sans"/>
               </a:rPr>
-              <a:t>首周GitHub 500+星标、7,000+专家候补、2家前沿实验室在谈</a:t>
+              <a:t>每个行业的入门岗位，AI最先接手：我们能快速、低成本覆盖</a:t>
             </a:r>
           </a:p>
         </p:txBody>
@@ -7945,7 +7945,7 @@
         </p:nvSpPr>
         <p:spPr>
           <a:xfrm>
-            <a:off x="4754880" y="3493008"/>
+            <a:off x="4754880" y="3141878"/>
             <a:ext cx="6885432" cy="9144"/>
           </a:xfrm>
           <a:prstGeom prst="rect">
@@ -7974,8 +7974,8 @@
         </p:nvSpPr>
         <p:spPr>
           <a:xfrm>
-            <a:off x="4754880" y="3493008"/>
-            <a:ext cx="457200" cy="585216"/>
+            <a:off x="4754880" y="3141878"/>
+            <a:ext cx="457200" cy="468173"/>
           </a:xfrm>
           <a:prstGeom prst="rect">
             <a:avLst/>
@@ -8023,8 +8023,8 @@
         </p:nvSpPr>
         <p:spPr>
           <a:xfrm>
-            <a:off x="5257800" y="3493008"/>
-            <a:ext cx="1600200" cy="585216"/>
+            <a:off x="5257800" y="3141878"/>
+            <a:ext cx="1600200" cy="468173"/>
           </a:xfrm>
           <a:prstGeom prst="rect">
             <a:avLst/>
@@ -8059,7 +8059,7 @@
                 <a:cs typeface="Newsreader"/>
                 <a:sym typeface="Newsreader"/>
               </a:rPr>
-              <a:t>过往战绩</a:t>
+              <a:t>市场验证</a:t>
             </a:r>
           </a:p>
         </p:txBody>
@@ -8072,8 +8072,8 @@
         </p:nvSpPr>
         <p:spPr>
           <a:xfrm>
-            <a:off x="6903720" y="3493008"/>
-            <a:ext cx="4736592" cy="585216"/>
+            <a:off x="6903720" y="3141878"/>
+            <a:ext cx="4736592" cy="468173"/>
           </a:xfrm>
           <a:prstGeom prst="rect">
             <a:avLst/>
@@ -8111,7 +8111,7 @@
                 <a:cs typeface="Instrument Sans"/>
                 <a:sym typeface="Instrument Sans"/>
               </a:rPr>
-              <a:t>U稳定币0→14亿美元、一个月上线Binance；五家顶级量化机构经历</a:t>
+              <a:t>首周GitHub 500+星标、7,000+专家候补、2家前沿实验室在谈</a:t>
             </a:r>
           </a:p>
         </p:txBody>
@@ -8124,7 +8124,7 @@
         </p:nvSpPr>
         <p:spPr>
           <a:xfrm>
-            <a:off x="4754880" y="4078224"/>
+            <a:off x="4754880" y="3610051"/>
             <a:ext cx="6885432" cy="9144"/>
           </a:xfrm>
           <a:prstGeom prst="rect">
@@ -8153,19 +8153,19 @@
         </p:nvSpPr>
         <p:spPr>
           <a:xfrm>
-            <a:off x="548640" y="4334256"/>
-            <a:ext cx="7315200" cy="201168"/>
-          </a:xfrm>
-          <a:prstGeom prst="rect">
-            <a:avLst/>
-          </a:prstGeom>
-          <a:noFill/>
-          <a:ln>
-            <a:noFill/>
-          </a:ln>
-        </p:spPr>
-        <p:txBody>
-          <a:bodyPr spcFirstLastPara="1" wrap="square" lIns="0" tIns="0" rIns="0" bIns="0" anchor="t" anchorCtr="0">
+            <a:off x="4754880" y="3610051"/>
+            <a:ext cx="457200" cy="468173"/>
+          </a:xfrm>
+          <a:prstGeom prst="rect">
+            <a:avLst/>
+          </a:prstGeom>
+          <a:noFill/>
+          <a:ln>
+            <a:noFill/>
+          </a:ln>
+        </p:spPr>
+        <p:txBody>
+          <a:bodyPr spcFirstLastPara="1" wrap="square" lIns="0" tIns="0" rIns="0" bIns="0" anchor="ctr" anchorCtr="0">
             <a:noAutofit/>
           </a:bodyPr>
           <a:lstStyle/>
@@ -8182,14 +8182,14 @@
             <a:r>
               <a:rPr lang="zh-CN" sz="1000" b="0" i="0" u="none" strike="noStrike" cap="none">
                 <a:solidFill>
-                  <a:srgbClr val="6E6C66"/>
+                  <a:srgbClr val="C2410C"/>
                 </a:solidFill>
                 <a:latin typeface="IBM Plex Mono"/>
                 <a:ea typeface="IBM Plex Mono"/>
                 <a:cs typeface="IBM Plex Mono"/>
                 <a:sym typeface="IBM Plex Mono"/>
               </a:rPr>
-              <a:t>AI的热点一直在变</a:t>
+              <a:t>05</a:t>
             </a:r>
           </a:p>
         </p:txBody>
@@ -8197,42 +8197,13 @@
       <p:sp>
         <p:nvSpPr>
           <p:cNvPr id="3028" name="SimReal 3028"/>
-          <p:cNvSpPr/>
-          <p:nvPr/>
-        </p:nvSpPr>
-        <p:spPr>
-          <a:xfrm>
-            <a:off x="548640" y="4572000"/>
-            <a:ext cx="2464308" cy="603504"/>
-          </a:xfrm>
-          <a:prstGeom prst="rect">
-            <a:avLst/>
-          </a:prstGeom>
-          <a:solidFill>
-            <a:srgbClr val="F2F1EC"/>
-          </a:solidFill>
-          <a:ln>
-            <a:noFill/>
-          </a:ln>
-        </p:spPr>
-        <p:txBody>
-          <a:bodyPr/>
-          <a:lstStyle/>
-          <a:p>
-            <a:endParaRPr/>
-          </a:p>
-        </p:txBody>
-      </p:sp>
-      <p:sp>
-        <p:nvSpPr>
-          <p:cNvPr id="3029" name="SimReal 3029"/>
-          <p:cNvSpPr txBox="1"/>
-          <p:nvPr/>
-        </p:nvSpPr>
-        <p:spPr>
-          <a:xfrm>
-            <a:off x="768096" y="4572000"/>
-            <a:ext cx="1280160" cy="603504"/>
+          <p:cNvSpPr txBox="1"/>
+          <p:nvPr/>
+        </p:nvSpPr>
+        <p:spPr>
+          <a:xfrm>
+            <a:off x="5257800" y="3610051"/>
+            <a:ext cx="1600200" cy="468173"/>
           </a:xfrm>
           <a:prstGeom prst="rect">
             <a:avLst/>
@@ -8258,7 +8229,7 @@
               <a:buNone/>
             </a:pPr>
             <a:r>
-              <a:rPr lang="zh-CN" sz="1500" b="0" i="0" u="none" strike="noStrike" cap="none">
+              <a:rPr lang="zh-CN" sz="1700" b="0" i="0" u="none" strike="noStrike" cap="none">
                 <a:solidFill>
                   <a:srgbClr val="111110"/>
                 </a:solidFill>
@@ -8267,7 +8238,59 @@
                 <a:cs typeface="Newsreader"/>
                 <a:sym typeface="Newsreader"/>
               </a:rPr>
-              <a:t>数据标注</a:t>
+              <a:t>过往战绩</a:t>
+            </a:r>
+          </a:p>
+        </p:txBody>
+      </p:sp>
+      <p:sp>
+        <p:nvSpPr>
+          <p:cNvPr id="3029" name="SimReal 3029"/>
+          <p:cNvSpPr txBox="1"/>
+          <p:nvPr/>
+        </p:nvSpPr>
+        <p:spPr>
+          <a:xfrm>
+            <a:off x="6903720" y="3610051"/>
+            <a:ext cx="4736592" cy="468173"/>
+          </a:xfrm>
+          <a:prstGeom prst="rect">
+            <a:avLst/>
+          </a:prstGeom>
+          <a:noFill/>
+          <a:ln>
+            <a:noFill/>
+          </a:ln>
+        </p:spPr>
+        <p:txBody>
+          <a:bodyPr spcFirstLastPara="1" wrap="square" lIns="0" tIns="0" rIns="0" bIns="0" anchor="ctr" anchorCtr="0">
+            <a:noAutofit/>
+          </a:bodyPr>
+          <a:lstStyle/>
+          <a:p>
+            <a:pPr marL="0" marR="0" lvl="0" indent="0" algn="l" rtl="0">
+              <a:lnSpc>
+                <a:spcPct val="110000"/>
+              </a:lnSpc>
+              <a:spcBef>
+                <a:spcPts val="0"/>
+              </a:spcBef>
+              <a:spcAft>
+                <a:spcPts val="0"/>
+              </a:spcAft>
+              <a:buNone/>
+            </a:pPr>
+            <a:r>
+              <a:rPr lang="zh-CN" sz="1100" b="0" i="0" u="none" strike="noStrike" cap="none">
+                <a:solidFill>
+                  <a:srgbClr val="6E6C66"/>
+                </a:solidFill>
+                <a:latin typeface="Instrument Sans"/>
+                <a:ea typeface="Instrument Sans"/>
+                <a:cs typeface="Instrument Sans"/>
+                <a:sym typeface="Instrument Sans"/>
+              </a:rPr>
+              <a:t>U稳定币0→14亿美元、一个月上线Binance；五家顶级量化机构经历</a:t>
             </a:r>
           </a:p>
         </p:txBody>
@@ -8275,29 +8298,58 @@
       <p:sp>
         <p:nvSpPr>
           <p:cNvPr id="3030" name="SimReal 3030"/>
-          <p:cNvSpPr txBox="1"/>
-          <p:nvPr/>
-        </p:nvSpPr>
-        <p:spPr>
-          <a:xfrm>
-            <a:off x="1920240" y="4572000"/>
-            <a:ext cx="891540" cy="603504"/>
-          </a:xfrm>
-          <a:prstGeom prst="rect">
-            <a:avLst/>
-          </a:prstGeom>
-          <a:noFill/>
-          <a:ln>
-            <a:noFill/>
-          </a:ln>
-        </p:spPr>
-        <p:txBody>
-          <a:bodyPr spcFirstLastPara="1" wrap="square" lIns="0" tIns="0" rIns="0" bIns="0" anchor="ctr" anchorCtr="0">
-            <a:noAutofit/>
-          </a:bodyPr>
-          <a:lstStyle/>
-          <a:p>
-            <a:pPr marL="0" marR="0" lvl="0" indent="0" algn="r" rtl="0">
+          <p:cNvSpPr/>
+          <p:nvPr/>
+        </p:nvSpPr>
+        <p:spPr>
+          <a:xfrm>
+            <a:off x="4754880" y="4078224"/>
+            <a:ext cx="6885432" cy="9144"/>
+          </a:xfrm>
+          <a:prstGeom prst="rect">
+            <a:avLst/>
+          </a:prstGeom>
+          <a:solidFill>
+            <a:srgbClr val="E2E0DA"/>
+          </a:solidFill>
+          <a:ln>
+            <a:noFill/>
+          </a:ln>
+        </p:spPr>
+        <p:txBody>
+          <a:bodyPr/>
+          <a:lstStyle/>
+          <a:p>
+            <a:endParaRPr/>
+          </a:p>
+        </p:txBody>
+      </p:sp>
+      <p:sp>
+        <p:nvSpPr>
+          <p:cNvPr id="3031" name="SimReal 3031"/>
+          <p:cNvSpPr txBox="1"/>
+          <p:nvPr/>
+        </p:nvSpPr>
+        <p:spPr>
+          <a:xfrm>
+            <a:off x="548640" y="4334256"/>
+            <a:ext cx="7315200" cy="201168"/>
+          </a:xfrm>
+          <a:prstGeom prst="rect">
+            <a:avLst/>
+          </a:prstGeom>
+          <a:noFill/>
+          <a:ln>
+            <a:noFill/>
+          </a:ln>
+        </p:spPr>
+        <p:txBody>
+          <a:bodyPr spcFirstLastPara="1" wrap="square" lIns="0" tIns="0" rIns="0" bIns="0" anchor="t" anchorCtr="0">
+            <a:noAutofit/>
+          </a:bodyPr>
+          <a:lstStyle/>
+          <a:p>
+            <a:pPr marL="0" marR="0" lvl="0" indent="0" algn="l" rtl="0">
               <a:spcBef>
                 <a:spcPts val="0"/>
               </a:spcBef>
@@ -8316,6 +8368,133 @@
                 <a:cs typeface="IBM Plex Mono"/>
                 <a:sym typeface="IBM Plex Mono"/>
               </a:rPr>
+              <a:t>AI的热点一直在变</a:t>
+            </a:r>
+          </a:p>
+        </p:txBody>
+      </p:sp>
+      <p:sp>
+        <p:nvSpPr>
+          <p:cNvPr id="3032" name="SimReal 3032"/>
+          <p:cNvSpPr/>
+          <p:nvPr/>
+        </p:nvSpPr>
+        <p:spPr>
+          <a:xfrm>
+            <a:off x="548640" y="4572000"/>
+            <a:ext cx="2464308" cy="603504"/>
+          </a:xfrm>
+          <a:prstGeom prst="rect">
+            <a:avLst/>
+          </a:prstGeom>
+          <a:solidFill>
+            <a:srgbClr val="F2F1EC"/>
+          </a:solidFill>
+          <a:ln>
+            <a:noFill/>
+          </a:ln>
+        </p:spPr>
+        <p:txBody>
+          <a:bodyPr/>
+          <a:lstStyle/>
+          <a:p>
+            <a:endParaRPr/>
+          </a:p>
+        </p:txBody>
+      </p:sp>
+      <p:sp>
+        <p:nvSpPr>
+          <p:cNvPr id="3033" name="SimReal 3033"/>
+          <p:cNvSpPr txBox="1"/>
+          <p:nvPr/>
+        </p:nvSpPr>
+        <p:spPr>
+          <a:xfrm>
+            <a:off x="768096" y="4572000"/>
+            <a:ext cx="1280160" cy="603504"/>
+          </a:xfrm>
+          <a:prstGeom prst="rect">
+            <a:avLst/>
+          </a:prstGeom>
+          <a:noFill/>
+          <a:ln>
+            <a:noFill/>
+          </a:ln>
+        </p:spPr>
+        <p:txBody>
+          <a:bodyPr spcFirstLastPara="1" wrap="square" lIns="0" tIns="0" rIns="0" bIns="0" anchor="ctr" anchorCtr="0">
+            <a:noAutofit/>
+          </a:bodyPr>
+          <a:lstStyle/>
+          <a:p>
+            <a:pPr marL="0" marR="0" lvl="0" indent="0" algn="l" rtl="0">
+              <a:spcBef>
+                <a:spcPts val="0"/>
+              </a:spcBef>
+              <a:spcAft>
+                <a:spcPts val="0"/>
+              </a:spcAft>
+              <a:buNone/>
+            </a:pPr>
+            <a:r>
+              <a:rPr lang="zh-CN" sz="1500" b="0" i="0" u="none" strike="noStrike" cap="none">
+                <a:solidFill>
+                  <a:srgbClr val="111110"/>
+                </a:solidFill>
+                <a:latin typeface="Newsreader"/>
+                <a:ea typeface="Newsreader"/>
+                <a:cs typeface="Newsreader"/>
+                <a:sym typeface="Newsreader"/>
+              </a:rPr>
+              <a:t>数据标注</a:t>
+            </a:r>
+          </a:p>
+        </p:txBody>
+      </p:sp>
+      <p:sp>
+        <p:nvSpPr>
+          <p:cNvPr id="3034" name="SimReal 3034"/>
+          <p:cNvSpPr txBox="1"/>
+          <p:nvPr/>
+        </p:nvSpPr>
+        <p:spPr>
+          <a:xfrm>
+            <a:off x="1920240" y="4572000"/>
+            <a:ext cx="891540" cy="603504"/>
+          </a:xfrm>
+          <a:prstGeom prst="rect">
+            <a:avLst/>
+          </a:prstGeom>
+          <a:noFill/>
+          <a:ln>
+            <a:noFill/>
+          </a:ln>
+        </p:spPr>
+        <p:txBody>
+          <a:bodyPr spcFirstLastPara="1" wrap="square" lIns="0" tIns="0" rIns="0" bIns="0" anchor="ctr" anchorCtr="0">
+            <a:noAutofit/>
+          </a:bodyPr>
+          <a:lstStyle/>
+          <a:p>
+            <a:pPr marL="0" marR="0" lvl="0" indent="0" algn="r" rtl="0">
+              <a:spcBef>
+                <a:spcPts val="0"/>
+              </a:spcBef>
+              <a:spcAft>
+                <a:spcPts val="0"/>
+              </a:spcAft>
+              <a:buNone/>
+            </a:pPr>
+            <a:r>
+              <a:rPr lang="zh-CN" sz="1000" b="0" i="0" u="none" strike="noStrike" cap="none">
+                <a:solidFill>
+                  <a:srgbClr val="6E6C66"/>
+                </a:solidFill>
+                <a:latin typeface="IBM Plex Mono"/>
+                <a:ea typeface="IBM Plex Mono"/>
+                <a:cs typeface="IBM Plex Mono"/>
+                <a:sym typeface="IBM Plex Mono"/>
+              </a:rPr>
               <a:t>Scale AI</a:t>
             </a:r>
           </a:p>
@@ -8323,7 +8502,7 @@
       </p:sp>
       <p:sp>
         <p:nvSpPr>
-          <p:cNvPr id="3031" name="SimReal 3031"/>
+          <p:cNvPr id="3035" name="SimReal 3035"/>
           <p:cNvSpPr txBox="1"/>
           <p:nvPr/>
         </p:nvSpPr>
@@ -8372,7 +8551,7 @@
       </p:sp>
       <p:sp>
         <p:nvSpPr>
-          <p:cNvPr id="3032" name="SimReal 3032"/>
+          <p:cNvPr id="3036" name="SimReal 3036"/>
           <p:cNvSpPr/>
           <p:nvPr/>
         </p:nvSpPr>
@@ -8401,7 +8580,7 @@
       </p:sp>
       <p:sp>
         <p:nvSpPr>
-          <p:cNvPr id="3033" name="SimReal 3033"/>
+          <p:cNvPr id="3037" name="SimReal 3037"/>
           <p:cNvSpPr txBox="1"/>
           <p:nvPr/>
         </p:nvSpPr>
@@ -8450,7 +8629,7 @@
       </p:sp>
       <p:sp>
         <p:nvSpPr>
-          <p:cNvPr id="3034" name="SimReal 3034"/>
+          <p:cNvPr id="3038" name="SimReal 3038"/>
           <p:cNvSpPr txBox="1"/>
           <p:nvPr/>
         </p:nvSpPr>
@@ -8499,7 +8678,7 @@
       </p:sp>
       <p:sp>
         <p:nvSpPr>
-          <p:cNvPr id="3035" name="SimReal 3035"/>
+          <p:cNvPr id="3039" name="SimReal 3039"/>
           <p:cNvSpPr txBox="1"/>
           <p:nvPr/>
         </p:nvSpPr>
@@ -8548,7 +8727,7 @@
       </p:sp>
       <p:sp>
         <p:nvSpPr>
-          <p:cNvPr id="3036" name="SimReal 3036"/>
+          <p:cNvPr id="3040" name="SimReal 3040"/>
           <p:cNvSpPr/>
           <p:nvPr/>
         </p:nvSpPr>
@@ -8577,7 +8756,7 @@
       </p:sp>
       <p:sp>
         <p:nvSpPr>
-          <p:cNvPr id="3037" name="SimReal 3037"/>
+          <p:cNvPr id="3041" name="SimReal 3041"/>
           <p:cNvSpPr txBox="1"/>
           <p:nvPr/>
         </p:nvSpPr>
@@ -8626,7 +8805,7 @@
       </p:sp>
       <p:sp>
         <p:nvSpPr>
-          <p:cNvPr id="3038" name="SimReal 3038"/>
+          <p:cNvPr id="3042" name="SimReal 3042"/>
           <p:cNvSpPr txBox="1"/>
           <p:nvPr/>
         </p:nvSpPr>
@@ -8675,7 +8854,7 @@
       </p:sp>
       <p:sp>
         <p:nvSpPr>
-          <p:cNvPr id="3039" name="SimReal 3039"/>
+          <p:cNvPr id="3043" name="SimReal 3043"/>
           <p:cNvSpPr txBox="1"/>
           <p:nvPr/>
         </p:nvSpPr>
@@ -8724,7 +8903,7 @@
       </p:sp>
       <p:sp>
         <p:nvSpPr>
-          <p:cNvPr id="3040" name="SimReal 3040"/>
+          <p:cNvPr id="3044" name="SimReal 3044"/>
           <p:cNvSpPr/>
           <p:nvPr/>
         </p:nvSpPr>
@@ -8753,7 +8932,7 @@
       </p:sp>
       <p:sp>
         <p:nvSpPr>
-          <p:cNvPr id="3041" name="SimReal 3041"/>
+          <p:cNvPr id="3045" name="SimReal 3045"/>
           <p:cNvSpPr txBox="1"/>
           <p:nvPr/>
         </p:nvSpPr>
@@ -8802,7 +8981,7 @@
       </p:sp>
       <p:sp>
         <p:nvSpPr>
-          <p:cNvPr id="3042" name="SimReal 3042"/>
+          <p:cNvPr id="3046" name="SimReal 3046"/>
           <p:cNvSpPr txBox="1"/>
           <p:nvPr/>
         </p:nvSpPr>
@@ -8851,7 +9030,7 @@
       </p:sp>
       <p:sp>
         <p:nvSpPr>
-          <p:cNvPr id="3043" name="SimReal 3043"/>
+          <p:cNvPr id="3047" name="SimReal 3047"/>
           <p:cNvSpPr txBox="1"/>
           <p:nvPr/>
         </p:nvSpPr>
@@ -12519,7 +12698,7 @@
                 <a:cs typeface="Instrument Sans"/>
                 <a:sym typeface="Instrument Sans"/>
               </a:rPr>
-              <a:t>每个训练世界，都能最快找到对的评分人</a:t>
+              <a:t>精准覆盖每个行业的入门岗位与顶尖科研，并持续深入</a:t>
             </a:r>
             <a:endParaRPr sz="1500" b="0" i="0" u="none" strike="noStrike" cap="none" dirty="0">
               <a:solidFill>
@@ -13464,6 +13643,329 @@
               <a:cs typeface="Instrument Sans"/>
               <a:sym typeface="Instrument Sans"/>
             </a:endParaRPr>
+          </a:p>
+        </p:txBody>
+      </p:sp>
+      <p:sp>
+        <p:nvSpPr>
+          <p:cNvPr id="3001" name="SimReal 3001"/>
+          <p:cNvSpPr/>
+          <p:nvPr/>
+        </p:nvSpPr>
+        <p:spPr>
+          <a:xfrm>
+            <a:off x="548640" y="4700016"/>
+            <a:ext cx="3566160" cy="9144"/>
+          </a:xfrm>
+          <a:prstGeom prst="rect">
+            <a:avLst/>
+          </a:prstGeom>
+          <a:solidFill>
+            <a:srgbClr val="E2E0DA"/>
+          </a:solidFill>
+          <a:ln>
+            <a:noFill/>
+          </a:ln>
+        </p:spPr>
+        <p:txBody>
+          <a:bodyPr/>
+          <a:lstStyle/>
+          <a:p>
+            <a:endParaRPr/>
+          </a:p>
+        </p:txBody>
+      </p:sp>
+      <p:sp>
+        <p:nvSpPr>
+          <p:cNvPr id="3002" name="SimReal 3002"/>
+          <p:cNvSpPr txBox="1"/>
+          <p:nvPr/>
+        </p:nvSpPr>
+        <p:spPr>
+          <a:xfrm>
+            <a:off x="548640" y="4773168"/>
+            <a:ext cx="1005840" cy="365760"/>
+          </a:xfrm>
+          <a:prstGeom prst="rect">
+            <a:avLst/>
+          </a:prstGeom>
+          <a:noFill/>
+          <a:ln>
+            <a:noFill/>
+          </a:ln>
+        </p:spPr>
+        <p:txBody>
+          <a:bodyPr spcFirstLastPara="1" wrap="square" lIns="0" tIns="0" rIns="0" bIns="0" anchor="ctr" anchorCtr="0">
+            <a:noAutofit/>
+          </a:bodyPr>
+          <a:lstStyle/>
+          <a:p>
+            <a:pPr marL="0" marR="0" lvl="0" indent="0" algn="l" rtl="0">
+              <a:spcBef>
+                <a:spcPts val="0"/>
+              </a:spcBef>
+              <a:spcAft>
+                <a:spcPts val="0"/>
+              </a:spcAft>
+              <a:buNone/>
+            </a:pPr>
+            <a:r>
+              <a:rPr lang="zh-CN" sz="1300" b="0" i="0" u="none" strike="noStrike" cap="none">
+                <a:solidFill>
+                  <a:srgbClr val="111110"/>
+                </a:solidFill>
+                <a:latin typeface="Newsreader"/>
+                <a:ea typeface="Newsreader"/>
+                <a:cs typeface="Newsreader"/>
+                <a:sym typeface="Newsreader"/>
+              </a:rPr>
+              <a:t>入门岗位</a:t>
+            </a:r>
+          </a:p>
+        </p:txBody>
+      </p:sp>
+      <p:sp>
+        <p:nvSpPr>
+          <p:cNvPr id="3003" name="SimReal 3003"/>
+          <p:cNvSpPr txBox="1"/>
+          <p:nvPr/>
+        </p:nvSpPr>
+        <p:spPr>
+          <a:xfrm>
+            <a:off x="1600200" y="4773168"/>
+            <a:ext cx="2651760" cy="365760"/>
+          </a:xfrm>
+          <a:prstGeom prst="rect">
+            <a:avLst/>
+          </a:prstGeom>
+          <a:noFill/>
+          <a:ln>
+            <a:noFill/>
+          </a:ln>
+        </p:spPr>
+        <p:txBody>
+          <a:bodyPr spcFirstLastPara="1" wrap="square" lIns="0" tIns="0" rIns="0" bIns="0" anchor="ctr" anchorCtr="0">
+            <a:noAutofit/>
+          </a:bodyPr>
+          <a:lstStyle/>
+          <a:p>
+            <a:pPr marL="0" marR="0" lvl="0" indent="0" algn="l" rtl="0">
+              <a:spcBef>
+                <a:spcPts val="0"/>
+              </a:spcBef>
+              <a:spcAft>
+                <a:spcPts val="0"/>
+              </a:spcAft>
+              <a:buNone/>
+            </a:pPr>
+            <a:r>
+              <a:rPr lang="zh-CN" sz="1050" b="0" i="0" u="none" strike="noStrike" cap="none">
+                <a:solidFill>
+                  <a:srgbClr val="6E6C66"/>
+                </a:solidFill>
+                <a:latin typeface="Instrument Sans"/>
+                <a:ea typeface="Instrument Sans"/>
+                <a:cs typeface="Instrument Sans"/>
+                <a:sym typeface="Instrument Sans"/>
+              </a:rPr>
+              <a:t>每个行业，AI最先接手的工作</a:t>
+            </a:r>
+          </a:p>
+        </p:txBody>
+      </p:sp>
+      <p:sp>
+        <p:nvSpPr>
+          <p:cNvPr id="3004" name="SimReal 3004"/>
+          <p:cNvSpPr txBox="1"/>
+          <p:nvPr/>
+        </p:nvSpPr>
+        <p:spPr>
+          <a:xfrm>
+            <a:off x="548640" y="5138928"/>
+            <a:ext cx="1005840" cy="365760"/>
+          </a:xfrm>
+          <a:prstGeom prst="rect">
+            <a:avLst/>
+          </a:prstGeom>
+          <a:noFill/>
+          <a:ln>
+            <a:noFill/>
+          </a:ln>
+        </p:spPr>
+        <p:txBody>
+          <a:bodyPr spcFirstLastPara="1" wrap="square" lIns="0" tIns="0" rIns="0" bIns="0" anchor="ctr" anchorCtr="0">
+            <a:noAutofit/>
+          </a:bodyPr>
+          <a:lstStyle/>
+          <a:p>
+            <a:pPr marL="0" marR="0" lvl="0" indent="0" algn="l" rtl="0">
+              <a:spcBef>
+                <a:spcPts val="0"/>
+              </a:spcBef>
+              <a:spcAft>
+                <a:spcPts val="0"/>
+              </a:spcAft>
+              <a:buNone/>
+            </a:pPr>
+            <a:r>
+              <a:rPr lang="zh-CN" sz="1300" b="0" i="0" u="none" strike="noStrike" cap="none">
+                <a:solidFill>
+                  <a:srgbClr val="111110"/>
+                </a:solidFill>
+                <a:latin typeface="Newsreader"/>
+                <a:ea typeface="Newsreader"/>
+                <a:cs typeface="Newsreader"/>
+                <a:sym typeface="Newsreader"/>
+              </a:rPr>
+              <a:t>顶尖科研</a:t>
+            </a:r>
+          </a:p>
+        </p:txBody>
+      </p:sp>
+      <p:sp>
+        <p:nvSpPr>
+          <p:cNvPr id="3005" name="SimReal 3005"/>
+          <p:cNvSpPr txBox="1"/>
+          <p:nvPr/>
+        </p:nvSpPr>
+        <p:spPr>
+          <a:xfrm>
+            <a:off x="1600200" y="5138928"/>
+            <a:ext cx="2651760" cy="365760"/>
+          </a:xfrm>
+          <a:prstGeom prst="rect">
+            <a:avLst/>
+          </a:prstGeom>
+          <a:noFill/>
+          <a:ln>
+            <a:noFill/>
+          </a:ln>
+        </p:spPr>
+        <p:txBody>
+          <a:bodyPr spcFirstLastPara="1" wrap="square" lIns="0" tIns="0" rIns="0" bIns="0" anchor="ctr" anchorCtr="0">
+            <a:noAutofit/>
+          </a:bodyPr>
+          <a:lstStyle/>
+          <a:p>
+            <a:pPr marL="0" marR="0" lvl="0" indent="0" algn="l" rtl="0">
+              <a:spcBef>
+                <a:spcPts val="0"/>
+              </a:spcBef>
+              <a:spcAft>
+                <a:spcPts val="0"/>
+              </a:spcAft>
+              <a:buNone/>
+            </a:pPr>
+            <a:r>
+              <a:rPr lang="zh-CN" sz="1050" b="0" i="0" u="none" strike="noStrike" cap="none">
+                <a:solidFill>
+                  <a:srgbClr val="6E6C66"/>
+                </a:solidFill>
+                <a:latin typeface="Instrument Sans"/>
+                <a:ea typeface="Instrument Sans"/>
+                <a:cs typeface="Instrument Sans"/>
+                <a:sym typeface="Instrument Sans"/>
+              </a:rPr>
+              <a:t>最难的问题，最难的评分标准</a:t>
+            </a:r>
+          </a:p>
+        </p:txBody>
+      </p:sp>
+      <p:sp>
+        <p:nvSpPr>
+          <p:cNvPr id="3006" name="SimReal 3006"/>
+          <p:cNvSpPr txBox="1"/>
+          <p:nvPr/>
+        </p:nvSpPr>
+        <p:spPr>
+          <a:xfrm>
+            <a:off x="548640" y="5504688"/>
+            <a:ext cx="1005840" cy="365760"/>
+          </a:xfrm>
+          <a:prstGeom prst="rect">
+            <a:avLst/>
+          </a:prstGeom>
+          <a:noFill/>
+          <a:ln>
+            <a:noFill/>
+          </a:ln>
+        </p:spPr>
+        <p:txBody>
+          <a:bodyPr spcFirstLastPara="1" wrap="square" lIns="0" tIns="0" rIns="0" bIns="0" anchor="ctr" anchorCtr="0">
+            <a:noAutofit/>
+          </a:bodyPr>
+          <a:lstStyle/>
+          <a:p>
+            <a:pPr marL="0" marR="0" lvl="0" indent="0" algn="l" rtl="0">
+              <a:spcBef>
+                <a:spcPts val="0"/>
+              </a:spcBef>
+              <a:spcAft>
+                <a:spcPts val="0"/>
+              </a:spcAft>
+              <a:buNone/>
+            </a:pPr>
+            <a:r>
+              <a:rPr lang="zh-CN" sz="1300" b="0" i="0" u="none" strike="noStrike" cap="none">
+                <a:solidFill>
+                  <a:srgbClr val="C2410C"/>
+                </a:solidFill>
+                <a:latin typeface="Newsreader"/>
+                <a:ea typeface="Newsreader"/>
+                <a:cs typeface="Newsreader"/>
+                <a:sym typeface="Newsreader"/>
+              </a:rPr>
+              <a:t>持续深入</a:t>
+            </a:r>
+          </a:p>
+        </p:txBody>
+      </p:sp>
+      <p:sp>
+        <p:nvSpPr>
+          <p:cNvPr id="3007" name="SimReal 3007"/>
+          <p:cNvSpPr txBox="1"/>
+          <p:nvPr/>
+        </p:nvSpPr>
+        <p:spPr>
+          <a:xfrm>
+            <a:off x="1600200" y="5504688"/>
+            <a:ext cx="2651760" cy="365760"/>
+          </a:xfrm>
+          <a:prstGeom prst="rect">
+            <a:avLst/>
+          </a:prstGeom>
+          <a:noFill/>
+          <a:ln>
+            <a:noFill/>
+          </a:ln>
+        </p:spPr>
+        <p:txBody>
+          <a:bodyPr spcFirstLastPara="1" wrap="square" lIns="0" tIns="0" rIns="0" bIns="0" anchor="ctr" anchorCtr="0">
+            <a:noAutofit/>
+          </a:bodyPr>
+          <a:lstStyle/>
+          <a:p>
+            <a:pPr marL="0" marR="0" lvl="0" indent="0" algn="l" rtl="0">
+              <a:spcBef>
+                <a:spcPts val="0"/>
+              </a:spcBef>
+              <a:spcAft>
+                <a:spcPts val="0"/>
+              </a:spcAft>
+              <a:buNone/>
+            </a:pPr>
+            <a:r>
+              <a:rPr lang="zh-CN" sz="1050" b="0" i="0" u="none" strike="noStrike" cap="none">
+                <a:solidFill>
+                  <a:srgbClr val="6E6C66"/>
+                </a:solidFill>
+                <a:latin typeface="Instrument Sans"/>
+                <a:ea typeface="Instrument Sans"/>
+                <a:cs typeface="Instrument Sans"/>
+                <a:sym typeface="Instrument Sans"/>
+              </a:rPr>
+              <a:t>每上线一个行业，网络就往更深处延伸</a:t>
+            </a:r>
           </a:p>
         </p:txBody>
       </p:sp>
@@ -15945,7 +16447,7 @@
         <p:spPr>
           <a:xfrm>
             <a:off x="548640" y="1600200"/>
-            <a:ext cx="6400800" cy="932688"/>
+            <a:ext cx="6400800" cy="713232"/>
           </a:xfrm>
           <a:prstGeom prst="rect">
             <a:avLst/>
@@ -15990,7 +16492,7 @@
         </p:nvSpPr>
         <p:spPr>
           <a:xfrm>
-            <a:off x="786384" y="1746504"/>
+            <a:off x="786384" y="1691640"/>
             <a:ext cx="2194560" cy="365760"/>
           </a:xfrm>
           <a:prstGeom prst="rect">
@@ -16053,8 +16555,8 @@
         </p:nvSpPr>
         <p:spPr>
           <a:xfrm>
-            <a:off x="786384" y="2130552"/>
-            <a:ext cx="2286000" cy="329184"/>
+            <a:off x="786384" y="2020824"/>
+            <a:ext cx="2286000" cy="256032"/>
           </a:xfrm>
           <a:prstGeom prst="rect">
             <a:avLst/>
@@ -16117,7 +16619,7 @@
         <p:spPr>
           <a:xfrm>
             <a:off x="3200400" y="1600200"/>
-            <a:ext cx="3520440" cy="932688"/>
+            <a:ext cx="3520440" cy="713232"/>
           </a:xfrm>
           <a:prstGeom prst="rect">
             <a:avLst/>
@@ -16179,8 +16681,8 @@
         </p:nvSpPr>
         <p:spPr>
           <a:xfrm>
-            <a:off x="548640" y="2642616"/>
-            <a:ext cx="6400800" cy="932688"/>
+            <a:off x="548640" y="3209544"/>
+            <a:ext cx="6400800" cy="713232"/>
           </a:xfrm>
           <a:prstGeom prst="rect">
             <a:avLst/>
@@ -16225,7 +16727,7 @@
         </p:nvSpPr>
         <p:spPr>
           <a:xfrm>
-            <a:off x="786384" y="2971800"/>
+            <a:off x="786384" y="3392424"/>
             <a:ext cx="2194560" cy="365760"/>
           </a:xfrm>
           <a:prstGeom prst="rect">
@@ -16288,8 +16790,8 @@
         </p:nvSpPr>
         <p:spPr>
           <a:xfrm>
-            <a:off x="3200400" y="2642616"/>
-            <a:ext cx="3520440" cy="932688"/>
+            <a:off x="3200400" y="3209544"/>
+            <a:ext cx="3520440" cy="713232"/>
           </a:xfrm>
           <a:prstGeom prst="rect">
             <a:avLst/>
@@ -16351,8 +16853,8 @@
         </p:nvSpPr>
         <p:spPr>
           <a:xfrm>
-            <a:off x="548640" y="3685032"/>
-            <a:ext cx="6400800" cy="932688"/>
+            <a:off x="548640" y="4014216"/>
+            <a:ext cx="6400800" cy="713232"/>
           </a:xfrm>
           <a:prstGeom prst="rect">
             <a:avLst/>
@@ -16397,7 +16899,7 @@
         </p:nvSpPr>
         <p:spPr>
           <a:xfrm>
-            <a:off x="777240" y="4014215"/>
+            <a:off x="777240" y="4197096"/>
             <a:ext cx="2194560" cy="365760"/>
           </a:xfrm>
           <a:prstGeom prst="rect">
@@ -16460,8 +16962,8 @@
         </p:nvSpPr>
         <p:spPr>
           <a:xfrm>
-            <a:off x="3200400" y="3685032"/>
-            <a:ext cx="3520440" cy="932688"/>
+            <a:off x="3200400" y="4014216"/>
+            <a:ext cx="3520440" cy="713232"/>
           </a:xfrm>
           <a:prstGeom prst="rect">
             <a:avLst/>
@@ -16523,8 +17025,8 @@
         </p:nvSpPr>
         <p:spPr>
           <a:xfrm>
-            <a:off x="548640" y="4727448"/>
-            <a:ext cx="6400800" cy="932688"/>
+            <a:off x="548640" y="4818888"/>
+            <a:ext cx="6400800" cy="713232"/>
           </a:xfrm>
           <a:prstGeom prst="rect">
             <a:avLst/>
@@ -16632,8 +17134,8 @@
         </p:nvSpPr>
         <p:spPr>
           <a:xfrm>
-            <a:off x="786384" y="5312663"/>
-            <a:ext cx="2286000" cy="329184"/>
+            <a:off x="786384" y="5257800"/>
+            <a:ext cx="2286000" cy="256032"/>
           </a:xfrm>
           <a:prstGeom prst="rect">
             <a:avLst/>
@@ -16695,8 +17197,8 @@
         </p:nvSpPr>
         <p:spPr>
           <a:xfrm>
-            <a:off x="3200400" y="4727448"/>
-            <a:ext cx="3520440" cy="932688"/>
+            <a:off x="3200400" y="4818888"/>
+            <a:ext cx="3520440" cy="713232"/>
           </a:xfrm>
           <a:prstGeom prst="rect">
             <a:avLst/>
@@ -17430,7 +17932,7 @@
                 <a:cs typeface="Instrument Sans"/>
                 <a:sym typeface="Instrument Sans"/>
               </a:rPr>
-              <a:t>每家实验室都能放心采购</a:t>
+              <a:t>不属于任何一家实验室：中美实验室都能放心采购</a:t>
             </a:r>
             <a:endParaRPr sz="1100" b="0" i="0" u="none" strike="noStrike" cap="none" dirty="0">
               <a:solidFill>
@@ -17620,6 +18122,325 @@
               <a:cs typeface="Instrument Sans"/>
               <a:sym typeface="Instrument Sans"/>
             </a:endParaRPr>
+          </a:p>
+        </p:txBody>
+      </p:sp>
+      <p:sp>
+        <p:nvSpPr>
+          <p:cNvPr id="4001" name="SimReal 4001"/>
+          <p:cNvSpPr/>
+          <p:nvPr/>
+        </p:nvSpPr>
+        <p:spPr>
+          <a:xfrm>
+            <a:off x="548640" y="2404872"/>
+            <a:ext cx="6400800" cy="713232"/>
+          </a:xfrm>
+          <a:prstGeom prst="rect">
+            <a:avLst/>
+          </a:prstGeom>
+          <a:solidFill>
+            <a:srgbClr val="FFFFFF"/>
+          </a:solidFill>
+          <a:ln w="9525" cap="flat" cmpd="sng">
+            <a:solidFill>
+              <a:srgbClr val="E2E0DA"/>
+            </a:solidFill>
+            <a:prstDash val="solid"/>
+            <a:round/>
+            <a:headEnd type="none" w="sm" len="sm"/>
+            <a:tailEnd type="none" w="sm" len="sm"/>
+          </a:ln>
+        </p:spPr>
+        <p:txBody>
+          <a:bodyPr spcFirstLastPara="1" wrap="square" lIns="91425" tIns="91425" rIns="91425" bIns="91425" anchor="ctr" anchorCtr="0">
+            <a:noAutofit/>
+          </a:bodyPr>
+          <a:lstStyle/>
+          <a:p>
+            <a:pPr marL="0" lvl="0" indent="0" algn="l" rtl="0">
+              <a:spcBef>
+                <a:spcPts val="0"/>
+              </a:spcBef>
+              <a:spcAft>
+                <a:spcPts val="0"/>
+              </a:spcAft>
+              <a:buNone/>
+            </a:pPr>
+            <a:endParaRPr/>
+          </a:p>
+        </p:txBody>
+      </p:sp>
+      <p:sp>
+        <p:nvSpPr>
+          <p:cNvPr id="4002" name="SimReal 4002"/>
+          <p:cNvSpPr txBox="1"/>
+          <p:nvPr/>
+        </p:nvSpPr>
+        <p:spPr>
+          <a:xfrm>
+            <a:off x="786384" y="2496312"/>
+            <a:ext cx="2194560" cy="365760"/>
+          </a:xfrm>
+          <a:prstGeom prst="rect">
+            <a:avLst/>
+          </a:prstGeom>
+          <a:noFill/>
+          <a:ln>
+            <a:noFill/>
+          </a:ln>
+        </p:spPr>
+        <p:txBody>
+          <a:bodyPr spcFirstLastPara="1" wrap="square" lIns="0" tIns="0" rIns="0" bIns="0" anchor="t" anchorCtr="0">
+            <a:noAutofit/>
+          </a:bodyPr>
+          <a:lstStyle/>
+          <a:p>
+            <a:pPr marL="0" marR="0" lvl="0" indent="0" algn="l" rtl="0">
+              <a:spcBef>
+                <a:spcPts val="0"/>
+              </a:spcBef>
+              <a:spcAft>
+                <a:spcPts val="0"/>
+              </a:spcAft>
+              <a:buClr>
+                <a:srgbClr val="111110"/>
+              </a:buClr>
+              <a:buSzPts val="1800"/>
+              <a:buFont typeface="Newsreader"/>
+              <a:buNone/>
+            </a:pPr>
+            <a:r>
+              <a:rPr lang="zh-CN" sz="1800" b="0" i="0" u="none" strike="noStrike" cap="none">
+                <a:solidFill>
+                  <a:srgbClr val="111110"/>
+                </a:solidFill>
+                <a:latin typeface="Newsreader"/>
+                <a:ea typeface="Newsreader"/>
+                <a:cs typeface="Newsreader"/>
+                <a:sym typeface="Newsreader"/>
+              </a:rPr>
+              <a:t>中国同行</a:t>
+            </a:r>
+            <a:endParaRPr sz="1800" b="0" i="0" u="none" strike="noStrike" cap="none">
+              <a:solidFill>
+                <a:schemeClr val="dk1"/>
+              </a:solidFill>
+              <a:latin typeface="Instrument Sans"/>
+              <a:ea typeface="Instrument Sans"/>
+              <a:cs typeface="Instrument Sans"/>
+              <a:sym typeface="Instrument Sans"/>
+            </a:endParaRPr>
+          </a:p>
+        </p:txBody>
+      </p:sp>
+      <p:sp>
+        <p:nvSpPr>
+          <p:cNvPr id="4003" name="SimReal 4003"/>
+          <p:cNvSpPr txBox="1"/>
+          <p:nvPr/>
+        </p:nvSpPr>
+        <p:spPr>
+          <a:xfrm>
+            <a:off x="786384" y="2825496"/>
+            <a:ext cx="2286000" cy="256032"/>
+          </a:xfrm>
+          <a:prstGeom prst="rect">
+            <a:avLst/>
+          </a:prstGeom>
+          <a:noFill/>
+          <a:ln>
+            <a:noFill/>
+          </a:ln>
+        </p:spPr>
+        <p:txBody>
+          <a:bodyPr spcFirstLastPara="1" wrap="square" lIns="0" tIns="0" rIns="0" bIns="0" anchor="t" anchorCtr="0">
+            <a:noAutofit/>
+          </a:bodyPr>
+          <a:lstStyle/>
+          <a:p>
+            <a:pPr marL="0" marR="0" lvl="0" indent="0" algn="l" rtl="0">
+              <a:spcBef>
+                <a:spcPts val="0"/>
+              </a:spcBef>
+              <a:spcAft>
+                <a:spcPts val="0"/>
+              </a:spcAft>
+              <a:buClr>
+                <a:srgbClr val="6E6C66"/>
+              </a:buClr>
+              <a:buSzPts val="1000"/>
+              <a:buFont typeface="Instrument Sans"/>
+              <a:buNone/>
+            </a:pPr>
+            <a:r>
+              <a:rPr lang="zh-CN" sz="1000" b="0" i="0" u="none" strike="noStrike" cap="none" dirty="0">
+                <a:solidFill>
+                  <a:srgbClr val="6E6C66"/>
+                </a:solidFill>
+                <a:latin typeface="Instrument Sans"/>
+                <a:ea typeface="Instrument Sans"/>
+                <a:cs typeface="Instrument Sans"/>
+                <a:sym typeface="Instrument Sans"/>
+              </a:rPr>
+              <a:t>UniPat、Humanlaya</a:t>
+            </a:r>
+            <a:endParaRPr sz="1000" b="0" i="0" u="none" strike="noStrike" cap="none" dirty="0">
+              <a:solidFill>
+                <a:schemeClr val="dk1"/>
+              </a:solidFill>
+              <a:latin typeface="Instrument Sans"/>
+              <a:ea typeface="Instrument Sans"/>
+              <a:cs typeface="Instrument Sans"/>
+              <a:sym typeface="Instrument Sans"/>
+            </a:endParaRPr>
+          </a:p>
+        </p:txBody>
+      </p:sp>
+      <p:sp>
+        <p:nvSpPr>
+          <p:cNvPr id="4004" name="SimReal 4004"/>
+          <p:cNvSpPr txBox="1"/>
+          <p:nvPr/>
+        </p:nvSpPr>
+        <p:spPr>
+          <a:xfrm>
+            <a:off x="3200400" y="2404872"/>
+            <a:ext cx="3520440" cy="713232"/>
+          </a:xfrm>
+          <a:prstGeom prst="rect">
+            <a:avLst/>
+          </a:prstGeom>
+          <a:noFill/>
+          <a:ln>
+            <a:noFill/>
+          </a:ln>
+        </p:spPr>
+        <p:txBody>
+          <a:bodyPr spcFirstLastPara="1" wrap="square" lIns="0" tIns="0" rIns="0" bIns="0" anchor="ctr" anchorCtr="0">
+            <a:noAutofit/>
+          </a:bodyPr>
+          <a:lstStyle/>
+          <a:p>
+            <a:pPr marL="0" marR="0" lvl="0" indent="0" algn="l" rtl="0">
+              <a:spcBef>
+                <a:spcPts val="0"/>
+              </a:spcBef>
+              <a:spcAft>
+                <a:spcPts val="0"/>
+              </a:spcAft>
+              <a:buClr>
+                <a:srgbClr val="33322F"/>
+              </a:buClr>
+              <a:buSzPts val="1300"/>
+              <a:buFont typeface="Instrument Sans"/>
+              <a:buNone/>
+            </a:pPr>
+            <a:r>
+              <a:rPr lang="zh-CN" sz="1300" b="0" i="0" u="none" strike="noStrike" cap="none" dirty="0">
+                <a:solidFill>
+                  <a:srgbClr val="33322F"/>
+                </a:solidFill>
+                <a:latin typeface="Instrument Sans"/>
+                <a:ea typeface="Instrument Sans"/>
+                <a:cs typeface="Instrument Sans"/>
+                <a:sym typeface="Instrument Sans"/>
+              </a:rPr>
+              <a:t>主要服务国内实验室：专家数据与评测</a:t>
+            </a:r>
+            <a:br>
+              <a:rPr lang="zh-CN" sz="1300" b="0" i="0" u="none" strike="noStrike" cap="none" dirty="0">
+                <a:solidFill>
+                  <a:srgbClr val="33322F"/>
+                </a:solidFill>
+                <a:latin typeface="Instrument Sans"/>
+                <a:ea typeface="Instrument Sans"/>
+                <a:cs typeface="Instrument Sans"/>
+                <a:sym typeface="Instrument Sans"/>
+              </a:rPr>
+            </a:br>
+            <a:r>
+              <a:rPr lang="zh-CN" sz="1300" b="0" i="0" u="none" strike="noStrike" cap="none" dirty="0">
+                <a:solidFill>
+                  <a:srgbClr val="33322F"/>
+                </a:solidFill>
+                <a:latin typeface="Instrument Sans"/>
+                <a:ea typeface="Instrument Sans"/>
+                <a:cs typeface="Instrument Sans"/>
+                <a:sym typeface="Instrument Sans"/>
+              </a:rPr>
+              <a:t>UniPat由阿里领投，估值25亿美元</a:t>
+            </a:r>
+            <a:endParaRPr sz="1300" b="0" i="0" u="none" strike="noStrike" cap="none" dirty="0">
+              <a:solidFill>
+                <a:schemeClr val="dk1"/>
+              </a:solidFill>
+              <a:latin typeface="Instrument Sans"/>
+              <a:ea typeface="Instrument Sans"/>
+              <a:cs typeface="Instrument Sans"/>
+              <a:sym typeface="Instrument Sans"/>
+            </a:endParaRPr>
+          </a:p>
+        </p:txBody>
+      </p:sp>
+      <p:sp>
+        <p:nvSpPr>
+          <p:cNvPr id="3001" name="SimReal 3001"/>
+          <p:cNvSpPr txBox="1"/>
+          <p:nvPr/>
+        </p:nvSpPr>
+        <p:spPr>
+          <a:xfrm>
+            <a:off x="548640" y="5760720"/>
+            <a:ext cx="11091672" cy="274320"/>
+          </a:xfrm>
+          <a:prstGeom prst="rect">
+            <a:avLst/>
+          </a:prstGeom>
+          <a:noFill/>
+          <a:ln>
+            <a:noFill/>
+          </a:ln>
+        </p:spPr>
+        <p:txBody>
+          <a:bodyPr spcFirstLastPara="1" wrap="square" lIns="0" tIns="0" rIns="0" bIns="0" anchor="ctr" anchorCtr="0">
+            <a:noAutofit/>
+          </a:bodyPr>
+          <a:lstStyle/>
+          <a:p>
+            <a:pPr marL="0" marR="0" lvl="0" indent="0" algn="l" rtl="0">
+              <a:spcBef>
+                <a:spcPts val="0"/>
+              </a:spcBef>
+              <a:spcAft>
+                <a:spcPts val="0"/>
+              </a:spcAft>
+              <a:buNone/>
+            </a:pPr>
+            <a:r>
+              <a:rPr lang="zh-CN" sz="1000" b="1" i="0" u="none" strike="noStrike" cap="none">
+                <a:solidFill>
+                  <a:srgbClr val="C2410C"/>
+                </a:solidFill>
+                <a:latin typeface="Instrument Sans"/>
+                <a:ea typeface="Instrument Sans"/>
+                <a:cs typeface="Instrument Sans"/>
+                <a:sym typeface="Instrument Sans"/>
+              </a:rPr>
+              <a:t>国内现状  </a:t>
+            </a:r>
+            <a:r>
+              <a:rPr lang="zh-CN" sz="1000" b="0" i="0" u="none" strike="noStrike" cap="none">
+                <a:solidFill>
+                  <a:srgbClr val="33322F"/>
+                </a:solidFill>
+                <a:latin typeface="Instrument Sans"/>
+                <a:ea typeface="Instrument Sans"/>
+                <a:cs typeface="Instrument Sans"/>
+                <a:sym typeface="Instrument Sans"/>
+              </a:rPr>
+              <a:t>9月，UniPat获阿里领投3亿美元（估值25亿美元），Humanlaya完成数亿元人民币Pre-A；阿里、字节、DeepSeek都已向两家采购。赛道在中美同时升温。</a:t>
+            </a:r>
           </a:p>
         </p:txBody>
       </p:sp>
@@ -30614,6 +31435,58 @@
                 <a:cs typeface="Instrument Sans SemiBold"/>
                 <a:sym typeface="Instrument Sans SemiBold"/>
               </a:rPr>
+              <a:t>国内现状：</a:t>
+            </a:r>
+            <a:r>
+              <a:rPr lang="zh-CN" sz="1000" b="0" i="0" u="none" strike="noStrike" cap="none">
+                <a:solidFill>
+                  <a:srgbClr val="33322F"/>
+                </a:solidFill>
+                <a:latin typeface="Instrument Sans"/>
+                <a:ea typeface="Instrument Sans"/>
+                <a:cs typeface="Instrument Sans"/>
+                <a:sym typeface="Instrument Sans"/>
+              </a:rPr>
+              <a:t>彭博（2026年9月10日）：阿里、字节、DeepSeek等国内模型公司已向UniPat与Humanlaya采购数据或服务；Humanlaya：2025年10月成立，2026年9月9日完成数亿元人民币Pre-A轮，鼎晖领投，红杉中国、今日资本、BAI参投（界面新闻、东方财富）</a:t>
+            </a:r>
+            <a:endParaRPr sz="1000" b="0" i="0" u="none" strike="noStrike" cap="none">
+              <a:solidFill>
+                <a:schemeClr val="dk1"/>
+              </a:solidFill>
+              <a:latin typeface="Instrument Sans"/>
+              <a:ea typeface="Instrument Sans"/>
+              <a:cs typeface="Instrument Sans"/>
+              <a:sym typeface="Instrument Sans"/>
+            </a:endParaRPr>
+          </a:p>
+          <a:p>
+            <a:pPr marL="0" marR="0" lvl="0" indent="0" algn="l" rtl="0">
+              <a:lnSpc>
+                <a:spcPct val="105000"/>
+              </a:lnSpc>
+              <a:spcBef>
+                <a:spcPts val="800"/>
+              </a:spcBef>
+              <a:spcAft>
+                <a:spcPts val="0"/>
+              </a:spcAft>
+              <a:buClr>
+                <a:srgbClr val="111110"/>
+              </a:buClr>
+              <a:buSzPts val="1000"/>
+              <a:buFont typeface="Instrument Sans SemiBold"/>
+              <a:buNone/>
+            </a:pPr>
+            <a:r>
+              <a:rPr lang="zh-CN" sz="1000" b="0" i="0" u="none" strike="noStrike" cap="none">
+                <a:solidFill>
+                  <a:srgbClr val="111110"/>
+                </a:solidFill>
+                <a:latin typeface="Instrument Sans SemiBold"/>
+                <a:ea typeface="Instrument Sans SemiBold"/>
+                <a:cs typeface="Instrument Sans SemiBold"/>
+                <a:sym typeface="Instrument Sans SemiBold"/>
+              </a:rPr>
               <a:t>融资与估值：</a:t>
             </a:r>
             <a:r>

</xml_diff>

<commit_message>
BP v17: industry coverage last on page 10, led by the university research network
Co-Authored-By: Claude Opus 5.5 <noreply@anthropic.com>
Claude-Session: https://claude.ai/code/session_01EKqGwTA92C8Wo4e47t73NN
</commit_message>
<xml_diff>
--- a/SimReal-BP-v17.pptx
+++ b/SimReal-BP-v17.pptx
@@ -7880,7 +7880,7 @@
                 <a:cs typeface="Newsreader"/>
                 <a:sym typeface="Newsreader"/>
               </a:rPr>
-              <a:t>行业覆盖</a:t>
+              <a:t>市场验证</a:t>
             </a:r>
           </a:p>
         </p:txBody>
@@ -7932,7 +7932,7 @@
                 <a:cs typeface="Instrument Sans"/>
                 <a:sym typeface="Instrument Sans"/>
               </a:rPr>
-              <a:t>每个行业的入门岗位，AI最先接手：我们能快速、低成本覆盖</a:t>
+              <a:t>首周GitHub 500+星标、7,000+专家候补、2家前沿实验室在谈</a:t>
             </a:r>
           </a:p>
         </p:txBody>
@@ -8059,7 +8059,7 @@
                 <a:cs typeface="Newsreader"/>
                 <a:sym typeface="Newsreader"/>
               </a:rPr>
-              <a:t>市场验证</a:t>
+              <a:t>过往战绩</a:t>
             </a:r>
           </a:p>
         </p:txBody>
@@ -8111,7 +8111,7 @@
                 <a:cs typeface="Instrument Sans"/>
                 <a:sym typeface="Instrument Sans"/>
               </a:rPr>
-              <a:t>首周GitHub 500+星标、7,000+专家候补、2家前沿实验室在谈</a:t>
+              <a:t>U稳定币0→14亿美元、一个月上线Binance；五家顶级量化机构经历</a:t>
             </a:r>
           </a:p>
         </p:txBody>
@@ -8238,7 +8238,7 @@
                 <a:cs typeface="Newsreader"/>
                 <a:sym typeface="Newsreader"/>
               </a:rPr>
-              <a:t>过往战绩</a:t>
+              <a:t>行业覆盖</a:t>
             </a:r>
           </a:p>
         </p:txBody>
@@ -8290,7 +8290,7 @@
                 <a:cs typeface="Instrument Sans"/>
                 <a:sym typeface="Instrument Sans"/>
               </a:rPr>
-              <a:t>U稳定币0→14亿美元、一个月上线Binance；五家顶级量化机构经历</a:t>
+              <a:t>21所顶尖大学的研究网络：快速、低成本覆盖每个行业的入门岗位</a:t>
             </a:r>
           </a:p>
         </p:txBody>

</xml_diff>

<commit_message>
BP v17: expert network climbs to senior roles as members are promoted
Co-Authored-By: Claude Opus 5.5 <noreply@anthropic.com>
Claude-Session: https://claude.ai/code/session_01EKqGwTA92C8Wo4e47t73NN
</commit_message>
<xml_diff>
--- a/SimReal-BP-v17.pptx
+++ b/SimReal-BP-v17.pptx
@@ -12698,7 +12698,7 @@
                 <a:cs typeface="Instrument Sans"/>
                 <a:sym typeface="Instrument Sans"/>
               </a:rPr>
-              <a:t>精准覆盖每个行业的入门岗位与顶尖科研，并持续深入</a:t>
+              <a:t>精准覆盖每个行业的入门岗位与顶尖科研，并逐步延伸到更高层</a:t>
             </a:r>
             <a:endParaRPr sz="1500" b="0" i="0" u="none" strike="noStrike" cap="none" dirty="0">
               <a:solidFill>
@@ -13915,7 +13915,7 @@
                 <a:cs typeface="Newsreader"/>
                 <a:sym typeface="Newsreader"/>
               </a:rPr>
-              <a:t>持续深入</a:t>
+              <a:t>向上延伸</a:t>
             </a:r>
           </a:p>
         </p:txBody>
@@ -13964,7 +13964,7 @@
                 <a:cs typeface="Instrument Sans"/>
                 <a:sym typeface="Instrument Sans"/>
               </a:rPr>
-              <a:t>每上线一个行业，网络就往更深处延伸</a:t>
+              <a:t>成员逐年晋升，网络延伸到资深与高层</a:t>
             </a:r>
           </a:p>
         </p:txBody>

</xml_diff>

<commit_message>
BP v17: hot-spot strip over the page-16 cards; coverage row adds frontier research
- Page 16: the page-10 hot-spot strip (labeling -> expert data -> RL
  environments -> self-evolution) sits over the four company cards, one
  wave per company; cards and closing line move down to make room.
- Page 10: the university research network covers entry roles and
  frontier research in every industry.

Co-Authored-By: Claude Opus 5.5 <noreply@anthropic.com>
Claude-Session: https://claude.ai/code/session_01EKqGwTA92C8Wo4e47t73NN
</commit_message>
<xml_diff>
--- a/SimReal-BP-v17.pptx
+++ b/SimReal-BP-v17.pptx
@@ -8290,7 +8290,7 @@
                 <a:cs typeface="Instrument Sans"/>
                 <a:sym typeface="Instrument Sans"/>
               </a:rPr>
-              <a:t>21所顶尖大学的研究网络：快速、低成本覆盖每个行业的入门岗位</a:t>
+              <a:t>21所顶尖大学研究网络：快速、低成本覆盖各行业入门岗位和前沿科研</a:t>
             </a:r>
           </a:p>
         </p:txBody>
@@ -18651,8 +18651,8 @@
         </p:nvSpPr>
         <p:spPr>
           <a:xfrm>
-            <a:off x="548640" y="1600200"/>
-            <a:ext cx="2636444" cy="3611880"/>
+            <a:off x="548640" y="2157984"/>
+            <a:ext cx="2636444" cy="3410712"/>
           </a:xfrm>
           <a:prstGeom prst="rect">
             <a:avLst/>
@@ -18697,7 +18697,7 @@
         </p:nvSpPr>
         <p:spPr>
           <a:xfrm>
-            <a:off x="786384" y="1783080"/>
+            <a:off x="786384" y="2340864"/>
             <a:ext cx="2160956" cy="329184"/>
           </a:xfrm>
           <a:prstGeom prst="rect">
@@ -18760,7 +18760,7 @@
         </p:nvSpPr>
         <p:spPr>
           <a:xfrm>
-            <a:off x="786384" y="2130552"/>
+            <a:off x="786384" y="2688336"/>
             <a:ext cx="2160956" cy="658368"/>
           </a:xfrm>
           <a:prstGeom prst="rect">
@@ -18823,7 +18823,7 @@
         </p:nvSpPr>
         <p:spPr>
           <a:xfrm>
-            <a:off x="786384" y="2788920"/>
+            <a:off x="786384" y="3346704"/>
             <a:ext cx="2160956" cy="237744"/>
           </a:xfrm>
           <a:prstGeom prst="rect">
@@ -18886,7 +18886,7 @@
         </p:nvCxnSpPr>
         <p:spPr>
           <a:xfrm>
-            <a:off x="786384" y="3172968"/>
+            <a:off x="786384" y="3730752"/>
             <a:ext cx="2160956" cy="0"/>
           </a:xfrm>
           <a:prstGeom prst="straightConnector1">
@@ -18912,7 +18912,7 @@
         </p:nvSpPr>
         <p:spPr>
           <a:xfrm>
-            <a:off x="786384" y="3246120"/>
+            <a:off x="786384" y="3803904"/>
             <a:ext cx="2160956" cy="530352"/>
           </a:xfrm>
           <a:prstGeom prst="rect">
@@ -18975,7 +18975,7 @@
         </p:nvCxnSpPr>
         <p:spPr>
           <a:xfrm>
-            <a:off x="786384" y="3813048"/>
+            <a:off x="786384" y="4279392"/>
             <a:ext cx="2160956" cy="0"/>
           </a:xfrm>
           <a:prstGeom prst="straightConnector1">
@@ -19001,7 +19001,7 @@
         </p:nvSpPr>
         <p:spPr>
           <a:xfrm>
-            <a:off x="786384" y="3886200"/>
+            <a:off x="786384" y="4352544"/>
             <a:ext cx="2160956" cy="530352"/>
           </a:xfrm>
           <a:prstGeom prst="rect">
@@ -19064,7 +19064,7 @@
         </p:nvCxnSpPr>
         <p:spPr>
           <a:xfrm>
-            <a:off x="786384" y="4453128"/>
+            <a:off x="786384" y="4828032"/>
             <a:ext cx="2160956" cy="0"/>
           </a:xfrm>
           <a:prstGeom prst="straightConnector1">
@@ -19090,7 +19090,7 @@
         </p:nvSpPr>
         <p:spPr>
           <a:xfrm>
-            <a:off x="786384" y="4526280"/>
+            <a:off x="786384" y="4901184"/>
             <a:ext cx="2160956" cy="530352"/>
           </a:xfrm>
           <a:prstGeom prst="rect">
@@ -19153,8 +19153,8 @@
         </p:nvSpPr>
         <p:spPr>
           <a:xfrm>
-            <a:off x="3367964" y="1600200"/>
-            <a:ext cx="2636444" cy="3611880"/>
+            <a:off x="3367964" y="2157984"/>
+            <a:ext cx="2636444" cy="3410712"/>
           </a:xfrm>
           <a:prstGeom prst="rect">
             <a:avLst/>
@@ -19199,7 +19199,7 @@
         </p:nvSpPr>
         <p:spPr>
           <a:xfrm>
-            <a:off x="3605708" y="1783080"/>
+            <a:off x="3605708" y="2340864"/>
             <a:ext cx="2160956" cy="329184"/>
           </a:xfrm>
           <a:prstGeom prst="rect">
@@ -19262,7 +19262,7 @@
         </p:nvSpPr>
         <p:spPr>
           <a:xfrm>
-            <a:off x="3605708" y="2130552"/>
+            <a:off x="3605708" y="2688336"/>
             <a:ext cx="2160956" cy="658368"/>
           </a:xfrm>
           <a:prstGeom prst="rect">
@@ -19325,7 +19325,7 @@
         </p:nvSpPr>
         <p:spPr>
           <a:xfrm>
-            <a:off x="3605708" y="2788920"/>
+            <a:off x="3605708" y="3346704"/>
             <a:ext cx="2160956" cy="237744"/>
           </a:xfrm>
           <a:prstGeom prst="rect">
@@ -19388,7 +19388,7 @@
         </p:nvCxnSpPr>
         <p:spPr>
           <a:xfrm>
-            <a:off x="3605708" y="3172968"/>
+            <a:off x="3605708" y="3730752"/>
             <a:ext cx="2160956" cy="0"/>
           </a:xfrm>
           <a:prstGeom prst="straightConnector1">
@@ -19414,7 +19414,7 @@
         </p:nvSpPr>
         <p:spPr>
           <a:xfrm>
-            <a:off x="3605708" y="3246120"/>
+            <a:off x="3605708" y="3803904"/>
             <a:ext cx="2160956" cy="530352"/>
           </a:xfrm>
           <a:prstGeom prst="rect">
@@ -19477,7 +19477,7 @@
         </p:nvCxnSpPr>
         <p:spPr>
           <a:xfrm>
-            <a:off x="3605708" y="3813048"/>
+            <a:off x="3605708" y="4279392"/>
             <a:ext cx="2160956" cy="0"/>
           </a:xfrm>
           <a:prstGeom prst="straightConnector1">
@@ -19503,7 +19503,7 @@
         </p:nvSpPr>
         <p:spPr>
           <a:xfrm>
-            <a:off x="3605708" y="3886200"/>
+            <a:off x="3605708" y="4352544"/>
             <a:ext cx="2160956" cy="530352"/>
           </a:xfrm>
           <a:prstGeom prst="rect">
@@ -19566,7 +19566,7 @@
         </p:nvCxnSpPr>
         <p:spPr>
           <a:xfrm>
-            <a:off x="3605708" y="4453128"/>
+            <a:off x="3605708" y="4828032"/>
             <a:ext cx="2160956" cy="0"/>
           </a:xfrm>
           <a:prstGeom prst="straightConnector1">
@@ -19592,7 +19592,7 @@
         </p:nvSpPr>
         <p:spPr>
           <a:xfrm>
-            <a:off x="3605708" y="4526280"/>
+            <a:off x="3605708" y="4901184"/>
             <a:ext cx="2160956" cy="530352"/>
           </a:xfrm>
           <a:prstGeom prst="rect">
@@ -19655,8 +19655,8 @@
         </p:nvSpPr>
         <p:spPr>
           <a:xfrm>
-            <a:off x="6187288" y="1600200"/>
-            <a:ext cx="2636444" cy="3611880"/>
+            <a:off x="6187288" y="2157984"/>
+            <a:ext cx="2636444" cy="3410712"/>
           </a:xfrm>
           <a:prstGeom prst="rect">
             <a:avLst/>
@@ -19701,7 +19701,7 @@
         </p:nvSpPr>
         <p:spPr>
           <a:xfrm>
-            <a:off x="6425032" y="1783080"/>
+            <a:off x="6425032" y="2340864"/>
             <a:ext cx="2160956" cy="329184"/>
           </a:xfrm>
           <a:prstGeom prst="rect">
@@ -19764,7 +19764,7 @@
         </p:nvSpPr>
         <p:spPr>
           <a:xfrm>
-            <a:off x="6425032" y="2130552"/>
+            <a:off x="6425032" y="2688336"/>
             <a:ext cx="2160956" cy="658368"/>
           </a:xfrm>
           <a:prstGeom prst="rect">
@@ -19827,7 +19827,7 @@
         </p:nvSpPr>
         <p:spPr>
           <a:xfrm>
-            <a:off x="6425032" y="2788920"/>
+            <a:off x="6425032" y="3346704"/>
             <a:ext cx="2160956" cy="237744"/>
           </a:xfrm>
           <a:prstGeom prst="rect">
@@ -19890,7 +19890,7 @@
         </p:nvCxnSpPr>
         <p:spPr>
           <a:xfrm>
-            <a:off x="6425032" y="3172968"/>
+            <a:off x="6425032" y="3730752"/>
             <a:ext cx="2160956" cy="0"/>
           </a:xfrm>
           <a:prstGeom prst="straightConnector1">
@@ -19916,7 +19916,7 @@
         </p:nvSpPr>
         <p:spPr>
           <a:xfrm>
-            <a:off x="6425032" y="3246120"/>
+            <a:off x="6425032" y="3803904"/>
             <a:ext cx="2160956" cy="530352"/>
           </a:xfrm>
           <a:prstGeom prst="rect">
@@ -19979,7 +19979,7 @@
         </p:nvCxnSpPr>
         <p:spPr>
           <a:xfrm>
-            <a:off x="6425032" y="3813048"/>
+            <a:off x="6425032" y="4279392"/>
             <a:ext cx="2160956" cy="0"/>
           </a:xfrm>
           <a:prstGeom prst="straightConnector1">
@@ -20005,7 +20005,7 @@
         </p:nvSpPr>
         <p:spPr>
           <a:xfrm>
-            <a:off x="6425032" y="3886200"/>
+            <a:off x="6425032" y="4352544"/>
             <a:ext cx="2160956" cy="530352"/>
           </a:xfrm>
           <a:prstGeom prst="rect">
@@ -20068,7 +20068,7 @@
         </p:nvCxnSpPr>
         <p:spPr>
           <a:xfrm>
-            <a:off x="6425032" y="4453128"/>
+            <a:off x="6425032" y="4828032"/>
             <a:ext cx="2160956" cy="0"/>
           </a:xfrm>
           <a:prstGeom prst="straightConnector1">
@@ -20094,7 +20094,7 @@
         </p:nvSpPr>
         <p:spPr>
           <a:xfrm>
-            <a:off x="6425032" y="4526280"/>
+            <a:off x="6425032" y="4901184"/>
             <a:ext cx="2160956" cy="530352"/>
           </a:xfrm>
           <a:prstGeom prst="rect">
@@ -20157,8 +20157,8 @@
         </p:nvSpPr>
         <p:spPr>
           <a:xfrm>
-            <a:off x="9006611" y="1600200"/>
-            <a:ext cx="2636444" cy="3611880"/>
+            <a:off x="9006611" y="2157984"/>
+            <a:ext cx="2636444" cy="3410712"/>
           </a:xfrm>
           <a:prstGeom prst="rect">
             <a:avLst/>
@@ -20203,7 +20203,7 @@
         </p:nvSpPr>
         <p:spPr>
           <a:xfrm>
-            <a:off x="9244355" y="1783080"/>
+            <a:off x="9244355" y="2340864"/>
             <a:ext cx="2160956" cy="329184"/>
           </a:xfrm>
           <a:prstGeom prst="rect">
@@ -20266,7 +20266,7 @@
         </p:nvSpPr>
         <p:spPr>
           <a:xfrm>
-            <a:off x="9244355" y="2130552"/>
+            <a:off x="9244355" y="2688336"/>
             <a:ext cx="2160956" cy="658368"/>
           </a:xfrm>
           <a:prstGeom prst="rect">
@@ -20329,7 +20329,7 @@
         </p:nvSpPr>
         <p:spPr>
           <a:xfrm>
-            <a:off x="9244355" y="2788920"/>
+            <a:off x="9244355" y="3346704"/>
             <a:ext cx="2160956" cy="237744"/>
           </a:xfrm>
           <a:prstGeom prst="rect">
@@ -20429,7 +20429,7 @@
         </p:nvCxnSpPr>
         <p:spPr>
           <a:xfrm>
-            <a:off x="9244355" y="3172968"/>
+            <a:off x="9244355" y="3730752"/>
             <a:ext cx="2160956" cy="0"/>
           </a:xfrm>
           <a:prstGeom prst="straightConnector1">
@@ -20455,7 +20455,7 @@
         </p:nvSpPr>
         <p:spPr>
           <a:xfrm>
-            <a:off x="9244355" y="3246120"/>
+            <a:off x="9244355" y="3803904"/>
             <a:ext cx="2160956" cy="530352"/>
           </a:xfrm>
           <a:prstGeom prst="rect">
@@ -20518,7 +20518,7 @@
         </p:nvCxnSpPr>
         <p:spPr>
           <a:xfrm>
-            <a:off x="9244355" y="3813048"/>
+            <a:off x="9244355" y="4279392"/>
             <a:ext cx="2160956" cy="0"/>
           </a:xfrm>
           <a:prstGeom prst="straightConnector1">
@@ -20544,7 +20544,7 @@
         </p:nvSpPr>
         <p:spPr>
           <a:xfrm>
-            <a:off x="9244355" y="3886200"/>
+            <a:off x="9244355" y="4352544"/>
             <a:ext cx="2160956" cy="530352"/>
           </a:xfrm>
           <a:prstGeom prst="rect">
@@ -20631,7 +20631,7 @@
         </p:nvCxnSpPr>
         <p:spPr>
           <a:xfrm>
-            <a:off x="9244355" y="4453128"/>
+            <a:off x="9244355" y="4828032"/>
             <a:ext cx="2160956" cy="0"/>
           </a:xfrm>
           <a:prstGeom prst="straightConnector1">
@@ -20657,7 +20657,7 @@
         </p:nvSpPr>
         <p:spPr>
           <a:xfrm>
-            <a:off x="9244355" y="4526280"/>
+            <a:off x="9244355" y="4901184"/>
             <a:ext cx="2160956" cy="530352"/>
           </a:xfrm>
           <a:prstGeom prst="rect">
@@ -20766,7 +20766,7 @@
         </p:nvSpPr>
         <p:spPr>
           <a:xfrm>
-            <a:off x="548640" y="5468112"/>
+            <a:off x="548640" y="5669280"/>
             <a:ext cx="11094415" cy="420624"/>
           </a:xfrm>
           <a:prstGeom prst="rect">
@@ -20987,6 +20987,514 @@
               <a:cs typeface="Instrument Sans"/>
               <a:sym typeface="Instrument Sans"/>
             </a:endParaRPr>
+          </a:p>
+        </p:txBody>
+      </p:sp>
+      <p:sp>
+        <p:nvSpPr>
+          <p:cNvPr id="3001" name="SimReal 3001"/>
+          <p:cNvSpPr txBox="1"/>
+          <p:nvPr/>
+        </p:nvSpPr>
+        <p:spPr>
+          <a:xfrm>
+            <a:off x="548640" y="1353312"/>
+            <a:ext cx="7315200" cy="182880"/>
+          </a:xfrm>
+          <a:prstGeom prst="rect">
+            <a:avLst/>
+          </a:prstGeom>
+          <a:noFill/>
+          <a:ln>
+            <a:noFill/>
+          </a:ln>
+        </p:spPr>
+        <p:txBody>
+          <a:bodyPr spcFirstLastPara="1" wrap="square" lIns="0" tIns="0" rIns="0" bIns="0" anchor="t" anchorCtr="0">
+            <a:noAutofit/>
+          </a:bodyPr>
+          <a:lstStyle/>
+          <a:p>
+            <a:pPr marL="0" marR="0" lvl="0" indent="0" algn="l" rtl="0">
+              <a:spcBef>
+                <a:spcPts val="0"/>
+              </a:spcBef>
+              <a:spcAft>
+                <a:spcPts val="0"/>
+              </a:spcAft>
+              <a:buNone/>
+            </a:pPr>
+            <a:r>
+              <a:rPr lang="zh-CN" sz="1000" b="0" i="0" u="none" strike="noStrike" cap="none">
+                <a:solidFill>
+                  <a:srgbClr val="6E6C66"/>
+                </a:solidFill>
+                <a:latin typeface="IBM Plex Mono"/>
+                <a:ea typeface="IBM Plex Mono"/>
+                <a:cs typeface="IBM Plex Mono"/>
+                <a:sym typeface="IBM Plex Mono"/>
+              </a:rPr>
+              <a:t>AI的热点一直在变</a:t>
+            </a:r>
+          </a:p>
+        </p:txBody>
+      </p:sp>
+      <p:sp>
+        <p:nvSpPr>
+          <p:cNvPr id="3002" name="SimReal 3002"/>
+          <p:cNvSpPr/>
+          <p:nvPr/>
+        </p:nvSpPr>
+        <p:spPr>
+          <a:xfrm>
+            <a:off x="548640" y="1591056"/>
+            <a:ext cx="2633472" cy="438912"/>
+          </a:xfrm>
+          <a:prstGeom prst="rect">
+            <a:avLst/>
+          </a:prstGeom>
+          <a:solidFill>
+            <a:srgbClr val="F2F1EC"/>
+          </a:solidFill>
+          <a:ln>
+            <a:noFill/>
+          </a:ln>
+        </p:spPr>
+        <p:txBody>
+          <a:bodyPr/>
+          <a:lstStyle/>
+          <a:p>
+            <a:endParaRPr/>
+          </a:p>
+        </p:txBody>
+      </p:sp>
+      <p:sp>
+        <p:nvSpPr>
+          <p:cNvPr id="3003" name="SimReal 3003"/>
+          <p:cNvSpPr txBox="1"/>
+          <p:nvPr/>
+        </p:nvSpPr>
+        <p:spPr>
+          <a:xfrm>
+            <a:off x="786384" y="1591056"/>
+            <a:ext cx="2267712" cy="438912"/>
+          </a:xfrm>
+          <a:prstGeom prst="rect">
+            <a:avLst/>
+          </a:prstGeom>
+          <a:noFill/>
+          <a:ln>
+            <a:noFill/>
+          </a:ln>
+        </p:spPr>
+        <p:txBody>
+          <a:bodyPr spcFirstLastPara="1" wrap="square" lIns="0" tIns="0" rIns="0" bIns="0" anchor="ctr" anchorCtr="0">
+            <a:noAutofit/>
+          </a:bodyPr>
+          <a:lstStyle/>
+          <a:p>
+            <a:pPr marL="0" marR="0" lvl="0" indent="0" algn="l" rtl="0">
+              <a:spcBef>
+                <a:spcPts val="0"/>
+              </a:spcBef>
+              <a:spcAft>
+                <a:spcPts val="0"/>
+              </a:spcAft>
+              <a:buNone/>
+            </a:pPr>
+            <a:r>
+              <a:rPr lang="zh-CN" sz="1400" b="0" i="0" u="none" strike="noStrike" cap="none">
+                <a:solidFill>
+                  <a:srgbClr val="111110"/>
+                </a:solidFill>
+                <a:latin typeface="Newsreader"/>
+                <a:ea typeface="Newsreader"/>
+                <a:cs typeface="Newsreader"/>
+                <a:sym typeface="Newsreader"/>
+              </a:rPr>
+              <a:t>数据标注</a:t>
+            </a:r>
+          </a:p>
+        </p:txBody>
+      </p:sp>
+      <p:sp>
+        <p:nvSpPr>
+          <p:cNvPr id="3004" name="SimReal 3004"/>
+          <p:cNvSpPr txBox="1"/>
+          <p:nvPr/>
+        </p:nvSpPr>
+        <p:spPr>
+          <a:xfrm>
+            <a:off x="3182112" y="1591056"/>
+            <a:ext cx="182880" cy="438912"/>
+          </a:xfrm>
+          <a:prstGeom prst="rect">
+            <a:avLst/>
+          </a:prstGeom>
+          <a:noFill/>
+          <a:ln>
+            <a:noFill/>
+          </a:ln>
+        </p:spPr>
+        <p:txBody>
+          <a:bodyPr spcFirstLastPara="1" wrap="square" lIns="0" tIns="0" rIns="0" bIns="0" anchor="ctr" anchorCtr="0">
+            <a:noAutofit/>
+          </a:bodyPr>
+          <a:lstStyle/>
+          <a:p>
+            <a:pPr marL="0" marR="0" lvl="0" indent="0" algn="ctr" rtl="0">
+              <a:spcBef>
+                <a:spcPts val="0"/>
+              </a:spcBef>
+              <a:spcAft>
+                <a:spcPts val="0"/>
+              </a:spcAft>
+              <a:buNone/>
+            </a:pPr>
+            <a:r>
+              <a:rPr lang="zh-CN" sz="1100" b="0" i="0" u="none" strike="noStrike" cap="none">
+                <a:solidFill>
+                  <a:srgbClr val="6E6C66"/>
+                </a:solidFill>
+                <a:latin typeface="Instrument Sans"/>
+                <a:ea typeface="Instrument Sans"/>
+                <a:cs typeface="Instrument Sans"/>
+                <a:sym typeface="Instrument Sans"/>
+              </a:rPr>
+              <a:t>→</a:t>
+            </a:r>
+          </a:p>
+        </p:txBody>
+      </p:sp>
+      <p:sp>
+        <p:nvSpPr>
+          <p:cNvPr id="3005" name="SimReal 3005"/>
+          <p:cNvSpPr/>
+          <p:nvPr/>
+        </p:nvSpPr>
+        <p:spPr>
+          <a:xfrm>
+            <a:off x="3364992" y="1591056"/>
+            <a:ext cx="2633472" cy="438912"/>
+          </a:xfrm>
+          <a:prstGeom prst="rect">
+            <a:avLst/>
+          </a:prstGeom>
+          <a:solidFill>
+            <a:srgbClr val="F2F1EC"/>
+          </a:solidFill>
+          <a:ln>
+            <a:noFill/>
+          </a:ln>
+        </p:spPr>
+        <p:txBody>
+          <a:bodyPr/>
+          <a:lstStyle/>
+          <a:p>
+            <a:endParaRPr/>
+          </a:p>
+        </p:txBody>
+      </p:sp>
+      <p:sp>
+        <p:nvSpPr>
+          <p:cNvPr id="3006" name="SimReal 3006"/>
+          <p:cNvSpPr txBox="1"/>
+          <p:nvPr/>
+        </p:nvSpPr>
+        <p:spPr>
+          <a:xfrm>
+            <a:off x="3602736" y="1591056"/>
+            <a:ext cx="2267712" cy="438912"/>
+          </a:xfrm>
+          <a:prstGeom prst="rect">
+            <a:avLst/>
+          </a:prstGeom>
+          <a:noFill/>
+          <a:ln>
+            <a:noFill/>
+          </a:ln>
+        </p:spPr>
+        <p:txBody>
+          <a:bodyPr spcFirstLastPara="1" wrap="square" lIns="0" tIns="0" rIns="0" bIns="0" anchor="ctr" anchorCtr="0">
+            <a:noAutofit/>
+          </a:bodyPr>
+          <a:lstStyle/>
+          <a:p>
+            <a:pPr marL="0" marR="0" lvl="0" indent="0" algn="l" rtl="0">
+              <a:spcBef>
+                <a:spcPts val="0"/>
+              </a:spcBef>
+              <a:spcAft>
+                <a:spcPts val="0"/>
+              </a:spcAft>
+              <a:buNone/>
+            </a:pPr>
+            <a:r>
+              <a:rPr lang="zh-CN" sz="1400" b="0" i="0" u="none" strike="noStrike" cap="none">
+                <a:solidFill>
+                  <a:srgbClr val="111110"/>
+                </a:solidFill>
+                <a:latin typeface="Newsreader"/>
+                <a:ea typeface="Newsreader"/>
+                <a:cs typeface="Newsreader"/>
+                <a:sym typeface="Newsreader"/>
+              </a:rPr>
+              <a:t>专家数据</a:t>
+            </a:r>
+          </a:p>
+        </p:txBody>
+      </p:sp>
+      <p:sp>
+        <p:nvSpPr>
+          <p:cNvPr id="3007" name="SimReal 3007"/>
+          <p:cNvSpPr txBox="1"/>
+          <p:nvPr/>
+        </p:nvSpPr>
+        <p:spPr>
+          <a:xfrm>
+            <a:off x="5998464" y="1591056"/>
+            <a:ext cx="192024" cy="438912"/>
+          </a:xfrm>
+          <a:prstGeom prst="rect">
+            <a:avLst/>
+          </a:prstGeom>
+          <a:noFill/>
+          <a:ln>
+            <a:noFill/>
+          </a:ln>
+        </p:spPr>
+        <p:txBody>
+          <a:bodyPr spcFirstLastPara="1" wrap="square" lIns="0" tIns="0" rIns="0" bIns="0" anchor="ctr" anchorCtr="0">
+            <a:noAutofit/>
+          </a:bodyPr>
+          <a:lstStyle/>
+          <a:p>
+            <a:pPr marL="0" marR="0" lvl="0" indent="0" algn="ctr" rtl="0">
+              <a:spcBef>
+                <a:spcPts val="0"/>
+              </a:spcBef>
+              <a:spcAft>
+                <a:spcPts val="0"/>
+              </a:spcAft>
+              <a:buNone/>
+            </a:pPr>
+            <a:r>
+              <a:rPr lang="zh-CN" sz="1100" b="0" i="0" u="none" strike="noStrike" cap="none">
+                <a:solidFill>
+                  <a:srgbClr val="6E6C66"/>
+                </a:solidFill>
+                <a:latin typeface="Instrument Sans"/>
+                <a:ea typeface="Instrument Sans"/>
+                <a:cs typeface="Instrument Sans"/>
+                <a:sym typeface="Instrument Sans"/>
+              </a:rPr>
+              <a:t>→</a:t>
+            </a:r>
+          </a:p>
+        </p:txBody>
+      </p:sp>
+      <p:sp>
+        <p:nvSpPr>
+          <p:cNvPr id="3008" name="SimReal 3008"/>
+          <p:cNvSpPr/>
+          <p:nvPr/>
+        </p:nvSpPr>
+        <p:spPr>
+          <a:xfrm>
+            <a:off x="6190488" y="1591056"/>
+            <a:ext cx="2633472" cy="438912"/>
+          </a:xfrm>
+          <a:prstGeom prst="rect">
+            <a:avLst/>
+          </a:prstGeom>
+          <a:solidFill>
+            <a:srgbClr val="F2F1EC"/>
+          </a:solidFill>
+          <a:ln>
+            <a:noFill/>
+          </a:ln>
+        </p:spPr>
+        <p:txBody>
+          <a:bodyPr/>
+          <a:lstStyle/>
+          <a:p>
+            <a:endParaRPr/>
+          </a:p>
+        </p:txBody>
+      </p:sp>
+      <p:sp>
+        <p:nvSpPr>
+          <p:cNvPr id="3009" name="SimReal 3009"/>
+          <p:cNvSpPr txBox="1"/>
+          <p:nvPr/>
+        </p:nvSpPr>
+        <p:spPr>
+          <a:xfrm>
+            <a:off x="6428232" y="1591056"/>
+            <a:ext cx="2267712" cy="438912"/>
+          </a:xfrm>
+          <a:prstGeom prst="rect">
+            <a:avLst/>
+          </a:prstGeom>
+          <a:noFill/>
+          <a:ln>
+            <a:noFill/>
+          </a:ln>
+        </p:spPr>
+        <p:txBody>
+          <a:bodyPr spcFirstLastPara="1" wrap="square" lIns="0" tIns="0" rIns="0" bIns="0" anchor="ctr" anchorCtr="0">
+            <a:noAutofit/>
+          </a:bodyPr>
+          <a:lstStyle/>
+          <a:p>
+            <a:pPr marL="0" marR="0" lvl="0" indent="0" algn="l" rtl="0">
+              <a:spcBef>
+                <a:spcPts val="0"/>
+              </a:spcBef>
+              <a:spcAft>
+                <a:spcPts val="0"/>
+              </a:spcAft>
+              <a:buNone/>
+            </a:pPr>
+            <a:r>
+              <a:rPr lang="zh-CN" sz="1400" b="0" i="0" u="none" strike="noStrike" cap="none">
+                <a:solidFill>
+                  <a:srgbClr val="111110"/>
+                </a:solidFill>
+                <a:latin typeface="Newsreader"/>
+                <a:ea typeface="Newsreader"/>
+                <a:cs typeface="Newsreader"/>
+                <a:sym typeface="Newsreader"/>
+              </a:rPr>
+              <a:t>RL环境</a:t>
+            </a:r>
+          </a:p>
+        </p:txBody>
+      </p:sp>
+      <p:sp>
+        <p:nvSpPr>
+          <p:cNvPr id="3010" name="SimReal 3010"/>
+          <p:cNvSpPr txBox="1"/>
+          <p:nvPr/>
+        </p:nvSpPr>
+        <p:spPr>
+          <a:xfrm>
+            <a:off x="8823960" y="1591056"/>
+            <a:ext cx="182880" cy="438912"/>
+          </a:xfrm>
+          <a:prstGeom prst="rect">
+            <a:avLst/>
+          </a:prstGeom>
+          <a:noFill/>
+          <a:ln>
+            <a:noFill/>
+          </a:ln>
+        </p:spPr>
+        <p:txBody>
+          <a:bodyPr spcFirstLastPara="1" wrap="square" lIns="0" tIns="0" rIns="0" bIns="0" anchor="ctr" anchorCtr="0">
+            <a:noAutofit/>
+          </a:bodyPr>
+          <a:lstStyle/>
+          <a:p>
+            <a:pPr marL="0" marR="0" lvl="0" indent="0" algn="ctr" rtl="0">
+              <a:spcBef>
+                <a:spcPts val="0"/>
+              </a:spcBef>
+              <a:spcAft>
+                <a:spcPts val="0"/>
+              </a:spcAft>
+              <a:buNone/>
+            </a:pPr>
+            <a:r>
+              <a:rPr lang="zh-CN" sz="1100" b="0" i="0" u="none" strike="noStrike" cap="none">
+                <a:solidFill>
+                  <a:srgbClr val="6E6C66"/>
+                </a:solidFill>
+                <a:latin typeface="Instrument Sans"/>
+                <a:ea typeface="Instrument Sans"/>
+                <a:cs typeface="Instrument Sans"/>
+                <a:sym typeface="Instrument Sans"/>
+              </a:rPr>
+              <a:t>→</a:t>
+            </a:r>
+          </a:p>
+        </p:txBody>
+      </p:sp>
+      <p:sp>
+        <p:nvSpPr>
+          <p:cNvPr id="3011" name="SimReal 3011"/>
+          <p:cNvSpPr/>
+          <p:nvPr/>
+        </p:nvSpPr>
+        <p:spPr>
+          <a:xfrm>
+            <a:off x="9006840" y="1591056"/>
+            <a:ext cx="2633472" cy="438912"/>
+          </a:xfrm>
+          <a:prstGeom prst="rect">
+            <a:avLst/>
+          </a:prstGeom>
+          <a:solidFill>
+            <a:srgbClr val="111110"/>
+          </a:solidFill>
+          <a:ln>
+            <a:noFill/>
+          </a:ln>
+        </p:spPr>
+        <p:txBody>
+          <a:bodyPr/>
+          <a:lstStyle/>
+          <a:p>
+            <a:endParaRPr/>
+          </a:p>
+        </p:txBody>
+      </p:sp>
+      <p:sp>
+        <p:nvSpPr>
+          <p:cNvPr id="3012" name="SimReal 3012"/>
+          <p:cNvSpPr txBox="1"/>
+          <p:nvPr/>
+        </p:nvSpPr>
+        <p:spPr>
+          <a:xfrm>
+            <a:off x="9244584" y="1591056"/>
+            <a:ext cx="2267712" cy="438912"/>
+          </a:xfrm>
+          <a:prstGeom prst="rect">
+            <a:avLst/>
+          </a:prstGeom>
+          <a:noFill/>
+          <a:ln>
+            <a:noFill/>
+          </a:ln>
+        </p:spPr>
+        <p:txBody>
+          <a:bodyPr spcFirstLastPara="1" wrap="square" lIns="0" tIns="0" rIns="0" bIns="0" anchor="ctr" anchorCtr="0">
+            <a:noAutofit/>
+          </a:bodyPr>
+          <a:lstStyle/>
+          <a:p>
+            <a:pPr marL="0" marR="0" lvl="0" indent="0" algn="l" rtl="0">
+              <a:spcBef>
+                <a:spcPts val="0"/>
+              </a:spcBef>
+              <a:spcAft>
+                <a:spcPts val="0"/>
+              </a:spcAft>
+              <a:buNone/>
+            </a:pPr>
+            <a:r>
+              <a:rPr lang="zh-CN" sz="1400" b="0" i="0" u="none" strike="noStrike" cap="none">
+                <a:solidFill>
+                  <a:srgbClr val="FAF9F6"/>
+                </a:solidFill>
+                <a:latin typeface="Newsreader"/>
+                <a:ea typeface="Newsreader"/>
+                <a:cs typeface="Newsreader"/>
+                <a:sym typeface="Newsreader"/>
+              </a:rPr>
+              <a:t>自我进化</a:t>
+            </a:r>
           </a:p>
         </p:txBody>
       </p:sp>

</xml_diff>

<commit_message>
BP v17: page 11 explains why labs keep paying
Rebuild the business-model page around four stages (paid pilot, license,
continuous updates, joint training/RSI): what the lab buys, what it pays
for, and why it buys again. Products and the AfterQuery proof shrink to
one line; three notes cover open-source vs paid, exclusive vs
non-exclusive, and what we still provide after delivery. Page 15's
stickiness line now says each upgrade needs new tasks, held-out sets and
verifier upkeep, rather than implying labs rebuy the same environment.

Co-Authored-By: Claude Opus 5.5 <noreply@anthropic.com>
Claude-Session: https://claude.ai/code/session_01EKqGwTA92C8Wo4e47t73NN
</commit_message>
<xml_diff>
--- a/SimReal-BP-v17.pptx
+++ b/SimReal-BP-v17.pptx
@@ -9134,955 +9134,6 @@
           <a:chExt cx="0" cy="0"/>
         </a:xfrm>
       </p:grpSpPr>
-      <p:sp>
-        <p:nvSpPr>
-          <p:cNvPr id="344" name="Google Shape;344;p13"/>
-          <p:cNvSpPr txBox="1"/>
-          <p:nvPr/>
-        </p:nvSpPr>
-        <p:spPr>
-          <a:xfrm>
-            <a:off x="548640" y="384048"/>
-            <a:ext cx="8229600" cy="219456"/>
-          </a:xfrm>
-          <a:prstGeom prst="rect">
-            <a:avLst/>
-          </a:prstGeom>
-          <a:noFill/>
-          <a:ln>
-            <a:noFill/>
-          </a:ln>
-        </p:spPr>
-        <p:txBody>
-          <a:bodyPr spcFirstLastPara="1" wrap="square" lIns="0" tIns="0" rIns="0" bIns="0" anchor="ctr" anchorCtr="0">
-            <a:noAutofit/>
-          </a:bodyPr>
-          <a:lstStyle/>
-          <a:p>
-            <a:pPr marL="0" marR="0" lvl="0" indent="0" algn="l" rtl="0">
-              <a:spcBef>
-                <a:spcPts val="0"/>
-              </a:spcBef>
-              <a:spcAft>
-                <a:spcPts val="0"/>
-              </a:spcAft>
-              <a:buClr>
-                <a:srgbClr val="C2410C"/>
-              </a:buClr>
-              <a:buSzPts val="1000"/>
-              <a:buFont typeface="IBM Plex Mono"/>
-              <a:buNone/>
-            </a:pPr>
-            <a:r>
-              <a:rPr lang="zh-CN" sz="1000" b="1" i="0" u="none" strike="noStrike" cap="none">
-                <a:solidFill>
-                  <a:srgbClr val="C2410C"/>
-                </a:solidFill>
-                <a:latin typeface="IBM Plex Mono"/>
-                <a:ea typeface="IBM Plex Mono"/>
-                <a:cs typeface="IBM Plex Mono"/>
-                <a:sym typeface="IBM Plex Mono"/>
-              </a:rPr>
-              <a:t>11</a:t>
-            </a:r>
-            <a:r>
-              <a:rPr lang="zh-CN" sz="1100" b="1" i="0" u="none" strike="noStrike" cap="none">
-                <a:solidFill>
-                  <a:srgbClr val="6E6C66"/>
-                </a:solidFill>
-                <a:latin typeface="Instrument Sans"/>
-                <a:ea typeface="Instrument Sans"/>
-                <a:cs typeface="Instrument Sans"/>
-                <a:sym typeface="Instrument Sans"/>
-              </a:rPr>
-              <a:t>    商业模式</a:t>
-            </a:r>
-            <a:endParaRPr sz="1300" b="1" i="0" u="none" strike="noStrike" cap="none">
-              <a:solidFill>
-                <a:schemeClr val="dk1"/>
-              </a:solidFill>
-              <a:latin typeface="Instrument Sans"/>
-              <a:ea typeface="Instrument Sans"/>
-              <a:cs typeface="Instrument Sans"/>
-              <a:sym typeface="Instrument Sans"/>
-            </a:endParaRPr>
-          </a:p>
-        </p:txBody>
-      </p:sp>
-      <p:sp>
-        <p:nvSpPr>
-          <p:cNvPr id="345" name="Google Shape;345;p13"/>
-          <p:cNvSpPr txBox="1"/>
-          <p:nvPr/>
-        </p:nvSpPr>
-        <p:spPr>
-          <a:xfrm>
-            <a:off x="548640" y="676656"/>
-            <a:ext cx="11094415" cy="566928"/>
-          </a:xfrm>
-          <a:prstGeom prst="rect">
-            <a:avLst/>
-          </a:prstGeom>
-          <a:noFill/>
-          <a:ln>
-            <a:noFill/>
-          </a:ln>
-        </p:spPr>
-        <p:txBody>
-          <a:bodyPr spcFirstLastPara="1" wrap="square" lIns="0" tIns="0" rIns="0" bIns="0" anchor="t" anchorCtr="0">
-            <a:noAutofit/>
-          </a:bodyPr>
-          <a:lstStyle/>
-          <a:p>
-            <a:pPr marL="0" marR="0" lvl="0" indent="0" algn="l" rtl="0">
-              <a:spcBef>
-                <a:spcPts val="0"/>
-              </a:spcBef>
-              <a:spcAft>
-                <a:spcPts val="0"/>
-              </a:spcAft>
-              <a:buClr>
-                <a:srgbClr val="111110"/>
-              </a:buClr>
-              <a:buSzPts val="2800"/>
-              <a:buFont typeface="Newsreader"/>
-              <a:buNone/>
-            </a:pPr>
-            <a:r>
-              <a:rPr lang="zh-CN" sz="2800" b="0" i="0" u="none" strike="noStrike" cap="none">
-                <a:solidFill>
-                  <a:srgbClr val="111110"/>
-                </a:solidFill>
-                <a:latin typeface="Newsreader"/>
-                <a:ea typeface="Newsreader"/>
-                <a:cs typeface="Newsreader"/>
-                <a:sym typeface="Newsreader"/>
-              </a:rPr>
-              <a:t>环境与数据打开合作，</a:t>
-            </a:r>
-            <a:r>
-              <a:rPr lang="zh-CN" sz="2800" b="0" i="0" u="none" strike="noStrike" cap="none">
-                <a:solidFill>
-                  <a:srgbClr val="C2410C"/>
-                </a:solidFill>
-                <a:latin typeface="Newsreader"/>
-                <a:ea typeface="Newsreader"/>
-                <a:cs typeface="Newsreader"/>
-                <a:sym typeface="Newsreader"/>
-              </a:rPr>
-              <a:t>自我进化服务带来持续收入</a:t>
-            </a:r>
-            <a:endParaRPr sz="2800" b="0" i="0" u="none" strike="noStrike" cap="none">
-              <a:solidFill>
-                <a:schemeClr val="dk1"/>
-              </a:solidFill>
-              <a:latin typeface="Instrument Sans"/>
-              <a:ea typeface="Instrument Sans"/>
-              <a:cs typeface="Instrument Sans"/>
-              <a:sym typeface="Instrument Sans"/>
-            </a:endParaRPr>
-          </a:p>
-        </p:txBody>
-      </p:sp>
-      <p:sp>
-        <p:nvSpPr>
-          <p:cNvPr id="363" name="Google Shape;363;p13"/>
-          <p:cNvSpPr txBox="1"/>
-          <p:nvPr/>
-        </p:nvSpPr>
-        <p:spPr>
-          <a:xfrm>
-            <a:off x="548640" y="4041648"/>
-            <a:ext cx="3657600" cy="201168"/>
-          </a:xfrm>
-          <a:prstGeom prst="rect">
-            <a:avLst/>
-          </a:prstGeom>
-          <a:noFill/>
-          <a:ln>
-            <a:noFill/>
-          </a:ln>
-        </p:spPr>
-        <p:txBody>
-          <a:bodyPr spcFirstLastPara="1" wrap="square" lIns="0" tIns="0" rIns="0" bIns="0" anchor="t" anchorCtr="0">
-            <a:noAutofit/>
-          </a:bodyPr>
-          <a:lstStyle/>
-          <a:p>
-            <a:pPr marL="0" marR="0" lvl="0" indent="0" algn="l" rtl="0">
-              <a:spcBef>
-                <a:spcPts val="0"/>
-              </a:spcBef>
-              <a:spcAft>
-                <a:spcPts val="0"/>
-              </a:spcAft>
-              <a:buClr>
-                <a:srgbClr val="6E6C66"/>
-              </a:buClr>
-              <a:buSzPts val="1000"/>
-              <a:buFont typeface="IBM Plex Mono"/>
-              <a:buNone/>
-            </a:pPr>
-            <a:r>
-              <a:rPr lang="zh-CN" sz="1000" b="0" i="0" u="none" strike="noStrike" cap="none">
-                <a:solidFill>
-                  <a:srgbClr val="6E6C66"/>
-                </a:solidFill>
-                <a:latin typeface="IBM Plex Mono"/>
-                <a:ea typeface="IBM Plex Mono"/>
-                <a:cs typeface="IBM Plex Mono"/>
-                <a:sym typeface="IBM Plex Mono"/>
-              </a:rPr>
-              <a:t>收费路径</a:t>
-            </a:r>
-            <a:endParaRPr sz="1000" b="0" i="0" u="none" strike="noStrike" cap="none">
-              <a:solidFill>
-                <a:schemeClr val="dk1"/>
-              </a:solidFill>
-              <a:latin typeface="Instrument Sans"/>
-              <a:ea typeface="Instrument Sans"/>
-              <a:cs typeface="Instrument Sans"/>
-              <a:sym typeface="Instrument Sans"/>
-            </a:endParaRPr>
-          </a:p>
-        </p:txBody>
-      </p:sp>
-      <p:sp>
-        <p:nvSpPr>
-          <p:cNvPr id="364" name="Google Shape;364;p13"/>
-          <p:cNvSpPr txBox="1"/>
-          <p:nvPr/>
-        </p:nvSpPr>
-        <p:spPr>
-          <a:xfrm>
-            <a:off x="548640" y="4279392"/>
-            <a:ext cx="6400800" cy="274320"/>
-          </a:xfrm>
-          <a:prstGeom prst="rect">
-            <a:avLst/>
-          </a:prstGeom>
-          <a:noFill/>
-          <a:ln>
-            <a:noFill/>
-          </a:ln>
-        </p:spPr>
-        <p:txBody>
-          <a:bodyPr spcFirstLastPara="1" wrap="square" lIns="0" tIns="0" rIns="0" bIns="0" anchor="t" anchorCtr="0">
-            <a:noAutofit/>
-          </a:bodyPr>
-          <a:lstStyle/>
-          <a:p>
-            <a:pPr marL="0" marR="0" lvl="0" indent="0" algn="l" rtl="0">
-              <a:spcBef>
-                <a:spcPts val="0"/>
-              </a:spcBef>
-              <a:spcAft>
-                <a:spcPts val="0"/>
-              </a:spcAft>
-              <a:buClr>
-                <a:srgbClr val="6E6C66"/>
-              </a:buClr>
-              <a:buSzPts val="1100"/>
-              <a:buFont typeface="Instrument Sans"/>
-              <a:buNone/>
-            </a:pPr>
-            <a:r>
-              <a:rPr lang="zh-CN" sz="1100" b="0" i="0" u="none" strike="noStrike" cap="none">
-                <a:solidFill>
-                  <a:srgbClr val="6E6C66"/>
-                </a:solidFill>
-                <a:latin typeface="Instrument Sans"/>
-                <a:ea typeface="Instrument Sans"/>
-                <a:cs typeface="Instrument Sans"/>
-                <a:sym typeface="Instrument Sans"/>
-              </a:rPr>
-              <a:t>实验室每训一个新模型，就回来再买一轮</a:t>
-            </a:r>
-            <a:endParaRPr sz="1100" b="0" i="0" u="none" strike="noStrike" cap="none">
-              <a:solidFill>
-                <a:schemeClr val="dk1"/>
-              </a:solidFill>
-              <a:latin typeface="Instrument Sans"/>
-              <a:ea typeface="Instrument Sans"/>
-              <a:cs typeface="Instrument Sans"/>
-              <a:sym typeface="Instrument Sans"/>
-            </a:endParaRPr>
-          </a:p>
-        </p:txBody>
-      </p:sp>
-      <p:sp>
-        <p:nvSpPr>
-          <p:cNvPr id="365" name="Google Shape;365;p13"/>
-          <p:cNvSpPr/>
-          <p:nvPr/>
-        </p:nvSpPr>
-        <p:spPr>
-          <a:xfrm>
-            <a:off x="548640" y="5422392"/>
-            <a:ext cx="1531620" cy="475488"/>
-          </a:xfrm>
-          <a:prstGeom prst="rect">
-            <a:avLst/>
-          </a:prstGeom>
-          <a:solidFill>
-            <a:srgbClr val="E2E0DA"/>
-          </a:solidFill>
-          <a:ln w="12700" cap="flat" cmpd="sng">
-            <a:solidFill>
-              <a:srgbClr val="E2E0DA"/>
-            </a:solidFill>
-            <a:prstDash val="solid"/>
-            <a:round/>
-            <a:headEnd type="none" w="sm" len="sm"/>
-            <a:tailEnd type="none" w="sm" len="sm"/>
-          </a:ln>
-        </p:spPr>
-        <p:txBody>
-          <a:bodyPr spcFirstLastPara="1" wrap="square" lIns="91425" tIns="91425" rIns="91425" bIns="91425" anchor="ctr" anchorCtr="0">
-            <a:noAutofit/>
-          </a:bodyPr>
-          <a:lstStyle/>
-          <a:p>
-            <a:pPr marL="0" lvl="0" indent="0" algn="l" rtl="0">
-              <a:spcBef>
-                <a:spcPts val="0"/>
-              </a:spcBef>
-              <a:spcAft>
-                <a:spcPts val="0"/>
-              </a:spcAft>
-              <a:buNone/>
-            </a:pPr>
-            <a:endParaRPr/>
-          </a:p>
-        </p:txBody>
-      </p:sp>
-      <p:sp>
-        <p:nvSpPr>
-          <p:cNvPr id="366" name="Google Shape;366;p13"/>
-          <p:cNvSpPr txBox="1"/>
-          <p:nvPr/>
-        </p:nvSpPr>
-        <p:spPr>
-          <a:xfrm>
-            <a:off x="676656" y="5513832"/>
-            <a:ext cx="1348740" cy="274320"/>
-          </a:xfrm>
-          <a:prstGeom prst="rect">
-            <a:avLst/>
-          </a:prstGeom>
-          <a:noFill/>
-          <a:ln>
-            <a:noFill/>
-          </a:ln>
-        </p:spPr>
-        <p:txBody>
-          <a:bodyPr spcFirstLastPara="1" wrap="square" lIns="0" tIns="0" rIns="0" bIns="0" anchor="t" anchorCtr="0">
-            <a:noAutofit/>
-          </a:bodyPr>
-          <a:lstStyle/>
-          <a:p>
-            <a:pPr marL="0" marR="0" lvl="0" indent="0" algn="l" rtl="0">
-              <a:spcBef>
-                <a:spcPts val="0"/>
-              </a:spcBef>
-              <a:spcAft>
-                <a:spcPts val="0"/>
-              </a:spcAft>
-              <a:buClr>
-                <a:srgbClr val="6E6C66"/>
-              </a:buClr>
-              <a:buSzPts val="900"/>
-              <a:buFont typeface="IBM Plex Mono"/>
-              <a:buNone/>
-            </a:pPr>
-            <a:r>
-              <a:rPr lang="zh-CN" sz="900" b="0" i="0" u="none" strike="noStrike" cap="none">
-                <a:solidFill>
-                  <a:srgbClr val="6E6C66"/>
-                </a:solidFill>
-                <a:latin typeface="IBM Plex Mono"/>
-                <a:ea typeface="IBM Plex Mono"/>
-                <a:cs typeface="IBM Plex Mono"/>
-                <a:sym typeface="IBM Plex Mono"/>
-              </a:rPr>
-              <a:t>01  </a:t>
-            </a:r>
-            <a:r>
-              <a:rPr lang="zh-CN" sz="1200" b="0" i="0" u="none" strike="noStrike" cap="none">
-                <a:solidFill>
-                  <a:srgbClr val="111110"/>
-                </a:solidFill>
-                <a:latin typeface="Instrument Sans SemiBold"/>
-                <a:ea typeface="Instrument Sans SemiBold"/>
-                <a:cs typeface="Instrument Sans SemiBold"/>
-                <a:sym typeface="Instrument Sans SemiBold"/>
-              </a:rPr>
-              <a:t>免费基准</a:t>
-            </a:r>
-            <a:endParaRPr sz="1300" b="0" i="0" u="none" strike="noStrike" cap="none">
-              <a:solidFill>
-                <a:schemeClr val="dk1"/>
-              </a:solidFill>
-              <a:latin typeface="Instrument Sans"/>
-              <a:ea typeface="Instrument Sans"/>
-              <a:cs typeface="Instrument Sans"/>
-              <a:sym typeface="Instrument Sans"/>
-            </a:endParaRPr>
-          </a:p>
-        </p:txBody>
-      </p:sp>
-      <p:sp>
-        <p:nvSpPr>
-          <p:cNvPr id="367" name="Google Shape;367;p13"/>
-          <p:cNvSpPr/>
-          <p:nvPr/>
-        </p:nvSpPr>
-        <p:spPr>
-          <a:xfrm>
-            <a:off x="2171700" y="5148072"/>
-            <a:ext cx="1531620" cy="749808"/>
-          </a:xfrm>
-          <a:prstGeom prst="rect">
-            <a:avLst/>
-          </a:prstGeom>
-          <a:solidFill>
-            <a:srgbClr val="D9D6CE"/>
-          </a:solidFill>
-          <a:ln w="12700" cap="flat" cmpd="sng">
-            <a:solidFill>
-              <a:srgbClr val="D9D6CE"/>
-            </a:solidFill>
-            <a:prstDash val="solid"/>
-            <a:round/>
-            <a:headEnd type="none" w="sm" len="sm"/>
-            <a:tailEnd type="none" w="sm" len="sm"/>
-          </a:ln>
-        </p:spPr>
-        <p:txBody>
-          <a:bodyPr spcFirstLastPara="1" wrap="square" lIns="91425" tIns="91425" rIns="91425" bIns="91425" anchor="ctr" anchorCtr="0">
-            <a:noAutofit/>
-          </a:bodyPr>
-          <a:lstStyle/>
-          <a:p>
-            <a:pPr marL="0" lvl="0" indent="0" algn="l" rtl="0">
-              <a:spcBef>
-                <a:spcPts val="0"/>
-              </a:spcBef>
-              <a:spcAft>
-                <a:spcPts val="0"/>
-              </a:spcAft>
-              <a:buNone/>
-            </a:pPr>
-            <a:endParaRPr/>
-          </a:p>
-        </p:txBody>
-      </p:sp>
-      <p:sp>
-        <p:nvSpPr>
-          <p:cNvPr id="368" name="Google Shape;368;p13"/>
-          <p:cNvSpPr txBox="1"/>
-          <p:nvPr/>
-        </p:nvSpPr>
-        <p:spPr>
-          <a:xfrm>
-            <a:off x="2299716" y="5239512"/>
-            <a:ext cx="1348740" cy="274320"/>
-          </a:xfrm>
-          <a:prstGeom prst="rect">
-            <a:avLst/>
-          </a:prstGeom>
-          <a:noFill/>
-          <a:ln>
-            <a:noFill/>
-          </a:ln>
-        </p:spPr>
-        <p:txBody>
-          <a:bodyPr spcFirstLastPara="1" wrap="square" lIns="0" tIns="0" rIns="0" bIns="0" anchor="t" anchorCtr="0">
-            <a:noAutofit/>
-          </a:bodyPr>
-          <a:lstStyle/>
-          <a:p>
-            <a:pPr marL="0" marR="0" lvl="0" indent="0" algn="l" rtl="0">
-              <a:spcBef>
-                <a:spcPts val="0"/>
-              </a:spcBef>
-              <a:spcAft>
-                <a:spcPts val="0"/>
-              </a:spcAft>
-              <a:buClr>
-                <a:srgbClr val="6E6C66"/>
-              </a:buClr>
-              <a:buSzPts val="900"/>
-              <a:buFont typeface="IBM Plex Mono"/>
-              <a:buNone/>
-            </a:pPr>
-            <a:r>
-              <a:rPr lang="zh-CN" sz="900" b="0" i="0" u="none" strike="noStrike" cap="none">
-                <a:solidFill>
-                  <a:srgbClr val="6E6C66"/>
-                </a:solidFill>
-                <a:latin typeface="IBM Plex Mono"/>
-                <a:ea typeface="IBM Plex Mono"/>
-                <a:cs typeface="IBM Plex Mono"/>
-                <a:sym typeface="IBM Plex Mono"/>
-              </a:rPr>
-              <a:t>02  </a:t>
-            </a:r>
-            <a:r>
-              <a:rPr lang="zh-CN" sz="1200" b="0" i="0" u="none" strike="noStrike" cap="none">
-                <a:solidFill>
-                  <a:srgbClr val="111110"/>
-                </a:solidFill>
-                <a:latin typeface="Instrument Sans SemiBold"/>
-                <a:ea typeface="Instrument Sans SemiBold"/>
-                <a:cs typeface="Instrument Sans SemiBold"/>
-                <a:sym typeface="Instrument Sans SemiBold"/>
-              </a:rPr>
-              <a:t>私有评测</a:t>
-            </a:r>
-            <a:endParaRPr sz="1300" b="0" i="0" u="none" strike="noStrike" cap="none">
-              <a:solidFill>
-                <a:schemeClr val="dk1"/>
-              </a:solidFill>
-              <a:latin typeface="Instrument Sans"/>
-              <a:ea typeface="Instrument Sans"/>
-              <a:cs typeface="Instrument Sans"/>
-              <a:sym typeface="Instrument Sans"/>
-            </a:endParaRPr>
-          </a:p>
-        </p:txBody>
-      </p:sp>
-      <p:sp>
-        <p:nvSpPr>
-          <p:cNvPr id="369" name="Google Shape;369;p13"/>
-          <p:cNvSpPr/>
-          <p:nvPr/>
-        </p:nvSpPr>
-        <p:spPr>
-          <a:xfrm>
-            <a:off x="3794760" y="4873752"/>
-            <a:ext cx="1531620" cy="1024128"/>
-          </a:xfrm>
-          <a:prstGeom prst="rect">
-            <a:avLst/>
-          </a:prstGeom>
-          <a:solidFill>
-            <a:srgbClr val="C4C0B7"/>
-          </a:solidFill>
-          <a:ln w="12700" cap="flat" cmpd="sng">
-            <a:solidFill>
-              <a:srgbClr val="C4C0B7"/>
-            </a:solidFill>
-            <a:prstDash val="solid"/>
-            <a:round/>
-            <a:headEnd type="none" w="sm" len="sm"/>
-            <a:tailEnd type="none" w="sm" len="sm"/>
-          </a:ln>
-        </p:spPr>
-        <p:txBody>
-          <a:bodyPr spcFirstLastPara="1" wrap="square" lIns="91425" tIns="91425" rIns="91425" bIns="91425" anchor="ctr" anchorCtr="0">
-            <a:noAutofit/>
-          </a:bodyPr>
-          <a:lstStyle/>
-          <a:p>
-            <a:pPr marL="0" lvl="0" indent="0" algn="l" rtl="0">
-              <a:spcBef>
-                <a:spcPts val="0"/>
-              </a:spcBef>
-              <a:spcAft>
-                <a:spcPts val="0"/>
-              </a:spcAft>
-              <a:buNone/>
-            </a:pPr>
-            <a:endParaRPr/>
-          </a:p>
-        </p:txBody>
-      </p:sp>
-      <p:sp>
-        <p:nvSpPr>
-          <p:cNvPr id="370" name="Google Shape;370;p13"/>
-          <p:cNvSpPr txBox="1"/>
-          <p:nvPr/>
-        </p:nvSpPr>
-        <p:spPr>
-          <a:xfrm>
-            <a:off x="3922776" y="4965192"/>
-            <a:ext cx="1348740" cy="274320"/>
-          </a:xfrm>
-          <a:prstGeom prst="rect">
-            <a:avLst/>
-          </a:prstGeom>
-          <a:noFill/>
-          <a:ln>
-            <a:noFill/>
-          </a:ln>
-        </p:spPr>
-        <p:txBody>
-          <a:bodyPr spcFirstLastPara="1" wrap="square" lIns="0" tIns="0" rIns="0" bIns="0" anchor="t" anchorCtr="0">
-            <a:noAutofit/>
-          </a:bodyPr>
-          <a:lstStyle/>
-          <a:p>
-            <a:pPr marL="0" marR="0" lvl="0" indent="0" algn="l" rtl="0">
-              <a:spcBef>
-                <a:spcPts val="0"/>
-              </a:spcBef>
-              <a:spcAft>
-                <a:spcPts val="0"/>
-              </a:spcAft>
-              <a:buClr>
-                <a:srgbClr val="6E6C66"/>
-              </a:buClr>
-              <a:buSzPts val="900"/>
-              <a:buFont typeface="IBM Plex Mono"/>
-              <a:buNone/>
-            </a:pPr>
-            <a:r>
-              <a:rPr lang="zh-CN" sz="900" b="0" i="0" u="none" strike="noStrike" cap="none">
-                <a:solidFill>
-                  <a:srgbClr val="6E6C66"/>
-                </a:solidFill>
-                <a:latin typeface="IBM Plex Mono"/>
-                <a:ea typeface="IBM Plex Mono"/>
-                <a:cs typeface="IBM Plex Mono"/>
-                <a:sym typeface="IBM Plex Mono"/>
-              </a:rPr>
-              <a:t>03  </a:t>
-            </a:r>
-            <a:r>
-              <a:rPr lang="zh-CN" sz="1200" b="0" i="0" u="none" strike="noStrike" cap="none">
-                <a:solidFill>
-                  <a:srgbClr val="111110"/>
-                </a:solidFill>
-                <a:latin typeface="Instrument Sans SemiBold"/>
-                <a:ea typeface="Instrument Sans SemiBold"/>
-                <a:cs typeface="Instrument Sans SemiBold"/>
-                <a:sym typeface="Instrument Sans SemiBold"/>
-              </a:rPr>
-              <a:t>环境授权</a:t>
-            </a:r>
-            <a:endParaRPr sz="1300" b="0" i="0" u="none" strike="noStrike" cap="none">
-              <a:solidFill>
-                <a:schemeClr val="dk1"/>
-              </a:solidFill>
-              <a:latin typeface="Instrument Sans"/>
-              <a:ea typeface="Instrument Sans"/>
-              <a:cs typeface="Instrument Sans"/>
-              <a:sym typeface="Instrument Sans"/>
-            </a:endParaRPr>
-          </a:p>
-        </p:txBody>
-      </p:sp>
-      <p:sp>
-        <p:nvSpPr>
-          <p:cNvPr id="371" name="Google Shape;371;p13"/>
-          <p:cNvSpPr/>
-          <p:nvPr/>
-        </p:nvSpPr>
-        <p:spPr>
-          <a:xfrm>
-            <a:off x="5417820" y="4599432"/>
-            <a:ext cx="1531620" cy="1298448"/>
-          </a:xfrm>
-          <a:prstGeom prst="rect">
-            <a:avLst/>
-          </a:prstGeom>
-          <a:solidFill>
-            <a:srgbClr val="C2410C"/>
-          </a:solidFill>
-          <a:ln w="12700" cap="flat" cmpd="sng">
-            <a:solidFill>
-              <a:srgbClr val="C2410C"/>
-            </a:solidFill>
-            <a:prstDash val="solid"/>
-            <a:round/>
-            <a:headEnd type="none" w="sm" len="sm"/>
-            <a:tailEnd type="none" w="sm" len="sm"/>
-          </a:ln>
-        </p:spPr>
-        <p:txBody>
-          <a:bodyPr spcFirstLastPara="1" wrap="square" lIns="91425" tIns="91425" rIns="91425" bIns="91425" anchor="ctr" anchorCtr="0">
-            <a:noAutofit/>
-          </a:bodyPr>
-          <a:lstStyle/>
-          <a:p>
-            <a:pPr marL="0" lvl="0" indent="0" algn="l" rtl="0">
-              <a:spcBef>
-                <a:spcPts val="0"/>
-              </a:spcBef>
-              <a:spcAft>
-                <a:spcPts val="0"/>
-              </a:spcAft>
-              <a:buNone/>
-            </a:pPr>
-            <a:endParaRPr/>
-          </a:p>
-        </p:txBody>
-      </p:sp>
-      <p:sp>
-        <p:nvSpPr>
-          <p:cNvPr id="372" name="Google Shape;372;p13"/>
-          <p:cNvSpPr txBox="1"/>
-          <p:nvPr/>
-        </p:nvSpPr>
-        <p:spPr>
-          <a:xfrm>
-            <a:off x="5545836" y="4690872"/>
-            <a:ext cx="1348740" cy="274320"/>
-          </a:xfrm>
-          <a:prstGeom prst="rect">
-            <a:avLst/>
-          </a:prstGeom>
-          <a:noFill/>
-          <a:ln>
-            <a:noFill/>
-          </a:ln>
-        </p:spPr>
-        <p:txBody>
-          <a:bodyPr spcFirstLastPara="1" wrap="square" lIns="0" tIns="0" rIns="0" bIns="0" anchor="t" anchorCtr="0">
-            <a:noAutofit/>
-          </a:bodyPr>
-          <a:lstStyle/>
-          <a:p>
-            <a:pPr marL="0" marR="0" lvl="0" indent="0" algn="l" rtl="0">
-              <a:spcBef>
-                <a:spcPts val="0"/>
-              </a:spcBef>
-              <a:spcAft>
-                <a:spcPts val="0"/>
-              </a:spcAft>
-              <a:buClr>
-                <a:srgbClr val="FAF9F6"/>
-              </a:buClr>
-              <a:buSzPts val="900"/>
-              <a:buFont typeface="IBM Plex Mono"/>
-              <a:buNone/>
-            </a:pPr>
-            <a:r>
-              <a:rPr lang="zh-CN" sz="900" b="0" i="0" u="none" strike="noStrike" cap="none">
-                <a:solidFill>
-                  <a:srgbClr val="FAF9F6"/>
-                </a:solidFill>
-                <a:latin typeface="IBM Plex Mono"/>
-                <a:ea typeface="IBM Plex Mono"/>
-                <a:cs typeface="IBM Plex Mono"/>
-                <a:sym typeface="IBM Plex Mono"/>
-              </a:rPr>
-              <a:t>04  </a:t>
-            </a:r>
-            <a:r>
-              <a:rPr lang="zh-CN" sz="1200" b="0" i="0" u="none" strike="noStrike" cap="none">
-                <a:solidFill>
-                  <a:srgbClr val="FAF9F6"/>
-                </a:solidFill>
-                <a:latin typeface="Instrument Sans SemiBold"/>
-                <a:ea typeface="Instrument Sans SemiBold"/>
-                <a:cs typeface="Instrument Sans SemiBold"/>
-                <a:sym typeface="Instrument Sans SemiBold"/>
-              </a:rPr>
-              <a:t>持续训练</a:t>
-            </a:r>
-            <a:endParaRPr sz="1300" b="0" i="0" u="none" strike="noStrike" cap="none">
-              <a:solidFill>
-                <a:schemeClr val="dk1"/>
-              </a:solidFill>
-              <a:latin typeface="Instrument Sans"/>
-              <a:ea typeface="Instrument Sans"/>
-              <a:cs typeface="Instrument Sans"/>
-              <a:sym typeface="Instrument Sans"/>
-            </a:endParaRPr>
-          </a:p>
-        </p:txBody>
-      </p:sp>
-      <p:cxnSp>
-        <p:nvCxnSpPr>
-          <p:cNvPr id="373" name="Google Shape;373;p13"/>
-          <p:cNvCxnSpPr/>
-          <p:nvPr/>
-        </p:nvCxnSpPr>
-        <p:spPr>
-          <a:xfrm>
-            <a:off x="7269480" y="4041648"/>
-            <a:ext cx="0" cy="1856232"/>
-          </a:xfrm>
-          <a:prstGeom prst="straightConnector1">
-            <a:avLst/>
-          </a:prstGeom>
-          <a:noFill/>
-          <a:ln w="9525" cap="flat" cmpd="sng">
-            <a:solidFill>
-              <a:srgbClr val="E2E0DA"/>
-            </a:solidFill>
-            <a:prstDash val="solid"/>
-            <a:round/>
-            <a:headEnd type="none" w="sm" len="sm"/>
-            <a:tailEnd type="none" w="sm" len="sm"/>
-          </a:ln>
-        </p:spPr>
-      </p:cxnSp>
-      <p:sp>
-        <p:nvSpPr>
-          <p:cNvPr id="374" name="Google Shape;374;p13"/>
-          <p:cNvSpPr txBox="1"/>
-          <p:nvPr/>
-        </p:nvSpPr>
-        <p:spPr>
-          <a:xfrm>
-            <a:off x="7589520" y="4114800"/>
-            <a:ext cx="4023360" cy="658368"/>
-          </a:xfrm>
-          <a:prstGeom prst="rect">
-            <a:avLst/>
-          </a:prstGeom>
-          <a:noFill/>
-          <a:ln>
-            <a:noFill/>
-          </a:ln>
-        </p:spPr>
-        <p:txBody>
-          <a:bodyPr spcFirstLastPara="1" wrap="square" lIns="0" tIns="0" rIns="0" bIns="0" anchor="t" anchorCtr="0">
-            <a:noAutofit/>
-          </a:bodyPr>
-          <a:lstStyle/>
-          <a:p>
-            <a:pPr marL="0" marR="0" lvl="0" indent="0" algn="l" rtl="0">
-              <a:spcBef>
-                <a:spcPts val="0"/>
-              </a:spcBef>
-              <a:spcAft>
-                <a:spcPts val="0"/>
-              </a:spcAft>
-              <a:buClr>
-                <a:srgbClr val="111110"/>
-              </a:buClr>
-              <a:buSzPts val="4000"/>
-              <a:buFont typeface="Newsreader"/>
-              <a:buNone/>
-            </a:pPr>
-            <a:r>
-              <a:rPr lang="zh-CN" sz="4000" b="0" i="0" u="none" strike="noStrike" cap="none">
-                <a:solidFill>
-                  <a:srgbClr val="111110"/>
-                </a:solidFill>
-                <a:latin typeface="Newsreader"/>
-                <a:ea typeface="Newsreader"/>
-                <a:cs typeface="Newsreader"/>
-                <a:sym typeface="Newsreader"/>
-              </a:rPr>
-              <a:t>1亿美元</a:t>
-            </a:r>
-            <a:endParaRPr sz="4000" b="0" i="0" u="none" strike="noStrike" cap="none">
-              <a:solidFill>
-                <a:schemeClr val="dk1"/>
-              </a:solidFill>
-              <a:latin typeface="Instrument Sans"/>
-              <a:ea typeface="Instrument Sans"/>
-              <a:cs typeface="Instrument Sans"/>
-              <a:sym typeface="Instrument Sans"/>
-            </a:endParaRPr>
-          </a:p>
-        </p:txBody>
-      </p:sp>
-      <p:sp>
-        <p:nvSpPr>
-          <p:cNvPr id="375" name="Google Shape;375;p13"/>
-          <p:cNvSpPr txBox="1"/>
-          <p:nvPr/>
-        </p:nvSpPr>
-        <p:spPr>
-          <a:xfrm>
-            <a:off x="7589520" y="4846320"/>
-            <a:ext cx="4023360" cy="548640"/>
-          </a:xfrm>
-          <a:prstGeom prst="rect">
-            <a:avLst/>
-          </a:prstGeom>
-          <a:noFill/>
-          <a:ln>
-            <a:noFill/>
-          </a:ln>
-        </p:spPr>
-        <p:txBody>
-          <a:bodyPr spcFirstLastPara="1" wrap="square" lIns="0" tIns="0" rIns="0" bIns="0" anchor="t" anchorCtr="0">
-            <a:noAutofit/>
-          </a:bodyPr>
-          <a:lstStyle/>
-          <a:p>
-            <a:pPr marL="0" marR="0" lvl="0" indent="0" algn="l" rtl="0">
-              <a:spcBef>
-                <a:spcPts val="0"/>
-              </a:spcBef>
-              <a:spcAft>
-                <a:spcPts val="0"/>
-              </a:spcAft>
-              <a:buClr>
-                <a:srgbClr val="33322F"/>
-              </a:buClr>
-              <a:buSzPts val="1200"/>
-              <a:buFont typeface="Instrument Sans"/>
-              <a:buNone/>
-            </a:pPr>
-            <a:r>
-              <a:rPr lang="zh-CN" sz="1200" b="0" i="0" u="none" strike="noStrike" cap="none">
-                <a:solidFill>
-                  <a:srgbClr val="33322F"/>
-                </a:solidFill>
-                <a:latin typeface="Instrument Sans"/>
-                <a:ea typeface="Instrument Sans"/>
-                <a:cs typeface="Instrument Sans"/>
-                <a:sym typeface="Instrument Sans"/>
-              </a:rPr>
-              <a:t>AfterQuery同一模式，14个月的年化收入</a:t>
-            </a:r>
-            <a:endParaRPr sz="1200" b="0" i="0" u="none" strike="noStrike" cap="none">
-              <a:solidFill>
-                <a:schemeClr val="dk1"/>
-              </a:solidFill>
-              <a:latin typeface="Instrument Sans"/>
-              <a:ea typeface="Instrument Sans"/>
-              <a:cs typeface="Instrument Sans"/>
-              <a:sym typeface="Instrument Sans"/>
-            </a:endParaRPr>
-          </a:p>
-          <a:p>
-            <a:pPr marL="0" marR="0" lvl="0" indent="0" algn="l" rtl="0">
-              <a:spcBef>
-                <a:spcPts val="300"/>
-              </a:spcBef>
-              <a:spcAft>
-                <a:spcPts val="0"/>
-              </a:spcAft>
-              <a:buClr>
-                <a:srgbClr val="6E6C66"/>
-              </a:buClr>
-              <a:buSzPts val="1200"/>
-              <a:buFont typeface="Instrument Sans"/>
-              <a:buNone/>
-            </a:pPr>
-            <a:r>
-              <a:rPr lang="zh-CN" sz="1200" b="0" i="0" u="none" strike="noStrike" cap="none">
-                <a:solidFill>
-                  <a:srgbClr val="6E6C66"/>
-                </a:solidFill>
-                <a:latin typeface="Instrument Sans"/>
-                <a:ea typeface="Instrument Sans"/>
-                <a:cs typeface="Instrument Sans"/>
-                <a:sym typeface="Instrument Sans"/>
-              </a:rPr>
-              <a:t>Mercor年化20亿美元，Snorkel一年18倍</a:t>
-            </a:r>
-            <a:endParaRPr sz="1200" b="0" i="0" u="none" strike="noStrike" cap="none">
-              <a:solidFill>
-                <a:schemeClr val="dk1"/>
-              </a:solidFill>
-              <a:latin typeface="Instrument Sans"/>
-              <a:ea typeface="Instrument Sans"/>
-              <a:cs typeface="Instrument Sans"/>
-              <a:sym typeface="Instrument Sans"/>
-            </a:endParaRPr>
-          </a:p>
-        </p:txBody>
-      </p:sp>
       <p:pic>
         <p:nvPicPr>
           <p:cNvPr id="376" name="Google Shape;376;p13" descr="SimReal"/>
@@ -10238,67 +9289,162 @@
       </p:sp>
       <p:sp>
         <p:nvSpPr>
-          <p:cNvPr id="379" name="TextBox 378"/>
-          <p:cNvSpPr txBox="1"/>
-          <p:nvPr/>
-        </p:nvSpPr>
-        <p:spPr>
-          <a:xfrm>
-            <a:off x="548640" y="1463040"/>
-            <a:ext cx="3017520" cy="256032"/>
-          </a:xfrm>
-          <a:prstGeom prst="rect">
-            <a:avLst/>
-          </a:prstGeom>
-          <a:noFill/>
-        </p:spPr>
-        <p:txBody>
-          <a:bodyPr wrap="square" lIns="0" tIns="0" rIns="0" bIns="0" anchor="ctr">
-            <a:spAutoFit/>
-          </a:bodyPr>
-          <a:lstStyle/>
-          <a:p>
-            <a:pPr algn="l"/>
-            <a:r>
-              <a:rPr sz="950" b="0">
-                <a:solidFill>
-                  <a:srgbClr val="6E6C66"/>
+          <p:cNvPr id="3001" name="SimReal 3001"/>
+          <p:cNvSpPr txBox="1"/>
+          <p:nvPr/>
+        </p:nvSpPr>
+        <p:spPr>
+          <a:xfrm>
+            <a:off x="548640" y="384048"/>
+            <a:ext cx="8229600" cy="219456"/>
+          </a:xfrm>
+          <a:prstGeom prst="rect">
+            <a:avLst/>
+          </a:prstGeom>
+          <a:noFill/>
+          <a:ln>
+            <a:noFill/>
+          </a:ln>
+        </p:spPr>
+        <p:txBody>
+          <a:bodyPr spcFirstLastPara="1" wrap="square" lIns="0" tIns="0" rIns="0" bIns="0" anchor="ctr" anchorCtr="0">
+            <a:noAutofit/>
+          </a:bodyPr>
+          <a:lstStyle/>
+          <a:p>
+            <a:pPr marL="0" marR="0" lvl="0" indent="0" algn="l" rtl="0">
+              <a:spcBef>
+                <a:spcPts val="0"/>
+              </a:spcBef>
+              <a:spcAft>
+                <a:spcPts val="0"/>
+              </a:spcAft>
+              <a:buNone/>
+            </a:pPr>
+            <a:r>
+              <a:rPr lang="zh-CN" sz="1000" b="1" i="0" u="none" strike="noStrike" cap="none">
+                <a:solidFill>
+                  <a:srgbClr val="C2410C"/>
                 </a:solidFill>
                 <a:latin typeface="IBM Plex Mono"/>
                 <a:ea typeface="IBM Plex Mono"/>
                 <a:cs typeface="IBM Plex Mono"/>
                 <a:sym typeface="IBM Plex Mono"/>
               </a:rPr>
-              <a:t>产品</a:t>
-            </a:r>
-          </a:p>
-        </p:txBody>
-      </p:sp>
-      <p:sp>
-        <p:nvSpPr>
-          <p:cNvPr id="380" name="TextBox 379"/>
-          <p:cNvSpPr txBox="1"/>
-          <p:nvPr/>
-        </p:nvSpPr>
-        <p:spPr>
-          <a:xfrm>
-            <a:off x="3703320" y="1463040"/>
-            <a:ext cx="4434840" cy="256032"/>
-          </a:xfrm>
-          <a:prstGeom prst="rect">
-            <a:avLst/>
-          </a:prstGeom>
-          <a:noFill/>
-        </p:spPr>
-        <p:txBody>
-          <a:bodyPr wrap="square" lIns="0" tIns="0" rIns="0" bIns="0" anchor="ctr">
-            <a:spAutoFit/>
-          </a:bodyPr>
-          <a:lstStyle/>
-          <a:p>
-            <a:pPr algn="l"/>
-            <a:r>
-              <a:rPr sz="950" b="0">
+              <a:t>11</a:t>
+            </a:r>
+            <a:r>
+              <a:rPr lang="zh-CN" sz="1100" b="1" i="0" u="none" strike="noStrike" cap="none">
+                <a:solidFill>
+                  <a:srgbClr val="6E6C66"/>
+                </a:solidFill>
+                <a:latin typeface="Instrument Sans"/>
+                <a:ea typeface="Instrument Sans"/>
+                <a:cs typeface="Instrument Sans"/>
+                <a:sym typeface="Instrument Sans"/>
+              </a:rPr>
+              <a:t>    商业模式</a:t>
+            </a:r>
+          </a:p>
+        </p:txBody>
+      </p:sp>
+      <p:sp>
+        <p:nvSpPr>
+          <p:cNvPr id="3002" name="SimReal 3002"/>
+          <p:cNvSpPr txBox="1"/>
+          <p:nvPr/>
+        </p:nvSpPr>
+        <p:spPr>
+          <a:xfrm>
+            <a:off x="548640" y="676656"/>
+            <a:ext cx="11091672" cy="566928"/>
+          </a:xfrm>
+          <a:prstGeom prst="rect">
+            <a:avLst/>
+          </a:prstGeom>
+          <a:noFill/>
+          <a:ln>
+            <a:noFill/>
+          </a:ln>
+        </p:spPr>
+        <p:txBody>
+          <a:bodyPr spcFirstLastPara="1" wrap="square" lIns="0" tIns="0" rIns="0" bIns="0" anchor="t" anchorCtr="0">
+            <a:noAutofit/>
+          </a:bodyPr>
+          <a:lstStyle/>
+          <a:p>
+            <a:pPr marL="0" marR="0" lvl="0" indent="0" algn="l" rtl="0">
+              <a:spcBef>
+                <a:spcPts val="0"/>
+              </a:spcBef>
+              <a:spcAft>
+                <a:spcPts val="0"/>
+              </a:spcAft>
+              <a:buNone/>
+            </a:pPr>
+            <a:r>
+              <a:rPr lang="zh-CN" sz="2800" b="0" i="0" u="none" strike="noStrike" cap="none">
+                <a:solidFill>
+                  <a:srgbClr val="111110"/>
+                </a:solidFill>
+                <a:latin typeface="Newsreader"/>
+                <a:ea typeface="Newsreader"/>
+                <a:cs typeface="Newsreader"/>
+                <a:sym typeface="Newsreader"/>
+              </a:rPr>
+              <a:t>每一轮都有新交付：</a:t>
+            </a:r>
+            <a:r>
+              <a:rPr lang="zh-CN" sz="2800" b="0" i="0" u="none" strike="noStrike" cap="none">
+                <a:solidFill>
+                  <a:srgbClr val="C2410C"/>
+                </a:solidFill>
+                <a:latin typeface="Newsreader"/>
+                <a:ea typeface="Newsreader"/>
+                <a:cs typeface="Newsreader"/>
+                <a:sym typeface="Newsreader"/>
+              </a:rPr>
+              <a:t>合作越深，收入越高</a:t>
+            </a:r>
+          </a:p>
+        </p:txBody>
+      </p:sp>
+      <p:sp>
+        <p:nvSpPr>
+          <p:cNvPr id="3003" name="SimReal 3003"/>
+          <p:cNvSpPr txBox="1"/>
+          <p:nvPr/>
+        </p:nvSpPr>
+        <p:spPr>
+          <a:xfrm>
+            <a:off x="548640" y="1463040"/>
+            <a:ext cx="6949440" cy="310896"/>
+          </a:xfrm>
+          <a:prstGeom prst="rect">
+            <a:avLst/>
+          </a:prstGeom>
+          <a:noFill/>
+          <a:ln>
+            <a:noFill/>
+          </a:ln>
+        </p:spPr>
+        <p:txBody>
+          <a:bodyPr spcFirstLastPara="1" wrap="square" lIns="0" tIns="0" rIns="0" bIns="0" anchor="ctr" anchorCtr="0">
+            <a:noAutofit/>
+          </a:bodyPr>
+          <a:lstStyle/>
+          <a:p>
+            <a:pPr marL="0" marR="0" lvl="0" indent="0" algn="l" rtl="0">
+              <a:spcBef>
+                <a:spcPts val="0"/>
+              </a:spcBef>
+              <a:spcAft>
+                <a:spcPts val="0"/>
+              </a:spcAft>
+              <a:buNone/>
+            </a:pPr>
+            <a:r>
+              <a:rPr lang="zh-CN" sz="1000" b="0" i="0" u="none" strike="noStrike" cap="none">
                 <a:solidFill>
                   <a:srgbClr val="6E6C66"/>
                 </a:solidFill>
@@ -10307,36 +9453,137 @@
                 <a:cs typeface="IBM Plex Mono"/>
                 <a:sym typeface="IBM Plex Mono"/>
               </a:rPr>
-              <a:t>卖点</a:t>
-            </a:r>
-          </a:p>
-        </p:txBody>
-      </p:sp>
-      <p:sp>
-        <p:nvSpPr>
-          <p:cNvPr id="381" name="TextBox 380"/>
-          <p:cNvSpPr txBox="1"/>
-          <p:nvPr/>
-        </p:nvSpPr>
-        <p:spPr>
-          <a:xfrm>
-            <a:off x="8275320" y="1463040"/>
-            <a:ext cx="3364992" cy="256032"/>
-          </a:xfrm>
-          <a:prstGeom prst="rect">
-            <a:avLst/>
-          </a:prstGeom>
-          <a:noFill/>
-        </p:spPr>
-        <p:txBody>
-          <a:bodyPr wrap="square" lIns="0" tIns="0" rIns="0" bIns="0" anchor="ctr">
-            <a:spAutoFit/>
-          </a:bodyPr>
-          <a:lstStyle/>
-          <a:p>
-            <a:pPr algn="l"/>
-            <a:r>
-              <a:rPr sz="950" b="0">
+              <a:t>四类产品   </a:t>
+            </a:r>
+            <a:r>
+              <a:rPr lang="zh-CN" sz="1400" b="0" i="0" u="none" strike="noStrike" cap="none">
+                <a:solidFill>
+                  <a:srgbClr val="111110"/>
+                </a:solidFill>
+                <a:latin typeface="Newsreader"/>
+                <a:ea typeface="Newsreader"/>
+                <a:cs typeface="Newsreader"/>
+                <a:sym typeface="Newsreader"/>
+              </a:rPr>
+              <a:t>训练环境  ·  专家数据  ·  评测与攻防测试  ·  RSI自我进化服务</a:t>
+            </a:r>
+          </a:p>
+        </p:txBody>
+      </p:sp>
+      <p:sp>
+        <p:nvSpPr>
+          <p:cNvPr id="3004" name="SimReal 3004"/>
+          <p:cNvSpPr txBox="1"/>
+          <p:nvPr/>
+        </p:nvSpPr>
+        <p:spPr>
+          <a:xfrm>
+            <a:off x="7589520" y="1463040"/>
+            <a:ext cx="4050792" cy="310896"/>
+          </a:xfrm>
+          <a:prstGeom prst="rect">
+            <a:avLst/>
+          </a:prstGeom>
+          <a:noFill/>
+          <a:ln>
+            <a:noFill/>
+          </a:ln>
+        </p:spPr>
+        <p:txBody>
+          <a:bodyPr spcFirstLastPara="1" wrap="square" lIns="0" tIns="0" rIns="0" bIns="0" anchor="ctr" anchorCtr="0">
+            <a:noAutofit/>
+          </a:bodyPr>
+          <a:lstStyle/>
+          <a:p>
+            <a:pPr marL="0" marR="0" lvl="0" indent="0" algn="r" rtl="0">
+              <a:spcBef>
+                <a:spcPts val="0"/>
+              </a:spcBef>
+              <a:spcAft>
+                <a:spcPts val="0"/>
+              </a:spcAft>
+              <a:buNone/>
+            </a:pPr>
+            <a:r>
+              <a:rPr lang="zh-CN" sz="1050" b="0" i="0" u="none" strike="noStrike" cap="none">
+                <a:solidFill>
+                  <a:srgbClr val="C2410C"/>
+                </a:solidFill>
+                <a:latin typeface="Instrument Sans"/>
+                <a:ea typeface="Instrument Sans"/>
+                <a:cs typeface="Instrument Sans"/>
+                <a:sym typeface="Instrument Sans"/>
+              </a:rPr>
+              <a:t>同一模式：AfterQuery 14个月做到年化1亿美元</a:t>
+            </a:r>
+          </a:p>
+        </p:txBody>
+      </p:sp>
+      <p:sp>
+        <p:nvSpPr>
+          <p:cNvPr id="3005" name="SimReal 3005"/>
+          <p:cNvSpPr/>
+          <p:nvPr/>
+        </p:nvSpPr>
+        <p:spPr>
+          <a:xfrm>
+            <a:off x="548640" y="1993392"/>
+            <a:ext cx="11091672" cy="9144"/>
+          </a:xfrm>
+          <a:prstGeom prst="rect">
+            <a:avLst/>
+          </a:prstGeom>
+          <a:solidFill>
+            <a:srgbClr val="111110"/>
+          </a:solidFill>
+          <a:ln>
+            <a:noFill/>
+          </a:ln>
+        </p:spPr>
+        <p:txBody>
+          <a:bodyPr/>
+          <a:lstStyle/>
+          <a:p>
+            <a:endParaRPr/>
+          </a:p>
+        </p:txBody>
+      </p:sp>
+      <p:sp>
+        <p:nvSpPr>
+          <p:cNvPr id="3006" name="SimReal 3006"/>
+          <p:cNvSpPr txBox="1"/>
+          <p:nvPr/>
+        </p:nvSpPr>
+        <p:spPr>
+          <a:xfrm>
+            <a:off x="731520" y="2048256"/>
+            <a:ext cx="2103120" cy="237744"/>
+          </a:xfrm>
+          <a:prstGeom prst="rect">
+            <a:avLst/>
+          </a:prstGeom>
+          <a:noFill/>
+          <a:ln>
+            <a:noFill/>
+          </a:ln>
+        </p:spPr>
+        <p:txBody>
+          <a:bodyPr spcFirstLastPara="1" wrap="square" lIns="0" tIns="0" rIns="0" bIns="0" anchor="ctr" anchorCtr="0">
+            <a:noAutofit/>
+          </a:bodyPr>
+          <a:lstStyle/>
+          <a:p>
+            <a:pPr marL="0" marR="0" lvl="0" indent="0" algn="l" rtl="0">
+              <a:spcBef>
+                <a:spcPts val="0"/>
+              </a:spcBef>
+              <a:spcAft>
+                <a:spcPts val="0"/>
+              </a:spcAft>
+              <a:buNone/>
+            </a:pPr>
+            <a:r>
+              <a:rPr lang="zh-CN" sz="950" b="0" i="0" u="none" strike="noStrike" cap="none">
                 <a:solidFill>
                   <a:srgbClr val="6E6C66"/>
                 </a:solidFill>
@@ -10345,21 +9592,168 @@
                 <a:cs typeface="IBM Plex Mono"/>
                 <a:sym typeface="IBM Plex Mono"/>
               </a:rPr>
-              <a:t>收费方式</a:t>
-            </a:r>
-          </a:p>
-        </p:txBody>
-      </p:sp>
-      <p:sp>
-        <p:nvSpPr>
-          <p:cNvPr id="382" name="Rectangle 381"/>
+              <a:t>合作阶段</a:t>
+            </a:r>
+          </a:p>
+        </p:txBody>
+      </p:sp>
+      <p:sp>
+        <p:nvSpPr>
+          <p:cNvPr id="3007" name="SimReal 3007"/>
+          <p:cNvSpPr txBox="1"/>
+          <p:nvPr/>
+        </p:nvSpPr>
+        <p:spPr>
+          <a:xfrm>
+            <a:off x="2926080" y="2048256"/>
+            <a:ext cx="3017520" cy="237744"/>
+          </a:xfrm>
+          <a:prstGeom prst="rect">
+            <a:avLst/>
+          </a:prstGeom>
+          <a:noFill/>
+          <a:ln>
+            <a:noFill/>
+          </a:ln>
+        </p:spPr>
+        <p:txBody>
+          <a:bodyPr spcFirstLastPara="1" wrap="square" lIns="0" tIns="0" rIns="0" bIns="0" anchor="ctr" anchorCtr="0">
+            <a:noAutofit/>
+          </a:bodyPr>
+          <a:lstStyle/>
+          <a:p>
+            <a:pPr marL="0" marR="0" lvl="0" indent="0" algn="l" rtl="0">
+              <a:spcBef>
+                <a:spcPts val="0"/>
+              </a:spcBef>
+              <a:spcAft>
+                <a:spcPts val="0"/>
+              </a:spcAft>
+              <a:buNone/>
+            </a:pPr>
+            <a:r>
+              <a:rPr lang="zh-CN" sz="950" b="0" i="0" u="none" strike="noStrike" cap="none">
+                <a:solidFill>
+                  <a:srgbClr val="6E6C66"/>
+                </a:solidFill>
+                <a:latin typeface="IBM Plex Mono"/>
+                <a:ea typeface="IBM Plex Mono"/>
+                <a:cs typeface="IBM Plex Mono"/>
+                <a:sym typeface="IBM Plex Mono"/>
+              </a:rPr>
+              <a:t>客户买什么</a:t>
+            </a:r>
+          </a:p>
+        </p:txBody>
+      </p:sp>
+      <p:sp>
+        <p:nvSpPr>
+          <p:cNvPr id="3008" name="SimReal 3008"/>
+          <p:cNvSpPr txBox="1"/>
+          <p:nvPr/>
+        </p:nvSpPr>
+        <p:spPr>
+          <a:xfrm>
+            <a:off x="6080760" y="2048256"/>
+            <a:ext cx="2377440" cy="237744"/>
+          </a:xfrm>
+          <a:prstGeom prst="rect">
+            <a:avLst/>
+          </a:prstGeom>
+          <a:noFill/>
+          <a:ln>
+            <a:noFill/>
+          </a:ln>
+        </p:spPr>
+        <p:txBody>
+          <a:bodyPr spcFirstLastPara="1" wrap="square" lIns="0" tIns="0" rIns="0" bIns="0" anchor="ctr" anchorCtr="0">
+            <a:noAutofit/>
+          </a:bodyPr>
+          <a:lstStyle/>
+          <a:p>
+            <a:pPr marL="0" marR="0" lvl="0" indent="0" algn="l" rtl="0">
+              <a:spcBef>
+                <a:spcPts val="0"/>
+              </a:spcBef>
+              <a:spcAft>
+                <a:spcPts val="0"/>
+              </a:spcAft>
+              <a:buNone/>
+            </a:pPr>
+            <a:r>
+              <a:rPr lang="zh-CN" sz="950" b="0" i="0" u="none" strike="noStrike" cap="none">
+                <a:solidFill>
+                  <a:srgbClr val="6E6C66"/>
+                </a:solidFill>
+                <a:latin typeface="IBM Plex Mono"/>
+                <a:ea typeface="IBM Plex Mono"/>
+                <a:cs typeface="IBM Plex Mono"/>
+                <a:sym typeface="IBM Plex Mono"/>
+              </a:rPr>
+              <a:t>收费依据</a:t>
+            </a:r>
+          </a:p>
+        </p:txBody>
+      </p:sp>
+      <p:sp>
+        <p:nvSpPr>
+          <p:cNvPr id="3009" name="SimReal 3009"/>
+          <p:cNvSpPr txBox="1"/>
+          <p:nvPr/>
+        </p:nvSpPr>
+        <p:spPr>
+          <a:xfrm>
+            <a:off x="8595360" y="2048256"/>
+            <a:ext cx="2880360" cy="237744"/>
+          </a:xfrm>
+          <a:prstGeom prst="rect">
+            <a:avLst/>
+          </a:prstGeom>
+          <a:noFill/>
+          <a:ln>
+            <a:noFill/>
+          </a:ln>
+        </p:spPr>
+        <p:txBody>
+          <a:bodyPr spcFirstLastPara="1" wrap="square" lIns="0" tIns="0" rIns="0" bIns="0" anchor="ctr" anchorCtr="0">
+            <a:noAutofit/>
+          </a:bodyPr>
+          <a:lstStyle/>
+          <a:p>
+            <a:pPr marL="0" marR="0" lvl="0" indent="0" algn="l" rtl="0">
+              <a:spcBef>
+                <a:spcPts val="0"/>
+              </a:spcBef>
+              <a:spcAft>
+                <a:spcPts val="0"/>
+              </a:spcAft>
+              <a:buNone/>
+            </a:pPr>
+            <a:r>
+              <a:rPr lang="zh-CN" sz="950" b="0" i="0" u="none" strike="noStrike" cap="none">
+                <a:solidFill>
+                  <a:srgbClr val="6E6C66"/>
+                </a:solidFill>
+                <a:latin typeface="IBM Plex Mono"/>
+                <a:ea typeface="IBM Plex Mono"/>
+                <a:cs typeface="IBM Plex Mono"/>
+                <a:sym typeface="IBM Plex Mono"/>
+              </a:rPr>
+              <a:t>为什么继续买</a:t>
+            </a:r>
+          </a:p>
+        </p:txBody>
+      </p:sp>
+      <p:sp>
+        <p:nvSpPr>
+          <p:cNvPr id="3010" name="SimReal 3010"/>
           <p:cNvSpPr/>
           <p:nvPr/>
         </p:nvSpPr>
         <p:spPr>
           <a:xfrm>
-            <a:off x="548640" y="1750885"/>
-            <a:ext cx="11091672" cy="9525"/>
+            <a:off x="548640" y="2340864"/>
+            <a:ext cx="11091672" cy="9144"/>
           </a:xfrm>
           <a:prstGeom prst="rect">
             <a:avLst/>
@@ -10372,7 +9766,7 @@
           </a:ln>
         </p:spPr>
         <p:txBody>
-          <a:bodyPr rtlCol="0" anchor="ctr"/>
+          <a:bodyPr/>
           <a:lstStyle/>
           <a:p>
             <a:endParaRPr/>
@@ -10381,29 +9775,89 @@
       </p:sp>
       <p:sp>
         <p:nvSpPr>
-          <p:cNvPr id="383" name="TextBox 382"/>
-          <p:cNvSpPr txBox="1"/>
-          <p:nvPr/>
-        </p:nvSpPr>
-        <p:spPr>
-          <a:xfrm>
-            <a:off x="548640" y="1801368"/>
-            <a:ext cx="2926080" cy="274320"/>
-          </a:xfrm>
-          <a:prstGeom prst="rect">
-            <a:avLst/>
-          </a:prstGeom>
-          <a:noFill/>
-        </p:spPr>
-        <p:txBody>
-          <a:bodyPr wrap="square" lIns="0" tIns="0" rIns="0" bIns="0" anchor="ctr">
-            <a:spAutoFit/>
-          </a:bodyPr>
-          <a:lstStyle/>
-          <a:p>
-            <a:pPr algn="l"/>
-            <a:r>
-              <a:rPr sz="1500" b="0">
+          <p:cNvPr id="3011" name="SimReal 3011"/>
+          <p:cNvSpPr txBox="1"/>
+          <p:nvPr/>
+        </p:nvSpPr>
+        <p:spPr>
+          <a:xfrm>
+            <a:off x="731520" y="2340864"/>
+            <a:ext cx="411480" cy="566928"/>
+          </a:xfrm>
+          <a:prstGeom prst="rect">
+            <a:avLst/>
+          </a:prstGeom>
+          <a:noFill/>
+          <a:ln>
+            <a:noFill/>
+          </a:ln>
+        </p:spPr>
+        <p:txBody>
+          <a:bodyPr spcFirstLastPara="1" wrap="square" lIns="0" tIns="0" rIns="0" bIns="0" anchor="ctr" anchorCtr="0">
+            <a:noAutofit/>
+          </a:bodyPr>
+          <a:lstStyle/>
+          <a:p>
+            <a:pPr marL="0" marR="0" lvl="0" indent="0" algn="l" rtl="0">
+              <a:spcBef>
+                <a:spcPts val="0"/>
+              </a:spcBef>
+              <a:spcAft>
+                <a:spcPts val="0"/>
+              </a:spcAft>
+              <a:buNone/>
+            </a:pPr>
+            <a:r>
+              <a:rPr lang="zh-CN" sz="1000" b="0" i="0" u="none" strike="noStrike" cap="none">
+                <a:solidFill>
+                  <a:srgbClr val="C2410C"/>
+                </a:solidFill>
+                <a:latin typeface="IBM Plex Mono"/>
+                <a:ea typeface="IBM Plex Mono"/>
+                <a:cs typeface="IBM Plex Mono"/>
+                <a:sym typeface="IBM Plex Mono"/>
+              </a:rPr>
+              <a:t>01</a:t>
+            </a:r>
+          </a:p>
+        </p:txBody>
+      </p:sp>
+      <p:sp>
+        <p:nvSpPr>
+          <p:cNvPr id="3012" name="SimReal 3012"/>
+          <p:cNvSpPr txBox="1"/>
+          <p:nvPr/>
+        </p:nvSpPr>
+        <p:spPr>
+          <a:xfrm>
+            <a:off x="1143000" y="2340864"/>
+            <a:ext cx="1737360" cy="566928"/>
+          </a:xfrm>
+          <a:prstGeom prst="rect">
+            <a:avLst/>
+          </a:prstGeom>
+          <a:noFill/>
+          <a:ln>
+            <a:noFill/>
+          </a:ln>
+        </p:spPr>
+        <p:txBody>
+          <a:bodyPr spcFirstLastPara="1" wrap="square" lIns="0" tIns="0" rIns="0" bIns="0" anchor="ctr" anchorCtr="0">
+            <a:noAutofit/>
+          </a:bodyPr>
+          <a:lstStyle/>
+          <a:p>
+            <a:pPr marL="0" marR="0" lvl="0" indent="0" algn="l" rtl="0">
+              <a:spcBef>
+                <a:spcPts val="0"/>
+              </a:spcBef>
+              <a:spcAft>
+                <a:spcPts val="0"/>
+              </a:spcAft>
+              <a:buNone/>
+            </a:pPr>
+            <a:r>
+              <a:rPr lang="zh-CN" sz="1500" b="0" i="0" u="none" strike="noStrike" cap="none">
                 <a:solidFill>
                   <a:srgbClr val="111110"/>
                 </a:solidFill>
@@ -10412,74 +9866,102 @@
                 <a:cs typeface="Newsreader"/>
                 <a:sym typeface="Newsreader"/>
               </a:rPr>
-              <a:t>训练环境</a:t>
-            </a:r>
-          </a:p>
-        </p:txBody>
-      </p:sp>
-      <p:sp>
-        <p:nvSpPr>
-          <p:cNvPr id="384" name="TextBox 383"/>
-          <p:cNvSpPr txBox="1"/>
-          <p:nvPr/>
-        </p:nvSpPr>
-        <p:spPr>
-          <a:xfrm>
-            <a:off x="548640" y="2057400"/>
-            <a:ext cx="2926080" cy="201168"/>
-          </a:xfrm>
-          <a:prstGeom prst="rect">
-            <a:avLst/>
-          </a:prstGeom>
-          <a:noFill/>
-        </p:spPr>
-        <p:txBody>
-          <a:bodyPr wrap="square" lIns="0" tIns="0" rIns="0" bIns="0" anchor="ctr">
-            <a:spAutoFit/>
-          </a:bodyPr>
-          <a:lstStyle/>
-          <a:p>
-            <a:pPr algn="l"/>
-            <a:r>
-              <a:rPr sz="850" b="0">
-                <a:solidFill>
-                  <a:srgbClr val="6E6C66"/>
+              <a:t>付费试点</a:t>
+            </a:r>
+          </a:p>
+        </p:txBody>
+      </p:sp>
+      <p:sp>
+        <p:nvSpPr>
+          <p:cNvPr id="3013" name="SimReal 3013"/>
+          <p:cNvSpPr txBox="1"/>
+          <p:nvPr/>
+        </p:nvSpPr>
+        <p:spPr>
+          <a:xfrm>
+            <a:off x="2926080" y="2340864"/>
+            <a:ext cx="3017520" cy="566928"/>
+          </a:xfrm>
+          <a:prstGeom prst="rect">
+            <a:avLst/>
+          </a:prstGeom>
+          <a:noFill/>
+          <a:ln>
+            <a:noFill/>
+          </a:ln>
+        </p:spPr>
+        <p:txBody>
+          <a:bodyPr spcFirstLastPara="1" wrap="square" lIns="0" tIns="0" rIns="0" bIns="0" anchor="ctr" anchorCtr="0">
+            <a:noAutofit/>
+          </a:bodyPr>
+          <a:lstStyle/>
+          <a:p>
+            <a:pPr marL="0" marR="0" lvl="0" indent="0" algn="l" rtl="0">
+              <a:lnSpc>
+                <a:spcPct val="110000"/>
+              </a:lnSpc>
+              <a:spcBef>
+                <a:spcPts val="0"/>
+              </a:spcBef>
+              <a:spcAft>
+                <a:spcPts val="0"/>
+              </a:spcAft>
+              <a:buNone/>
+            </a:pPr>
+            <a:r>
+              <a:rPr lang="zh-CN" sz="1100" b="0" i="0" u="none" strike="noStrike" cap="none">
+                <a:solidFill>
+                  <a:srgbClr val="33322F"/>
                 </a:solidFill>
                 <a:latin typeface="Instrument Sans"/>
                 <a:ea typeface="Instrument Sans"/>
                 <a:cs typeface="Instrument Sans"/>
                 <a:sym typeface="Instrument Sans"/>
               </a:rPr>
-              <a:t>Xitadel、MLBench等7款，含企业定制</a:t>
-            </a:r>
-          </a:p>
-        </p:txBody>
-      </p:sp>
-      <p:sp>
-        <p:nvSpPr>
-          <p:cNvPr id="385" name="TextBox 384"/>
-          <p:cNvSpPr txBox="1"/>
-          <p:nvPr/>
-        </p:nvSpPr>
-        <p:spPr>
-          <a:xfrm>
-            <a:off x="3703320" y="1755648"/>
-            <a:ext cx="4434840" cy="548640"/>
-          </a:xfrm>
-          <a:prstGeom prst="rect">
-            <a:avLst/>
-          </a:prstGeom>
-          <a:noFill/>
-        </p:spPr>
-        <p:txBody>
-          <a:bodyPr wrap="square" lIns="0" tIns="0" rIns="0" bIns="0" anchor="ctr">
-            <a:spAutoFit/>
-          </a:bodyPr>
-          <a:lstStyle/>
-          <a:p>
-            <a:pPr algn="l"/>
-            <a:r>
-              <a:rPr sz="1150" b="0">
+              <a:t>一个能力目标的环境与评测包</a:t>
+            </a:r>
+          </a:p>
+        </p:txBody>
+      </p:sp>
+      <p:sp>
+        <p:nvSpPr>
+          <p:cNvPr id="3014" name="SimReal 3014"/>
+          <p:cNvSpPr txBox="1"/>
+          <p:nvPr/>
+        </p:nvSpPr>
+        <p:spPr>
+          <a:xfrm>
+            <a:off x="6080760" y="2340864"/>
+            <a:ext cx="2377440" cy="566928"/>
+          </a:xfrm>
+          <a:prstGeom prst="rect">
+            <a:avLst/>
+          </a:prstGeom>
+          <a:noFill/>
+          <a:ln>
+            <a:noFill/>
+          </a:ln>
+        </p:spPr>
+        <p:txBody>
+          <a:bodyPr spcFirstLastPara="1" wrap="square" lIns="0" tIns="0" rIns="0" bIns="0" anchor="ctr" anchorCtr="0">
+            <a:noAutofit/>
+          </a:bodyPr>
+          <a:lstStyle/>
+          <a:p>
+            <a:pPr marL="0" marR="0" lvl="0" indent="0" algn="l" rtl="0">
+              <a:lnSpc>
+                <a:spcPct val="110000"/>
+              </a:lnSpc>
+              <a:spcBef>
+                <a:spcPts val="0"/>
+              </a:spcBef>
+              <a:spcAft>
+                <a:spcPts val="0"/>
+              </a:spcAft>
+              <a:buNone/>
+            </a:pPr>
+            <a:r>
+              <a:rPr lang="zh-CN" sz="1100" b="0" i="0" u="none" strike="noStrike" cap="none">
                 <a:solidFill>
                   <a:srgbClr val="33322F"/>
                 </a:solidFill>
@@ -10488,36 +9970,50 @@
                 <a:cs typeface="Instrument Sans"/>
                 <a:sym typeface="Instrument Sans"/>
               </a:rPr>
-              <a:t>按真实结果评分，AI无法作弊</a:t>
-            </a:r>
-          </a:p>
-        </p:txBody>
-      </p:sp>
-      <p:sp>
-        <p:nvSpPr>
-          <p:cNvPr id="386" name="TextBox 385"/>
-          <p:cNvSpPr txBox="1"/>
-          <p:nvPr/>
-        </p:nvSpPr>
-        <p:spPr>
-          <a:xfrm>
-            <a:off x="8275320" y="1755648"/>
-            <a:ext cx="3246120" cy="548640"/>
-          </a:xfrm>
-          <a:prstGeom prst="rect">
-            <a:avLst/>
-          </a:prstGeom>
-          <a:noFill/>
-        </p:spPr>
-        <p:txBody>
-          <a:bodyPr wrap="square" lIns="0" tIns="0" rIns="0" bIns="0" anchor="ctr">
-            <a:spAutoFit/>
-          </a:bodyPr>
-          <a:lstStyle/>
-          <a:p>
-            <a:pPr algn="l"/>
-            <a:r>
-              <a:rPr sz="1150" b="0">
+              <a:t>固定范围、固定验收标准</a:t>
+            </a:r>
+          </a:p>
+        </p:txBody>
+      </p:sp>
+      <p:sp>
+        <p:nvSpPr>
+          <p:cNvPr id="3015" name="SimReal 3015"/>
+          <p:cNvSpPr txBox="1"/>
+          <p:nvPr/>
+        </p:nvSpPr>
+        <p:spPr>
+          <a:xfrm>
+            <a:off x="8595360" y="2340864"/>
+            <a:ext cx="2880360" cy="566928"/>
+          </a:xfrm>
+          <a:prstGeom prst="rect">
+            <a:avLst/>
+          </a:prstGeom>
+          <a:noFill/>
+          <a:ln>
+            <a:noFill/>
+          </a:ln>
+        </p:spPr>
+        <p:txBody>
+          <a:bodyPr spcFirstLastPara="1" wrap="square" lIns="0" tIns="0" rIns="0" bIns="0" anchor="ctr" anchorCtr="0">
+            <a:noAutofit/>
+          </a:bodyPr>
+          <a:lstStyle/>
+          <a:p>
+            <a:pPr marL="0" marR="0" lvl="0" indent="0" algn="l" rtl="0">
+              <a:lnSpc>
+                <a:spcPct val="110000"/>
+              </a:lnSpc>
+              <a:spcBef>
+                <a:spcPts val="0"/>
+              </a:spcBef>
+              <a:spcAft>
+                <a:spcPts val="0"/>
+              </a:spcAft>
+              <a:buNone/>
+            </a:pPr>
+            <a:r>
+              <a:rPr lang="zh-CN" sz="1100" b="1" i="0" u="none" strike="noStrike" cap="none">
                 <a:solidFill>
                   <a:srgbClr val="111110"/>
                 </a:solidFill>
@@ -10526,21 +10022,21 @@
                 <a:cs typeface="Instrument Sans"/>
                 <a:sym typeface="Instrument Sans"/>
               </a:rPr>
-              <a:t>环境授权；独家价4–5倍</a:t>
-            </a:r>
-          </a:p>
-        </p:txBody>
-      </p:sp>
-      <p:sp>
-        <p:nvSpPr>
-          <p:cNvPr id="387" name="Rectangle 386"/>
+              <a:t>验证接入与训练价值</a:t>
+            </a:r>
+          </a:p>
+        </p:txBody>
+      </p:sp>
+      <p:sp>
+        <p:nvSpPr>
+          <p:cNvPr id="3016" name="SimReal 3016"/>
           <p:cNvSpPr/>
           <p:nvPr/>
         </p:nvSpPr>
         <p:spPr>
           <a:xfrm>
-            <a:off x="548640" y="2299525"/>
-            <a:ext cx="11091672" cy="9525"/>
+            <a:off x="548640" y="2907792"/>
+            <a:ext cx="11091672" cy="9144"/>
           </a:xfrm>
           <a:prstGeom prst="rect">
             <a:avLst/>
@@ -10553,7 +10049,7 @@
           </a:ln>
         </p:spPr>
         <p:txBody>
-          <a:bodyPr rtlCol="0" anchor="ctr"/>
+          <a:bodyPr/>
           <a:lstStyle/>
           <a:p>
             <a:endParaRPr/>
@@ -10562,29 +10058,89 @@
       </p:sp>
       <p:sp>
         <p:nvSpPr>
-          <p:cNvPr id="388" name="TextBox 387"/>
-          <p:cNvSpPr txBox="1"/>
-          <p:nvPr/>
-        </p:nvSpPr>
-        <p:spPr>
-          <a:xfrm>
-            <a:off x="548640" y="2350008"/>
-            <a:ext cx="2926080" cy="274320"/>
-          </a:xfrm>
-          <a:prstGeom prst="rect">
-            <a:avLst/>
-          </a:prstGeom>
-          <a:noFill/>
-        </p:spPr>
-        <p:txBody>
-          <a:bodyPr wrap="square" lIns="0" tIns="0" rIns="0" bIns="0" anchor="ctr">
-            <a:spAutoFit/>
-          </a:bodyPr>
-          <a:lstStyle/>
-          <a:p>
-            <a:pPr algn="l"/>
-            <a:r>
-              <a:rPr sz="1500" b="0">
+          <p:cNvPr id="3017" name="SimReal 3017"/>
+          <p:cNvSpPr txBox="1"/>
+          <p:nvPr/>
+        </p:nvSpPr>
+        <p:spPr>
+          <a:xfrm>
+            <a:off x="731520" y="2907792"/>
+            <a:ext cx="411480" cy="566928"/>
+          </a:xfrm>
+          <a:prstGeom prst="rect">
+            <a:avLst/>
+          </a:prstGeom>
+          <a:noFill/>
+          <a:ln>
+            <a:noFill/>
+          </a:ln>
+        </p:spPr>
+        <p:txBody>
+          <a:bodyPr spcFirstLastPara="1" wrap="square" lIns="0" tIns="0" rIns="0" bIns="0" anchor="ctr" anchorCtr="0">
+            <a:noAutofit/>
+          </a:bodyPr>
+          <a:lstStyle/>
+          <a:p>
+            <a:pPr marL="0" marR="0" lvl="0" indent="0" algn="l" rtl="0">
+              <a:spcBef>
+                <a:spcPts val="0"/>
+              </a:spcBef>
+              <a:spcAft>
+                <a:spcPts val="0"/>
+              </a:spcAft>
+              <a:buNone/>
+            </a:pPr>
+            <a:r>
+              <a:rPr lang="zh-CN" sz="1000" b="0" i="0" u="none" strike="noStrike" cap="none">
+                <a:solidFill>
+                  <a:srgbClr val="C2410C"/>
+                </a:solidFill>
+                <a:latin typeface="IBM Plex Mono"/>
+                <a:ea typeface="IBM Plex Mono"/>
+                <a:cs typeface="IBM Plex Mono"/>
+                <a:sym typeface="IBM Plex Mono"/>
+              </a:rPr>
+              <a:t>02</a:t>
+            </a:r>
+          </a:p>
+        </p:txBody>
+      </p:sp>
+      <p:sp>
+        <p:nvSpPr>
+          <p:cNvPr id="3018" name="SimReal 3018"/>
+          <p:cNvSpPr txBox="1"/>
+          <p:nvPr/>
+        </p:nvSpPr>
+        <p:spPr>
+          <a:xfrm>
+            <a:off x="1143000" y="2907792"/>
+            <a:ext cx="1737360" cy="566928"/>
+          </a:xfrm>
+          <a:prstGeom prst="rect">
+            <a:avLst/>
+          </a:prstGeom>
+          <a:noFill/>
+          <a:ln>
+            <a:noFill/>
+          </a:ln>
+        </p:spPr>
+        <p:txBody>
+          <a:bodyPr spcFirstLastPara="1" wrap="square" lIns="0" tIns="0" rIns="0" bIns="0" anchor="ctr" anchorCtr="0">
+            <a:noAutofit/>
+          </a:bodyPr>
+          <a:lstStyle/>
+          <a:p>
+            <a:pPr marL="0" marR="0" lvl="0" indent="0" algn="l" rtl="0">
+              <a:spcBef>
+                <a:spcPts val="0"/>
+              </a:spcBef>
+              <a:spcAft>
+                <a:spcPts val="0"/>
+              </a:spcAft>
+              <a:buNone/>
+            </a:pPr>
+            <a:r>
+              <a:rPr lang="zh-CN" sz="1500" b="0" i="0" u="none" strike="noStrike" cap="none">
                 <a:solidFill>
                   <a:srgbClr val="111110"/>
                 </a:solidFill>
@@ -10593,74 +10149,102 @@
                 <a:cs typeface="Newsreader"/>
                 <a:sym typeface="Newsreader"/>
               </a:rPr>
-              <a:t>专家数据</a:t>
-            </a:r>
-          </a:p>
-        </p:txBody>
-      </p:sp>
-      <p:sp>
-        <p:nvSpPr>
-          <p:cNvPr id="389" name="TextBox 388"/>
-          <p:cNvSpPr txBox="1"/>
-          <p:nvPr/>
-        </p:nvSpPr>
-        <p:spPr>
-          <a:xfrm>
-            <a:off x="548640" y="2606040"/>
-            <a:ext cx="2926080" cy="201168"/>
-          </a:xfrm>
-          <a:prstGeom prst="rect">
-            <a:avLst/>
-          </a:prstGeom>
-          <a:noFill/>
-        </p:spPr>
-        <p:txBody>
-          <a:bodyPr wrap="square" lIns="0" tIns="0" rIns="0" bIns="0" anchor="ctr">
-            <a:spAutoFit/>
-          </a:bodyPr>
-          <a:lstStyle/>
-          <a:p>
-            <a:pPr algn="l"/>
-            <a:r>
-              <a:rPr sz="850" b="0">
-                <a:solidFill>
-                  <a:srgbClr val="6E6C66"/>
+              <a:t>正式授权</a:t>
+            </a:r>
+          </a:p>
+        </p:txBody>
+      </p:sp>
+      <p:sp>
+        <p:nvSpPr>
+          <p:cNvPr id="3019" name="SimReal 3019"/>
+          <p:cNvSpPr txBox="1"/>
+          <p:nvPr/>
+        </p:nvSpPr>
+        <p:spPr>
+          <a:xfrm>
+            <a:off x="2926080" y="2907792"/>
+            <a:ext cx="3017520" cy="566928"/>
+          </a:xfrm>
+          <a:prstGeom prst="rect">
+            <a:avLst/>
+          </a:prstGeom>
+          <a:noFill/>
+          <a:ln>
+            <a:noFill/>
+          </a:ln>
+        </p:spPr>
+        <p:txBody>
+          <a:bodyPr spcFirstLastPara="1" wrap="square" lIns="0" tIns="0" rIns="0" bIns="0" anchor="ctr" anchorCtr="0">
+            <a:noAutofit/>
+          </a:bodyPr>
+          <a:lstStyle/>
+          <a:p>
+            <a:pPr marL="0" marR="0" lvl="0" indent="0" algn="l" rtl="0">
+              <a:lnSpc>
+                <a:spcPct val="110000"/>
+              </a:lnSpc>
+              <a:spcBef>
+                <a:spcPts val="0"/>
+              </a:spcBef>
+              <a:spcAft>
+                <a:spcPts val="0"/>
+              </a:spcAft>
+              <a:buNone/>
+            </a:pPr>
+            <a:r>
+              <a:rPr lang="zh-CN" sz="1100" b="0" i="0" u="none" strike="noStrike" cap="none">
+                <a:solidFill>
+                  <a:srgbClr val="33322F"/>
                 </a:solidFill>
                 <a:latin typeface="Instrument Sans"/>
                 <a:ea typeface="Instrument Sans"/>
                 <a:cs typeface="Instrument Sans"/>
                 <a:sym typeface="Instrument Sans"/>
               </a:rPr>
-              <a:t>来自7,000+候补专家</a:t>
-            </a:r>
-          </a:p>
-        </p:txBody>
-      </p:sp>
-      <p:sp>
-        <p:nvSpPr>
-          <p:cNvPr id="390" name="TextBox 389"/>
-          <p:cNvSpPr txBox="1"/>
-          <p:nvPr/>
-        </p:nvSpPr>
-        <p:spPr>
-          <a:xfrm>
-            <a:off x="3703320" y="2304288"/>
-            <a:ext cx="4434840" cy="548640"/>
-          </a:xfrm>
-          <a:prstGeom prst="rect">
-            <a:avLst/>
-          </a:prstGeom>
-          <a:noFill/>
-        </p:spPr>
-        <p:txBody>
-          <a:bodyPr wrap="square" lIns="0" tIns="0" rIns="0" bIns="0" anchor="ctr">
-            <a:spAutoFit/>
-          </a:bodyPr>
-          <a:lstStyle/>
-          <a:p>
-            <a:pPr algn="l"/>
-            <a:r>
-              <a:rPr sz="1150" b="0">
+              <a:t>环境、任务集、验证器、约定使用权</a:t>
+            </a:r>
+          </a:p>
+        </p:txBody>
+      </p:sp>
+      <p:sp>
+        <p:nvSpPr>
+          <p:cNvPr id="3020" name="SimReal 3020"/>
+          <p:cNvSpPr txBox="1"/>
+          <p:nvPr/>
+        </p:nvSpPr>
+        <p:spPr>
+          <a:xfrm>
+            <a:off x="6080760" y="2907792"/>
+            <a:ext cx="2377440" cy="566928"/>
+          </a:xfrm>
+          <a:prstGeom prst="rect">
+            <a:avLst/>
+          </a:prstGeom>
+          <a:noFill/>
+          <a:ln>
+            <a:noFill/>
+          </a:ln>
+        </p:spPr>
+        <p:txBody>
+          <a:bodyPr spcFirstLastPara="1" wrap="square" lIns="0" tIns="0" rIns="0" bIns="0" anchor="ctr" anchorCtr="0">
+            <a:noAutofit/>
+          </a:bodyPr>
+          <a:lstStyle/>
+          <a:p>
+            <a:pPr marL="0" marR="0" lvl="0" indent="0" algn="l" rtl="0">
+              <a:lnSpc>
+                <a:spcPct val="110000"/>
+              </a:lnSpc>
+              <a:spcBef>
+                <a:spcPts val="0"/>
+              </a:spcBef>
+              <a:spcAft>
+                <a:spcPts val="0"/>
+              </a:spcAft>
+              <a:buNone/>
+            </a:pPr>
+            <a:r>
+              <a:rPr lang="zh-CN" sz="1100" b="0" i="0" u="none" strike="noStrike" cap="none">
                 <a:solidFill>
                   <a:srgbClr val="33322F"/>
                 </a:solidFill>
@@ -10669,36 +10253,50 @@
                 <a:cs typeface="Instrument Sans"/>
                 <a:sym typeface="Instrument Sans"/>
               </a:rPr>
-              <a:t>真实工作的示范与判断</a:t>
-            </a:r>
-          </a:p>
-        </p:txBody>
-      </p:sp>
-      <p:sp>
-        <p:nvSpPr>
-          <p:cNvPr id="391" name="TextBox 390"/>
-          <p:cNvSpPr txBox="1"/>
-          <p:nvPr/>
-        </p:nvSpPr>
-        <p:spPr>
-          <a:xfrm>
-            <a:off x="8275320" y="2304288"/>
-            <a:ext cx="3246120" cy="548640"/>
-          </a:xfrm>
-          <a:prstGeom prst="rect">
-            <a:avLst/>
-          </a:prstGeom>
-          <a:noFill/>
-        </p:spPr>
-        <p:txBody>
-          <a:bodyPr wrap="square" lIns="0" tIns="0" rIns="0" bIns="0" anchor="ctr">
-            <a:spAutoFit/>
-          </a:bodyPr>
-          <a:lstStyle/>
-          <a:p>
-            <a:pPr algn="l"/>
-            <a:r>
-              <a:rPr sz="1150" b="0">
+              <a:t>期限、范围、独占性、交付量</a:t>
+            </a:r>
+          </a:p>
+        </p:txBody>
+      </p:sp>
+      <p:sp>
+        <p:nvSpPr>
+          <p:cNvPr id="3021" name="SimReal 3021"/>
+          <p:cNvSpPr txBox="1"/>
+          <p:nvPr/>
+        </p:nvSpPr>
+        <p:spPr>
+          <a:xfrm>
+            <a:off x="8595360" y="2907792"/>
+            <a:ext cx="2880360" cy="566928"/>
+          </a:xfrm>
+          <a:prstGeom prst="rect">
+            <a:avLst/>
+          </a:prstGeom>
+          <a:noFill/>
+          <a:ln>
+            <a:noFill/>
+          </a:ln>
+        </p:spPr>
+        <p:txBody>
+          <a:bodyPr spcFirstLastPara="1" wrap="square" lIns="0" tIns="0" rIns="0" bIns="0" anchor="ctr" anchorCtr="0">
+            <a:noAutofit/>
+          </a:bodyPr>
+          <a:lstStyle/>
+          <a:p>
+            <a:pPr marL="0" marR="0" lvl="0" indent="0" algn="l" rtl="0">
+              <a:lnSpc>
+                <a:spcPct val="110000"/>
+              </a:lnSpc>
+              <a:spcBef>
+                <a:spcPts val="0"/>
+              </a:spcBef>
+              <a:spcAft>
+                <a:spcPts val="0"/>
+              </a:spcAft>
+              <a:buNone/>
+            </a:pPr>
+            <a:r>
+              <a:rPr lang="zh-CN" sz="1100" b="1" i="0" u="none" strike="noStrike" cap="none">
                 <a:solidFill>
                   <a:srgbClr val="111110"/>
                 </a:solidFill>
@@ -10707,21 +10305,21 @@
                 <a:cs typeface="Instrument Sans"/>
                 <a:sym typeface="Instrument Sans"/>
               </a:rPr>
-              <a:t>按交付量收费</a:t>
-            </a:r>
-          </a:p>
-        </p:txBody>
-      </p:sp>
-      <p:sp>
-        <p:nvSpPr>
-          <p:cNvPr id="392" name="Rectangle 391"/>
+              <a:t>扩大领域与任务覆盖</a:t>
+            </a:r>
+          </a:p>
+        </p:txBody>
+      </p:sp>
+      <p:sp>
+        <p:nvSpPr>
+          <p:cNvPr id="3022" name="SimReal 3022"/>
           <p:cNvSpPr/>
           <p:nvPr/>
         </p:nvSpPr>
         <p:spPr>
           <a:xfrm>
-            <a:off x="548640" y="2848165"/>
-            <a:ext cx="11091672" cy="9525"/>
+            <a:off x="548640" y="3474720"/>
+            <a:ext cx="11091672" cy="9144"/>
           </a:xfrm>
           <a:prstGeom prst="rect">
             <a:avLst/>
@@ -10734,7 +10332,7 @@
           </a:ln>
         </p:spPr>
         <p:txBody>
-          <a:bodyPr rtlCol="0" anchor="ctr"/>
+          <a:bodyPr/>
           <a:lstStyle/>
           <a:p>
             <a:endParaRPr/>
@@ -10743,29 +10341,89 @@
       </p:sp>
       <p:sp>
         <p:nvSpPr>
-          <p:cNvPr id="393" name="TextBox 392"/>
-          <p:cNvSpPr txBox="1"/>
-          <p:nvPr/>
-        </p:nvSpPr>
-        <p:spPr>
-          <a:xfrm>
-            <a:off x="548640" y="2898648"/>
-            <a:ext cx="2926080" cy="274320"/>
-          </a:xfrm>
-          <a:prstGeom prst="rect">
-            <a:avLst/>
-          </a:prstGeom>
-          <a:noFill/>
-        </p:spPr>
-        <p:txBody>
-          <a:bodyPr wrap="square" lIns="0" tIns="0" rIns="0" bIns="0" anchor="ctr">
-            <a:spAutoFit/>
-          </a:bodyPr>
-          <a:lstStyle/>
-          <a:p>
-            <a:pPr algn="l"/>
-            <a:r>
-              <a:rPr sz="1500" b="0">
+          <p:cNvPr id="3023" name="SimReal 3023"/>
+          <p:cNvSpPr txBox="1"/>
+          <p:nvPr/>
+        </p:nvSpPr>
+        <p:spPr>
+          <a:xfrm>
+            <a:off x="731520" y="3474720"/>
+            <a:ext cx="411480" cy="566928"/>
+          </a:xfrm>
+          <a:prstGeom prst="rect">
+            <a:avLst/>
+          </a:prstGeom>
+          <a:noFill/>
+          <a:ln>
+            <a:noFill/>
+          </a:ln>
+        </p:spPr>
+        <p:txBody>
+          <a:bodyPr spcFirstLastPara="1" wrap="square" lIns="0" tIns="0" rIns="0" bIns="0" anchor="ctr" anchorCtr="0">
+            <a:noAutofit/>
+          </a:bodyPr>
+          <a:lstStyle/>
+          <a:p>
+            <a:pPr marL="0" marR="0" lvl="0" indent="0" algn="l" rtl="0">
+              <a:spcBef>
+                <a:spcPts val="0"/>
+              </a:spcBef>
+              <a:spcAft>
+                <a:spcPts val="0"/>
+              </a:spcAft>
+              <a:buNone/>
+            </a:pPr>
+            <a:r>
+              <a:rPr lang="zh-CN" sz="1000" b="0" i="0" u="none" strike="noStrike" cap="none">
+                <a:solidFill>
+                  <a:srgbClr val="C2410C"/>
+                </a:solidFill>
+                <a:latin typeface="IBM Plex Mono"/>
+                <a:ea typeface="IBM Plex Mono"/>
+                <a:cs typeface="IBM Plex Mono"/>
+                <a:sym typeface="IBM Plex Mono"/>
+              </a:rPr>
+              <a:t>03</a:t>
+            </a:r>
+          </a:p>
+        </p:txBody>
+      </p:sp>
+      <p:sp>
+        <p:nvSpPr>
+          <p:cNvPr id="3024" name="SimReal 3024"/>
+          <p:cNvSpPr txBox="1"/>
+          <p:nvPr/>
+        </p:nvSpPr>
+        <p:spPr>
+          <a:xfrm>
+            <a:off x="1143000" y="3474720"/>
+            <a:ext cx="1737360" cy="566928"/>
+          </a:xfrm>
+          <a:prstGeom prst="rect">
+            <a:avLst/>
+          </a:prstGeom>
+          <a:noFill/>
+          <a:ln>
+            <a:noFill/>
+          </a:ln>
+        </p:spPr>
+        <p:txBody>
+          <a:bodyPr spcFirstLastPara="1" wrap="square" lIns="0" tIns="0" rIns="0" bIns="0" anchor="ctr" anchorCtr="0">
+            <a:noAutofit/>
+          </a:bodyPr>
+          <a:lstStyle/>
+          <a:p>
+            <a:pPr marL="0" marR="0" lvl="0" indent="0" algn="l" rtl="0">
+              <a:spcBef>
+                <a:spcPts val="0"/>
+              </a:spcBef>
+              <a:spcAft>
+                <a:spcPts val="0"/>
+              </a:spcAft>
+              <a:buNone/>
+            </a:pPr>
+            <a:r>
+              <a:rPr lang="zh-CN" sz="1500" b="0" i="0" u="none" strike="noStrike" cap="none">
                 <a:solidFill>
                   <a:srgbClr val="111110"/>
                 </a:solidFill>
@@ -10774,74 +10432,102 @@
                 <a:cs typeface="Newsreader"/>
                 <a:sym typeface="Newsreader"/>
               </a:rPr>
-              <a:t>评测与攻防测试</a:t>
-            </a:r>
-          </a:p>
-        </p:txBody>
-      </p:sp>
-      <p:sp>
-        <p:nvSpPr>
-          <p:cNvPr id="394" name="TextBox 393"/>
-          <p:cNvSpPr txBox="1"/>
-          <p:nvPr/>
-        </p:nvSpPr>
-        <p:spPr>
-          <a:xfrm>
-            <a:off x="548640" y="3154680"/>
-            <a:ext cx="2926080" cy="201168"/>
-          </a:xfrm>
-          <a:prstGeom prst="rect">
-            <a:avLst/>
-          </a:prstGeom>
-          <a:noFill/>
-        </p:spPr>
-        <p:txBody>
-          <a:bodyPr wrap="square" lIns="0" tIns="0" rIns="0" bIns="0" anchor="ctr">
-            <a:spAutoFit/>
-          </a:bodyPr>
-          <a:lstStyle/>
-          <a:p>
-            <a:pPr algn="l"/>
-            <a:r>
-              <a:rPr sz="850" b="0">
-                <a:solidFill>
-                  <a:srgbClr val="6E6C66"/>
+              <a:t>持续更新</a:t>
+            </a:r>
+          </a:p>
+        </p:txBody>
+      </p:sp>
+      <p:sp>
+        <p:nvSpPr>
+          <p:cNvPr id="3025" name="SimReal 3025"/>
+          <p:cNvSpPr txBox="1"/>
+          <p:nvPr/>
+        </p:nvSpPr>
+        <p:spPr>
+          <a:xfrm>
+            <a:off x="2926080" y="3474720"/>
+            <a:ext cx="3017520" cy="566928"/>
+          </a:xfrm>
+          <a:prstGeom prst="rect">
+            <a:avLst/>
+          </a:prstGeom>
+          <a:noFill/>
+          <a:ln>
+            <a:noFill/>
+          </a:ln>
+        </p:spPr>
+        <p:txBody>
+          <a:bodyPr spcFirstLastPara="1" wrap="square" lIns="0" tIns="0" rIns="0" bIns="0" anchor="ctr" anchorCtr="0">
+            <a:noAutofit/>
+          </a:bodyPr>
+          <a:lstStyle/>
+          <a:p>
+            <a:pPr marL="0" marR="0" lvl="0" indent="0" algn="l" rtl="0">
+              <a:lnSpc>
+                <a:spcPct val="110000"/>
+              </a:lnSpc>
+              <a:spcBef>
+                <a:spcPts val="0"/>
+              </a:spcBef>
+              <a:spcAft>
+                <a:spcPts val="0"/>
+              </a:spcAft>
+              <a:buNone/>
+            </a:pPr>
+            <a:r>
+              <a:rPr lang="zh-CN" sz="1100" b="0" i="0" u="none" strike="noStrike" cap="none">
+                <a:solidFill>
+                  <a:srgbClr val="33322F"/>
                 </a:solidFill>
                 <a:latin typeface="Instrument Sans"/>
                 <a:ea typeface="Instrument Sans"/>
                 <a:cs typeface="Instrument Sans"/>
                 <a:sym typeface="Instrument Sans"/>
               </a:rPr>
-              <a:t>私有评测、公开基准</a:t>
-            </a:r>
-          </a:p>
-        </p:txBody>
-      </p:sp>
-      <p:sp>
-        <p:nvSpPr>
-          <p:cNvPr id="395" name="TextBox 394"/>
-          <p:cNvSpPr txBox="1"/>
-          <p:nvPr/>
-        </p:nvSpPr>
-        <p:spPr>
-          <a:xfrm>
-            <a:off x="3703320" y="2852928"/>
-            <a:ext cx="4434840" cy="548640"/>
-          </a:xfrm>
-          <a:prstGeom prst="rect">
-            <a:avLst/>
-          </a:prstGeom>
-          <a:noFill/>
-        </p:spPr>
-        <p:txBody>
-          <a:bodyPr wrap="square" lIns="0" tIns="0" rIns="0" bIns="0" anchor="ctr">
-            <a:spAutoFit/>
-          </a:bodyPr>
-          <a:lstStyle/>
-          <a:p>
-            <a:pPr algn="l"/>
-            <a:r>
-              <a:rPr sz="1150" b="0">
+              <a:t>新场景、新任务、私有留出集、验证器维护</a:t>
+            </a:r>
+          </a:p>
+        </p:txBody>
+      </p:sp>
+      <p:sp>
+        <p:nvSpPr>
+          <p:cNvPr id="3026" name="SimReal 3026"/>
+          <p:cNvSpPr txBox="1"/>
+          <p:nvPr/>
+        </p:nvSpPr>
+        <p:spPr>
+          <a:xfrm>
+            <a:off x="6080760" y="3474720"/>
+            <a:ext cx="2377440" cy="566928"/>
+          </a:xfrm>
+          <a:prstGeom prst="rect">
+            <a:avLst/>
+          </a:prstGeom>
+          <a:noFill/>
+          <a:ln>
+            <a:noFill/>
+          </a:ln>
+        </p:spPr>
+        <p:txBody>
+          <a:bodyPr spcFirstLastPara="1" wrap="square" lIns="0" tIns="0" rIns="0" bIns="0" anchor="ctr" anchorCtr="0">
+            <a:noAutofit/>
+          </a:bodyPr>
+          <a:lstStyle/>
+          <a:p>
+            <a:pPr marL="0" marR="0" lvl="0" indent="0" algn="l" rtl="0">
+              <a:lnSpc>
+                <a:spcPct val="110000"/>
+              </a:lnSpc>
+              <a:spcBef>
+                <a:spcPts val="0"/>
+              </a:spcBef>
+              <a:spcAft>
+                <a:spcPts val="0"/>
+              </a:spcAft>
+              <a:buNone/>
+            </a:pPr>
+            <a:r>
+              <a:rPr lang="zh-CN" sz="1100" b="0" i="0" u="none" strike="noStrike" cap="none">
                 <a:solidFill>
                   <a:srgbClr val="33322F"/>
                 </a:solidFill>
@@ -10850,36 +10536,50 @@
                 <a:cs typeface="Instrument Sans"/>
                 <a:sym typeface="Instrument Sans"/>
               </a:rPr>
-              <a:t>上线前先攻击，找出评分漏洞</a:t>
-            </a:r>
-          </a:p>
-        </p:txBody>
-      </p:sp>
-      <p:sp>
-        <p:nvSpPr>
-          <p:cNvPr id="396" name="TextBox 395"/>
-          <p:cNvSpPr txBox="1"/>
-          <p:nvPr/>
-        </p:nvSpPr>
-        <p:spPr>
-          <a:xfrm>
-            <a:off x="8275320" y="2852928"/>
-            <a:ext cx="3246120" cy="548640"/>
-          </a:xfrm>
-          <a:prstGeom prst="rect">
-            <a:avLst/>
-          </a:prstGeom>
-          <a:noFill/>
-        </p:spPr>
-        <p:txBody>
-          <a:bodyPr wrap="square" lIns="0" tIns="0" rIns="0" bIns="0" anchor="ctr">
-            <a:spAutoFit/>
-          </a:bodyPr>
-          <a:lstStyle/>
-          <a:p>
-            <a:pPr algn="l"/>
-            <a:r>
-              <a:rPr sz="1150" b="0">
+              <a:t>年度合同或分批订单</a:t>
+            </a:r>
+          </a:p>
+        </p:txBody>
+      </p:sp>
+      <p:sp>
+        <p:nvSpPr>
+          <p:cNvPr id="3027" name="SimReal 3027"/>
+          <p:cNvSpPr txBox="1"/>
+          <p:nvPr/>
+        </p:nvSpPr>
+        <p:spPr>
+          <a:xfrm>
+            <a:off x="8595360" y="3474720"/>
+            <a:ext cx="2880360" cy="566928"/>
+          </a:xfrm>
+          <a:prstGeom prst="rect">
+            <a:avLst/>
+          </a:prstGeom>
+          <a:noFill/>
+          <a:ln>
+            <a:noFill/>
+          </a:ln>
+        </p:spPr>
+        <p:txBody>
+          <a:bodyPr spcFirstLastPara="1" wrap="square" lIns="0" tIns="0" rIns="0" bIns="0" anchor="ctr" anchorCtr="0">
+            <a:noAutofit/>
+          </a:bodyPr>
+          <a:lstStyle/>
+          <a:p>
+            <a:pPr marL="0" marR="0" lvl="0" indent="0" algn="l" rtl="0">
+              <a:lnSpc>
+                <a:spcPct val="110000"/>
+              </a:lnSpc>
+              <a:spcBef>
+                <a:spcPts val="0"/>
+              </a:spcBef>
+              <a:spcAft>
+                <a:spcPts val="0"/>
+              </a:spcAft>
+              <a:buNone/>
+            </a:pPr>
+            <a:r>
+              <a:rPr lang="zh-CN" sz="1100" b="1" i="0" u="none" strike="noStrike" cap="none">
                 <a:solidFill>
                   <a:srgbClr val="111110"/>
                 </a:solidFill>
@@ -10888,21 +10588,50 @@
                 <a:cs typeface="Instrument Sans"/>
                 <a:sym typeface="Instrument Sans"/>
               </a:rPr>
-              <a:t>按项目收费</a:t>
-            </a:r>
-          </a:p>
-        </p:txBody>
-      </p:sp>
-      <p:sp>
-        <p:nvSpPr>
-          <p:cNvPr id="397" name="Rectangle 396"/>
+              <a:t>旧任务会被做饱和，新能力需要新任务</a:t>
+            </a:r>
+          </a:p>
+        </p:txBody>
+      </p:sp>
+      <p:sp>
+        <p:nvSpPr>
+          <p:cNvPr id="3028" name="SimReal 3028"/>
           <p:cNvSpPr/>
           <p:nvPr/>
         </p:nvSpPr>
         <p:spPr>
           <a:xfrm>
-            <a:off x="548640" y="3401568"/>
-            <a:ext cx="11091672" cy="548640"/>
+            <a:off x="548640" y="4041648"/>
+            <a:ext cx="11091672" cy="9144"/>
+          </a:xfrm>
+          <a:prstGeom prst="rect">
+            <a:avLst/>
+          </a:prstGeom>
+          <a:solidFill>
+            <a:srgbClr val="E2E0DA"/>
+          </a:solidFill>
+          <a:ln>
+            <a:noFill/>
+          </a:ln>
+        </p:spPr>
+        <p:txBody>
+          <a:bodyPr/>
+          <a:lstStyle/>
+          <a:p>
+            <a:endParaRPr/>
+          </a:p>
+        </p:txBody>
+      </p:sp>
+      <p:sp>
+        <p:nvSpPr>
+          <p:cNvPr id="3029" name="SimReal 3029"/>
+          <p:cNvSpPr/>
+          <p:nvPr/>
+        </p:nvSpPr>
+        <p:spPr>
+          <a:xfrm>
+            <a:off x="548640" y="4041648"/>
+            <a:ext cx="11091672" cy="566928"/>
           </a:xfrm>
           <a:prstGeom prst="rect">
             <a:avLst/>
@@ -10915,7 +10644,7 @@
           </a:ln>
         </p:spPr>
         <p:txBody>
-          <a:bodyPr rtlCol="0" anchor="ctr"/>
+          <a:bodyPr/>
           <a:lstStyle/>
           <a:p>
             <a:endParaRPr/>
@@ -10924,29 +10653,89 @@
       </p:sp>
       <p:sp>
         <p:nvSpPr>
-          <p:cNvPr id="398" name="TextBox 397"/>
-          <p:cNvSpPr txBox="1"/>
-          <p:nvPr/>
-        </p:nvSpPr>
-        <p:spPr>
-          <a:xfrm>
-            <a:off x="685800" y="3447287"/>
-            <a:ext cx="2926080" cy="274320"/>
-          </a:xfrm>
-          <a:prstGeom prst="rect">
-            <a:avLst/>
-          </a:prstGeom>
-          <a:noFill/>
-        </p:spPr>
-        <p:txBody>
-          <a:bodyPr wrap="square" lIns="0" tIns="0" rIns="0" bIns="0" anchor="ctr">
-            <a:spAutoFit/>
-          </a:bodyPr>
-          <a:lstStyle/>
-          <a:p>
-            <a:pPr algn="l"/>
-            <a:r>
-              <a:rPr sz="1500" b="0">
+          <p:cNvPr id="3030" name="SimReal 3030"/>
+          <p:cNvSpPr txBox="1"/>
+          <p:nvPr/>
+        </p:nvSpPr>
+        <p:spPr>
+          <a:xfrm>
+            <a:off x="731520" y="4041648"/>
+            <a:ext cx="411480" cy="566928"/>
+          </a:xfrm>
+          <a:prstGeom prst="rect">
+            <a:avLst/>
+          </a:prstGeom>
+          <a:noFill/>
+          <a:ln>
+            <a:noFill/>
+          </a:ln>
+        </p:spPr>
+        <p:txBody>
+          <a:bodyPr spcFirstLastPara="1" wrap="square" lIns="0" tIns="0" rIns="0" bIns="0" anchor="ctr" anchorCtr="0">
+            <a:noAutofit/>
+          </a:bodyPr>
+          <a:lstStyle/>
+          <a:p>
+            <a:pPr marL="0" marR="0" lvl="0" indent="0" algn="l" rtl="0">
+              <a:spcBef>
+                <a:spcPts val="0"/>
+              </a:spcBef>
+              <a:spcAft>
+                <a:spcPts val="0"/>
+              </a:spcAft>
+              <a:buNone/>
+            </a:pPr>
+            <a:r>
+              <a:rPr lang="zh-CN" sz="1000" b="0" i="0" u="none" strike="noStrike" cap="none">
+                <a:solidFill>
+                  <a:srgbClr val="E27A3F"/>
+                </a:solidFill>
+                <a:latin typeface="IBM Plex Mono"/>
+                <a:ea typeface="IBM Plex Mono"/>
+                <a:cs typeface="IBM Plex Mono"/>
+                <a:sym typeface="IBM Plex Mono"/>
+              </a:rPr>
+              <a:t>04</a:t>
+            </a:r>
+          </a:p>
+        </p:txBody>
+      </p:sp>
+      <p:sp>
+        <p:nvSpPr>
+          <p:cNvPr id="3031" name="SimReal 3031"/>
+          <p:cNvSpPr txBox="1"/>
+          <p:nvPr/>
+        </p:nvSpPr>
+        <p:spPr>
+          <a:xfrm>
+            <a:off x="1143000" y="4041648"/>
+            <a:ext cx="1737360" cy="566928"/>
+          </a:xfrm>
+          <a:prstGeom prst="rect">
+            <a:avLst/>
+          </a:prstGeom>
+          <a:noFill/>
+          <a:ln>
+            <a:noFill/>
+          </a:ln>
+        </p:spPr>
+        <p:txBody>
+          <a:bodyPr spcFirstLastPara="1" wrap="square" lIns="0" tIns="0" rIns="0" bIns="0" anchor="ctr" anchorCtr="0">
+            <a:noAutofit/>
+          </a:bodyPr>
+          <a:lstStyle/>
+          <a:p>
+            <a:pPr marL="0" marR="0" lvl="0" indent="0" algn="l" rtl="0">
+              <a:spcBef>
+                <a:spcPts val="0"/>
+              </a:spcBef>
+              <a:spcAft>
+                <a:spcPts val="0"/>
+              </a:spcAft>
+              <a:buNone/>
+            </a:pPr>
+            <a:r>
+              <a:rPr lang="zh-CN" sz="1500" b="0" i="0" u="none" strike="noStrike" cap="none">
                 <a:solidFill>
                   <a:srgbClr val="FAF9F6"/>
                 </a:solidFill>
@@ -10955,112 +10744,154 @@
                 <a:cs typeface="Newsreader"/>
                 <a:sym typeface="Newsreader"/>
               </a:rPr>
-              <a:t>RSI自我进化服务</a:t>
-            </a:r>
-          </a:p>
-        </p:txBody>
-      </p:sp>
-      <p:sp>
-        <p:nvSpPr>
-          <p:cNvPr id="399" name="TextBox 398"/>
-          <p:cNvSpPr txBox="1"/>
-          <p:nvPr/>
-        </p:nvSpPr>
-        <p:spPr>
-          <a:xfrm>
-            <a:off x="685800" y="3703320"/>
-            <a:ext cx="2926080" cy="201168"/>
-          </a:xfrm>
-          <a:prstGeom prst="rect">
-            <a:avLst/>
-          </a:prstGeom>
-          <a:noFill/>
-        </p:spPr>
-        <p:txBody>
-          <a:bodyPr wrap="square" lIns="0" tIns="0" rIns="0" bIns="0" anchor="ctr">
-            <a:spAutoFit/>
-          </a:bodyPr>
-          <a:lstStyle/>
-          <a:p>
-            <a:pPr algn="l"/>
-            <a:r>
-              <a:rPr sz="850" b="0">
-                <a:solidFill>
-                  <a:srgbClr val="E27A3F"/>
+              <a:t>联合训练（RSI）</a:t>
+            </a:r>
+          </a:p>
+        </p:txBody>
+      </p:sp>
+      <p:sp>
+        <p:nvSpPr>
+          <p:cNvPr id="3032" name="SimReal 3032"/>
+          <p:cNvSpPr txBox="1"/>
+          <p:nvPr/>
+        </p:nvSpPr>
+        <p:spPr>
+          <a:xfrm>
+            <a:off x="2926080" y="4041648"/>
+            <a:ext cx="3017520" cy="566928"/>
+          </a:xfrm>
+          <a:prstGeom prst="rect">
+            <a:avLst/>
+          </a:prstGeom>
+          <a:noFill/>
+          <a:ln>
+            <a:noFill/>
+          </a:ln>
+        </p:spPr>
+        <p:txBody>
+          <a:bodyPr spcFirstLastPara="1" wrap="square" lIns="0" tIns="0" rIns="0" bIns="0" anchor="ctr" anchorCtr="0">
+            <a:noAutofit/>
+          </a:bodyPr>
+          <a:lstStyle/>
+          <a:p>
+            <a:pPr marL="0" marR="0" lvl="0" indent="0" algn="l" rtl="0">
+              <a:lnSpc>
+                <a:spcPct val="110000"/>
+              </a:lnSpc>
+              <a:spcBef>
+                <a:spcPts val="0"/>
+              </a:spcBef>
+              <a:spcAft>
+                <a:spcPts val="0"/>
+              </a:spcAft>
+              <a:buNone/>
+            </a:pPr>
+            <a:r>
+              <a:rPr lang="zh-CN" sz="1100" b="0" i="0" u="none" strike="noStrike" cap="none">
+                <a:solidFill>
+                  <a:srgbClr val="C4C0B7"/>
                 </a:solidFill>
                 <a:latin typeface="Instrument Sans"/>
                 <a:ea typeface="Instrument Sans"/>
                 <a:cs typeface="Instrument Sans"/>
                 <a:sym typeface="Instrument Sans"/>
               </a:rPr>
-              <a:t>独有</a:t>
-            </a:r>
-          </a:p>
-        </p:txBody>
-      </p:sp>
-      <p:sp>
-        <p:nvSpPr>
-          <p:cNvPr id="400" name="TextBox 399"/>
-          <p:cNvSpPr txBox="1"/>
-          <p:nvPr/>
-        </p:nvSpPr>
-        <p:spPr>
-          <a:xfrm>
-            <a:off x="3703320" y="3401568"/>
-            <a:ext cx="4434840" cy="548640"/>
-          </a:xfrm>
-          <a:prstGeom prst="rect">
-            <a:avLst/>
-          </a:prstGeom>
-          <a:noFill/>
-        </p:spPr>
-        <p:txBody>
-          <a:bodyPr wrap="square" lIns="0" tIns="0" rIns="0" bIns="0" anchor="ctr">
-            <a:spAutoFit/>
-          </a:bodyPr>
-          <a:lstStyle/>
-          <a:p>
-            <a:pPr algn="l"/>
-            <a:r>
-              <a:rPr sz="1150" b="0">
-                <a:solidFill>
-                  <a:srgbClr val="FAF9F6"/>
+              <a:t>训练实验、消融分析、迁移验证、托管运行</a:t>
+            </a:r>
+          </a:p>
+        </p:txBody>
+      </p:sp>
+      <p:sp>
+        <p:nvSpPr>
+          <p:cNvPr id="3033" name="SimReal 3033"/>
+          <p:cNvSpPr txBox="1"/>
+          <p:nvPr/>
+        </p:nvSpPr>
+        <p:spPr>
+          <a:xfrm>
+            <a:off x="6080760" y="4041648"/>
+            <a:ext cx="2377440" cy="566928"/>
+          </a:xfrm>
+          <a:prstGeom prst="rect">
+            <a:avLst/>
+          </a:prstGeom>
+          <a:noFill/>
+          <a:ln>
+            <a:noFill/>
+          </a:ln>
+        </p:spPr>
+        <p:txBody>
+          <a:bodyPr spcFirstLastPara="1" wrap="square" lIns="0" tIns="0" rIns="0" bIns="0" anchor="ctr" anchorCtr="0">
+            <a:noAutofit/>
+          </a:bodyPr>
+          <a:lstStyle/>
+          <a:p>
+            <a:pPr marL="0" marR="0" lvl="0" indent="0" algn="l" rtl="0">
+              <a:lnSpc>
+                <a:spcPct val="110000"/>
+              </a:lnSpc>
+              <a:spcBef>
+                <a:spcPts val="0"/>
+              </a:spcBef>
+              <a:spcAft>
+                <a:spcPts val="0"/>
+              </a:spcAft>
+              <a:buNone/>
+            </a:pPr>
+            <a:r>
+              <a:rPr lang="zh-CN" sz="1100" b="0" i="0" u="none" strike="noStrike" cap="none">
+                <a:solidFill>
+                  <a:srgbClr val="C4C0B7"/>
                 </a:solidFill>
                 <a:latin typeface="Instrument Sans"/>
                 <a:ea typeface="Instrument Sans"/>
                 <a:cs typeface="Instrument Sans"/>
                 <a:sym typeface="Instrument Sans"/>
               </a:rPr>
-              <a:t>每次模型升级，都回来再训练</a:t>
-            </a:r>
-          </a:p>
-        </p:txBody>
-      </p:sp>
-      <p:sp>
-        <p:nvSpPr>
-          <p:cNvPr id="401" name="TextBox 400"/>
-          <p:cNvSpPr txBox="1"/>
-          <p:nvPr/>
-        </p:nvSpPr>
-        <p:spPr>
-          <a:xfrm>
-            <a:off x="8275320" y="3401568"/>
-            <a:ext cx="3246120" cy="548640"/>
-          </a:xfrm>
-          <a:prstGeom prst="rect">
-            <a:avLst/>
-          </a:prstGeom>
-          <a:noFill/>
-        </p:spPr>
-        <p:txBody>
-          <a:bodyPr wrap="square" lIns="0" tIns="0" rIns="0" bIns="0" anchor="ctr">
-            <a:spAutoFit/>
-          </a:bodyPr>
-          <a:lstStyle/>
-          <a:p>
-            <a:pPr algn="l"/>
-            <a:r>
-              <a:rPr sz="1150" b="0">
+              <a:t>项目或持续服务合同</a:t>
+            </a:r>
+          </a:p>
+        </p:txBody>
+      </p:sp>
+      <p:sp>
+        <p:nvSpPr>
+          <p:cNvPr id="3034" name="SimReal 3034"/>
+          <p:cNvSpPr txBox="1"/>
+          <p:nvPr/>
+        </p:nvSpPr>
+        <p:spPr>
+          <a:xfrm>
+            <a:off x="8595360" y="4041648"/>
+            <a:ext cx="2880360" cy="566928"/>
+          </a:xfrm>
+          <a:prstGeom prst="rect">
+            <a:avLst/>
+          </a:prstGeom>
+          <a:noFill/>
+          <a:ln>
+            <a:noFill/>
+          </a:ln>
+        </p:spPr>
+        <p:txBody>
+          <a:bodyPr spcFirstLastPara="1" wrap="square" lIns="0" tIns="0" rIns="0" bIns="0" anchor="ctr" anchorCtr="0">
+            <a:noAutofit/>
+          </a:bodyPr>
+          <a:lstStyle/>
+          <a:p>
+            <a:pPr marL="0" marR="0" lvl="0" indent="0" algn="l" rtl="0">
+              <a:lnSpc>
+                <a:spcPct val="110000"/>
+              </a:lnSpc>
+              <a:spcBef>
+                <a:spcPts val="0"/>
+              </a:spcBef>
+              <a:spcAft>
+                <a:spcPts val="0"/>
+              </a:spcAft>
+              <a:buNone/>
+            </a:pPr>
+            <a:r>
+              <a:rPr lang="zh-CN" sz="1100" b="1" i="0" u="none" strike="noStrike" cap="none">
                 <a:solidFill>
                   <a:srgbClr val="E27A3F"/>
                 </a:solidFill>
@@ -11069,7 +10900,457 @@
                 <a:cs typeface="Instrument Sans"/>
                 <a:sym typeface="Instrument Sans"/>
               </a:rPr>
-              <a:t>持续收费，随模型升级增长</a:t>
+              <a:t>解决客户下一阶段的能力缺口</a:t>
+            </a:r>
+          </a:p>
+        </p:txBody>
+      </p:sp>
+      <p:sp>
+        <p:nvSpPr>
+          <p:cNvPr id="3035" name="SimReal 3035"/>
+          <p:cNvSpPr/>
+          <p:nvPr/>
+        </p:nvSpPr>
+        <p:spPr>
+          <a:xfrm>
+            <a:off x="548640" y="4864608"/>
+            <a:ext cx="3544824" cy="1024128"/>
+          </a:xfrm>
+          <a:prstGeom prst="rect">
+            <a:avLst/>
+          </a:prstGeom>
+          <a:solidFill>
+            <a:srgbClr val="F2F1EC"/>
+          </a:solidFill>
+          <a:ln>
+            <a:noFill/>
+          </a:ln>
+        </p:spPr>
+        <p:txBody>
+          <a:bodyPr/>
+          <a:lstStyle/>
+          <a:p>
+            <a:endParaRPr/>
+          </a:p>
+        </p:txBody>
+      </p:sp>
+      <p:sp>
+        <p:nvSpPr>
+          <p:cNvPr id="3036" name="SimReal 3036"/>
+          <p:cNvSpPr txBox="1"/>
+          <p:nvPr/>
+        </p:nvSpPr>
+        <p:spPr>
+          <a:xfrm>
+            <a:off x="786384" y="5010912"/>
+            <a:ext cx="3069336" cy="310896"/>
+          </a:xfrm>
+          <a:prstGeom prst="rect">
+            <a:avLst/>
+          </a:prstGeom>
+          <a:noFill/>
+          <a:ln>
+            <a:noFill/>
+          </a:ln>
+        </p:spPr>
+        <p:txBody>
+          <a:bodyPr spcFirstLastPara="1" wrap="square" lIns="0" tIns="0" rIns="0" bIns="0" anchor="ctr" anchorCtr="0">
+            <a:noAutofit/>
+          </a:bodyPr>
+          <a:lstStyle/>
+          <a:p>
+            <a:pPr marL="0" marR="0" lvl="0" indent="0" algn="l" rtl="0">
+              <a:spcBef>
+                <a:spcPts val="0"/>
+              </a:spcBef>
+              <a:spcAft>
+                <a:spcPts val="0"/>
+              </a:spcAft>
+              <a:buNone/>
+            </a:pPr>
+            <a:r>
+              <a:rPr lang="zh-CN" sz="1400" b="0" i="0" u="none" strike="noStrike" cap="none">
+                <a:solidFill>
+                  <a:srgbClr val="111110"/>
+                </a:solidFill>
+                <a:latin typeface="Newsreader"/>
+                <a:ea typeface="Newsreader"/>
+                <a:cs typeface="Newsreader"/>
+                <a:sym typeface="Newsreader"/>
+              </a:rPr>
+              <a:t>开源 vs 付费</a:t>
+            </a:r>
+          </a:p>
+        </p:txBody>
+      </p:sp>
+      <p:sp>
+        <p:nvSpPr>
+          <p:cNvPr id="3037" name="SimReal 3037"/>
+          <p:cNvSpPr txBox="1"/>
+          <p:nvPr/>
+        </p:nvSpPr>
+        <p:spPr>
+          <a:xfrm>
+            <a:off x="786384" y="5358384"/>
+            <a:ext cx="3069336" cy="457200"/>
+          </a:xfrm>
+          <a:prstGeom prst="rect">
+            <a:avLst/>
+          </a:prstGeom>
+          <a:noFill/>
+          <a:ln>
+            <a:noFill/>
+          </a:ln>
+        </p:spPr>
+        <p:txBody>
+          <a:bodyPr spcFirstLastPara="1" wrap="square" lIns="0" tIns="0" rIns="0" bIns="0" anchor="t" anchorCtr="0">
+            <a:noAutofit/>
+          </a:bodyPr>
+          <a:lstStyle/>
+          <a:p>
+            <a:pPr marL="0" marR="0" lvl="0" indent="0" algn="l" rtl="0">
+              <a:spcBef>
+                <a:spcPts val="0"/>
+              </a:spcBef>
+              <a:spcAft>
+                <a:spcPts val="0"/>
+              </a:spcAft>
+              <a:buNone/>
+            </a:pPr>
+            <a:r>
+              <a:rPr lang="zh-CN" sz="1050" b="0" i="0" u="none" strike="noStrike" cap="none">
+                <a:solidFill>
+                  <a:srgbClr val="33322F"/>
+                </a:solidFill>
+                <a:latin typeface="Instrument Sans"/>
+                <a:ea typeface="Instrument Sans"/>
+                <a:cs typeface="Instrument Sans"/>
+                <a:sym typeface="Instrument Sans"/>
+              </a:rPr>
+              <a:t>开源基准：公开，用来建立信任</a:t>
+            </a:r>
+          </a:p>
+          <a:p>
+            <a:pPr marL="0" marR="0" lvl="0" indent="0" algn="l" rtl="0">
+              <a:spcBef>
+                <a:spcPts val="200"/>
+              </a:spcBef>
+              <a:spcAft>
+                <a:spcPts val="0"/>
+              </a:spcAft>
+              <a:buNone/>
+            </a:pPr>
+            <a:r>
+              <a:rPr lang="zh-CN" sz="1050" b="0" i="0" u="none" strike="noStrike" cap="none">
+                <a:solidFill>
+                  <a:srgbClr val="33322F"/>
+                </a:solidFill>
+                <a:latin typeface="Instrument Sans"/>
+                <a:ea typeface="Instrument Sans"/>
+                <a:cs typeface="Instrument Sans"/>
+                <a:sym typeface="Instrument Sans"/>
+              </a:rPr>
+              <a:t>付费产品：私有任务、留出集与验证器</a:t>
+            </a:r>
+          </a:p>
+        </p:txBody>
+      </p:sp>
+      <p:sp>
+        <p:nvSpPr>
+          <p:cNvPr id="3038" name="SimReal 3038"/>
+          <p:cNvSpPr/>
+          <p:nvPr/>
+        </p:nvSpPr>
+        <p:spPr>
+          <a:xfrm>
+            <a:off x="4322064" y="4864608"/>
+            <a:ext cx="3544824" cy="1024128"/>
+          </a:xfrm>
+          <a:prstGeom prst="rect">
+            <a:avLst/>
+          </a:prstGeom>
+          <a:solidFill>
+            <a:srgbClr val="F2F1EC"/>
+          </a:solidFill>
+          <a:ln>
+            <a:noFill/>
+          </a:ln>
+        </p:spPr>
+        <p:txBody>
+          <a:bodyPr/>
+          <a:lstStyle/>
+          <a:p>
+            <a:endParaRPr/>
+          </a:p>
+        </p:txBody>
+      </p:sp>
+      <p:sp>
+        <p:nvSpPr>
+          <p:cNvPr id="3039" name="SimReal 3039"/>
+          <p:cNvSpPr txBox="1"/>
+          <p:nvPr/>
+        </p:nvSpPr>
+        <p:spPr>
+          <a:xfrm>
+            <a:off x="4559808" y="5010912"/>
+            <a:ext cx="3069336" cy="310896"/>
+          </a:xfrm>
+          <a:prstGeom prst="rect">
+            <a:avLst/>
+          </a:prstGeom>
+          <a:noFill/>
+          <a:ln>
+            <a:noFill/>
+          </a:ln>
+        </p:spPr>
+        <p:txBody>
+          <a:bodyPr spcFirstLastPara="1" wrap="square" lIns="0" tIns="0" rIns="0" bIns="0" anchor="ctr" anchorCtr="0">
+            <a:noAutofit/>
+          </a:bodyPr>
+          <a:lstStyle/>
+          <a:p>
+            <a:pPr marL="0" marR="0" lvl="0" indent="0" algn="l" rtl="0">
+              <a:spcBef>
+                <a:spcPts val="0"/>
+              </a:spcBef>
+              <a:spcAft>
+                <a:spcPts val="0"/>
+              </a:spcAft>
+              <a:buNone/>
+            </a:pPr>
+            <a:r>
+              <a:rPr lang="zh-CN" sz="1400" b="0" i="0" u="none" strike="noStrike" cap="none">
+                <a:solidFill>
+                  <a:srgbClr val="111110"/>
+                </a:solidFill>
+                <a:latin typeface="Newsreader"/>
+                <a:ea typeface="Newsreader"/>
+                <a:cs typeface="Newsreader"/>
+                <a:sym typeface="Newsreader"/>
+              </a:rPr>
+              <a:t>非独家 vs 独家</a:t>
+            </a:r>
+          </a:p>
+        </p:txBody>
+      </p:sp>
+      <p:sp>
+        <p:nvSpPr>
+          <p:cNvPr id="3040" name="SimReal 3040"/>
+          <p:cNvSpPr txBox="1"/>
+          <p:nvPr/>
+        </p:nvSpPr>
+        <p:spPr>
+          <a:xfrm>
+            <a:off x="4559808" y="5358384"/>
+            <a:ext cx="3069336" cy="457200"/>
+          </a:xfrm>
+          <a:prstGeom prst="rect">
+            <a:avLst/>
+          </a:prstGeom>
+          <a:noFill/>
+          <a:ln>
+            <a:noFill/>
+          </a:ln>
+        </p:spPr>
+        <p:txBody>
+          <a:bodyPr spcFirstLastPara="1" wrap="square" lIns="0" tIns="0" rIns="0" bIns="0" anchor="t" anchorCtr="0">
+            <a:noAutofit/>
+          </a:bodyPr>
+          <a:lstStyle/>
+          <a:p>
+            <a:pPr marL="0" marR="0" lvl="0" indent="0" algn="l" rtl="0">
+              <a:spcBef>
+                <a:spcPts val="0"/>
+              </a:spcBef>
+              <a:spcAft>
+                <a:spcPts val="0"/>
+              </a:spcAft>
+              <a:buNone/>
+            </a:pPr>
+            <a:r>
+              <a:rPr lang="zh-CN" sz="1050" b="0" i="0" u="none" strike="noStrike" cap="none">
+                <a:solidFill>
+                  <a:srgbClr val="33322F"/>
+                </a:solidFill>
+                <a:latin typeface="Instrument Sans"/>
+                <a:ea typeface="Instrument Sans"/>
+                <a:cs typeface="Instrument Sans"/>
+                <a:sym typeface="Instrument Sans"/>
+              </a:rPr>
+              <a:t>非独家：同一环境可授权给多家实验室</a:t>
+            </a:r>
+          </a:p>
+          <a:p>
+            <a:pPr marL="0" marR="0" lvl="0" indent="0" algn="l" rtl="0">
+              <a:spcBef>
+                <a:spcPts val="200"/>
+              </a:spcBef>
+              <a:spcAft>
+                <a:spcPts val="0"/>
+              </a:spcAft>
+              <a:buNone/>
+            </a:pPr>
+            <a:r>
+              <a:rPr lang="zh-CN" sz="1050" b="0" i="0" u="none" strike="noStrike" cap="none">
+                <a:solidFill>
+                  <a:srgbClr val="33322F"/>
+                </a:solidFill>
+                <a:latin typeface="Instrument Sans"/>
+                <a:ea typeface="Instrument Sans"/>
+                <a:cs typeface="Instrument Sans"/>
+                <a:sym typeface="Instrument Sans"/>
+              </a:rPr>
+              <a:t>独家：按领域与期限锁定，溢价较大（Epoch AI）</a:t>
+            </a:r>
+          </a:p>
+        </p:txBody>
+      </p:sp>
+      <p:sp>
+        <p:nvSpPr>
+          <p:cNvPr id="3041" name="SimReal 3041"/>
+          <p:cNvSpPr/>
+          <p:nvPr/>
+        </p:nvSpPr>
+        <p:spPr>
+          <a:xfrm>
+            <a:off x="8095488" y="4864608"/>
+            <a:ext cx="3544824" cy="1024128"/>
+          </a:xfrm>
+          <a:prstGeom prst="rect">
+            <a:avLst/>
+          </a:prstGeom>
+          <a:solidFill>
+            <a:srgbClr val="F2F1EC"/>
+          </a:solidFill>
+          <a:ln>
+            <a:noFill/>
+          </a:ln>
+        </p:spPr>
+        <p:txBody>
+          <a:bodyPr/>
+          <a:lstStyle/>
+          <a:p>
+            <a:endParaRPr/>
+          </a:p>
+        </p:txBody>
+      </p:sp>
+      <p:sp>
+        <p:nvSpPr>
+          <p:cNvPr id="3042" name="SimReal 3042"/>
+          <p:cNvSpPr txBox="1"/>
+          <p:nvPr/>
+        </p:nvSpPr>
+        <p:spPr>
+          <a:xfrm>
+            <a:off x="8333232" y="5010912"/>
+            <a:ext cx="3069336" cy="310896"/>
+          </a:xfrm>
+          <a:prstGeom prst="rect">
+            <a:avLst/>
+          </a:prstGeom>
+          <a:noFill/>
+          <a:ln>
+            <a:noFill/>
+          </a:ln>
+        </p:spPr>
+        <p:txBody>
+          <a:bodyPr spcFirstLastPara="1" wrap="square" lIns="0" tIns="0" rIns="0" bIns="0" anchor="ctr" anchorCtr="0">
+            <a:noAutofit/>
+          </a:bodyPr>
+          <a:lstStyle/>
+          <a:p>
+            <a:pPr marL="0" marR="0" lvl="0" indent="0" algn="l" rtl="0">
+              <a:spcBef>
+                <a:spcPts val="0"/>
+              </a:spcBef>
+              <a:spcAft>
+                <a:spcPts val="0"/>
+              </a:spcAft>
+              <a:buNone/>
+            </a:pPr>
+            <a:r>
+              <a:rPr lang="zh-CN" sz="1400" b="0" i="0" u="none" strike="noStrike" cap="none">
+                <a:solidFill>
+                  <a:srgbClr val="111110"/>
+                </a:solidFill>
+                <a:latin typeface="Newsreader"/>
+                <a:ea typeface="Newsreader"/>
+                <a:cs typeface="Newsreader"/>
+                <a:sym typeface="Newsreader"/>
+              </a:rPr>
+              <a:t>交付之后，仍由我们提供</a:t>
+            </a:r>
+          </a:p>
+        </p:txBody>
+      </p:sp>
+      <p:sp>
+        <p:nvSpPr>
+          <p:cNvPr id="3043" name="SimReal 3043"/>
+          <p:cNvSpPr txBox="1"/>
+          <p:nvPr/>
+        </p:nvSpPr>
+        <p:spPr>
+          <a:xfrm>
+            <a:off x="8333232" y="5358384"/>
+            <a:ext cx="3069336" cy="457200"/>
+          </a:xfrm>
+          <a:prstGeom prst="rect">
+            <a:avLst/>
+          </a:prstGeom>
+          <a:noFill/>
+          <a:ln>
+            <a:noFill/>
+          </a:ln>
+        </p:spPr>
+        <p:txBody>
+          <a:bodyPr spcFirstLastPara="1" wrap="square" lIns="0" tIns="0" rIns="0" bIns="0" anchor="t" anchorCtr="0">
+            <a:noAutofit/>
+          </a:bodyPr>
+          <a:lstStyle/>
+          <a:p>
+            <a:pPr marL="0" marR="0" lvl="0" indent="0" algn="l" rtl="0">
+              <a:spcBef>
+                <a:spcPts val="0"/>
+              </a:spcBef>
+              <a:spcAft>
+                <a:spcPts val="0"/>
+              </a:spcAft>
+              <a:buNone/>
+            </a:pPr>
+            <a:r>
+              <a:rPr lang="zh-CN" sz="1050" b="0" i="0" u="none" strike="noStrike" cap="none">
+                <a:solidFill>
+                  <a:srgbClr val="33322F"/>
+                </a:solidFill>
+                <a:latin typeface="Instrument Sans"/>
+                <a:ea typeface="Instrument Sans"/>
+                <a:cs typeface="Instrument Sans"/>
+                <a:sym typeface="Instrument Sans"/>
+              </a:rPr>
+              <a:t>验证器维护、防作弊修补</a:t>
+            </a:r>
+          </a:p>
+          <a:p>
+            <a:pPr marL="0" marR="0" lvl="0" indent="0" algn="l" rtl="0">
+              <a:spcBef>
+                <a:spcPts val="200"/>
+              </a:spcBef>
+              <a:spcAft>
+                <a:spcPts val="0"/>
+              </a:spcAft>
+              <a:buNone/>
+            </a:pPr>
+            <a:r>
+              <a:rPr lang="zh-CN" sz="1050" b="0" i="0" u="none" strike="noStrike" cap="none">
+                <a:solidFill>
+                  <a:srgbClr val="33322F"/>
+                </a:solidFill>
+                <a:latin typeface="Instrument Sans"/>
+                <a:ea typeface="Instrument Sans"/>
+                <a:cs typeface="Instrument Sans"/>
+                <a:sym typeface="Instrument Sans"/>
+              </a:rPr>
+              <a:t>难度升级、托管运行</a:t>
             </a:r>
           </a:p>
         </p:txBody>
@@ -17628,7 +17909,7 @@
                 <a:cs typeface="Instrument Sans"/>
                 <a:sym typeface="Instrument Sans"/>
               </a:rPr>
-              <a:t>每次模型升级，都回到同一套环境对比、再训练</a:t>
+              <a:t>每轮升级都需要新任务、新留出集和验证器维护</a:t>
             </a:r>
             <a:endParaRPr sz="1100" b="0" i="0" u="none" strike="noStrike" cap="none" dirty="0">
               <a:solidFill>

</xml_diff>

<commit_message>
BP v17: page 17 states this round's business goal
From pilots to verifiable paid purchases and repeat purchases, placed in
the round box between the valuation line and the revenue targets.

Co-Authored-By: Claude Opus 5.5 <noreply@anthropic.com>
Claude-Session: https://claude.ai/code/session_01EKqGwTA92C8Wo4e47t73NN
</commit_message>
<xml_diff>
--- a/SimReal-BP-v17.pptx
+++ b/SimReal-BP-v17.pptx
@@ -22033,7 +22033,7 @@
         <p:spPr>
           <a:xfrm>
             <a:off x="548640" y="1481328"/>
-            <a:ext cx="3566160" cy="2697480"/>
+            <a:ext cx="3566160" cy="2743200"/>
           </a:xfrm>
           <a:prstGeom prst="rect">
             <a:avLst/>
@@ -22061,7 +22061,7 @@
         </p:nvSpPr>
         <p:spPr>
           <a:xfrm>
-            <a:off x="868680" y="1700784"/>
+            <a:off x="868680" y="1664208"/>
             <a:ext cx="2743200" cy="201168"/>
           </a:xfrm>
           <a:prstGeom prst="rect">
@@ -22110,8 +22110,8 @@
         </p:nvSpPr>
         <p:spPr>
           <a:xfrm>
-            <a:off x="868680" y="1938528"/>
-            <a:ext cx="3017520" cy="914400"/>
+            <a:off x="868680" y="1847088"/>
+            <a:ext cx="3017520" cy="804672"/>
           </a:xfrm>
           <a:prstGeom prst="rect">
             <a:avLst/>
@@ -22137,7 +22137,7 @@
               <a:buNone/>
             </a:pPr>
             <a:r>
-              <a:rPr lang="zh-CN" sz="6400" b="0" i="0" u="none" strike="noStrike" cap="none">
+              <a:rPr lang="zh-CN" sz="5600" b="0" i="0" u="none" strike="noStrike" cap="none">
                 <a:solidFill>
                   <a:srgbClr val="E27A3F"/>
                 </a:solidFill>
@@ -22159,8 +22159,8 @@
         </p:nvSpPr>
         <p:spPr>
           <a:xfrm>
-            <a:off x="868680" y="2926080"/>
-            <a:ext cx="3017520" cy="274320"/>
+            <a:off x="868680" y="2688336"/>
+            <a:ext cx="3017520" cy="256032"/>
           </a:xfrm>
           <a:prstGeom prst="rect">
             <a:avLst/>
@@ -22203,13 +22203,42 @@
       <p:sp>
         <p:nvSpPr>
           <p:cNvPr id="3007" name="SimReal 3007"/>
-          <p:cNvSpPr txBox="1"/>
-          <p:nvPr/>
-        </p:nvSpPr>
-        <p:spPr>
-          <a:xfrm>
-            <a:off x="868680" y="3291840"/>
-            <a:ext cx="3017520" cy="640080"/>
+          <p:cNvSpPr/>
+          <p:nvPr/>
+        </p:nvSpPr>
+        <p:spPr>
+          <a:xfrm>
+            <a:off x="868680" y="3054096"/>
+            <a:ext cx="2926080" cy="9144"/>
+          </a:xfrm>
+          <a:prstGeom prst="rect">
+            <a:avLst/>
+          </a:prstGeom>
+          <a:solidFill>
+            <a:srgbClr val="3A3935"/>
+          </a:solidFill>
+          <a:ln>
+            <a:noFill/>
+          </a:ln>
+        </p:spPr>
+        <p:txBody>
+          <a:bodyPr/>
+          <a:lstStyle/>
+          <a:p>
+            <a:endParaRPr/>
+          </a:p>
+        </p:txBody>
+      </p:sp>
+      <p:sp>
+        <p:nvSpPr>
+          <p:cNvPr id="3008" name="SimReal 3008"/>
+          <p:cNvSpPr txBox="1"/>
+          <p:nvPr/>
+        </p:nvSpPr>
+        <p:spPr>
+          <a:xfrm>
+            <a:off x="868680" y="3145536"/>
+            <a:ext cx="3017520" cy="182880"/>
           </a:xfrm>
           <a:prstGeom prst="rect">
             <a:avLst/>
@@ -22235,22 +22264,97 @@
               <a:buNone/>
             </a:pPr>
             <a:r>
-              <a:rPr lang="zh-CN" sz="1300" b="1" i="0" u="none" strike="noStrike" cap="none">
-                <a:solidFill>
-                  <a:srgbClr val="E27A3F"/>
+              <a:rPr lang="zh-CN" sz="950" b="0" i="0" u="none" strike="noStrike" cap="none">
+                <a:solidFill>
+                  <a:srgbClr val="C4C0B7"/>
+                </a:solidFill>
+                <a:latin typeface="IBM Plex Mono"/>
+                <a:ea typeface="IBM Plex Mono"/>
+                <a:cs typeface="IBM Plex Mono"/>
+                <a:sym typeface="IBM Plex Mono"/>
+              </a:rPr>
+              <a:t>本轮商业目标</a:t>
+            </a:r>
+          </a:p>
+        </p:txBody>
+      </p:sp>
+      <p:sp>
+        <p:nvSpPr>
+          <p:cNvPr id="3009" name="SimReal 3009"/>
+          <p:cNvSpPr txBox="1"/>
+          <p:nvPr/>
+        </p:nvSpPr>
+        <p:spPr>
+          <a:xfrm>
+            <a:off x="868680" y="3346704"/>
+            <a:ext cx="3017520" cy="274320"/>
+          </a:xfrm>
+          <a:prstGeom prst="rect">
+            <a:avLst/>
+          </a:prstGeom>
+          <a:noFill/>
+          <a:ln>
+            <a:noFill/>
+          </a:ln>
+        </p:spPr>
+        <p:txBody>
+          <a:bodyPr spcFirstLastPara="1" wrap="square" lIns="0" tIns="0" rIns="0" bIns="0" anchor="ctr" anchorCtr="0">
+            <a:noAutofit/>
+          </a:bodyPr>
+          <a:lstStyle/>
+          <a:p>
+            <a:pPr marL="0" marR="0" lvl="0" indent="0" algn="l" rtl="0">
+              <a:spcBef>
+                <a:spcPts val="0"/>
+              </a:spcBef>
+              <a:spcAft>
+                <a:spcPts val="0"/>
+              </a:spcAft>
+              <a:buNone/>
+            </a:pPr>
+            <a:r>
+              <a:rPr lang="zh-CN" sz="1250" b="0" i="0" u="none" strike="noStrike" cap="none">
+                <a:solidFill>
+                  <a:srgbClr val="FAF9F6"/>
                 </a:solidFill>
                 <a:latin typeface="Instrument Sans"/>
                 <a:ea typeface="Instrument Sans"/>
                 <a:cs typeface="Instrument Sans"/>
                 <a:sym typeface="Instrument Sans"/>
               </a:rPr>
-              <a:t>6个月年化收入1亿美元</a:t>
-            </a:r>
-          </a:p>
+              <a:t>从试点推进到可验证的付费采购与复购</a:t>
+            </a:r>
+          </a:p>
+        </p:txBody>
+      </p:sp>
+      <p:sp>
+        <p:nvSpPr>
+          <p:cNvPr id="3010" name="SimReal 3010"/>
+          <p:cNvSpPr txBox="1"/>
+          <p:nvPr/>
+        </p:nvSpPr>
+        <p:spPr>
+          <a:xfrm>
+            <a:off x="868680" y="3675888"/>
+            <a:ext cx="3017520" cy="493776"/>
+          </a:xfrm>
+          <a:prstGeom prst="rect">
+            <a:avLst/>
+          </a:prstGeom>
+          <a:noFill/>
+          <a:ln>
+            <a:noFill/>
+          </a:ln>
+        </p:spPr>
+        <p:txBody>
+          <a:bodyPr spcFirstLastPara="1" wrap="square" lIns="0" tIns="0" rIns="0" bIns="0" anchor="t" anchorCtr="0">
+            <a:noAutofit/>
+          </a:bodyPr>
+          <a:lstStyle/>
           <a:p>
             <a:pPr marL="0" marR="0" lvl="0" indent="0" algn="l" rtl="0">
               <a:spcBef>
-                <a:spcPts val="300"/>
+                <a:spcPts val="0"/>
               </a:spcBef>
               <a:spcAft>
                 <a:spcPts val="0"/>
@@ -22267,6 +22371,29 @@
                 <a:cs typeface="Instrument Sans"/>
                 <a:sym typeface="Instrument Sans"/>
               </a:rPr>
+              <a:t>6个月年化收入1亿美元</a:t>
+            </a:r>
+          </a:p>
+          <a:p>
+            <a:pPr marL="0" marR="0" lvl="0" indent="0" algn="l" rtl="0">
+              <a:spcBef>
+                <a:spcPts val="300"/>
+              </a:spcBef>
+              <a:spcAft>
+                <a:spcPts val="0"/>
+              </a:spcAft>
+              <a:buNone/>
+            </a:pPr>
+            <a:r>
+              <a:rPr lang="zh-CN" sz="1300" b="1" i="0" u="none" strike="noStrike" cap="none">
+                <a:solidFill>
+                  <a:srgbClr val="E27A3F"/>
+                </a:solidFill>
+                <a:latin typeface="Instrument Sans"/>
+                <a:ea typeface="Instrument Sans"/>
+                <a:cs typeface="Instrument Sans"/>
+                <a:sym typeface="Instrument Sans"/>
+              </a:rPr>
               <a:t>12个月年化收入3亿美元</a:t>
             </a:r>
           </a:p>
@@ -22274,7 +22401,7 @@
       </p:sp>
       <p:sp>
         <p:nvSpPr>
-          <p:cNvPr id="3008" name="SimReal 3008"/>
+          <p:cNvPr id="3011" name="SimReal 3011"/>
           <p:cNvSpPr txBox="1"/>
           <p:nvPr/>
         </p:nvSpPr>
@@ -22323,7 +22450,7 @@
       </p:sp>
       <p:sp>
         <p:nvSpPr>
-          <p:cNvPr id="3009" name="SimReal 3009"/>
+          <p:cNvPr id="3012" name="SimReal 3012"/>
           <p:cNvSpPr/>
           <p:nvPr/>
         </p:nvSpPr>
@@ -22352,7 +22479,7 @@
       </p:sp>
       <p:sp>
         <p:nvSpPr>
-          <p:cNvPr id="3010" name="SimReal 3010"/>
+          <p:cNvPr id="3013" name="SimReal 3013"/>
           <p:cNvSpPr txBox="1"/>
           <p:nvPr/>
         </p:nvSpPr>
@@ -22401,7 +22528,7 @@
       </p:sp>
       <p:sp>
         <p:nvSpPr>
-          <p:cNvPr id="3011" name="SimReal 3011"/>
+          <p:cNvPr id="3014" name="SimReal 3014"/>
           <p:cNvSpPr txBox="1"/>
           <p:nvPr/>
         </p:nvSpPr>
@@ -22450,7 +22577,7 @@
       </p:sp>
       <p:sp>
         <p:nvSpPr>
-          <p:cNvPr id="3012" name="SimReal 3012"/>
+          <p:cNvPr id="3015" name="SimReal 3015"/>
           <p:cNvSpPr txBox="1"/>
           <p:nvPr/>
         </p:nvSpPr>
@@ -22502,7 +22629,7 @@
       </p:sp>
       <p:sp>
         <p:nvSpPr>
-          <p:cNvPr id="3013" name="SimReal 3013"/>
+          <p:cNvPr id="3016" name="SimReal 3016"/>
           <p:cNvSpPr/>
           <p:nvPr/>
         </p:nvSpPr>
@@ -22531,7 +22658,7 @@
       </p:sp>
       <p:sp>
         <p:nvSpPr>
-          <p:cNvPr id="3014" name="SimReal 3014"/>
+          <p:cNvPr id="3017" name="SimReal 3017"/>
           <p:cNvSpPr txBox="1"/>
           <p:nvPr/>
         </p:nvSpPr>
@@ -22580,7 +22707,7 @@
       </p:sp>
       <p:sp>
         <p:nvSpPr>
-          <p:cNvPr id="3015" name="SimReal 3015"/>
+          <p:cNvPr id="3018" name="SimReal 3018"/>
           <p:cNvSpPr txBox="1"/>
           <p:nvPr/>
         </p:nvSpPr>
@@ -22629,7 +22756,7 @@
       </p:sp>
       <p:sp>
         <p:nvSpPr>
-          <p:cNvPr id="3016" name="SimReal 3016"/>
+          <p:cNvPr id="3019" name="SimReal 3019"/>
           <p:cNvSpPr txBox="1"/>
           <p:nvPr/>
         </p:nvSpPr>
@@ -22681,7 +22808,7 @@
       </p:sp>
       <p:sp>
         <p:nvSpPr>
-          <p:cNvPr id="3017" name="SimReal 3017"/>
+          <p:cNvPr id="3020" name="SimReal 3020"/>
           <p:cNvSpPr/>
           <p:nvPr/>
         </p:nvSpPr>
@@ -22710,7 +22837,7 @@
       </p:sp>
       <p:sp>
         <p:nvSpPr>
-          <p:cNvPr id="3018" name="SimReal 3018"/>
+          <p:cNvPr id="3021" name="SimReal 3021"/>
           <p:cNvSpPr txBox="1"/>
           <p:nvPr/>
         </p:nvSpPr>
@@ -22759,7 +22886,7 @@
       </p:sp>
       <p:sp>
         <p:nvSpPr>
-          <p:cNvPr id="3019" name="SimReal 3019"/>
+          <p:cNvPr id="3022" name="SimReal 3022"/>
           <p:cNvSpPr txBox="1"/>
           <p:nvPr/>
         </p:nvSpPr>
@@ -22808,7 +22935,7 @@
       </p:sp>
       <p:sp>
         <p:nvSpPr>
-          <p:cNvPr id="3020" name="SimReal 3020"/>
+          <p:cNvPr id="3023" name="SimReal 3023"/>
           <p:cNvSpPr txBox="1"/>
           <p:nvPr/>
         </p:nvSpPr>
@@ -22860,7 +22987,7 @@
       </p:sp>
       <p:sp>
         <p:nvSpPr>
-          <p:cNvPr id="3021" name="SimReal 3021"/>
+          <p:cNvPr id="3024" name="SimReal 3024"/>
           <p:cNvSpPr/>
           <p:nvPr/>
         </p:nvSpPr>
@@ -22889,7 +23016,7 @@
       </p:sp>
       <p:sp>
         <p:nvSpPr>
-          <p:cNvPr id="3022" name="SimReal 3022"/>
+          <p:cNvPr id="3025" name="SimReal 3025"/>
           <p:cNvSpPr txBox="1"/>
           <p:nvPr/>
         </p:nvSpPr>
@@ -22938,7 +23065,7 @@
       </p:sp>
       <p:sp>
         <p:nvSpPr>
-          <p:cNvPr id="3023" name="SimReal 3023"/>
+          <p:cNvPr id="3026" name="SimReal 3026"/>
           <p:cNvSpPr txBox="1"/>
           <p:nvPr/>
         </p:nvSpPr>
@@ -22987,7 +23114,7 @@
       </p:sp>
       <p:sp>
         <p:nvSpPr>
-          <p:cNvPr id="3024" name="SimReal 3024"/>
+          <p:cNvPr id="3027" name="SimReal 3027"/>
           <p:cNvSpPr txBox="1"/>
           <p:nvPr/>
         </p:nvSpPr>
@@ -23039,7 +23166,7 @@
       </p:sp>
       <p:sp>
         <p:nvSpPr>
-          <p:cNvPr id="3025" name="SimReal 3025"/>
+          <p:cNvPr id="3028" name="SimReal 3028"/>
           <p:cNvSpPr/>
           <p:nvPr/>
         </p:nvSpPr>
@@ -23068,7 +23195,7 @@
       </p:sp>
       <p:sp>
         <p:nvSpPr>
-          <p:cNvPr id="3026" name="SimReal 3026"/>
+          <p:cNvPr id="3029" name="SimReal 3029"/>
           <p:cNvSpPr txBox="1"/>
           <p:nvPr/>
         </p:nvSpPr>
@@ -23117,7 +23244,7 @@
       </p:sp>
       <p:sp>
         <p:nvSpPr>
-          <p:cNvPr id="3027" name="SimReal 3027"/>
+          <p:cNvPr id="3030" name="SimReal 3030"/>
           <p:cNvSpPr/>
           <p:nvPr/>
         </p:nvSpPr>
@@ -23146,7 +23273,7 @@
       </p:sp>
       <p:sp>
         <p:nvSpPr>
-          <p:cNvPr id="3028" name="SimReal 3028"/>
+          <p:cNvPr id="3031" name="SimReal 3031"/>
           <p:cNvSpPr txBox="1"/>
           <p:nvPr/>
         </p:nvSpPr>
@@ -23195,7 +23322,7 @@
       </p:sp>
       <p:sp>
         <p:nvSpPr>
-          <p:cNvPr id="3029" name="SimReal 3029"/>
+          <p:cNvPr id="3032" name="SimReal 3032"/>
           <p:cNvSpPr txBox="1"/>
           <p:nvPr/>
         </p:nvSpPr>
@@ -23244,7 +23371,7 @@
       </p:sp>
       <p:sp>
         <p:nvSpPr>
-          <p:cNvPr id="3030" name="SimReal 3030"/>
+          <p:cNvPr id="3033" name="SimReal 3033"/>
           <p:cNvSpPr txBox="1"/>
           <p:nvPr/>
         </p:nvSpPr>
@@ -23293,7 +23420,7 @@
       </p:sp>
       <p:sp>
         <p:nvSpPr>
-          <p:cNvPr id="3031" name="SimReal 3031"/>
+          <p:cNvPr id="3034" name="SimReal 3034"/>
           <p:cNvSpPr/>
           <p:nvPr/>
         </p:nvSpPr>
@@ -23322,7 +23449,7 @@
       </p:sp>
       <p:sp>
         <p:nvSpPr>
-          <p:cNvPr id="3032" name="SimReal 3032"/>
+          <p:cNvPr id="3035" name="SimReal 3035"/>
           <p:cNvSpPr txBox="1"/>
           <p:nvPr/>
         </p:nvSpPr>
@@ -23371,7 +23498,7 @@
       </p:sp>
       <p:sp>
         <p:nvSpPr>
-          <p:cNvPr id="3033" name="SimReal 3033"/>
+          <p:cNvPr id="3036" name="SimReal 3036"/>
           <p:cNvSpPr txBox="1"/>
           <p:nvPr/>
         </p:nvSpPr>
@@ -23420,7 +23547,7 @@
       </p:sp>
       <p:sp>
         <p:nvSpPr>
-          <p:cNvPr id="3034" name="SimReal 3034"/>
+          <p:cNvPr id="3037" name="SimReal 3037"/>
           <p:cNvSpPr txBox="1"/>
           <p:nvPr/>
         </p:nvSpPr>
@@ -23469,7 +23596,7 @@
       </p:sp>
       <p:sp>
         <p:nvSpPr>
-          <p:cNvPr id="3035" name="SimReal 3035"/>
+          <p:cNvPr id="3038" name="SimReal 3038"/>
           <p:cNvSpPr/>
           <p:nvPr/>
         </p:nvSpPr>
@@ -23498,7 +23625,7 @@
       </p:sp>
       <p:sp>
         <p:nvSpPr>
-          <p:cNvPr id="3036" name="SimReal 3036"/>
+          <p:cNvPr id="3039" name="SimReal 3039"/>
           <p:cNvSpPr txBox="1"/>
           <p:nvPr/>
         </p:nvSpPr>
@@ -23547,7 +23674,7 @@
       </p:sp>
       <p:sp>
         <p:nvSpPr>
-          <p:cNvPr id="3037" name="SimReal 3037"/>
+          <p:cNvPr id="3040" name="SimReal 3040"/>
           <p:cNvSpPr txBox="1"/>
           <p:nvPr/>
         </p:nvSpPr>
@@ -23596,7 +23723,7 @@
       </p:sp>
       <p:sp>
         <p:nvSpPr>
-          <p:cNvPr id="3038" name="SimReal 3038"/>
+          <p:cNvPr id="3041" name="SimReal 3041"/>
           <p:cNvSpPr txBox="1"/>
           <p:nvPr/>
         </p:nvSpPr>
@@ -23645,7 +23772,7 @@
       </p:sp>
       <p:sp>
         <p:nvSpPr>
-          <p:cNvPr id="3039" name="SimReal 3039"/>
+          <p:cNvPr id="3042" name="SimReal 3042"/>
           <p:cNvSpPr/>
           <p:nvPr/>
         </p:nvSpPr>
@@ -23674,7 +23801,7 @@
       </p:sp>
       <p:sp>
         <p:nvSpPr>
-          <p:cNvPr id="3040" name="SimReal 3040"/>
+          <p:cNvPr id="3043" name="SimReal 3043"/>
           <p:cNvSpPr txBox="1"/>
           <p:nvPr/>
         </p:nvSpPr>
@@ -23723,7 +23850,7 @@
       </p:sp>
       <p:sp>
         <p:nvSpPr>
-          <p:cNvPr id="3041" name="SimReal 3041"/>
+          <p:cNvPr id="3044" name="SimReal 3044"/>
           <p:cNvSpPr txBox="1"/>
           <p:nvPr/>
         </p:nvSpPr>
@@ -23772,7 +23899,7 @@
       </p:sp>
       <p:sp>
         <p:nvSpPr>
-          <p:cNvPr id="3042" name="SimReal 3042"/>
+          <p:cNvPr id="3045" name="SimReal 3045"/>
           <p:cNvSpPr txBox="1"/>
           <p:nvPr/>
         </p:nvSpPr>
@@ -23821,7 +23948,7 @@
       </p:sp>
       <p:sp>
         <p:nvSpPr>
-          <p:cNvPr id="3043" name="SimReal 3043"/>
+          <p:cNvPr id="3046" name="SimReal 3046"/>
           <p:cNvSpPr txBox="1"/>
           <p:nvPr/>
         </p:nvSpPr>
@@ -23870,7 +23997,7 @@
       </p:sp>
       <p:sp>
         <p:nvSpPr>
-          <p:cNvPr id="3044" name="SimReal 3044"/>
+          <p:cNvPr id="3047" name="SimReal 3047"/>
           <p:cNvSpPr txBox="1"/>
           <p:nvPr/>
         </p:nvSpPr>

</xml_diff>